<commit_message>
Refresh competitive intelligence data and harden pipeline
</commit_message>
<xml_diff>
--- a/deploy-site/exports/waters-nextgen-leadership-brief.pptx
+++ b/deploy-site/exports/waters-nextgen-leadership-brief.pptx
@@ -2,20 +2,20 @@
 <file path=ppt/presentation.xml><?xml version="1.0" encoding="utf-8"?>
 <p:presentation xmlns:p="http://schemas.openxmlformats.org/presentationml/2006/main">
   <p:sldMasterIdLst>
-    <p:sldMasterId xmlns:r="http://schemas.openxmlformats.org/officeDocument/2006/relationships" id="2147483648" r:id="R47025f820bd44dc9"/>
+    <p:sldMasterId xmlns:r="http://schemas.openxmlformats.org/officeDocument/2006/relationships" id="2147483648" r:id="R05da7cc905b64ff5"/>
   </p:sldMasterIdLst>
   <p:notesMasterIdLst>
-    <p:notesMasterId xmlns:r="http://schemas.openxmlformats.org/officeDocument/2006/relationships" r:id="Ra26fa839c44d4450"/>
+    <p:notesMasterId xmlns:r="http://schemas.openxmlformats.org/officeDocument/2006/relationships" r:id="Rb544a85706c54157"/>
   </p:notesMasterIdLst>
   <p:sldIdLst>
-    <p:sldId xmlns:r="http://schemas.openxmlformats.org/officeDocument/2006/relationships" id="256" r:id="Rbbd4b53579344fb9"/>
-    <p:sldId xmlns:r="http://schemas.openxmlformats.org/officeDocument/2006/relationships" id="257" r:id="Rfdc95bf5ca9343a0"/>
-    <p:sldId xmlns:r="http://schemas.openxmlformats.org/officeDocument/2006/relationships" id="258" r:id="Re9ccaa700412492d"/>
-    <p:sldId xmlns:r="http://schemas.openxmlformats.org/officeDocument/2006/relationships" id="259" r:id="Rae6ac13d472a464b"/>
-    <p:sldId xmlns:r="http://schemas.openxmlformats.org/officeDocument/2006/relationships" id="260" r:id="R39662f3792504b4e"/>
-    <p:sldId xmlns:r="http://schemas.openxmlformats.org/officeDocument/2006/relationships" id="261" r:id="Rb48859e6fa594dee"/>
-    <p:sldId xmlns:r="http://schemas.openxmlformats.org/officeDocument/2006/relationships" id="262" r:id="R12c666dbf7664d59"/>
-    <p:sldId xmlns:r="http://schemas.openxmlformats.org/officeDocument/2006/relationships" id="263" r:id="R480b47ed46344084"/>
+    <p:sldId xmlns:r="http://schemas.openxmlformats.org/officeDocument/2006/relationships" id="256" r:id="R071aa9813b4b4b31"/>
+    <p:sldId xmlns:r="http://schemas.openxmlformats.org/officeDocument/2006/relationships" id="257" r:id="R9e3b7c803930429b"/>
+    <p:sldId xmlns:r="http://schemas.openxmlformats.org/officeDocument/2006/relationships" id="258" r:id="R0e85141eda3b4ad1"/>
+    <p:sldId xmlns:r="http://schemas.openxmlformats.org/officeDocument/2006/relationships" id="259" r:id="R6ed19f9d9c5242e9"/>
+    <p:sldId xmlns:r="http://schemas.openxmlformats.org/officeDocument/2006/relationships" id="260" r:id="R2ade433dfa8c4ffa"/>
+    <p:sldId xmlns:r="http://schemas.openxmlformats.org/officeDocument/2006/relationships" id="261" r:id="Rd937389090654348"/>
+    <p:sldId xmlns:r="http://schemas.openxmlformats.org/officeDocument/2006/relationships" id="262" r:id="Rbf5174700954410a"/>
+    <p:sldId xmlns:r="http://schemas.openxmlformats.org/officeDocument/2006/relationships" id="263" r:id="Rf8bb5d70a61e4a73"/>
   </p:sldIdLst>
   <p:sldSz cx="12192000" cy="6858000"/>
   <p:notesSz cx="6858000" cy="9144000"/>
@@ -529,17 +529,17 @@
           </a:p>
           <a:p xmlns:a="http://schemas.openxmlformats.org/drawingml/2006/main">
             <a:r>
-              <a:t>- https://pubmed.ncbi.nlm.nih.gov/?term=%28%28%22laboratory+automation%22+OR+%22workflow+software%22+OR+%22AI%22%29+AND+%28%22LC-MS%22+OR+chromatography+OR+%22mass+spectrometry%22%29%29+AND+%28%222025%2F08%2F20%22%5BDate+-+Publication%5D+%3A+%222026%2F08%2F20%22%5BDate+-+Publication%5D%29</a:t>
-            </a:r>
-          </a:p>
-          <a:p xmlns:a="http://schemas.openxmlformats.org/drawingml/2006/main">
-            <a:r>
-              <a:t>- https://pubmed.ncbi.nlm.nih.gov/?term=%28%28PFAS+OR+%22per-+and+polyfluoroalkyl%22%29+AND+%28%22LC-MS%22+OR+%22LC-MS%2FMS%22+OR+chromatography%29%29+AND+%28%222025%2F08%2F20%22%5BDate+-+Publication%5D+%3A+%222026%2F08%2F20%22%5BDate+-+Publication%5D%29</a:t>
-            </a:r>
-          </a:p>
-          <a:p xmlns:a="http://schemas.openxmlformats.org/drawingml/2006/main">
-            <a:r>
-              <a:t>- https://pubmed.ncbi.nlm.nih.gov/?term=%28%28oligonucleotide+OR+%22nucleic+acid%22+OR+siRNA%29+AND+%28%22LC-MS%22+OR+chromatography+OR+%22mass+spectrometry%22%29%29+AND+%28%222025%2F08%2F20%22%5BDate+-+Publication%5D+%3A+%222026%2F08%2F20%22%5BDate+-+Publication%5D%29</a:t>
+              <a:t>- https://pubmed.ncbi.nlm.nih.gov/?term=%28%28%22laboratory+automation%22+OR+%22workflow+software%22+OR+%22AI%22%29+AND+%28%22LC-MS%22+OR+chromatography+OR+%22mass+spectrometry%22%29%29+AND+%28%222025%2F09%2F08%22%5BDate+-+Publication%5D+%3A+%222026%2F09%2F08%22%5BDate+-+Publication%5D%29</a:t>
+            </a:r>
+          </a:p>
+          <a:p xmlns:a="http://schemas.openxmlformats.org/drawingml/2006/main">
+            <a:r>
+              <a:t>- https://pubmed.ncbi.nlm.nih.gov/?term=%28%28PFAS+OR+%22per-+and+polyfluoroalkyl%22%29+AND+%28%22LC-MS%22+OR+%22LC-MS%2FMS%22+OR+chromatography%29%29+AND+%28%222025%2F09%2F08%22%5BDate+-+Publication%5D+%3A+%222026%2F09%2F08%22%5BDate+-+Publication%5D%29</a:t>
+            </a:r>
+          </a:p>
+          <a:p xmlns:a="http://schemas.openxmlformats.org/drawingml/2006/main">
+            <a:r>
+              <a:t>- https://pubmed.ncbi.nlm.nih.gov/?term=%28%28oligonucleotide+OR+%22nucleic+acid%22+OR+siRNA%29+AND+%28%22LC-MS%22+OR+chromatography+OR+%22mass+spectrometry%22%29%29+AND+%28%222025%2F09%2F08%22%5BDate+-+Publication%5D+%3A+%222026%2F09%2F08%22%5BDate+-+Publication%5D%29</a:t>
             </a:r>
           </a:p>
           <a:p xmlns:a="http://schemas.openxmlformats.org/drawingml/2006/main">
@@ -619,7 +619,7 @@
           </a:p>
           <a:p xmlns:a="http://schemas.openxmlformats.org/drawingml/2006/main">
             <a:r>
-              <a:t>- https://pubmed.ncbi.nlm.nih.gov/?term=%28%28PFAS+OR+%22per-+and+polyfluoroalkyl%22%29+AND+%28%22LC-MS%22+OR+%22LC-MS%2FMS%22+OR+chromatography%29%29+AND+%28%222025%2F08%2F20%22%5BDate+-+Publication%5D+%3A+%222026%2F08%2F20%22%5BDate+-+Publication%5D%29</a:t>
+              <a:t>- https://pubmed.ncbi.nlm.nih.gov/?term=%28%28PFAS+OR+%22per-+and+polyfluoroalkyl%22%29+AND+%28%22LC-MS%22+OR+%22LC-MS%2FMS%22+OR+chromatography%29%29+AND+%28%222025%2F09%2F08%22%5BDate+-+Publication%5D+%3A+%222026%2F09%2F08%22%5BDate+-+Publication%5D%29</a:t>
             </a:r>
           </a:p>
           <a:p xmlns:a="http://schemas.openxmlformats.org/drawingml/2006/main">
@@ -644,12 +644,12 @@
           </a:p>
           <a:p xmlns:a="http://schemas.openxmlformats.org/drawingml/2006/main">
             <a:r>
-              <a:t>- https://www.reddit.com/r/CHROMATOGRAPHY/comments/xlr4pf/best_uhplc_on_the_market/</a:t>
-            </a:r>
-          </a:p>
-          <a:p xmlns:a="http://schemas.openxmlformats.org/drawingml/2006/main">
-            <a:r>
-              <a:t>- https://www.reddit.com/r/massspectrometry/comments/1uxyipd/efficient_quant_workflow_for_targetlynx/</a:t>
+              <a:t>- https://www.selectscience.net/product/acquity-uplc-r-beh-c18-and-c8-columns</a:t>
+            </a:r>
+          </a:p>
+          <a:p xmlns:a="http://schemas.openxmlformats.org/drawingml/2006/main">
+            <a:r>
+              <a:t>- https://www.fda.gov/inspections-compliance-enforcement-and-criminal-investigations/compliance-actions-and-activities/warning-letters/datatables-data?_format=xlsx&amp;page=0</a:t>
             </a:r>
           </a:p>
           <a:p xmlns:a="http://schemas.openxmlformats.org/drawingml/2006/main">
@@ -829,37 +829,37 @@
           </a:p>
           <a:p xmlns:a="http://schemas.openxmlformats.org/drawingml/2006/main">
             <a:r>
-              <a:t>- https://www.reddit.com/r/CHROMATOGRAPHY/comments/xlr4pf/best_uhplc_on_the_market/</a:t>
-            </a:r>
-          </a:p>
-          <a:p xmlns:a="http://schemas.openxmlformats.org/drawingml/2006/main">
-            <a:r>
-              <a:t>- https://www.reddit.com/r/massspectrometry/comments/1uxyipd/efficient_quant_workflow_for_targetlynx/</a:t>
-            </a:r>
-          </a:p>
-          <a:p xmlns:a="http://schemas.openxmlformats.org/drawingml/2006/main">
-            <a:r>
-              <a:t>- https://www.reddit.com/r/massspectrometry/comments/1ux1imr/most_frustrating_thing_about_mass_spectrometry/</a:t>
-            </a:r>
-          </a:p>
-          <a:p xmlns:a="http://schemas.openxmlformats.org/drawingml/2006/main">
-            <a:r>
-              <a:t>- https://www.reddit.com/r/massspectrometry/comments/1u1dpq6/synapt_nonresponsive_fluidics_purge_issue/</a:t>
-            </a:r>
-          </a:p>
-          <a:p xmlns:a="http://schemas.openxmlformats.org/drawingml/2006/main">
-            <a:r>
-              <a:t>- https://www.reddit.com/r/massspectrometry/comments/1up1dlw/best_software_to_use_agilent_g3540a_gc_with/</a:t>
-            </a:r>
-          </a:p>
-          <a:p xmlns:a="http://schemas.openxmlformats.org/drawingml/2006/main">
-            <a:r>
-              <a:t>- https://www.reddit.com/r/CHROMATOGRAPHY/comments/1sbtsdx/comparing_vendors_and_systems_thoughts/</a:t>
-            </a:r>
-          </a:p>
-          <a:p xmlns:a="http://schemas.openxmlformats.org/drawingml/2006/main">
-            <a:r>
-              <a:t>- https://www.reddit.com/r/massspectrometry/comments/1sognqt/what_is_the_fastest_way_to_convert_raw_files_to/</a:t>
+              <a:t>- https://www.selectscience.net/product/acquity-uplc-r-beh-c18-and-c8-columns</a:t>
+            </a:r>
+          </a:p>
+          <a:p xmlns:a="http://schemas.openxmlformats.org/drawingml/2006/main">
+            <a:r>
+              <a:t>- https://www.fda.gov/inspections-compliance-enforcement-and-criminal-investigations/compliance-actions-and-activities/warning-letters/datatables-data?_format=xlsx&amp;page=0</a:t>
+            </a:r>
+          </a:p>
+          <a:p xmlns:a="http://schemas.openxmlformats.org/drawingml/2006/main">
+            <a:r>
+              <a:t>- https://www.fda.gov/media/190190/download?attachment=</a:t>
+            </a:r>
+          </a:p>
+          <a:p xmlns:a="http://schemas.openxmlformats.org/drawingml/2006/main">
+            <a:r>
+              <a:t>- https://www.selectscience.net/product/arc-hplc-system?reviewItem=c6866ce0f446fc50</a:t>
+            </a:r>
+          </a:p>
+          <a:p xmlns:a="http://schemas.openxmlformats.org/drawingml/2006/main">
+            <a:r>
+              <a:t>- https://www.selectscience.net/product/arc-hplc-system?reviewItem=0e5b2545d7d11f15</a:t>
+            </a:r>
+          </a:p>
+          <a:p xmlns:a="http://schemas.openxmlformats.org/drawingml/2006/main">
+            <a:r>
+              <a:t>- https://www.selectscience.net/product/arc-hplc-system?reviewItem=0568db63471e745f</a:t>
+            </a:r>
+          </a:p>
+          <a:p xmlns:a="http://schemas.openxmlformats.org/drawingml/2006/main">
+            <a:r>
+              <a:t>- https://www.selectscience.net/product/arc-hplc-system?reviewItem=dd59084477b562c5</a:t>
             </a:r>
           </a:p>
           <a:p xmlns:a="http://schemas.openxmlformats.org/drawingml/2006/main">
@@ -949,7 +949,7 @@
           </a:p>
           <a:p xmlns:a="http://schemas.openxmlformats.org/drawingml/2006/main">
             <a:r>
-              <a:t>- https://pubmed.ncbi.nlm.nih.gov/?term=%28%28PFAS+OR+%22per-+and+polyfluoroalkyl%22%29+AND+%28%22LC-MS%22+OR+%22LC-MS%2FMS%22+OR+chromatography%29%29+AND+%28%222025%2F08%2F20%22%5BDate+-+Publication%5D+%3A+%222026%2F08%2F20%22%5BDate+-+Publication%5D%29</a:t>
+              <a:t>- https://pubmed.ncbi.nlm.nih.gov/?term=%28%28PFAS+OR+%22per-+and+polyfluoroalkyl%22%29+AND+%28%22LC-MS%22+OR+%22LC-MS%2FMS%22+OR+chromatography%29%29+AND+%28%222025%2F09%2F08%22%5BDate+-+Publication%5D+%3A+%222026%2F09%2F08%22%5BDate+-+Publication%5D%29</a:t>
             </a:r>
           </a:p>
           <a:p xmlns:a="http://schemas.openxmlformats.org/drawingml/2006/main">
@@ -964,12 +964,12 @@
           </a:p>
           <a:p xmlns:a="http://schemas.openxmlformats.org/drawingml/2006/main">
             <a:r>
-              <a:t>- https://www.thermofisher.com/us/en/home/industrial/chromatography/liquid-chromatography-lc/hplc-uhplc-systems/vanquish-amplify-uhplc-system.html</a:t>
-            </a:r>
-          </a:p>
-          <a:p xmlns:a="http://schemas.openxmlformats.org/drawingml/2006/main">
-            <a:r>
-              <a:t>- https://pubmed.ncbi.nlm.nih.gov/?term=%28%28%22laboratory+automation%22+OR+%22workflow+software%22+OR+%22AI%22%29+AND+%28%22LC-MS%22+OR+chromatography+OR+%22mass+spectrometry%22%29%29+AND+%28%222025%2F08%2F20%22%5BDate+-+Publication%5D+%3A+%222026%2F08%2F20%22%5BDate+-+Publication%5D%29</a:t>
+              <a:t>- https://www.thermofisher.com/order/catalog/product/VQ-AMPLIFY</a:t>
+            </a:r>
+          </a:p>
+          <a:p xmlns:a="http://schemas.openxmlformats.org/drawingml/2006/main">
+            <a:r>
+              <a:t>- https://pubmed.ncbi.nlm.nih.gov/?term=%28%28%22laboratory+automation%22+OR+%22workflow+software%22+OR+%22AI%22%29+AND+%28%22LC-MS%22+OR+chromatography+OR+%22mass+spectrometry%22%29%29+AND+%28%222025%2F09%2F08%22%5BDate+-+Publication%5D+%3A+%222026%2F09%2F08%22%5BDate+-+Publication%5D%29</a:t>
             </a:r>
           </a:p>
           <a:p xmlns:a="http://schemas.openxmlformats.org/drawingml/2006/main">
@@ -979,12 +979,7 @@
           </a:p>
           <a:p xmlns:a="http://schemas.openxmlformats.org/drawingml/2006/main">
             <a:r>
-              <a:t>- https://www.thermofisher.com/order/catalog/product/VQ-AMPLIFY</a:t>
-            </a:r>
-          </a:p>
-          <a:p xmlns:a="http://schemas.openxmlformats.org/drawingml/2006/main">
-            <a:r>
-              <a:t>- https://pubmed.ncbi.nlm.nih.gov/?term=%28%28oligonucleotide+OR+%22nucleic+acid%22+OR+siRNA%29+AND+%28%22LC-MS%22+OR+chromatography+OR+%22mass+spectrometry%22%29%29+AND+%28%222025%2F08%2F20%22%5BDate+-+Publication%5D+%3A+%222026%2F08%2F20%22%5BDate+-+Publication%5D%29</a:t>
+              <a:t>- https://pubmed.ncbi.nlm.nih.gov/?term=%28%28oligonucleotide+OR+%22nucleic+acid%22+OR+siRNA%29+AND+%28%22LC-MS%22+OR+chromatography+OR+%22mass+spectrometry%22%29%29+AND+%28%222025%2F09%2F08%22%5BDate+-+Publication%5D+%3A+%222026%2F09%2F08%22%5BDate+-+Publication%5D%29</a:t>
             </a:r>
           </a:p>
           <a:p xmlns:a="http://schemas.openxmlformats.org/drawingml/2006/main">
@@ -1079,7 +1074,7 @@
           </a:p>
           <a:p xmlns:a="http://schemas.openxmlformats.org/drawingml/2006/main">
             <a:r>
-              <a:t>- https://pubmed.ncbi.nlm.nih.gov/?term=%28%28PFAS+OR+%22per-+and+polyfluoroalkyl%22%29+AND+%28%22LC-MS%22+OR+%22LC-MS%2FMS%22+OR+chromatography%29%29+AND+%28%222025%2F08%2F20%22%5BDate+-+Publication%5D+%3A+%222026%2F08%2F20%22%5BDate+-+Publication%5D%29</a:t>
+              <a:t>- https://pubmed.ncbi.nlm.nih.gov/?term=%28%28PFAS+OR+%22per-+and+polyfluoroalkyl%22%29+AND+%28%22LC-MS%22+OR+%22LC-MS%2FMS%22+OR+chromatography%29%29+AND+%28%222025%2F09%2F08%22%5BDate+-+Publication%5D+%3A+%222026%2F09%2F08%22%5BDate+-+Publication%5D%29</a:t>
             </a:r>
           </a:p>
           <a:p xmlns:a="http://schemas.openxmlformats.org/drawingml/2006/main">
@@ -1094,12 +1089,12 @@
           </a:p>
           <a:p xmlns:a="http://schemas.openxmlformats.org/drawingml/2006/main">
             <a:r>
-              <a:t>- https://www.thermofisher.com/us/en/home/industrial/chromatography/liquid-chromatography-lc/hplc-uhplc-systems/vanquish-amplify-uhplc-system.html</a:t>
-            </a:r>
-          </a:p>
-          <a:p xmlns:a="http://schemas.openxmlformats.org/drawingml/2006/main">
-            <a:r>
-              <a:t>- https://pubmed.ncbi.nlm.nih.gov/?term=%28%28%22laboratory+automation%22+OR+%22workflow+software%22+OR+%22AI%22%29+AND+%28%22LC-MS%22+OR+chromatography+OR+%22mass+spectrometry%22%29%29+AND+%28%222025%2F08%2F20%22%5BDate+-+Publication%5D+%3A+%222026%2F08%2F20%22%5BDate+-+Publication%5D%29</a:t>
+              <a:t>- https://www.thermofisher.com/order/catalog/product/VQ-AMPLIFY</a:t>
+            </a:r>
+          </a:p>
+          <a:p xmlns:a="http://schemas.openxmlformats.org/drawingml/2006/main">
+            <a:r>
+              <a:t>- https://pubmed.ncbi.nlm.nih.gov/?term=%28%28%22laboratory+automation%22+OR+%22workflow+software%22+OR+%22AI%22%29+AND+%28%22LC-MS%22+OR+chromatography+OR+%22mass+spectrometry%22%29%29+AND+%28%222025%2F09%2F08%22%5BDate+-+Publication%5D+%3A+%222026%2F09%2F08%22%5BDate+-+Publication%5D%29</a:t>
             </a:r>
           </a:p>
           <a:p xmlns:a="http://schemas.openxmlformats.org/drawingml/2006/main">
@@ -1109,12 +1104,7 @@
           </a:p>
           <a:p xmlns:a="http://schemas.openxmlformats.org/drawingml/2006/main">
             <a:r>
-              <a:t>- https://www.thermofisher.com/order/catalog/product/VQ-AMPLIFY</a:t>
-            </a:r>
-          </a:p>
-          <a:p xmlns:a="http://schemas.openxmlformats.org/drawingml/2006/main">
-            <a:r>
-              <a:t>- https://pubmed.ncbi.nlm.nih.gov/?term=%28%28oligonucleotide+OR+%22nucleic+acid%22+OR+siRNA%29+AND+%28%22LC-MS%22+OR+chromatography+OR+%22mass+spectrometry%22%29%29+AND+%28%222025%2F08%2F20%22%5BDate+-+Publication%5D+%3A+%222026%2F08%2F20%22%5BDate+-+Publication%5D%29</a:t>
+              <a:t>- https://pubmed.ncbi.nlm.nih.gov/?term=%28%28oligonucleotide+OR+%22nucleic+acid%22+OR+siRNA%29+AND+%28%22LC-MS%22+OR+chromatography+OR+%22mass+spectrometry%22%29%29+AND+%28%222025%2F09%2F08%22%5BDate+-+Publication%5D+%3A+%222026%2F09%2F08%22%5BDate+-+Publication%5D%29</a:t>
             </a:r>
           </a:p>
           <a:p xmlns:a="http://schemas.openxmlformats.org/drawingml/2006/main">
@@ -1194,7 +1184,7 @@
           </a:p>
           <a:p xmlns:a="http://schemas.openxmlformats.org/drawingml/2006/main">
             <a:r>
-              <a:t>- https://pubmed.ncbi.nlm.nih.gov/?term=%28%28PFAS+OR+%22per-+and+polyfluoroalkyl%22%29+AND+%28%22LC-MS%22+OR+%22LC-MS%2FMS%22+OR+chromatography%29%29+AND+%28%222025%2F08%2F20%22%5BDate+-+Publication%5D+%3A+%222026%2F08%2F20%22%5BDate+-+Publication%5D%29</a:t>
+              <a:t>- https://pubmed.ncbi.nlm.nih.gov/?term=%28%28PFAS+OR+%22per-+and+polyfluoroalkyl%22%29+AND+%28%22LC-MS%22+OR+%22LC-MS%2FMS%22+OR+chromatography%29%29+AND+%28%222025%2F09%2F08%22%5BDate+-+Publication%5D+%3A+%222026%2F09%2F08%22%5BDate+-+Publication%5D%29</a:t>
             </a:r>
           </a:p>
           <a:p xmlns:a="http://schemas.openxmlformats.org/drawingml/2006/main">
@@ -1292,7 +1282,7 @@
   </p:cSld>
   <p:clrMap bg1="lt1" tx1="dk1" bg2="lt2" tx2="dk2" accent1="accent1" accent2="accent2" accent3="accent3" accent4="accent4" accent5="accent5" accent6="accent6" hlink="hlink" folHlink="folHlink"/>
   <p:sldLayoutIdLst>
-    <p:sldLayoutId xmlns:r="http://schemas.openxmlformats.org/officeDocument/2006/relationships" id="2147483649" r:id="R470b4c11bcea4911"/>
+    <p:sldLayoutId xmlns:r="http://schemas.openxmlformats.org/officeDocument/2006/relationships" id="2147483649" r:id="Re62b86348e90434d"/>
   </p:sldLayoutIdLst>
   <p:txStyles>
     <p:titleStyle>
@@ -1843,7 +1833,7 @@
           <p:cNvPr id="14" name="">
             <a:extLst xmlns:a="http://schemas.openxmlformats.org/drawingml/2006/main">
               <a:ext uri="{FF2B5EF4-FFF2-40B4-BE49-F238E27FC236}">
-                <a16:creationId xmlns:a16="http://schemas.microsoft.com/office/drawing/2014/main" id="{446D0D9F-2982-47F8-BF9D-8FCBD8EB5E5B}"/>
+                <a16:creationId xmlns:a16="http://schemas.microsoft.com/office/drawing/2014/main" id="{816D2D08-6F2D-4889-AAA8-65A1395F956B}"/>
               </a:ext>
             </a:extLst>
           </p:cNvPr>
@@ -1876,7 +1866,7 @@
           <p:cNvPr id="2" name="">
             <a:extLst xmlns:a="http://schemas.openxmlformats.org/drawingml/2006/main">
               <a:ext uri="{FF2B5EF4-FFF2-40B4-BE49-F238E27FC236}">
-                <a16:creationId xmlns:a16="http://schemas.microsoft.com/office/drawing/2014/main" id="{0CDC7B97-CEA7-4F0A-B453-BDB68C9C8C0A}"/>
+                <a16:creationId xmlns:a16="http://schemas.microsoft.com/office/drawing/2014/main" id="{42FA9606-F7D9-4D7F-9A59-211D867BD9D5}"/>
               </a:ext>
             </a:extLst>
           </p:cNvPr>
@@ -1934,7 +1924,7 @@
           <p:cNvPr id="3" name="">
             <a:extLst xmlns:a="http://schemas.openxmlformats.org/drawingml/2006/main">
               <a:ext uri="{FF2B5EF4-FFF2-40B4-BE49-F238E27FC236}">
-                <a16:creationId xmlns:a16="http://schemas.microsoft.com/office/drawing/2014/main" id="{9472343C-A13D-42FD-8710-D3570575E07F}"/>
+                <a16:creationId xmlns:a16="http://schemas.microsoft.com/office/drawing/2014/main" id="{7FF306E3-6204-48E7-A41B-42A387AF0314}"/>
               </a:ext>
             </a:extLst>
           </p:cNvPr>
@@ -1992,7 +1982,7 @@
           <p:cNvPr id="4" name="">
             <a:extLst xmlns:a="http://schemas.openxmlformats.org/drawingml/2006/main">
               <a:ext uri="{FF2B5EF4-FFF2-40B4-BE49-F238E27FC236}">
-                <a16:creationId xmlns:a16="http://schemas.microsoft.com/office/drawing/2014/main" id="{46DB0F60-F44E-4154-95AE-85EB21B5AE59}"/>
+                <a16:creationId xmlns:a16="http://schemas.microsoft.com/office/drawing/2014/main" id="{CE7AF293-9AA1-4087-8250-F17C490C6EFB}"/>
               </a:ext>
             </a:extLst>
           </p:cNvPr>
@@ -2050,7 +2040,7 @@
           <p:cNvPr id="5" name="">
             <a:extLst xmlns:a="http://schemas.openxmlformats.org/drawingml/2006/main">
               <a:ext uri="{FF2B5EF4-FFF2-40B4-BE49-F238E27FC236}">
-                <a16:creationId xmlns:a16="http://schemas.microsoft.com/office/drawing/2014/main" id="{F60B3F64-161E-4F1F-884D-5217A1B5D030}"/>
+                <a16:creationId xmlns:a16="http://schemas.microsoft.com/office/drawing/2014/main" id="{CD67FCB9-CB51-4008-814B-EFF8563052B2}"/>
               </a:ext>
             </a:extLst>
           </p:cNvPr>
@@ -2108,7 +2098,7 @@
           <p:cNvPr id="6" name="">
             <a:extLst xmlns:a="http://schemas.openxmlformats.org/drawingml/2006/main">
               <a:ext uri="{FF2B5EF4-FFF2-40B4-BE49-F238E27FC236}">
-                <a16:creationId xmlns:a16="http://schemas.microsoft.com/office/drawing/2014/main" id="{59CE457D-E199-48CA-AFD9-EAA9272E3C3E}"/>
+                <a16:creationId xmlns:a16="http://schemas.microsoft.com/office/drawing/2014/main" id="{960AE30F-AC74-4350-9CD4-DA5C1A7E017D}"/>
               </a:ext>
             </a:extLst>
           </p:cNvPr>
@@ -2143,7 +2133,7 @@
           <p:cNvPr id="7" name="">
             <a:extLst xmlns:a="http://schemas.openxmlformats.org/drawingml/2006/main">
               <a:ext uri="{FF2B5EF4-FFF2-40B4-BE49-F238E27FC236}">
-                <a16:creationId xmlns:a16="http://schemas.microsoft.com/office/drawing/2014/main" id="{5FA23563-9A35-4EC2-85A6-B9131B3936FF}"/>
+                <a16:creationId xmlns:a16="http://schemas.microsoft.com/office/drawing/2014/main" id="{05A125CC-F6EF-4407-A457-DB7A7BE70548}"/>
               </a:ext>
             </a:extLst>
           </p:cNvPr>
@@ -2201,7 +2191,7 @@
           <p:cNvPr id="8" name="">
             <a:extLst xmlns:a="http://schemas.openxmlformats.org/drawingml/2006/main">
               <a:ext uri="{FF2B5EF4-FFF2-40B4-BE49-F238E27FC236}">
-                <a16:creationId xmlns:a16="http://schemas.microsoft.com/office/drawing/2014/main" id="{65EDC6AD-BFFF-4681-8B38-9EE827B6945E}"/>
+                <a16:creationId xmlns:a16="http://schemas.microsoft.com/office/drawing/2014/main" id="{078FF3E4-DC10-4EC6-AE4B-BB933704C6D0}"/>
               </a:ext>
             </a:extLst>
           </p:cNvPr>
@@ -2249,7 +2239,7 @@
                 <a:ea typeface="Aptos"/>
                 <a:cs typeface="Aptos"/>
               </a:rPr>
-              <a:t>23</a:t>
+              <a:t>08</a:t>
             </a:r>
           </a:p>
         </p:txBody>
@@ -2259,7 +2249,7 @@
           <p:cNvPr id="9" name="">
             <a:extLst xmlns:a="http://schemas.openxmlformats.org/drawingml/2006/main">
               <a:ext uri="{FF2B5EF4-FFF2-40B4-BE49-F238E27FC236}">
-                <a16:creationId xmlns:a16="http://schemas.microsoft.com/office/drawing/2014/main" id="{63327954-BAE3-4591-9DA1-5D515ADEE2AB}"/>
+                <a16:creationId xmlns:a16="http://schemas.microsoft.com/office/drawing/2014/main" id="{18F4EBAD-50BD-4D92-9D2D-3FE7340F18CB}"/>
               </a:ext>
             </a:extLst>
           </p:cNvPr>
@@ -2307,7 +2297,7 @@
                 <a:ea typeface="Aptos"/>
                 <a:cs typeface="Aptos"/>
               </a:rPr>
-              <a:t>AUG 2026</a:t>
+              <a:t>SEP 2026</a:t>
             </a:r>
           </a:p>
         </p:txBody>
@@ -2317,7 +2307,7 @@
           <p:cNvPr id="10" name="">
             <a:extLst xmlns:a="http://schemas.openxmlformats.org/drawingml/2006/main">
               <a:ext uri="{FF2B5EF4-FFF2-40B4-BE49-F238E27FC236}">
-                <a16:creationId xmlns:a16="http://schemas.microsoft.com/office/drawing/2014/main" id="{CD8FABA7-3752-4E3B-89E9-9FDCFE91DC4F}"/>
+                <a16:creationId xmlns:a16="http://schemas.microsoft.com/office/drawing/2014/main" id="{19D4478D-71F0-44F6-9CE1-4D1E519A15F1}"/>
               </a:ext>
             </a:extLst>
           </p:cNvPr>
@@ -2350,7 +2340,7 @@
           <p:cNvPr id="11" name="">
             <a:extLst xmlns:a="http://schemas.openxmlformats.org/drawingml/2006/main">
               <a:ext uri="{FF2B5EF4-FFF2-40B4-BE49-F238E27FC236}">
-                <a16:creationId xmlns:a16="http://schemas.microsoft.com/office/drawing/2014/main" id="{B080C26D-01D2-4842-B663-81AC30CCDFD0}"/>
+                <a16:creationId xmlns:a16="http://schemas.microsoft.com/office/drawing/2014/main" id="{5E3536DE-33C2-4D43-9256-AE8DD3032AB9}"/>
               </a:ext>
             </a:extLst>
           </p:cNvPr>
@@ -2408,7 +2398,7 @@
           <p:cNvPr id="12" name="">
             <a:extLst xmlns:a="http://schemas.openxmlformats.org/drawingml/2006/main">
               <a:ext uri="{FF2B5EF4-FFF2-40B4-BE49-F238E27FC236}">
-                <a16:creationId xmlns:a16="http://schemas.microsoft.com/office/drawing/2014/main" id="{47B2A43E-994A-4B51-BCA2-105331B3A3E5}"/>
+                <a16:creationId xmlns:a16="http://schemas.microsoft.com/office/drawing/2014/main" id="{2E5C39BE-3E6D-48DD-880E-2988F6892C4B}"/>
               </a:ext>
             </a:extLst>
           </p:cNvPr>
@@ -2456,7 +2446,7 @@
                 <a:ea typeface="Aptos"/>
                 <a:cs typeface="Aptos"/>
               </a:rPr>
-              <a:t>Prepared for roadmap review · waters-ci-20260820104036</a:t>
+              <a:t>Prepared for roadmap review · waters-ci-20260909030324</a:t>
             </a:r>
           </a:p>
         </p:txBody>
@@ -2466,7 +2456,7 @@
           <p:cNvPr id="13" name="">
             <a:extLst xmlns:a="http://schemas.openxmlformats.org/drawingml/2006/main">
               <a:ext uri="{FF2B5EF4-FFF2-40B4-BE49-F238E27FC236}">
-                <a16:creationId xmlns:a16="http://schemas.microsoft.com/office/drawing/2014/main" id="{0EA2BD30-D561-4F23-948F-E363AAA75566}"/>
+                <a16:creationId xmlns:a16="http://schemas.microsoft.com/office/drawing/2014/main" id="{3912F3CA-BF8D-4DC8-A2C3-2C0D15883682}"/>
               </a:ext>
             </a:extLst>
           </p:cNvPr>
@@ -2522,7 +2512,7 @@
     </p:spTree>
     <p:extLst>
       <p:ext uri="{BB962C8B-B14F-4D97-AF65-F5344CB8AC3E}">
-        <p14:creationId xmlns:p14="http://schemas.microsoft.com/office/powerpoint/2010/main" val="1784191674"/>
+        <p14:creationId xmlns:p14="http://schemas.microsoft.com/office/powerpoint/2010/main" val="1230188574"/>
       </p:ext>
     </p:extLst>
   </p:cSld>
@@ -2553,7 +2543,7 @@
           <p:cNvPr id="25" name="">
             <a:extLst xmlns:a="http://schemas.openxmlformats.org/drawingml/2006/main">
               <a:ext uri="{FF2B5EF4-FFF2-40B4-BE49-F238E27FC236}">
-                <a16:creationId xmlns:a16="http://schemas.microsoft.com/office/drawing/2014/main" id="{07765648-078A-436B-807F-8A75E2764254}"/>
+                <a16:creationId xmlns:a16="http://schemas.microsoft.com/office/drawing/2014/main" id="{16E3C63B-074B-4A6C-9474-3614B144AD78}"/>
               </a:ext>
             </a:extLst>
           </p:cNvPr>
@@ -2611,7 +2601,7 @@
           <p:cNvPr id="2" name="">
             <a:extLst xmlns:a="http://schemas.openxmlformats.org/drawingml/2006/main">
               <a:ext uri="{FF2B5EF4-FFF2-40B4-BE49-F238E27FC236}">
-                <a16:creationId xmlns:a16="http://schemas.microsoft.com/office/drawing/2014/main" id="{A4E45576-440A-4C72-84BF-283607CBD931}"/>
+                <a16:creationId xmlns:a16="http://schemas.microsoft.com/office/drawing/2014/main" id="{573A4362-C2EA-47AB-B259-49BCE6BD3295}"/>
               </a:ext>
             </a:extLst>
           </p:cNvPr>
@@ -2669,7 +2659,7 @@
           <p:cNvPr id="3" name="">
             <a:extLst xmlns:a="http://schemas.openxmlformats.org/drawingml/2006/main">
               <a:ext uri="{FF2B5EF4-FFF2-40B4-BE49-F238E27FC236}">
-                <a16:creationId xmlns:a16="http://schemas.microsoft.com/office/drawing/2014/main" id="{266241CD-1DFC-4DA0-852B-D83F4DA3C3C8}"/>
+                <a16:creationId xmlns:a16="http://schemas.microsoft.com/office/drawing/2014/main" id="{B33A178A-A323-4921-A7D5-2B8B1C4C13BB}"/>
               </a:ext>
             </a:extLst>
           </p:cNvPr>
@@ -2727,7 +2717,7 @@
           <p:cNvPr id="4" name="">
             <a:extLst xmlns:a="http://schemas.openxmlformats.org/drawingml/2006/main">
               <a:ext uri="{FF2B5EF4-FFF2-40B4-BE49-F238E27FC236}">
-                <a16:creationId xmlns:a16="http://schemas.microsoft.com/office/drawing/2014/main" id="{448C179F-80C2-4070-96DE-D9D4C0042071}"/>
+                <a16:creationId xmlns:a16="http://schemas.microsoft.com/office/drawing/2014/main" id="{83CC72B2-E6DB-4E94-837B-FE918204D40A}"/>
               </a:ext>
             </a:extLst>
           </p:cNvPr>
@@ -2760,7 +2750,7 @@
           <p:cNvPr id="5" name="">
             <a:extLst xmlns:a="http://schemas.openxmlformats.org/drawingml/2006/main">
               <a:ext uri="{FF2B5EF4-FFF2-40B4-BE49-F238E27FC236}">
-                <a16:creationId xmlns:a16="http://schemas.microsoft.com/office/drawing/2014/main" id="{1D700C2A-75EF-4BB3-A50B-6FD24774261C}"/>
+                <a16:creationId xmlns:a16="http://schemas.microsoft.com/office/drawing/2014/main" id="{ABFCCA17-7506-41FF-854B-A24E60B435F2}"/>
               </a:ext>
             </a:extLst>
           </p:cNvPr>
@@ -2795,7 +2785,7 @@
           <p:cNvPr id="6" name="">
             <a:extLst xmlns:a="http://schemas.openxmlformats.org/drawingml/2006/main">
               <a:ext uri="{FF2B5EF4-FFF2-40B4-BE49-F238E27FC236}">
-                <a16:creationId xmlns:a16="http://schemas.microsoft.com/office/drawing/2014/main" id="{19FB8E75-8814-446E-A9B9-5BAFC6716254}"/>
+                <a16:creationId xmlns:a16="http://schemas.microsoft.com/office/drawing/2014/main" id="{BDE935D3-A634-4F3A-AA56-96E008EEDAA1}"/>
               </a:ext>
             </a:extLst>
           </p:cNvPr>
@@ -2853,7 +2843,7 @@
           <p:cNvPr id="7" name="">
             <a:extLst xmlns:a="http://schemas.openxmlformats.org/drawingml/2006/main">
               <a:ext uri="{FF2B5EF4-FFF2-40B4-BE49-F238E27FC236}">
-                <a16:creationId xmlns:a16="http://schemas.microsoft.com/office/drawing/2014/main" id="{F46ABA17-EEC4-445E-BED3-01E63980CAE3}"/>
+                <a16:creationId xmlns:a16="http://schemas.microsoft.com/office/drawing/2014/main" id="{AA523CBE-C2C9-421F-B0A4-A1E464172DAD}"/>
               </a:ext>
             </a:extLst>
           </p:cNvPr>
@@ -2911,7 +2901,7 @@
           <p:cNvPr id="8" name="">
             <a:extLst xmlns:a="http://schemas.openxmlformats.org/drawingml/2006/main">
               <a:ext uri="{FF2B5EF4-FFF2-40B4-BE49-F238E27FC236}">
-                <a16:creationId xmlns:a16="http://schemas.microsoft.com/office/drawing/2014/main" id="{45B16D81-AEE3-4300-A69A-68F3874A2870}"/>
+                <a16:creationId xmlns:a16="http://schemas.microsoft.com/office/drawing/2014/main" id="{8A2B7C99-EC7F-400C-B0B0-33067C876E8E}"/>
               </a:ext>
             </a:extLst>
           </p:cNvPr>
@@ -2946,7 +2936,7 @@
           <p:cNvPr id="9" name="">
             <a:extLst xmlns:a="http://schemas.openxmlformats.org/drawingml/2006/main">
               <a:ext uri="{FF2B5EF4-FFF2-40B4-BE49-F238E27FC236}">
-                <a16:creationId xmlns:a16="http://schemas.microsoft.com/office/drawing/2014/main" id="{0C722A6D-112E-40DF-AFBC-F1CE6A25F856}"/>
+                <a16:creationId xmlns:a16="http://schemas.microsoft.com/office/drawing/2014/main" id="{70AFA9D7-D6D0-4858-BC11-02309F81A155}"/>
               </a:ext>
             </a:extLst>
           </p:cNvPr>
@@ -2979,7 +2969,7 @@
           <p:cNvPr id="10" name="">
             <a:extLst xmlns:a="http://schemas.openxmlformats.org/drawingml/2006/main">
               <a:ext uri="{FF2B5EF4-FFF2-40B4-BE49-F238E27FC236}">
-                <a16:creationId xmlns:a16="http://schemas.microsoft.com/office/drawing/2014/main" id="{CE232432-D719-49C9-90FA-E0B2422BC11F}"/>
+                <a16:creationId xmlns:a16="http://schemas.microsoft.com/office/drawing/2014/main" id="{F9D0E9CC-C2B2-4436-B76E-C963CE1945C8}"/>
               </a:ext>
             </a:extLst>
           </p:cNvPr>
@@ -3027,7 +3017,7 @@
                 <a:ea typeface="Aptos"/>
                 <a:cs typeface="Aptos"/>
               </a:rPr>
-              <a:t>1,142</a:t>
+              <a:t>1,166</a:t>
             </a:r>
           </a:p>
         </p:txBody>
@@ -3037,7 +3027,7 @@
           <p:cNvPr id="11" name="">
             <a:extLst xmlns:a="http://schemas.openxmlformats.org/drawingml/2006/main">
               <a:ext uri="{FF2B5EF4-FFF2-40B4-BE49-F238E27FC236}">
-                <a16:creationId xmlns:a16="http://schemas.microsoft.com/office/drawing/2014/main" id="{EE7F7E69-3ABC-4A46-9214-2AAB24E2751F}"/>
+                <a16:creationId xmlns:a16="http://schemas.microsoft.com/office/drawing/2014/main" id="{C3332E5E-0781-42EB-B7F7-BCC63FBF059D}"/>
               </a:ext>
             </a:extLst>
           </p:cNvPr>
@@ -3095,7 +3085,7 @@
           <p:cNvPr id="12" name="">
             <a:extLst xmlns:a="http://schemas.openxmlformats.org/drawingml/2006/main">
               <a:ext uri="{FF2B5EF4-FFF2-40B4-BE49-F238E27FC236}">
-                <a16:creationId xmlns:a16="http://schemas.microsoft.com/office/drawing/2014/main" id="{C04A01DE-C1E2-4BBB-91E0-49AD099B39A9}"/>
+                <a16:creationId xmlns:a16="http://schemas.microsoft.com/office/drawing/2014/main" id="{0FD549D2-8D15-43BE-9B76-DE308CE232D7}"/>
               </a:ext>
             </a:extLst>
           </p:cNvPr>
@@ -3153,7 +3143,7 @@
           <p:cNvPr id="13" name="">
             <a:extLst xmlns:a="http://schemas.openxmlformats.org/drawingml/2006/main">
               <a:ext uri="{FF2B5EF4-FFF2-40B4-BE49-F238E27FC236}">
-                <a16:creationId xmlns:a16="http://schemas.microsoft.com/office/drawing/2014/main" id="{F8752766-7A0A-4FF3-9D2B-E202AD2E367F}"/>
+                <a16:creationId xmlns:a16="http://schemas.microsoft.com/office/drawing/2014/main" id="{4A0B9265-2E17-4CAC-9338-DB3E2E057C57}"/>
               </a:ext>
             </a:extLst>
           </p:cNvPr>
@@ -3188,7 +3178,7 @@
           <p:cNvPr id="14" name="">
             <a:extLst xmlns:a="http://schemas.openxmlformats.org/drawingml/2006/main">
               <a:ext uri="{FF2B5EF4-FFF2-40B4-BE49-F238E27FC236}">
-                <a16:creationId xmlns:a16="http://schemas.microsoft.com/office/drawing/2014/main" id="{029CBF8B-F0F1-46CE-B0AC-A42BD9FF63FA}"/>
+                <a16:creationId xmlns:a16="http://schemas.microsoft.com/office/drawing/2014/main" id="{ABD57E74-3415-4636-8795-12F821449460}"/>
               </a:ext>
             </a:extLst>
           </p:cNvPr>
@@ -3221,7 +3211,7 @@
           <p:cNvPr id="15" name="">
             <a:extLst xmlns:a="http://schemas.openxmlformats.org/drawingml/2006/main">
               <a:ext uri="{FF2B5EF4-FFF2-40B4-BE49-F238E27FC236}">
-                <a16:creationId xmlns:a16="http://schemas.microsoft.com/office/drawing/2014/main" id="{3F16295B-0479-460C-92C7-F15677DF8CA9}"/>
+                <a16:creationId xmlns:a16="http://schemas.microsoft.com/office/drawing/2014/main" id="{13E89803-C0EE-40AF-BC1B-65B2EECCEC16}"/>
               </a:ext>
             </a:extLst>
           </p:cNvPr>
@@ -3269,7 +3259,7 @@
                 <a:ea typeface="Aptos"/>
                 <a:cs typeface="Aptos"/>
               </a:rPr>
-              <a:t>336</a:t>
+              <a:t>342</a:t>
             </a:r>
           </a:p>
         </p:txBody>
@@ -3279,7 +3269,7 @@
           <p:cNvPr id="16" name="">
             <a:extLst xmlns:a="http://schemas.openxmlformats.org/drawingml/2006/main">
               <a:ext uri="{FF2B5EF4-FFF2-40B4-BE49-F238E27FC236}">
-                <a16:creationId xmlns:a16="http://schemas.microsoft.com/office/drawing/2014/main" id="{7E50B898-3139-4CCB-B073-A6B3D568B33D}"/>
+                <a16:creationId xmlns:a16="http://schemas.microsoft.com/office/drawing/2014/main" id="{B6CFCD61-349F-4774-9BC6-FB6B27E6967A}"/>
               </a:ext>
             </a:extLst>
           </p:cNvPr>
@@ -3337,7 +3327,7 @@
           <p:cNvPr id="17" name="">
             <a:extLst xmlns:a="http://schemas.openxmlformats.org/drawingml/2006/main">
               <a:ext uri="{FF2B5EF4-FFF2-40B4-BE49-F238E27FC236}">
-                <a16:creationId xmlns:a16="http://schemas.microsoft.com/office/drawing/2014/main" id="{4ADFCD2A-F3B2-4136-82A7-4E631AD4ABB4}"/>
+                <a16:creationId xmlns:a16="http://schemas.microsoft.com/office/drawing/2014/main" id="{25616117-AA9F-4631-B695-23F56103E07A}"/>
               </a:ext>
             </a:extLst>
           </p:cNvPr>
@@ -3395,7 +3385,7 @@
           <p:cNvPr id="18" name="">
             <a:extLst xmlns:a="http://schemas.openxmlformats.org/drawingml/2006/main">
               <a:ext uri="{FF2B5EF4-FFF2-40B4-BE49-F238E27FC236}">
-                <a16:creationId xmlns:a16="http://schemas.microsoft.com/office/drawing/2014/main" id="{43CA8A53-A542-4CD0-930E-7A6777AEBEC1}"/>
+                <a16:creationId xmlns:a16="http://schemas.microsoft.com/office/drawing/2014/main" id="{0993A712-A51D-4656-85DD-4C5F48FFCA27}"/>
               </a:ext>
             </a:extLst>
           </p:cNvPr>
@@ -3430,7 +3420,7 @@
           <p:cNvPr id="19" name="">
             <a:extLst xmlns:a="http://schemas.openxmlformats.org/drawingml/2006/main">
               <a:ext uri="{FF2B5EF4-FFF2-40B4-BE49-F238E27FC236}">
-                <a16:creationId xmlns:a16="http://schemas.microsoft.com/office/drawing/2014/main" id="{C71B33EF-43CC-41B3-863E-05578F32D84D}"/>
+                <a16:creationId xmlns:a16="http://schemas.microsoft.com/office/drawing/2014/main" id="{C492CB43-95A8-473F-8C29-A92803FF777F}"/>
               </a:ext>
             </a:extLst>
           </p:cNvPr>
@@ -3463,7 +3453,7 @@
           <p:cNvPr id="20" name="">
             <a:extLst xmlns:a="http://schemas.openxmlformats.org/drawingml/2006/main">
               <a:ext uri="{FF2B5EF4-FFF2-40B4-BE49-F238E27FC236}">
-                <a16:creationId xmlns:a16="http://schemas.microsoft.com/office/drawing/2014/main" id="{E0DEFCF0-C20A-415E-B3D8-8AECBDA3C138}"/>
+                <a16:creationId xmlns:a16="http://schemas.microsoft.com/office/drawing/2014/main" id="{87BB350F-3F22-4970-A84D-B9A14BF5D1CC}"/>
               </a:ext>
             </a:extLst>
           </p:cNvPr>
@@ -3511,7 +3501,7 @@
                 <a:ea typeface="Aptos"/>
                 <a:cs typeface="Aptos"/>
               </a:rPr>
-              <a:t>656</a:t>
+              <a:t>666</a:t>
             </a:r>
           </a:p>
         </p:txBody>
@@ -3521,7 +3511,7 @@
           <p:cNvPr id="21" name="">
             <a:extLst xmlns:a="http://schemas.openxmlformats.org/drawingml/2006/main">
               <a:ext uri="{FF2B5EF4-FFF2-40B4-BE49-F238E27FC236}">
-                <a16:creationId xmlns:a16="http://schemas.microsoft.com/office/drawing/2014/main" id="{05E12317-426E-48B4-BB07-8996C12F32B0}"/>
+                <a16:creationId xmlns:a16="http://schemas.microsoft.com/office/drawing/2014/main" id="{82C883BA-45CE-488F-9B75-C413A7A0D1FA}"/>
               </a:ext>
             </a:extLst>
           </p:cNvPr>
@@ -3579,7 +3569,7 @@
           <p:cNvPr id="22" name="">
             <a:extLst xmlns:a="http://schemas.openxmlformats.org/drawingml/2006/main">
               <a:ext uri="{FF2B5EF4-FFF2-40B4-BE49-F238E27FC236}">
-                <a16:creationId xmlns:a16="http://schemas.microsoft.com/office/drawing/2014/main" id="{3B063F08-CBBA-4965-80BA-26B1428609DC}"/>
+                <a16:creationId xmlns:a16="http://schemas.microsoft.com/office/drawing/2014/main" id="{234BB85C-1403-4811-A8E5-4EB403B9AB32}"/>
               </a:ext>
             </a:extLst>
           </p:cNvPr>
@@ -3637,7 +3627,7 @@
           <p:cNvPr id="23" name="">
             <a:extLst xmlns:a="http://schemas.openxmlformats.org/drawingml/2006/main">
               <a:ext uri="{FF2B5EF4-FFF2-40B4-BE49-F238E27FC236}">
-                <a16:creationId xmlns:a16="http://schemas.microsoft.com/office/drawing/2014/main" id="{F812C9C7-9A02-4FD7-B625-8FF3C159F8DB}"/>
+                <a16:creationId xmlns:a16="http://schemas.microsoft.com/office/drawing/2014/main" id="{DAC5DA38-DC6D-4CBA-81C3-64498A7145AE}"/>
               </a:ext>
             </a:extLst>
           </p:cNvPr>
@@ -3685,7 +3675,7 @@
                 <a:ea typeface="Aptos"/>
                 <a:cs typeface="Aptos"/>
               </a:rPr>
-              <a:t>WATERS NEXT GEN COMPETITIVE INTELLIGENCE · 23 AUG 2026 · waters-ci-20260820104036</a:t>
+              <a:t>WATERS NEXT GEN COMPETITIVE INTELLIGENCE · 08 SEP 2026 · waters-ci-20260909030324</a:t>
             </a:r>
           </a:p>
         </p:txBody>
@@ -3695,7 +3685,7 @@
           <p:cNvPr id="24" name="">
             <a:extLst xmlns:a="http://schemas.openxmlformats.org/drawingml/2006/main">
               <a:ext uri="{FF2B5EF4-FFF2-40B4-BE49-F238E27FC236}">
-                <a16:creationId xmlns:a16="http://schemas.microsoft.com/office/drawing/2014/main" id="{B2FA46A9-E74B-4D1A-8301-4CB6A45F115D}"/>
+                <a16:creationId xmlns:a16="http://schemas.microsoft.com/office/drawing/2014/main" id="{21EBE62A-93EE-4FE7-8207-FF5CC31CEABB}"/>
               </a:ext>
             </a:extLst>
           </p:cNvPr>
@@ -3751,7 +3741,7 @@
     </p:spTree>
     <p:extLst>
       <p:ext uri="{BB962C8B-B14F-4D97-AF65-F5344CB8AC3E}">
-        <p14:creationId xmlns:p14="http://schemas.microsoft.com/office/powerpoint/2010/main" val="48565560"/>
+        <p14:creationId xmlns:p14="http://schemas.microsoft.com/office/powerpoint/2010/main" val="1529244957"/>
       </p:ext>
     </p:extLst>
   </p:cSld>
@@ -3782,7 +3772,7 @@
           <p:cNvPr id="37" name="">
             <a:extLst xmlns:a="http://schemas.openxmlformats.org/drawingml/2006/main">
               <a:ext uri="{FF2B5EF4-FFF2-40B4-BE49-F238E27FC236}">
-                <a16:creationId xmlns:a16="http://schemas.microsoft.com/office/drawing/2014/main" id="{CFE8EAF1-A21A-4024-96AE-42493369608B}"/>
+                <a16:creationId xmlns:a16="http://schemas.microsoft.com/office/drawing/2014/main" id="{9425EAD0-0B98-47C4-9660-1F0874DC6417}"/>
               </a:ext>
             </a:extLst>
           </p:cNvPr>
@@ -3840,7 +3830,7 @@
           <p:cNvPr id="2" name="">
             <a:extLst xmlns:a="http://schemas.openxmlformats.org/drawingml/2006/main">
               <a:ext uri="{FF2B5EF4-FFF2-40B4-BE49-F238E27FC236}">
-                <a16:creationId xmlns:a16="http://schemas.microsoft.com/office/drawing/2014/main" id="{23E5462F-A644-4E75-93D4-8B08150F3B47}"/>
+                <a16:creationId xmlns:a16="http://schemas.microsoft.com/office/drawing/2014/main" id="{601A4FFF-43C8-471A-82CF-6E5F49550703}"/>
               </a:ext>
             </a:extLst>
           </p:cNvPr>
@@ -3898,7 +3888,7 @@
           <p:cNvPr id="3" name="">
             <a:extLst xmlns:a="http://schemas.openxmlformats.org/drawingml/2006/main">
               <a:ext uri="{FF2B5EF4-FFF2-40B4-BE49-F238E27FC236}">
-                <a16:creationId xmlns:a16="http://schemas.microsoft.com/office/drawing/2014/main" id="{A1FA54E5-3011-4270-97D5-F0D64073D73B}"/>
+                <a16:creationId xmlns:a16="http://schemas.microsoft.com/office/drawing/2014/main" id="{4CBDF04D-F667-4A44-BBE6-F481007CD14B}"/>
               </a:ext>
             </a:extLst>
           </p:cNvPr>
@@ -3956,7 +3946,7 @@
           <p:cNvPr id="4" name="">
             <a:extLst xmlns:a="http://schemas.openxmlformats.org/drawingml/2006/main">
               <a:ext uri="{FF2B5EF4-FFF2-40B4-BE49-F238E27FC236}">
-                <a16:creationId xmlns:a16="http://schemas.microsoft.com/office/drawing/2014/main" id="{CC565C6B-6517-4BEC-9F61-D20747111561}"/>
+                <a16:creationId xmlns:a16="http://schemas.microsoft.com/office/drawing/2014/main" id="{90E84CCE-7291-4692-B093-036E5EE7CC8A}"/>
               </a:ext>
             </a:extLst>
           </p:cNvPr>
@@ -3989,7 +3979,7 @@
           <p:cNvPr id="5" name="">
             <a:extLst xmlns:a="http://schemas.openxmlformats.org/drawingml/2006/main">
               <a:ext uri="{FF2B5EF4-FFF2-40B4-BE49-F238E27FC236}">
-                <a16:creationId xmlns:a16="http://schemas.microsoft.com/office/drawing/2014/main" id="{2A7AD552-5983-4B7A-B4E6-24EA0810BB69}"/>
+                <a16:creationId xmlns:a16="http://schemas.microsoft.com/office/drawing/2014/main" id="{E2174DD5-851D-44EC-B06F-1C2224CADB86}"/>
               </a:ext>
             </a:extLst>
           </p:cNvPr>
@@ -4024,7 +4014,7 @@
           <p:cNvPr id="6" name="">
             <a:extLst xmlns:a="http://schemas.openxmlformats.org/drawingml/2006/main">
               <a:ext uri="{FF2B5EF4-FFF2-40B4-BE49-F238E27FC236}">
-                <a16:creationId xmlns:a16="http://schemas.microsoft.com/office/drawing/2014/main" id="{4EE33C26-EF61-4213-8B5D-F7C68106C112}"/>
+                <a16:creationId xmlns:a16="http://schemas.microsoft.com/office/drawing/2014/main" id="{52BBAAA9-51D3-4D0A-8679-8F30DDCE1BAD}"/>
               </a:ext>
             </a:extLst>
           </p:cNvPr>
@@ -4059,7 +4049,7 @@
           <p:cNvPr id="7" name="">
             <a:extLst xmlns:a="http://schemas.openxmlformats.org/drawingml/2006/main">
               <a:ext uri="{FF2B5EF4-FFF2-40B4-BE49-F238E27FC236}">
-                <a16:creationId xmlns:a16="http://schemas.microsoft.com/office/drawing/2014/main" id="{0893FFCB-3625-47F3-8769-3C5FCC50C1B4}"/>
+                <a16:creationId xmlns:a16="http://schemas.microsoft.com/office/drawing/2014/main" id="{623C7E45-EDC6-49D6-9613-0DC0975F2D59}"/>
               </a:ext>
             </a:extLst>
           </p:cNvPr>
@@ -4117,7 +4107,7 @@
           <p:cNvPr id="8" name="">
             <a:extLst xmlns:a="http://schemas.openxmlformats.org/drawingml/2006/main">
               <a:ext uri="{FF2B5EF4-FFF2-40B4-BE49-F238E27FC236}">
-                <a16:creationId xmlns:a16="http://schemas.microsoft.com/office/drawing/2014/main" id="{583D8C26-ECB2-4DA0-9EC0-2A0D9FF3E6F3}"/>
+                <a16:creationId xmlns:a16="http://schemas.microsoft.com/office/drawing/2014/main" id="{907EF886-7C34-47FE-8954-DF82A024ADD1}"/>
               </a:ext>
             </a:extLst>
           </p:cNvPr>
@@ -4175,7 +4165,7 @@
           <p:cNvPr id="9" name="">
             <a:extLst xmlns:a="http://schemas.openxmlformats.org/drawingml/2006/main">
               <a:ext uri="{FF2B5EF4-FFF2-40B4-BE49-F238E27FC236}">
-                <a16:creationId xmlns:a16="http://schemas.microsoft.com/office/drawing/2014/main" id="{2013F8A4-2366-4E62-B044-A86063B61FC6}"/>
+                <a16:creationId xmlns:a16="http://schemas.microsoft.com/office/drawing/2014/main" id="{F4A780A3-42DA-456B-B398-B64B70F06286}"/>
               </a:ext>
             </a:extLst>
           </p:cNvPr>
@@ -4233,7 +4223,7 @@
           <p:cNvPr id="10" name="">
             <a:extLst xmlns:a="http://schemas.openxmlformats.org/drawingml/2006/main">
               <a:ext uri="{FF2B5EF4-FFF2-40B4-BE49-F238E27FC236}">
-                <a16:creationId xmlns:a16="http://schemas.microsoft.com/office/drawing/2014/main" id="{26E89E93-206E-4140-AFD2-C4337D38A313}"/>
+                <a16:creationId xmlns:a16="http://schemas.microsoft.com/office/drawing/2014/main" id="{57FB0847-9391-494C-B5DB-F8AD03A9699E}"/>
               </a:ext>
             </a:extLst>
           </p:cNvPr>
@@ -4281,7 +4271,7 @@
                 <a:ea typeface="Aptos"/>
                 <a:cs typeface="Aptos"/>
               </a:rPr>
-              <a:t>336 records from the canonical PubMed query.</a:t>
+              <a:t>342 records from the canonical PubMed query.</a:t>
             </a:r>
           </a:p>
         </p:txBody>
@@ -4291,7 +4281,7 @@
           <p:cNvPr id="11" name="">
             <a:extLst xmlns:a="http://schemas.openxmlformats.org/drawingml/2006/main">
               <a:ext uri="{FF2B5EF4-FFF2-40B4-BE49-F238E27FC236}">
-                <a16:creationId xmlns:a16="http://schemas.microsoft.com/office/drawing/2014/main" id="{24EC296D-7245-427C-BC1B-023C3B82AC21}"/>
+                <a16:creationId xmlns:a16="http://schemas.microsoft.com/office/drawing/2014/main" id="{478CA587-974B-4005-B484-B200669144BD}"/>
               </a:ext>
             </a:extLst>
           </p:cNvPr>
@@ -4326,7 +4316,7 @@
           <p:cNvPr id="12" name="">
             <a:extLst xmlns:a="http://schemas.openxmlformats.org/drawingml/2006/main">
               <a:ext uri="{FF2B5EF4-FFF2-40B4-BE49-F238E27FC236}">
-                <a16:creationId xmlns:a16="http://schemas.microsoft.com/office/drawing/2014/main" id="{FB15A235-AA52-4FE2-80CA-D1CCFB8F9EEF}"/>
+                <a16:creationId xmlns:a16="http://schemas.microsoft.com/office/drawing/2014/main" id="{5ACC7C2B-C10F-4F12-819E-B8B10E552375}"/>
               </a:ext>
             </a:extLst>
           </p:cNvPr>
@@ -4361,7 +4351,7 @@
           <p:cNvPr id="13" name="">
             <a:extLst xmlns:a="http://schemas.openxmlformats.org/drawingml/2006/main">
               <a:ext uri="{FF2B5EF4-FFF2-40B4-BE49-F238E27FC236}">
-                <a16:creationId xmlns:a16="http://schemas.microsoft.com/office/drawing/2014/main" id="{8729F9B8-1E1A-4F47-8FD4-831760808D1C}"/>
+                <a16:creationId xmlns:a16="http://schemas.microsoft.com/office/drawing/2014/main" id="{9A764D32-CF35-4E61-A0B6-34DBF55E19F4}"/>
               </a:ext>
             </a:extLst>
           </p:cNvPr>
@@ -4419,7 +4409,7 @@
           <p:cNvPr id="14" name="">
             <a:extLst xmlns:a="http://schemas.openxmlformats.org/drawingml/2006/main">
               <a:ext uri="{FF2B5EF4-FFF2-40B4-BE49-F238E27FC236}">
-                <a16:creationId xmlns:a16="http://schemas.microsoft.com/office/drawing/2014/main" id="{6A556FE4-232B-4F6A-9F21-B92D870FA519}"/>
+                <a16:creationId xmlns:a16="http://schemas.microsoft.com/office/drawing/2014/main" id="{F4EF14DD-4DAD-4162-960E-B18F46A8E75D}"/>
               </a:ext>
             </a:extLst>
           </p:cNvPr>
@@ -4477,7 +4467,7 @@
           <p:cNvPr id="15" name="">
             <a:extLst xmlns:a="http://schemas.openxmlformats.org/drawingml/2006/main">
               <a:ext uri="{FF2B5EF4-FFF2-40B4-BE49-F238E27FC236}">
-                <a16:creationId xmlns:a16="http://schemas.microsoft.com/office/drawing/2014/main" id="{F26E49A3-7BB4-4449-9BB7-3E9607566399}"/>
+                <a16:creationId xmlns:a16="http://schemas.microsoft.com/office/drawing/2014/main" id="{B0F8340B-F6A3-48EF-85F7-EC4243EC1C53}"/>
               </a:ext>
             </a:extLst>
           </p:cNvPr>
@@ -4535,7 +4525,7 @@
           <p:cNvPr id="16" name="">
             <a:extLst xmlns:a="http://schemas.openxmlformats.org/drawingml/2006/main">
               <a:ext uri="{FF2B5EF4-FFF2-40B4-BE49-F238E27FC236}">
-                <a16:creationId xmlns:a16="http://schemas.microsoft.com/office/drawing/2014/main" id="{5AA72654-F562-4F5E-8C9D-CD318DABC136}"/>
+                <a16:creationId xmlns:a16="http://schemas.microsoft.com/office/drawing/2014/main" id="{6151D791-763B-44B1-860F-BD36A9D116AA}"/>
               </a:ext>
             </a:extLst>
           </p:cNvPr>
@@ -4593,7 +4583,7 @@
           <p:cNvPr id="17" name="">
             <a:extLst xmlns:a="http://schemas.openxmlformats.org/drawingml/2006/main">
               <a:ext uri="{FF2B5EF4-FFF2-40B4-BE49-F238E27FC236}">
-                <a16:creationId xmlns:a16="http://schemas.microsoft.com/office/drawing/2014/main" id="{8EB50748-499B-470A-8450-E5F7285C725C}"/>
+                <a16:creationId xmlns:a16="http://schemas.microsoft.com/office/drawing/2014/main" id="{21545107-47C7-4EE4-9B5D-D67EC128FE7A}"/>
               </a:ext>
             </a:extLst>
           </p:cNvPr>
@@ -4628,7 +4618,7 @@
           <p:cNvPr id="18" name="">
             <a:extLst xmlns:a="http://schemas.openxmlformats.org/drawingml/2006/main">
               <a:ext uri="{FF2B5EF4-FFF2-40B4-BE49-F238E27FC236}">
-                <a16:creationId xmlns:a16="http://schemas.microsoft.com/office/drawing/2014/main" id="{4BF37AFA-28EC-49B8-832D-D759C1CC8C35}"/>
+                <a16:creationId xmlns:a16="http://schemas.microsoft.com/office/drawing/2014/main" id="{56CCD6D8-4F68-40EB-932C-703DC72D5033}"/>
               </a:ext>
             </a:extLst>
           </p:cNvPr>
@@ -4663,7 +4653,7 @@
           <p:cNvPr id="19" name="">
             <a:extLst xmlns:a="http://schemas.openxmlformats.org/drawingml/2006/main">
               <a:ext uri="{FF2B5EF4-FFF2-40B4-BE49-F238E27FC236}">
-                <a16:creationId xmlns:a16="http://schemas.microsoft.com/office/drawing/2014/main" id="{D793DCDC-4854-4F04-8242-4A08EC88EC5C}"/>
+                <a16:creationId xmlns:a16="http://schemas.microsoft.com/office/drawing/2014/main" id="{4442EB07-8367-4A84-92AA-4C5AAC993089}"/>
               </a:ext>
             </a:extLst>
           </p:cNvPr>
@@ -4721,7 +4711,7 @@
           <p:cNvPr id="20" name="">
             <a:extLst xmlns:a="http://schemas.openxmlformats.org/drawingml/2006/main">
               <a:ext uri="{FF2B5EF4-FFF2-40B4-BE49-F238E27FC236}">
-                <a16:creationId xmlns:a16="http://schemas.microsoft.com/office/drawing/2014/main" id="{FA138BD7-9CF9-47A1-8916-DFAF0D8087E7}"/>
+                <a16:creationId xmlns:a16="http://schemas.microsoft.com/office/drawing/2014/main" id="{D2D2D592-EB6F-44BE-BFE8-24CFB0CC8584}"/>
               </a:ext>
             </a:extLst>
           </p:cNvPr>
@@ -4779,7 +4769,7 @@
           <p:cNvPr id="21" name="">
             <a:extLst xmlns:a="http://schemas.openxmlformats.org/drawingml/2006/main">
               <a:ext uri="{FF2B5EF4-FFF2-40B4-BE49-F238E27FC236}">
-                <a16:creationId xmlns:a16="http://schemas.microsoft.com/office/drawing/2014/main" id="{0464B3CC-28E0-4B25-9846-958C2ED4F9F8}"/>
+                <a16:creationId xmlns:a16="http://schemas.microsoft.com/office/drawing/2014/main" id="{2BDAC30F-A7A7-4555-B2F1-0AAB164CC9FF}"/>
               </a:ext>
             </a:extLst>
           </p:cNvPr>
@@ -4837,7 +4827,7 @@
           <p:cNvPr id="22" name="">
             <a:extLst xmlns:a="http://schemas.openxmlformats.org/drawingml/2006/main">
               <a:ext uri="{FF2B5EF4-FFF2-40B4-BE49-F238E27FC236}">
-                <a16:creationId xmlns:a16="http://schemas.microsoft.com/office/drawing/2014/main" id="{5E992DBE-D81E-43CC-9948-F66069A82F57}"/>
+                <a16:creationId xmlns:a16="http://schemas.microsoft.com/office/drawing/2014/main" id="{4A0DC9ED-FE92-4006-B546-BC5E7EAC0458}"/>
               </a:ext>
             </a:extLst>
           </p:cNvPr>
@@ -4895,7 +4885,7 @@
           <p:cNvPr id="23" name="">
             <a:extLst xmlns:a="http://schemas.openxmlformats.org/drawingml/2006/main">
               <a:ext uri="{FF2B5EF4-FFF2-40B4-BE49-F238E27FC236}">
-                <a16:creationId xmlns:a16="http://schemas.microsoft.com/office/drawing/2014/main" id="{872C910D-1B42-4F0E-88C4-1ED4153C11B9}"/>
+                <a16:creationId xmlns:a16="http://schemas.microsoft.com/office/drawing/2014/main" id="{34D20631-22E7-484C-B149-B6CA98C5246D}"/>
               </a:ext>
             </a:extLst>
           </p:cNvPr>
@@ -4930,7 +4920,7 @@
           <p:cNvPr id="24" name="">
             <a:extLst xmlns:a="http://schemas.openxmlformats.org/drawingml/2006/main">
               <a:ext uri="{FF2B5EF4-FFF2-40B4-BE49-F238E27FC236}">
-                <a16:creationId xmlns:a16="http://schemas.microsoft.com/office/drawing/2014/main" id="{4772E6E0-5937-4B03-85C0-E15743EA2E99}"/>
+                <a16:creationId xmlns:a16="http://schemas.microsoft.com/office/drawing/2014/main" id="{2D478D25-69C8-483B-923B-D2EB33D8373A}"/>
               </a:ext>
             </a:extLst>
           </p:cNvPr>
@@ -4965,7 +4955,7 @@
           <p:cNvPr id="25" name="">
             <a:extLst xmlns:a="http://schemas.openxmlformats.org/drawingml/2006/main">
               <a:ext uri="{FF2B5EF4-FFF2-40B4-BE49-F238E27FC236}">
-                <a16:creationId xmlns:a16="http://schemas.microsoft.com/office/drawing/2014/main" id="{7AEC93B3-DDBD-4EF9-95D6-00213BB500E1}"/>
+                <a16:creationId xmlns:a16="http://schemas.microsoft.com/office/drawing/2014/main" id="{7088377D-7ACD-4D03-BCB4-96415ECB522F}"/>
               </a:ext>
             </a:extLst>
           </p:cNvPr>
@@ -5023,7 +5013,7 @@
           <p:cNvPr id="26" name="">
             <a:extLst xmlns:a="http://schemas.openxmlformats.org/drawingml/2006/main">
               <a:ext uri="{FF2B5EF4-FFF2-40B4-BE49-F238E27FC236}">
-                <a16:creationId xmlns:a16="http://schemas.microsoft.com/office/drawing/2014/main" id="{A80B17E9-D374-414C-8A04-C4B0A68BFFFC}"/>
+                <a16:creationId xmlns:a16="http://schemas.microsoft.com/office/drawing/2014/main" id="{5CF28A4E-8B80-4DD0-B3E7-E315F383693E}"/>
               </a:ext>
             </a:extLst>
           </p:cNvPr>
@@ -5081,7 +5071,7 @@
           <p:cNvPr id="27" name="">
             <a:extLst xmlns:a="http://schemas.openxmlformats.org/drawingml/2006/main">
               <a:ext uri="{FF2B5EF4-FFF2-40B4-BE49-F238E27FC236}">
-                <a16:creationId xmlns:a16="http://schemas.microsoft.com/office/drawing/2014/main" id="{AE086DFF-4305-4024-81B0-8FD48B74CB27}"/>
+                <a16:creationId xmlns:a16="http://schemas.microsoft.com/office/drawing/2014/main" id="{E4D2A87E-8A07-43B0-B6B3-6552BE9B6529}"/>
               </a:ext>
             </a:extLst>
           </p:cNvPr>
@@ -5139,7 +5129,7 @@
           <p:cNvPr id="28" name="">
             <a:extLst xmlns:a="http://schemas.openxmlformats.org/drawingml/2006/main">
               <a:ext uri="{FF2B5EF4-FFF2-40B4-BE49-F238E27FC236}">
-                <a16:creationId xmlns:a16="http://schemas.microsoft.com/office/drawing/2014/main" id="{2F885BC6-7E30-422F-8407-820B7BA85168}"/>
+                <a16:creationId xmlns:a16="http://schemas.microsoft.com/office/drawing/2014/main" id="{215F3F96-28E4-4810-A520-9FA8A4E8B0A0}"/>
               </a:ext>
             </a:extLst>
           </p:cNvPr>
@@ -5197,7 +5187,7 @@
           <p:cNvPr id="29" name="">
             <a:extLst xmlns:a="http://schemas.openxmlformats.org/drawingml/2006/main">
               <a:ext uri="{FF2B5EF4-FFF2-40B4-BE49-F238E27FC236}">
-                <a16:creationId xmlns:a16="http://schemas.microsoft.com/office/drawing/2014/main" id="{FBC23F28-90C1-4AD0-8B6A-541CDBFE899F}"/>
+                <a16:creationId xmlns:a16="http://schemas.microsoft.com/office/drawing/2014/main" id="{5CD85CE6-35A5-44C9-90E7-2403C6118B28}"/>
               </a:ext>
             </a:extLst>
           </p:cNvPr>
@@ -5232,7 +5222,7 @@
           <p:cNvPr id="30" name="">
             <a:extLst xmlns:a="http://schemas.openxmlformats.org/drawingml/2006/main">
               <a:ext uri="{FF2B5EF4-FFF2-40B4-BE49-F238E27FC236}">
-                <a16:creationId xmlns:a16="http://schemas.microsoft.com/office/drawing/2014/main" id="{D4B4C873-8F2F-48C1-BF3E-17655EFE33AA}"/>
+                <a16:creationId xmlns:a16="http://schemas.microsoft.com/office/drawing/2014/main" id="{F82A22EC-D696-48D7-A3CA-2D39A7CC10EE}"/>
               </a:ext>
             </a:extLst>
           </p:cNvPr>
@@ -5267,7 +5257,7 @@
           <p:cNvPr id="31" name="">
             <a:extLst xmlns:a="http://schemas.openxmlformats.org/drawingml/2006/main">
               <a:ext uri="{FF2B5EF4-FFF2-40B4-BE49-F238E27FC236}">
-                <a16:creationId xmlns:a16="http://schemas.microsoft.com/office/drawing/2014/main" id="{104A8D82-370C-4534-87ED-5C31A87E4A86}"/>
+                <a16:creationId xmlns:a16="http://schemas.microsoft.com/office/drawing/2014/main" id="{D65E0F88-1921-416F-A849-C19218E2EA3E}"/>
               </a:ext>
             </a:extLst>
           </p:cNvPr>
@@ -5325,7 +5315,7 @@
           <p:cNvPr id="32" name="">
             <a:extLst xmlns:a="http://schemas.openxmlformats.org/drawingml/2006/main">
               <a:ext uri="{FF2B5EF4-FFF2-40B4-BE49-F238E27FC236}">
-                <a16:creationId xmlns:a16="http://schemas.microsoft.com/office/drawing/2014/main" id="{34C0943D-D3DB-4F05-AE0A-B0367D570B88}"/>
+                <a16:creationId xmlns:a16="http://schemas.microsoft.com/office/drawing/2014/main" id="{2AED8A8F-93C9-496C-A3AA-F01FA24F3633}"/>
               </a:ext>
             </a:extLst>
           </p:cNvPr>
@@ -5383,7 +5373,7 @@
           <p:cNvPr id="33" name="">
             <a:extLst xmlns:a="http://schemas.openxmlformats.org/drawingml/2006/main">
               <a:ext uri="{FF2B5EF4-FFF2-40B4-BE49-F238E27FC236}">
-                <a16:creationId xmlns:a16="http://schemas.microsoft.com/office/drawing/2014/main" id="{B80A9B53-8C94-4777-BA08-93D035912AA1}"/>
+                <a16:creationId xmlns:a16="http://schemas.microsoft.com/office/drawing/2014/main" id="{FCA21FB7-68C2-4C57-8FCA-C1F3FF925838}"/>
               </a:ext>
             </a:extLst>
           </p:cNvPr>
@@ -5441,7 +5431,7 @@
           <p:cNvPr id="34" name="">
             <a:extLst xmlns:a="http://schemas.openxmlformats.org/drawingml/2006/main">
               <a:ext uri="{FF2B5EF4-FFF2-40B4-BE49-F238E27FC236}">
-                <a16:creationId xmlns:a16="http://schemas.microsoft.com/office/drawing/2014/main" id="{6E6F4135-CBB9-40FC-8F28-22B129F41240}"/>
+                <a16:creationId xmlns:a16="http://schemas.microsoft.com/office/drawing/2014/main" id="{0B9544B1-CF45-453F-AF30-662CC03CF390}"/>
               </a:ext>
             </a:extLst>
           </p:cNvPr>
@@ -5499,7 +5489,7 @@
           <p:cNvPr id="35" name="">
             <a:extLst xmlns:a="http://schemas.openxmlformats.org/drawingml/2006/main">
               <a:ext uri="{FF2B5EF4-FFF2-40B4-BE49-F238E27FC236}">
-                <a16:creationId xmlns:a16="http://schemas.microsoft.com/office/drawing/2014/main" id="{597E0818-83ED-4EEB-B52C-16063C8FF8E1}"/>
+                <a16:creationId xmlns:a16="http://schemas.microsoft.com/office/drawing/2014/main" id="{E8524B9F-4F33-4940-8610-86B9CE3B113F}"/>
               </a:ext>
             </a:extLst>
           </p:cNvPr>
@@ -5547,7 +5537,7 @@
                 <a:ea typeface="Aptos"/>
                 <a:cs typeface="Aptos"/>
               </a:rPr>
-              <a:t>WATERS NEXT GEN COMPETITIVE INTELLIGENCE · 23 AUG 2026 · waters-ci-20260820104036</a:t>
+              <a:t>WATERS NEXT GEN COMPETITIVE INTELLIGENCE · 08 SEP 2026 · waters-ci-20260909030324</a:t>
             </a:r>
           </a:p>
         </p:txBody>
@@ -5557,7 +5547,7 @@
           <p:cNvPr id="36" name="">
             <a:extLst xmlns:a="http://schemas.openxmlformats.org/drawingml/2006/main">
               <a:ext uri="{FF2B5EF4-FFF2-40B4-BE49-F238E27FC236}">
-                <a16:creationId xmlns:a16="http://schemas.microsoft.com/office/drawing/2014/main" id="{31EE01B3-325A-4148-80E7-673DDB889770}"/>
+                <a16:creationId xmlns:a16="http://schemas.microsoft.com/office/drawing/2014/main" id="{AE06BF92-3B9A-48E0-86DA-957808508729}"/>
               </a:ext>
             </a:extLst>
           </p:cNvPr>
@@ -5613,7 +5603,7 @@
     </p:spTree>
     <p:extLst>
       <p:ext uri="{BB962C8B-B14F-4D97-AF65-F5344CB8AC3E}">
-        <p14:creationId xmlns:p14="http://schemas.microsoft.com/office/powerpoint/2010/main" val="2038538785"/>
+        <p14:creationId xmlns:p14="http://schemas.microsoft.com/office/powerpoint/2010/main" val="1499131285"/>
       </p:ext>
     </p:extLst>
   </p:cSld>
@@ -5644,7 +5634,7 @@
           <p:cNvPr id="31" name="">
             <a:extLst xmlns:a="http://schemas.openxmlformats.org/drawingml/2006/main">
               <a:ext uri="{FF2B5EF4-FFF2-40B4-BE49-F238E27FC236}">
-                <a16:creationId xmlns:a16="http://schemas.microsoft.com/office/drawing/2014/main" id="{44AEA82A-8746-48B9-A0B4-8B014FD6448B}"/>
+                <a16:creationId xmlns:a16="http://schemas.microsoft.com/office/drawing/2014/main" id="{BEE9F860-65BB-452B-B65A-BB7746E13674}"/>
               </a:ext>
             </a:extLst>
           </p:cNvPr>
@@ -5702,7 +5692,7 @@
           <p:cNvPr id="2" name="">
             <a:extLst xmlns:a="http://schemas.openxmlformats.org/drawingml/2006/main">
               <a:ext uri="{FF2B5EF4-FFF2-40B4-BE49-F238E27FC236}">
-                <a16:creationId xmlns:a16="http://schemas.microsoft.com/office/drawing/2014/main" id="{88DE207F-BABE-47AB-8C18-D00AF70690F9}"/>
+                <a16:creationId xmlns:a16="http://schemas.microsoft.com/office/drawing/2014/main" id="{3EEE5DF6-451B-4ECA-A489-5EC355AA3915}"/>
               </a:ext>
             </a:extLst>
           </p:cNvPr>
@@ -5760,7 +5750,7 @@
           <p:cNvPr id="3" name="">
             <a:extLst xmlns:a="http://schemas.openxmlformats.org/drawingml/2006/main">
               <a:ext uri="{FF2B5EF4-FFF2-40B4-BE49-F238E27FC236}">
-                <a16:creationId xmlns:a16="http://schemas.microsoft.com/office/drawing/2014/main" id="{2A163A8A-28FB-4F20-A411-33927703636E}"/>
+                <a16:creationId xmlns:a16="http://schemas.microsoft.com/office/drawing/2014/main" id="{76660F28-755B-405D-AD0D-320679E4BA32}"/>
               </a:ext>
             </a:extLst>
           </p:cNvPr>
@@ -5818,7 +5808,7 @@
           <p:cNvPr id="4" name="">
             <a:extLst xmlns:a="http://schemas.openxmlformats.org/drawingml/2006/main">
               <a:ext uri="{FF2B5EF4-FFF2-40B4-BE49-F238E27FC236}">
-                <a16:creationId xmlns:a16="http://schemas.microsoft.com/office/drawing/2014/main" id="{33351EC9-938E-49E8-B6F0-BD182B2D88F7}"/>
+                <a16:creationId xmlns:a16="http://schemas.microsoft.com/office/drawing/2014/main" id="{B84531C1-7D57-4060-9C7B-37F0D6596D35}"/>
               </a:ext>
             </a:extLst>
           </p:cNvPr>
@@ -5851,7 +5841,7 @@
           <p:cNvPr id="5" name="">
             <a:extLst xmlns:a="http://schemas.openxmlformats.org/drawingml/2006/main">
               <a:ext uri="{FF2B5EF4-FFF2-40B4-BE49-F238E27FC236}">
-                <a16:creationId xmlns:a16="http://schemas.microsoft.com/office/drawing/2014/main" id="{B9C7A60D-F53B-4BAB-B5BC-1DD660DB259E}"/>
+                <a16:creationId xmlns:a16="http://schemas.microsoft.com/office/drawing/2014/main" id="{39E73918-46AC-4CA6-8D4D-BD88C8C16D0D}"/>
               </a:ext>
             </a:extLst>
           </p:cNvPr>
@@ -5886,7 +5876,7 @@
           <p:cNvPr id="6" name="">
             <a:extLst xmlns:a="http://schemas.openxmlformats.org/drawingml/2006/main">
               <a:ext uri="{FF2B5EF4-FFF2-40B4-BE49-F238E27FC236}">
-                <a16:creationId xmlns:a16="http://schemas.microsoft.com/office/drawing/2014/main" id="{B7E1D81D-2B14-491B-9D80-7D2732EBDFBD}"/>
+                <a16:creationId xmlns:a16="http://schemas.microsoft.com/office/drawing/2014/main" id="{DD45F7C3-309E-4A7E-AB73-05BF33533144}"/>
               </a:ext>
             </a:extLst>
           </p:cNvPr>
@@ -5919,7 +5909,7 @@
           <p:cNvPr id="7" name="">
             <a:extLst xmlns:a="http://schemas.openxmlformats.org/drawingml/2006/main">
               <a:ext uri="{FF2B5EF4-FFF2-40B4-BE49-F238E27FC236}">
-                <a16:creationId xmlns:a16="http://schemas.microsoft.com/office/drawing/2014/main" id="{1B8FDACD-87D9-4BEC-944D-25AA3AD96FB3}"/>
+                <a16:creationId xmlns:a16="http://schemas.microsoft.com/office/drawing/2014/main" id="{C5543680-B2AB-4681-B464-9850161FA28A}"/>
               </a:ext>
             </a:extLst>
           </p:cNvPr>
@@ -5977,7 +5967,7 @@
           <p:cNvPr id="8" name="">
             <a:extLst xmlns:a="http://schemas.openxmlformats.org/drawingml/2006/main">
               <a:ext uri="{FF2B5EF4-FFF2-40B4-BE49-F238E27FC236}">
-                <a16:creationId xmlns:a16="http://schemas.microsoft.com/office/drawing/2014/main" id="{8EAA95A1-A682-4ABE-9538-3428E7438539}"/>
+                <a16:creationId xmlns:a16="http://schemas.microsoft.com/office/drawing/2014/main" id="{7CE639CC-44AC-48CC-A655-B1405ED4A165}"/>
               </a:ext>
             </a:extLst>
           </p:cNvPr>
@@ -6035,7 +6025,7 @@
           <p:cNvPr id="9" name="">
             <a:extLst xmlns:a="http://schemas.openxmlformats.org/drawingml/2006/main">
               <a:ext uri="{FF2B5EF4-FFF2-40B4-BE49-F238E27FC236}">
-                <a16:creationId xmlns:a16="http://schemas.microsoft.com/office/drawing/2014/main" id="{93C42C20-124C-44CC-9E69-419451593BF4}"/>
+                <a16:creationId xmlns:a16="http://schemas.microsoft.com/office/drawing/2014/main" id="{076CEBCA-5B75-40EC-BFE6-2C84A193350A}"/>
               </a:ext>
             </a:extLst>
           </p:cNvPr>
@@ -6093,7 +6083,7 @@
           <p:cNvPr id="10" name="">
             <a:extLst xmlns:a="http://schemas.openxmlformats.org/drawingml/2006/main">
               <a:ext uri="{FF2B5EF4-FFF2-40B4-BE49-F238E27FC236}">
-                <a16:creationId xmlns:a16="http://schemas.microsoft.com/office/drawing/2014/main" id="{B6D65A2D-A738-40FA-8334-853F260365CE}"/>
+                <a16:creationId xmlns:a16="http://schemas.microsoft.com/office/drawing/2014/main" id="{53413D71-4E44-4ECC-BB05-B7D53F11AE89}"/>
               </a:ext>
             </a:extLst>
           </p:cNvPr>
@@ -6151,7 +6141,7 @@
           <p:cNvPr id="11" name="">
             <a:extLst xmlns:a="http://schemas.openxmlformats.org/drawingml/2006/main">
               <a:ext uri="{FF2B5EF4-FFF2-40B4-BE49-F238E27FC236}">
-                <a16:creationId xmlns:a16="http://schemas.microsoft.com/office/drawing/2014/main" id="{23CCA060-B0BA-430F-9AEC-FADFC714AF94}"/>
+                <a16:creationId xmlns:a16="http://schemas.microsoft.com/office/drawing/2014/main" id="{0CBF8771-AE4B-4855-8419-3176707D06CF}"/>
               </a:ext>
             </a:extLst>
           </p:cNvPr>
@@ -6186,7 +6176,7 @@
           <p:cNvPr id="12" name="">
             <a:extLst xmlns:a="http://schemas.openxmlformats.org/drawingml/2006/main">
               <a:ext uri="{FF2B5EF4-FFF2-40B4-BE49-F238E27FC236}">
-                <a16:creationId xmlns:a16="http://schemas.microsoft.com/office/drawing/2014/main" id="{0D74E736-F90F-49A8-B418-0259CE58DE0E}"/>
+                <a16:creationId xmlns:a16="http://schemas.microsoft.com/office/drawing/2014/main" id="{82E6B103-08D7-487B-8436-98C9EC2F9F48}"/>
               </a:ext>
             </a:extLst>
           </p:cNvPr>
@@ -6219,7 +6209,7 @@
           <p:cNvPr id="13" name="">
             <a:extLst xmlns:a="http://schemas.openxmlformats.org/drawingml/2006/main">
               <a:ext uri="{FF2B5EF4-FFF2-40B4-BE49-F238E27FC236}">
-                <a16:creationId xmlns:a16="http://schemas.microsoft.com/office/drawing/2014/main" id="{BD7B1821-2516-4A18-ACE9-77B0391C77FF}"/>
+                <a16:creationId xmlns:a16="http://schemas.microsoft.com/office/drawing/2014/main" id="{354A54C4-8F80-4027-8CF7-F371D089E841}"/>
               </a:ext>
             </a:extLst>
           </p:cNvPr>
@@ -6277,7 +6267,7 @@
           <p:cNvPr id="14" name="">
             <a:extLst xmlns:a="http://schemas.openxmlformats.org/drawingml/2006/main">
               <a:ext uri="{FF2B5EF4-FFF2-40B4-BE49-F238E27FC236}">
-                <a16:creationId xmlns:a16="http://schemas.microsoft.com/office/drawing/2014/main" id="{B87871D9-6A94-4D30-8548-BC0FACC200D1}"/>
+                <a16:creationId xmlns:a16="http://schemas.microsoft.com/office/drawing/2014/main" id="{A779A06A-9BFA-440C-9F0F-966C5EABD2F5}"/>
               </a:ext>
             </a:extLst>
           </p:cNvPr>
@@ -6335,7 +6325,7 @@
           <p:cNvPr id="15" name="">
             <a:extLst xmlns:a="http://schemas.openxmlformats.org/drawingml/2006/main">
               <a:ext uri="{FF2B5EF4-FFF2-40B4-BE49-F238E27FC236}">
-                <a16:creationId xmlns:a16="http://schemas.microsoft.com/office/drawing/2014/main" id="{5CFA351A-921D-4A2E-8713-85293B772A33}"/>
+                <a16:creationId xmlns:a16="http://schemas.microsoft.com/office/drawing/2014/main" id="{6BAB717E-2D81-4201-BC4F-177FFF50C9D6}"/>
               </a:ext>
             </a:extLst>
           </p:cNvPr>
@@ -6393,7 +6383,7 @@
           <p:cNvPr id="16" name="">
             <a:extLst xmlns:a="http://schemas.openxmlformats.org/drawingml/2006/main">
               <a:ext uri="{FF2B5EF4-FFF2-40B4-BE49-F238E27FC236}">
-                <a16:creationId xmlns:a16="http://schemas.microsoft.com/office/drawing/2014/main" id="{D7B809C4-FEA7-4D1D-8509-27EB41DD6979}"/>
+                <a16:creationId xmlns:a16="http://schemas.microsoft.com/office/drawing/2014/main" id="{BB9FB638-3744-4BD1-BC04-E9099C803369}"/>
               </a:ext>
             </a:extLst>
           </p:cNvPr>
@@ -6451,7 +6441,7 @@
           <p:cNvPr id="17" name="">
             <a:extLst xmlns:a="http://schemas.openxmlformats.org/drawingml/2006/main">
               <a:ext uri="{FF2B5EF4-FFF2-40B4-BE49-F238E27FC236}">
-                <a16:creationId xmlns:a16="http://schemas.microsoft.com/office/drawing/2014/main" id="{05163DF2-9163-408B-9951-9F80F9ECB172}"/>
+                <a16:creationId xmlns:a16="http://schemas.microsoft.com/office/drawing/2014/main" id="{3175898F-958F-468C-A9D9-AC2CB6624632}"/>
               </a:ext>
             </a:extLst>
           </p:cNvPr>
@@ -6486,7 +6476,7 @@
           <p:cNvPr id="18" name="">
             <a:extLst xmlns:a="http://schemas.openxmlformats.org/drawingml/2006/main">
               <a:ext uri="{FF2B5EF4-FFF2-40B4-BE49-F238E27FC236}">
-                <a16:creationId xmlns:a16="http://schemas.microsoft.com/office/drawing/2014/main" id="{ACDFB479-6A68-4E4F-8676-A41E68E64928}"/>
+                <a16:creationId xmlns:a16="http://schemas.microsoft.com/office/drawing/2014/main" id="{EEC97B05-9CE3-4D3A-9786-A0D700A9073F}"/>
               </a:ext>
             </a:extLst>
           </p:cNvPr>
@@ -6519,7 +6509,7 @@
           <p:cNvPr id="19" name="">
             <a:extLst xmlns:a="http://schemas.openxmlformats.org/drawingml/2006/main">
               <a:ext uri="{FF2B5EF4-FFF2-40B4-BE49-F238E27FC236}">
-                <a16:creationId xmlns:a16="http://schemas.microsoft.com/office/drawing/2014/main" id="{D6C79DC1-EA49-4B6A-984B-776F11C582F0}"/>
+                <a16:creationId xmlns:a16="http://schemas.microsoft.com/office/drawing/2014/main" id="{08F7440B-4F75-48AA-91FA-AB5506E9131F}"/>
               </a:ext>
             </a:extLst>
           </p:cNvPr>
@@ -6577,7 +6567,7 @@
           <p:cNvPr id="20" name="">
             <a:extLst xmlns:a="http://schemas.openxmlformats.org/drawingml/2006/main">
               <a:ext uri="{FF2B5EF4-FFF2-40B4-BE49-F238E27FC236}">
-                <a16:creationId xmlns:a16="http://schemas.microsoft.com/office/drawing/2014/main" id="{8A3B0328-FA30-452B-8E7D-1A44977AB599}"/>
+                <a16:creationId xmlns:a16="http://schemas.microsoft.com/office/drawing/2014/main" id="{2D6420C3-9C48-4838-BC6E-DF48B6BB5571}"/>
               </a:ext>
             </a:extLst>
           </p:cNvPr>
@@ -6635,7 +6625,7 @@
           <p:cNvPr id="21" name="">
             <a:extLst xmlns:a="http://schemas.openxmlformats.org/drawingml/2006/main">
               <a:ext uri="{FF2B5EF4-FFF2-40B4-BE49-F238E27FC236}">
-                <a16:creationId xmlns:a16="http://schemas.microsoft.com/office/drawing/2014/main" id="{831D0D3D-21E7-41AF-A36E-EC25B0E31712}"/>
+                <a16:creationId xmlns:a16="http://schemas.microsoft.com/office/drawing/2014/main" id="{72186550-ED95-49DB-B622-0E1C6DB91E33}"/>
               </a:ext>
             </a:extLst>
           </p:cNvPr>
@@ -6693,7 +6683,7 @@
           <p:cNvPr id="22" name="">
             <a:extLst xmlns:a="http://schemas.openxmlformats.org/drawingml/2006/main">
               <a:ext uri="{FF2B5EF4-FFF2-40B4-BE49-F238E27FC236}">
-                <a16:creationId xmlns:a16="http://schemas.microsoft.com/office/drawing/2014/main" id="{CBDA7503-E3A6-4207-92F5-5F34F74BC469}"/>
+                <a16:creationId xmlns:a16="http://schemas.microsoft.com/office/drawing/2014/main" id="{E930D6A5-1D84-4740-AF24-21BE5A94F548}"/>
               </a:ext>
             </a:extLst>
           </p:cNvPr>
@@ -6751,7 +6741,7 @@
           <p:cNvPr id="23" name="">
             <a:extLst xmlns:a="http://schemas.openxmlformats.org/drawingml/2006/main">
               <a:ext uri="{FF2B5EF4-FFF2-40B4-BE49-F238E27FC236}">
-                <a16:creationId xmlns:a16="http://schemas.microsoft.com/office/drawing/2014/main" id="{E01DE9E7-FBB0-4ED1-8D63-C977CE2ED8AE}"/>
+                <a16:creationId xmlns:a16="http://schemas.microsoft.com/office/drawing/2014/main" id="{5F1A57C7-741E-4A05-9B89-31BE777B9CDA}"/>
               </a:ext>
             </a:extLst>
           </p:cNvPr>
@@ -6786,7 +6776,7 @@
           <p:cNvPr id="24" name="">
             <a:extLst xmlns:a="http://schemas.openxmlformats.org/drawingml/2006/main">
               <a:ext uri="{FF2B5EF4-FFF2-40B4-BE49-F238E27FC236}">
-                <a16:creationId xmlns:a16="http://schemas.microsoft.com/office/drawing/2014/main" id="{3FB70F43-66AF-49F2-8962-2850D3F19CC4}"/>
+                <a16:creationId xmlns:a16="http://schemas.microsoft.com/office/drawing/2014/main" id="{181E2AC3-FEC6-453B-BE08-A46195B4743A}"/>
               </a:ext>
             </a:extLst>
           </p:cNvPr>
@@ -6819,7 +6809,7 @@
           <p:cNvPr id="25" name="">
             <a:extLst xmlns:a="http://schemas.openxmlformats.org/drawingml/2006/main">
               <a:ext uri="{FF2B5EF4-FFF2-40B4-BE49-F238E27FC236}">
-                <a16:creationId xmlns:a16="http://schemas.microsoft.com/office/drawing/2014/main" id="{D8387D7B-D2BB-47B3-A446-12D83A3FFF61}"/>
+                <a16:creationId xmlns:a16="http://schemas.microsoft.com/office/drawing/2014/main" id="{72733955-385A-4B0E-99ED-E0E844561BB8}"/>
               </a:ext>
             </a:extLst>
           </p:cNvPr>
@@ -6877,7 +6867,7 @@
           <p:cNvPr id="26" name="">
             <a:extLst xmlns:a="http://schemas.openxmlformats.org/drawingml/2006/main">
               <a:ext uri="{FF2B5EF4-FFF2-40B4-BE49-F238E27FC236}">
-                <a16:creationId xmlns:a16="http://schemas.microsoft.com/office/drawing/2014/main" id="{988A2C73-B8F3-4786-B436-4B81DB1C7E2B}"/>
+                <a16:creationId xmlns:a16="http://schemas.microsoft.com/office/drawing/2014/main" id="{3133330A-9D1C-4C97-8E7F-BE0361FC3F87}"/>
               </a:ext>
             </a:extLst>
           </p:cNvPr>
@@ -6935,7 +6925,7 @@
           <p:cNvPr id="27" name="">
             <a:extLst xmlns:a="http://schemas.openxmlformats.org/drawingml/2006/main">
               <a:ext uri="{FF2B5EF4-FFF2-40B4-BE49-F238E27FC236}">
-                <a16:creationId xmlns:a16="http://schemas.microsoft.com/office/drawing/2014/main" id="{8BCADF0A-3CE4-48B2-B73A-AF4C2267BC63}"/>
+                <a16:creationId xmlns:a16="http://schemas.microsoft.com/office/drawing/2014/main" id="{0F8D5872-5D3E-4B59-8B2D-222CE6343FCD}"/>
               </a:ext>
             </a:extLst>
           </p:cNvPr>
@@ -6993,7 +6983,7 @@
           <p:cNvPr id="28" name="">
             <a:extLst xmlns:a="http://schemas.openxmlformats.org/drawingml/2006/main">
               <a:ext uri="{FF2B5EF4-FFF2-40B4-BE49-F238E27FC236}">
-                <a16:creationId xmlns:a16="http://schemas.microsoft.com/office/drawing/2014/main" id="{35DB14B6-753D-455A-88EE-6DA6C0278675}"/>
+                <a16:creationId xmlns:a16="http://schemas.microsoft.com/office/drawing/2014/main" id="{8B75211D-09F5-43DF-B768-1D94B47AB425}"/>
               </a:ext>
             </a:extLst>
           </p:cNvPr>
@@ -7051,7 +7041,7 @@
           <p:cNvPr id="29" name="">
             <a:extLst xmlns:a="http://schemas.openxmlformats.org/drawingml/2006/main">
               <a:ext uri="{FF2B5EF4-FFF2-40B4-BE49-F238E27FC236}">
-                <a16:creationId xmlns:a16="http://schemas.microsoft.com/office/drawing/2014/main" id="{11851F2E-3DB5-4505-B302-8D9DF786007D}"/>
+                <a16:creationId xmlns:a16="http://schemas.microsoft.com/office/drawing/2014/main" id="{9D3805F9-3486-4FA1-B441-E988BEFBC7C6}"/>
               </a:ext>
             </a:extLst>
           </p:cNvPr>
@@ -7099,7 +7089,7 @@
                 <a:ea typeface="Aptos"/>
                 <a:cs typeface="Aptos"/>
               </a:rPr>
-              <a:t>WATERS NEXT GEN COMPETITIVE INTELLIGENCE · 23 AUG 2026 · waters-ci-20260820104036</a:t>
+              <a:t>WATERS NEXT GEN COMPETITIVE INTELLIGENCE · 08 SEP 2026 · waters-ci-20260909030324</a:t>
             </a:r>
           </a:p>
         </p:txBody>
@@ -7109,7 +7099,7 @@
           <p:cNvPr id="30" name="">
             <a:extLst xmlns:a="http://schemas.openxmlformats.org/drawingml/2006/main">
               <a:ext uri="{FF2B5EF4-FFF2-40B4-BE49-F238E27FC236}">
-                <a16:creationId xmlns:a16="http://schemas.microsoft.com/office/drawing/2014/main" id="{8378B022-67C0-40D1-9CC5-511CE0E34E64}"/>
+                <a16:creationId xmlns:a16="http://schemas.microsoft.com/office/drawing/2014/main" id="{0546C7E6-58B9-448D-AB3D-A6BD3DE592B0}"/>
               </a:ext>
             </a:extLst>
           </p:cNvPr>
@@ -7165,7 +7155,7 @@
     </p:spTree>
     <p:extLst>
       <p:ext uri="{BB962C8B-B14F-4D97-AF65-F5344CB8AC3E}">
-        <p14:creationId xmlns:p14="http://schemas.microsoft.com/office/powerpoint/2010/main" val="1835208491"/>
+        <p14:creationId xmlns:p14="http://schemas.microsoft.com/office/powerpoint/2010/main" val="597419331"/>
       </p:ext>
     </p:extLst>
   </p:cSld>
@@ -7196,7 +7186,7 @@
           <p:cNvPr id="17" name="">
             <a:extLst xmlns:a="http://schemas.openxmlformats.org/drawingml/2006/main">
               <a:ext uri="{FF2B5EF4-FFF2-40B4-BE49-F238E27FC236}">
-                <a16:creationId xmlns:a16="http://schemas.microsoft.com/office/drawing/2014/main" id="{13F76A70-9E12-4CD1-85D3-D5B6CDE40616}"/>
+                <a16:creationId xmlns:a16="http://schemas.microsoft.com/office/drawing/2014/main" id="{812C675F-A60F-4BDC-8A5B-5CE95F98819F}"/>
               </a:ext>
             </a:extLst>
           </p:cNvPr>
@@ -7254,7 +7244,7 @@
           <p:cNvPr id="2" name="">
             <a:extLst xmlns:a="http://schemas.openxmlformats.org/drawingml/2006/main">
               <a:ext uri="{FF2B5EF4-FFF2-40B4-BE49-F238E27FC236}">
-                <a16:creationId xmlns:a16="http://schemas.microsoft.com/office/drawing/2014/main" id="{AFED4C1C-55AF-48BA-867A-65A2E16C612A}"/>
+                <a16:creationId xmlns:a16="http://schemas.microsoft.com/office/drawing/2014/main" id="{0E4E539D-C354-420D-B2EF-A7E8482859C3}"/>
               </a:ext>
             </a:extLst>
           </p:cNvPr>
@@ -7312,7 +7302,7 @@
           <p:cNvPr id="3" name="">
             <a:extLst xmlns:a="http://schemas.openxmlformats.org/drawingml/2006/main">
               <a:ext uri="{FF2B5EF4-FFF2-40B4-BE49-F238E27FC236}">
-                <a16:creationId xmlns:a16="http://schemas.microsoft.com/office/drawing/2014/main" id="{A3AB8350-7329-4246-98C6-BBB52B9E20C1}"/>
+                <a16:creationId xmlns:a16="http://schemas.microsoft.com/office/drawing/2014/main" id="{187B6C6B-8B84-434F-9A90-0FEEE9162425}"/>
               </a:ext>
             </a:extLst>
           </p:cNvPr>
@@ -7370,7 +7360,7 @@
           <p:cNvPr id="4" name="">
             <a:extLst xmlns:a="http://schemas.openxmlformats.org/drawingml/2006/main">
               <a:ext uri="{FF2B5EF4-FFF2-40B4-BE49-F238E27FC236}">
-                <a16:creationId xmlns:a16="http://schemas.microsoft.com/office/drawing/2014/main" id="{FE28304C-D0C5-4EE1-AA98-082D86F2359C}"/>
+                <a16:creationId xmlns:a16="http://schemas.microsoft.com/office/drawing/2014/main" id="{2CB0DFC1-95AA-4571-BFB1-0CE7DD808D2E}"/>
               </a:ext>
             </a:extLst>
           </p:cNvPr>
@@ -7403,7 +7393,7 @@
           <p:cNvPr id="5" name="">
             <a:extLst xmlns:a="http://schemas.openxmlformats.org/drawingml/2006/main">
               <a:ext uri="{FF2B5EF4-FFF2-40B4-BE49-F238E27FC236}">
-                <a16:creationId xmlns:a16="http://schemas.microsoft.com/office/drawing/2014/main" id="{8B790196-516E-423A-BA51-85E9E00353B0}"/>
+                <a16:creationId xmlns:a16="http://schemas.microsoft.com/office/drawing/2014/main" id="{98586857-327A-4266-B333-25105DFD5CE2}"/>
               </a:ext>
             </a:extLst>
           </p:cNvPr>
@@ -7438,7 +7428,7 @@
           <p:cNvPr id="6" name="">
             <a:extLst xmlns:a="http://schemas.openxmlformats.org/drawingml/2006/main">
               <a:ext uri="{FF2B5EF4-FFF2-40B4-BE49-F238E27FC236}">
-                <a16:creationId xmlns:a16="http://schemas.microsoft.com/office/drawing/2014/main" id="{E340163A-C5BF-4073-8DE3-206FF2EE15CB}"/>
+                <a16:creationId xmlns:a16="http://schemas.microsoft.com/office/drawing/2014/main" id="{8C8648ED-BFB2-4C1F-AD01-81BA6A6E0B6E}"/>
               </a:ext>
             </a:extLst>
           </p:cNvPr>
@@ -7496,7 +7486,7 @@
           <p:cNvPr id="7" name="">
             <a:extLst xmlns:a="http://schemas.openxmlformats.org/drawingml/2006/main">
               <a:ext uri="{FF2B5EF4-FFF2-40B4-BE49-F238E27FC236}">
-                <a16:creationId xmlns:a16="http://schemas.microsoft.com/office/drawing/2014/main" id="{2CE900DC-BEC5-45BC-9E80-FEE74D7BAE70}"/>
+                <a16:creationId xmlns:a16="http://schemas.microsoft.com/office/drawing/2014/main" id="{4919631C-C2AD-4557-AA4D-AC040C2371D7}"/>
               </a:ext>
             </a:extLst>
           </p:cNvPr>
@@ -7554,7 +7544,7 @@
           <p:cNvPr id="8" name="">
             <a:extLst xmlns:a="http://schemas.openxmlformats.org/drawingml/2006/main">
               <a:ext uri="{FF2B5EF4-FFF2-40B4-BE49-F238E27FC236}">
-                <a16:creationId xmlns:a16="http://schemas.microsoft.com/office/drawing/2014/main" id="{93AFDA85-1180-4297-AA99-6E9826076AA1}"/>
+                <a16:creationId xmlns:a16="http://schemas.microsoft.com/office/drawing/2014/main" id="{D77E9DC8-B3BE-4ADC-8E97-8542C6C70AA7}"/>
               </a:ext>
             </a:extLst>
           </p:cNvPr>
@@ -7612,7 +7602,7 @@
           <p:cNvPr id="9" name="">
             <a:extLst xmlns:a="http://schemas.openxmlformats.org/drawingml/2006/main">
               <a:ext uri="{FF2B5EF4-FFF2-40B4-BE49-F238E27FC236}">
-                <a16:creationId xmlns:a16="http://schemas.microsoft.com/office/drawing/2014/main" id="{66C2D2F7-4924-4D18-8FE5-238887F28352}"/>
+                <a16:creationId xmlns:a16="http://schemas.microsoft.com/office/drawing/2014/main" id="{C8F991A1-EF10-4379-AC86-1F5716361A04}"/>
               </a:ext>
             </a:extLst>
           </p:cNvPr>
@@ -7693,7 +7683,7 @@
           <p:cNvPr id="10" name="">
             <a:extLst xmlns:a="http://schemas.openxmlformats.org/drawingml/2006/main">
               <a:ext uri="{FF2B5EF4-FFF2-40B4-BE49-F238E27FC236}">
-                <a16:creationId xmlns:a16="http://schemas.microsoft.com/office/drawing/2014/main" id="{0D7BF52D-B542-490C-A5BE-1F0DC1823220}"/>
+                <a16:creationId xmlns:a16="http://schemas.microsoft.com/office/drawing/2014/main" id="{56E32CD9-2944-4A68-8D6C-9585B853FC5E}"/>
               </a:ext>
             </a:extLst>
           </p:cNvPr>
@@ -7728,7 +7718,7 @@
           <p:cNvPr id="11" name="">
             <a:extLst xmlns:a="http://schemas.openxmlformats.org/drawingml/2006/main">
               <a:ext uri="{FF2B5EF4-FFF2-40B4-BE49-F238E27FC236}">
-                <a16:creationId xmlns:a16="http://schemas.microsoft.com/office/drawing/2014/main" id="{152799C3-A769-4E66-B512-40E04C2C3BC3}"/>
+                <a16:creationId xmlns:a16="http://schemas.microsoft.com/office/drawing/2014/main" id="{BD94B9FE-1302-4EA6-8C64-890E4CE4F4B3}"/>
               </a:ext>
             </a:extLst>
           </p:cNvPr>
@@ -7786,7 +7776,7 @@
           <p:cNvPr id="12" name="">
             <a:extLst xmlns:a="http://schemas.openxmlformats.org/drawingml/2006/main">
               <a:ext uri="{FF2B5EF4-FFF2-40B4-BE49-F238E27FC236}">
-                <a16:creationId xmlns:a16="http://schemas.microsoft.com/office/drawing/2014/main" id="{9B281AEB-2CB9-45E4-A866-82AEEAC2C34B}"/>
+                <a16:creationId xmlns:a16="http://schemas.microsoft.com/office/drawing/2014/main" id="{1B6DFD02-542C-4729-A600-4086F6CAF1E2}"/>
               </a:ext>
             </a:extLst>
           </p:cNvPr>
@@ -7844,7 +7834,7 @@
           <p:cNvPr id="13" name="">
             <a:extLst xmlns:a="http://schemas.openxmlformats.org/drawingml/2006/main">
               <a:ext uri="{FF2B5EF4-FFF2-40B4-BE49-F238E27FC236}">
-                <a16:creationId xmlns:a16="http://schemas.microsoft.com/office/drawing/2014/main" id="{1F3435AF-D0B9-42C3-AE69-02DDF592070C}"/>
+                <a16:creationId xmlns:a16="http://schemas.microsoft.com/office/drawing/2014/main" id="{5481FC40-EC03-4935-9E0F-8DF5CCD5D00E}"/>
               </a:ext>
             </a:extLst>
           </p:cNvPr>
@@ -7902,7 +7892,7 @@
           <p:cNvPr id="14" name="">
             <a:extLst xmlns:a="http://schemas.openxmlformats.org/drawingml/2006/main">
               <a:ext uri="{FF2B5EF4-FFF2-40B4-BE49-F238E27FC236}">
-                <a16:creationId xmlns:a16="http://schemas.microsoft.com/office/drawing/2014/main" id="{9F4D3C59-A541-4FEA-BC6C-6978F38E40D4}"/>
+                <a16:creationId xmlns:a16="http://schemas.microsoft.com/office/drawing/2014/main" id="{89A84237-4DD5-4C1B-8D56-84F42D0A7FDD}"/>
               </a:ext>
             </a:extLst>
           </p:cNvPr>
@@ -8006,7 +7996,7 @@
           <p:cNvPr id="15" name="">
             <a:extLst xmlns:a="http://schemas.openxmlformats.org/drawingml/2006/main">
               <a:ext uri="{FF2B5EF4-FFF2-40B4-BE49-F238E27FC236}">
-                <a16:creationId xmlns:a16="http://schemas.microsoft.com/office/drawing/2014/main" id="{188A7A28-8D89-492B-9E59-28D038EE06D5}"/>
+                <a16:creationId xmlns:a16="http://schemas.microsoft.com/office/drawing/2014/main" id="{C3028690-D994-4E73-9C7B-F3D8DE864F4B}"/>
               </a:ext>
             </a:extLst>
           </p:cNvPr>
@@ -8054,7 +8044,7 @@
                 <a:ea typeface="Aptos"/>
                 <a:cs typeface="Aptos"/>
               </a:rPr>
-              <a:t>WATERS NEXT GEN COMPETITIVE INTELLIGENCE · 23 AUG 2026 · waters-ci-20260820104036</a:t>
+              <a:t>WATERS NEXT GEN COMPETITIVE INTELLIGENCE · 08 SEP 2026 · waters-ci-20260909030324</a:t>
             </a:r>
           </a:p>
         </p:txBody>
@@ -8064,7 +8054,7 @@
           <p:cNvPr id="16" name="">
             <a:extLst xmlns:a="http://schemas.openxmlformats.org/drawingml/2006/main">
               <a:ext uri="{FF2B5EF4-FFF2-40B4-BE49-F238E27FC236}">
-                <a16:creationId xmlns:a16="http://schemas.microsoft.com/office/drawing/2014/main" id="{56B1F886-CF5A-4B67-9E1F-A31D1AE824C7}"/>
+                <a16:creationId xmlns:a16="http://schemas.microsoft.com/office/drawing/2014/main" id="{8CA19DED-5AC6-4C8C-A158-50900A0E45D0}"/>
               </a:ext>
             </a:extLst>
           </p:cNvPr>
@@ -8120,7 +8110,7 @@
     </p:spTree>
     <p:extLst>
       <p:ext uri="{BB962C8B-B14F-4D97-AF65-F5344CB8AC3E}">
-        <p14:creationId xmlns:p14="http://schemas.microsoft.com/office/powerpoint/2010/main" val="1763329019"/>
+        <p14:creationId xmlns:p14="http://schemas.microsoft.com/office/powerpoint/2010/main" val="1640282933"/>
       </p:ext>
     </p:extLst>
   </p:cSld>
@@ -8151,7 +8141,7 @@
           <p:cNvPr id="37" name="">
             <a:extLst xmlns:a="http://schemas.openxmlformats.org/drawingml/2006/main">
               <a:ext uri="{FF2B5EF4-FFF2-40B4-BE49-F238E27FC236}">
-                <a16:creationId xmlns:a16="http://schemas.microsoft.com/office/drawing/2014/main" id="{F03C5B79-2721-4831-B2FF-53F3F370C3C4}"/>
+                <a16:creationId xmlns:a16="http://schemas.microsoft.com/office/drawing/2014/main" id="{DD36E7DF-A606-425A-981C-2E05398B2551}"/>
               </a:ext>
             </a:extLst>
           </p:cNvPr>
@@ -8209,7 +8199,7 @@
           <p:cNvPr id="2" name="">
             <a:extLst xmlns:a="http://schemas.openxmlformats.org/drawingml/2006/main">
               <a:ext uri="{FF2B5EF4-FFF2-40B4-BE49-F238E27FC236}">
-                <a16:creationId xmlns:a16="http://schemas.microsoft.com/office/drawing/2014/main" id="{C2DA951B-9D25-47B4-9C20-FEB6999EE5D3}"/>
+                <a16:creationId xmlns:a16="http://schemas.microsoft.com/office/drawing/2014/main" id="{F598DCF4-11D6-4C25-BF6E-0FEFF8A0C1E6}"/>
               </a:ext>
             </a:extLst>
           </p:cNvPr>
@@ -8267,7 +8257,7 @@
           <p:cNvPr id="3" name="">
             <a:extLst xmlns:a="http://schemas.openxmlformats.org/drawingml/2006/main">
               <a:ext uri="{FF2B5EF4-FFF2-40B4-BE49-F238E27FC236}">
-                <a16:creationId xmlns:a16="http://schemas.microsoft.com/office/drawing/2014/main" id="{B34D7B53-E11D-458C-8269-F97BD8FDB890}"/>
+                <a16:creationId xmlns:a16="http://schemas.microsoft.com/office/drawing/2014/main" id="{DA8B72B2-A7A7-40D1-9470-2767EC1CA8EF}"/>
               </a:ext>
             </a:extLst>
           </p:cNvPr>
@@ -8325,7 +8315,7 @@
           <p:cNvPr id="4" name="">
             <a:extLst xmlns:a="http://schemas.openxmlformats.org/drawingml/2006/main">
               <a:ext uri="{FF2B5EF4-FFF2-40B4-BE49-F238E27FC236}">
-                <a16:creationId xmlns:a16="http://schemas.microsoft.com/office/drawing/2014/main" id="{2976DFA8-85F7-4524-9D7C-CDE9971C8A80}"/>
+                <a16:creationId xmlns:a16="http://schemas.microsoft.com/office/drawing/2014/main" id="{1B9CD9A9-21B1-462B-80F9-E328FC585CE0}"/>
               </a:ext>
             </a:extLst>
           </p:cNvPr>
@@ -8358,7 +8348,7 @@
           <p:cNvPr id="5" name="">
             <a:extLst xmlns:a="http://schemas.openxmlformats.org/drawingml/2006/main">
               <a:ext uri="{FF2B5EF4-FFF2-40B4-BE49-F238E27FC236}">
-                <a16:creationId xmlns:a16="http://schemas.microsoft.com/office/drawing/2014/main" id="{7D03E38B-BB3B-492B-B5E1-757553FA0DE8}"/>
+                <a16:creationId xmlns:a16="http://schemas.microsoft.com/office/drawing/2014/main" id="{6D6821B2-744A-4028-A819-B729183EE17D}"/>
               </a:ext>
             </a:extLst>
           </p:cNvPr>
@@ -8393,7 +8383,7 @@
           <p:cNvPr id="6" name="">
             <a:extLst xmlns:a="http://schemas.openxmlformats.org/drawingml/2006/main">
               <a:ext uri="{FF2B5EF4-FFF2-40B4-BE49-F238E27FC236}">
-                <a16:creationId xmlns:a16="http://schemas.microsoft.com/office/drawing/2014/main" id="{1A18C4A0-8AE5-4EA4-AED0-19DC2FF02EC7}"/>
+                <a16:creationId xmlns:a16="http://schemas.microsoft.com/office/drawing/2014/main" id="{54585FE8-04A7-4987-A477-422B5DCD6829}"/>
               </a:ext>
             </a:extLst>
           </p:cNvPr>
@@ -8426,7 +8416,7 @@
           <p:cNvPr id="7" name="">
             <a:extLst xmlns:a="http://schemas.openxmlformats.org/drawingml/2006/main">
               <a:ext uri="{FF2B5EF4-FFF2-40B4-BE49-F238E27FC236}">
-                <a16:creationId xmlns:a16="http://schemas.microsoft.com/office/drawing/2014/main" id="{44C3AAF6-9C51-4ADF-A420-581D7B8D3AC0}"/>
+                <a16:creationId xmlns:a16="http://schemas.microsoft.com/office/drawing/2014/main" id="{7994E29C-23C6-41C5-A113-6250C6E24274}"/>
               </a:ext>
             </a:extLst>
           </p:cNvPr>
@@ -8484,7 +8474,7 @@
           <p:cNvPr id="8" name="">
             <a:extLst xmlns:a="http://schemas.openxmlformats.org/drawingml/2006/main">
               <a:ext uri="{FF2B5EF4-FFF2-40B4-BE49-F238E27FC236}">
-                <a16:creationId xmlns:a16="http://schemas.microsoft.com/office/drawing/2014/main" id="{FB4A736D-A992-48B1-9960-F07A6D52AE3E}"/>
+                <a16:creationId xmlns:a16="http://schemas.microsoft.com/office/drawing/2014/main" id="{56E87CD3-9A04-44A6-8F03-DCFC8911B429}"/>
               </a:ext>
             </a:extLst>
           </p:cNvPr>
@@ -8542,7 +8532,7 @@
           <p:cNvPr id="9" name="">
             <a:extLst xmlns:a="http://schemas.openxmlformats.org/drawingml/2006/main">
               <a:ext uri="{FF2B5EF4-FFF2-40B4-BE49-F238E27FC236}">
-                <a16:creationId xmlns:a16="http://schemas.microsoft.com/office/drawing/2014/main" id="{8A1FF304-1899-46C2-ADFD-8EDE500C36FE}"/>
+                <a16:creationId xmlns:a16="http://schemas.microsoft.com/office/drawing/2014/main" id="{DA15368F-63B9-4C0F-885E-D8E055647BFF}"/>
               </a:ext>
             </a:extLst>
           </p:cNvPr>
@@ -8600,7 +8590,7 @@
           <p:cNvPr id="10" name="">
             <a:extLst xmlns:a="http://schemas.openxmlformats.org/drawingml/2006/main">
               <a:ext uri="{FF2B5EF4-FFF2-40B4-BE49-F238E27FC236}">
-                <a16:creationId xmlns:a16="http://schemas.microsoft.com/office/drawing/2014/main" id="{E0B0B09F-8108-4236-8914-542ECDE7DF2C}"/>
+                <a16:creationId xmlns:a16="http://schemas.microsoft.com/office/drawing/2014/main" id="{0AFCA8E5-4599-4967-8BA5-39DA0B3726B7}"/>
               </a:ext>
             </a:extLst>
           </p:cNvPr>
@@ -8658,7 +8648,7 @@
           <p:cNvPr id="11" name="">
             <a:extLst xmlns:a="http://schemas.openxmlformats.org/drawingml/2006/main">
               <a:ext uri="{FF2B5EF4-FFF2-40B4-BE49-F238E27FC236}">
-                <a16:creationId xmlns:a16="http://schemas.microsoft.com/office/drawing/2014/main" id="{3D801700-A21C-48BC-8A4B-CAFAC3EA05C8}"/>
+                <a16:creationId xmlns:a16="http://schemas.microsoft.com/office/drawing/2014/main" id="{69C790FF-3F5D-4981-A581-E7C5E3353F5D}"/>
               </a:ext>
             </a:extLst>
           </p:cNvPr>
@@ -8691,7 +8681,7 @@
           <p:cNvPr id="12" name="">
             <a:extLst xmlns:a="http://schemas.openxmlformats.org/drawingml/2006/main">
               <a:ext uri="{FF2B5EF4-FFF2-40B4-BE49-F238E27FC236}">
-                <a16:creationId xmlns:a16="http://schemas.microsoft.com/office/drawing/2014/main" id="{95C91568-F045-43E4-9240-763C28CDE27D}"/>
+                <a16:creationId xmlns:a16="http://schemas.microsoft.com/office/drawing/2014/main" id="{6129B736-5AFB-4DAE-970F-0F599A86926D}"/>
               </a:ext>
             </a:extLst>
           </p:cNvPr>
@@ -8749,7 +8739,7 @@
           <p:cNvPr id="13" name="">
             <a:extLst xmlns:a="http://schemas.openxmlformats.org/drawingml/2006/main">
               <a:ext uri="{FF2B5EF4-FFF2-40B4-BE49-F238E27FC236}">
-                <a16:creationId xmlns:a16="http://schemas.microsoft.com/office/drawing/2014/main" id="{6297C0C5-BC54-4CBA-BEF1-4BB380DCBAE4}"/>
+                <a16:creationId xmlns:a16="http://schemas.microsoft.com/office/drawing/2014/main" id="{59AC6582-D35D-48BC-8744-D5F4F620559F}"/>
               </a:ext>
             </a:extLst>
           </p:cNvPr>
@@ -8807,7 +8797,7 @@
           <p:cNvPr id="14" name="">
             <a:extLst xmlns:a="http://schemas.openxmlformats.org/drawingml/2006/main">
               <a:ext uri="{FF2B5EF4-FFF2-40B4-BE49-F238E27FC236}">
-                <a16:creationId xmlns:a16="http://schemas.microsoft.com/office/drawing/2014/main" id="{DA901248-ECE7-4560-B6B9-A8C10798C1F3}"/>
+                <a16:creationId xmlns:a16="http://schemas.microsoft.com/office/drawing/2014/main" id="{32A08DE1-1483-4214-A80D-E60AF4287535}"/>
               </a:ext>
             </a:extLst>
           </p:cNvPr>
@@ -8865,7 +8855,7 @@
           <p:cNvPr id="15" name="">
             <a:extLst xmlns:a="http://schemas.openxmlformats.org/drawingml/2006/main">
               <a:ext uri="{FF2B5EF4-FFF2-40B4-BE49-F238E27FC236}">
-                <a16:creationId xmlns:a16="http://schemas.microsoft.com/office/drawing/2014/main" id="{9DD6F60D-21BF-400E-934E-25EA39F34F5D}"/>
+                <a16:creationId xmlns:a16="http://schemas.microsoft.com/office/drawing/2014/main" id="{A3F74913-A3EF-4359-8C66-30F8CDAA79EC}"/>
               </a:ext>
             </a:extLst>
           </p:cNvPr>
@@ -8900,7 +8890,7 @@
           <p:cNvPr id="16" name="">
             <a:extLst xmlns:a="http://schemas.openxmlformats.org/drawingml/2006/main">
               <a:ext uri="{FF2B5EF4-FFF2-40B4-BE49-F238E27FC236}">
-                <a16:creationId xmlns:a16="http://schemas.microsoft.com/office/drawing/2014/main" id="{61C4A74B-CD41-46B2-833E-9CB717958DDB}"/>
+                <a16:creationId xmlns:a16="http://schemas.microsoft.com/office/drawing/2014/main" id="{79651A8C-9692-4C48-955C-D3185BBD8D09}"/>
               </a:ext>
             </a:extLst>
           </p:cNvPr>
@@ -8933,7 +8923,7 @@
           <p:cNvPr id="17" name="">
             <a:extLst xmlns:a="http://schemas.openxmlformats.org/drawingml/2006/main">
               <a:ext uri="{FF2B5EF4-FFF2-40B4-BE49-F238E27FC236}">
-                <a16:creationId xmlns:a16="http://schemas.microsoft.com/office/drawing/2014/main" id="{7F027D94-96C6-4051-8106-E6DD48886FB4}"/>
+                <a16:creationId xmlns:a16="http://schemas.microsoft.com/office/drawing/2014/main" id="{70F4C76E-03D9-4F38-A342-91A9563745C3}"/>
               </a:ext>
             </a:extLst>
           </p:cNvPr>
@@ -8991,7 +8981,7 @@
           <p:cNvPr id="18" name="">
             <a:extLst xmlns:a="http://schemas.openxmlformats.org/drawingml/2006/main">
               <a:ext uri="{FF2B5EF4-FFF2-40B4-BE49-F238E27FC236}">
-                <a16:creationId xmlns:a16="http://schemas.microsoft.com/office/drawing/2014/main" id="{0DA9AFFE-059F-4E59-BF05-1930DCD79A26}"/>
+                <a16:creationId xmlns:a16="http://schemas.microsoft.com/office/drawing/2014/main" id="{D0A8FD67-73AB-4449-B89B-DA8231560B67}"/>
               </a:ext>
             </a:extLst>
           </p:cNvPr>
@@ -9049,7 +9039,7 @@
           <p:cNvPr id="19" name="">
             <a:extLst xmlns:a="http://schemas.openxmlformats.org/drawingml/2006/main">
               <a:ext uri="{FF2B5EF4-FFF2-40B4-BE49-F238E27FC236}">
-                <a16:creationId xmlns:a16="http://schemas.microsoft.com/office/drawing/2014/main" id="{20BD726C-9A43-4E1D-A349-C26D21BA7895}"/>
+                <a16:creationId xmlns:a16="http://schemas.microsoft.com/office/drawing/2014/main" id="{B11AC53B-136F-459E-852E-0365BCB9D797}"/>
               </a:ext>
             </a:extLst>
           </p:cNvPr>
@@ -9097,7 +9087,7 @@
                 <a:ea typeface="Aptos"/>
                 <a:cs typeface="Aptos"/>
               </a:rPr>
-              <a:t>63/100</a:t>
+              <a:t>59/100</a:t>
             </a:r>
           </a:p>
         </p:txBody>
@@ -9107,7 +9097,7 @@
           <p:cNvPr id="20" name="">
             <a:extLst xmlns:a="http://schemas.openxmlformats.org/drawingml/2006/main">
               <a:ext uri="{FF2B5EF4-FFF2-40B4-BE49-F238E27FC236}">
-                <a16:creationId xmlns:a16="http://schemas.microsoft.com/office/drawing/2014/main" id="{9B3DBB0E-FA4E-49CB-89E3-8205A2FCE9D7}"/>
+                <a16:creationId xmlns:a16="http://schemas.microsoft.com/office/drawing/2014/main" id="{29F92417-F2A9-4D24-9D92-B622581FC1E9}"/>
               </a:ext>
             </a:extLst>
           </p:cNvPr>
@@ -9165,7 +9155,7 @@
           <p:cNvPr id="21" name="">
             <a:extLst xmlns:a="http://schemas.openxmlformats.org/drawingml/2006/main">
               <a:ext uri="{FF2B5EF4-FFF2-40B4-BE49-F238E27FC236}">
-                <a16:creationId xmlns:a16="http://schemas.microsoft.com/office/drawing/2014/main" id="{0FEE1F48-EEA6-442F-AD9D-99EEB9FBA47C}"/>
+                <a16:creationId xmlns:a16="http://schemas.microsoft.com/office/drawing/2014/main" id="{97539F60-52AA-4F52-81F6-CBD87819AE52}"/>
               </a:ext>
             </a:extLst>
           </p:cNvPr>
@@ -9198,7 +9188,7 @@
           <p:cNvPr id="22" name="">
             <a:extLst xmlns:a="http://schemas.openxmlformats.org/drawingml/2006/main">
               <a:ext uri="{FF2B5EF4-FFF2-40B4-BE49-F238E27FC236}">
-                <a16:creationId xmlns:a16="http://schemas.microsoft.com/office/drawing/2014/main" id="{B9F923EF-7CB7-4F7B-86D6-C464F19780FA}"/>
+                <a16:creationId xmlns:a16="http://schemas.microsoft.com/office/drawing/2014/main" id="{181B8002-8459-485F-81A8-A6D705D038D3}"/>
               </a:ext>
             </a:extLst>
           </p:cNvPr>
@@ -9256,7 +9246,7 @@
           <p:cNvPr id="23" name="">
             <a:extLst xmlns:a="http://schemas.openxmlformats.org/drawingml/2006/main">
               <a:ext uri="{FF2B5EF4-FFF2-40B4-BE49-F238E27FC236}">
-                <a16:creationId xmlns:a16="http://schemas.microsoft.com/office/drawing/2014/main" id="{EBFEE523-329E-4446-8753-30663FB3EE3B}"/>
+                <a16:creationId xmlns:a16="http://schemas.microsoft.com/office/drawing/2014/main" id="{C6399A75-23D9-4984-B962-620498BBC0FD}"/>
               </a:ext>
             </a:extLst>
           </p:cNvPr>
@@ -9314,7 +9304,7 @@
           <p:cNvPr id="24" name="">
             <a:extLst xmlns:a="http://schemas.openxmlformats.org/drawingml/2006/main">
               <a:ext uri="{FF2B5EF4-FFF2-40B4-BE49-F238E27FC236}">
-                <a16:creationId xmlns:a16="http://schemas.microsoft.com/office/drawing/2014/main" id="{6E0AB0B1-514B-4159-B12F-C966C581D10F}"/>
+                <a16:creationId xmlns:a16="http://schemas.microsoft.com/office/drawing/2014/main" id="{E4AAAC38-6634-4A03-BBDC-CC1894B4A38B}"/>
               </a:ext>
             </a:extLst>
           </p:cNvPr>
@@ -9372,7 +9362,7 @@
           <p:cNvPr id="25" name="">
             <a:extLst xmlns:a="http://schemas.openxmlformats.org/drawingml/2006/main">
               <a:ext uri="{FF2B5EF4-FFF2-40B4-BE49-F238E27FC236}">
-                <a16:creationId xmlns:a16="http://schemas.microsoft.com/office/drawing/2014/main" id="{8985191D-EE81-4341-8A30-06166C8F89F9}"/>
+                <a16:creationId xmlns:a16="http://schemas.microsoft.com/office/drawing/2014/main" id="{8B81254A-B588-46E3-A6E2-DAF711551FE3}"/>
               </a:ext>
             </a:extLst>
           </p:cNvPr>
@@ -9407,7 +9397,7 @@
           <p:cNvPr id="26" name="">
             <a:extLst xmlns:a="http://schemas.openxmlformats.org/drawingml/2006/main">
               <a:ext uri="{FF2B5EF4-FFF2-40B4-BE49-F238E27FC236}">
-                <a16:creationId xmlns:a16="http://schemas.microsoft.com/office/drawing/2014/main" id="{F8E048B0-8639-46AF-875A-1BA1EA77050A}"/>
+                <a16:creationId xmlns:a16="http://schemas.microsoft.com/office/drawing/2014/main" id="{E5FAE185-9AE1-4FA3-A70C-EFACE3939BC4}"/>
               </a:ext>
             </a:extLst>
           </p:cNvPr>
@@ -9440,7 +9430,7 @@
           <p:cNvPr id="27" name="">
             <a:extLst xmlns:a="http://schemas.openxmlformats.org/drawingml/2006/main">
               <a:ext uri="{FF2B5EF4-FFF2-40B4-BE49-F238E27FC236}">
-                <a16:creationId xmlns:a16="http://schemas.microsoft.com/office/drawing/2014/main" id="{C8CDA726-9E12-41F0-96A8-22C4FA9096A5}"/>
+                <a16:creationId xmlns:a16="http://schemas.microsoft.com/office/drawing/2014/main" id="{33DDB467-432E-4992-82A8-51108E762B12}"/>
               </a:ext>
             </a:extLst>
           </p:cNvPr>
@@ -9498,7 +9488,7 @@
           <p:cNvPr id="28" name="">
             <a:extLst xmlns:a="http://schemas.openxmlformats.org/drawingml/2006/main">
               <a:ext uri="{FF2B5EF4-FFF2-40B4-BE49-F238E27FC236}">
-                <a16:creationId xmlns:a16="http://schemas.microsoft.com/office/drawing/2014/main" id="{392D58CC-8B35-408C-ADBE-FA823A7DCEE0}"/>
+                <a16:creationId xmlns:a16="http://schemas.microsoft.com/office/drawing/2014/main" id="{30B8A807-11FD-4BAA-9B6A-23B465515274}"/>
               </a:ext>
             </a:extLst>
           </p:cNvPr>
@@ -9556,7 +9546,7 @@
           <p:cNvPr id="29" name="">
             <a:extLst xmlns:a="http://schemas.openxmlformats.org/drawingml/2006/main">
               <a:ext uri="{FF2B5EF4-FFF2-40B4-BE49-F238E27FC236}">
-                <a16:creationId xmlns:a16="http://schemas.microsoft.com/office/drawing/2014/main" id="{2240FD40-EDA0-4D30-A2A5-E581338575C0}"/>
+                <a16:creationId xmlns:a16="http://schemas.microsoft.com/office/drawing/2014/main" id="{3EB68402-E958-403D-9BEA-DC61D96AF2EB}"/>
               </a:ext>
             </a:extLst>
           </p:cNvPr>
@@ -9614,7 +9604,7 @@
           <p:cNvPr id="30" name="">
             <a:extLst xmlns:a="http://schemas.openxmlformats.org/drawingml/2006/main">
               <a:ext uri="{FF2B5EF4-FFF2-40B4-BE49-F238E27FC236}">
-                <a16:creationId xmlns:a16="http://schemas.microsoft.com/office/drawing/2014/main" id="{4A0271AA-2915-40D4-9888-284453AA324A}"/>
+                <a16:creationId xmlns:a16="http://schemas.microsoft.com/office/drawing/2014/main" id="{D10167B4-38B5-4636-8538-8DE79E0D1B95}"/>
               </a:ext>
             </a:extLst>
           </p:cNvPr>
@@ -9672,7 +9662,7 @@
           <p:cNvPr id="31" name="">
             <a:extLst xmlns:a="http://schemas.openxmlformats.org/drawingml/2006/main">
               <a:ext uri="{FF2B5EF4-FFF2-40B4-BE49-F238E27FC236}">
-                <a16:creationId xmlns:a16="http://schemas.microsoft.com/office/drawing/2014/main" id="{89931BA9-B054-4155-A347-6607FB415BFC}"/>
+                <a16:creationId xmlns:a16="http://schemas.microsoft.com/office/drawing/2014/main" id="{3A1A602A-F0B9-4AAF-9B8D-A9570F1C5BC2}"/>
               </a:ext>
             </a:extLst>
           </p:cNvPr>
@@ -9705,7 +9695,7 @@
           <p:cNvPr id="32" name="">
             <a:extLst xmlns:a="http://schemas.openxmlformats.org/drawingml/2006/main">
               <a:ext uri="{FF2B5EF4-FFF2-40B4-BE49-F238E27FC236}">
-                <a16:creationId xmlns:a16="http://schemas.microsoft.com/office/drawing/2014/main" id="{1434706D-FF73-41F3-97F0-88D41A96AAF7}"/>
+                <a16:creationId xmlns:a16="http://schemas.microsoft.com/office/drawing/2014/main" id="{B571B3C7-69F2-4A8F-8F75-787C13F65EBD}"/>
               </a:ext>
             </a:extLst>
           </p:cNvPr>
@@ -9763,7 +9753,7 @@
           <p:cNvPr id="33" name="">
             <a:extLst xmlns:a="http://schemas.openxmlformats.org/drawingml/2006/main">
               <a:ext uri="{FF2B5EF4-FFF2-40B4-BE49-F238E27FC236}">
-                <a16:creationId xmlns:a16="http://schemas.microsoft.com/office/drawing/2014/main" id="{F9AE5847-484D-4466-ADA3-8E2D35FBC6F3}"/>
+                <a16:creationId xmlns:a16="http://schemas.microsoft.com/office/drawing/2014/main" id="{3F88E60B-E992-4A56-AC5B-82A9B5763815}"/>
               </a:ext>
             </a:extLst>
           </p:cNvPr>
@@ -9821,7 +9811,7 @@
           <p:cNvPr id="34" name="">
             <a:extLst xmlns:a="http://schemas.openxmlformats.org/drawingml/2006/main">
               <a:ext uri="{FF2B5EF4-FFF2-40B4-BE49-F238E27FC236}">
-                <a16:creationId xmlns:a16="http://schemas.microsoft.com/office/drawing/2014/main" id="{2577ACB3-CE68-48E6-8CA3-8E89C6A729D2}"/>
+                <a16:creationId xmlns:a16="http://schemas.microsoft.com/office/drawing/2014/main" id="{3488CE9E-87EC-4719-8BDC-146A101F120E}"/>
               </a:ext>
             </a:extLst>
           </p:cNvPr>
@@ -9879,7 +9869,7 @@
           <p:cNvPr id="35" name="">
             <a:extLst xmlns:a="http://schemas.openxmlformats.org/drawingml/2006/main">
               <a:ext uri="{FF2B5EF4-FFF2-40B4-BE49-F238E27FC236}">
-                <a16:creationId xmlns:a16="http://schemas.microsoft.com/office/drawing/2014/main" id="{B77D1AF7-9D10-4BA8-9561-2E7261D733E5}"/>
+                <a16:creationId xmlns:a16="http://schemas.microsoft.com/office/drawing/2014/main" id="{B9F06C0D-FAD7-47D3-AA5A-CC3D520FAB3E}"/>
               </a:ext>
             </a:extLst>
           </p:cNvPr>
@@ -9927,7 +9917,7 @@
                 <a:ea typeface="Aptos"/>
                 <a:cs typeface="Aptos"/>
               </a:rPr>
-              <a:t>WATERS NEXT GEN COMPETITIVE INTELLIGENCE · 23 AUG 2026 · waters-ci-20260820104036</a:t>
+              <a:t>WATERS NEXT GEN COMPETITIVE INTELLIGENCE · 08 SEP 2026 · waters-ci-20260909030324</a:t>
             </a:r>
           </a:p>
         </p:txBody>
@@ -9937,7 +9927,7 @@
           <p:cNvPr id="36" name="">
             <a:extLst xmlns:a="http://schemas.openxmlformats.org/drawingml/2006/main">
               <a:ext uri="{FF2B5EF4-FFF2-40B4-BE49-F238E27FC236}">
-                <a16:creationId xmlns:a16="http://schemas.microsoft.com/office/drawing/2014/main" id="{600EC9C0-6759-4C3E-B7A9-CF378CD91F1E}"/>
+                <a16:creationId xmlns:a16="http://schemas.microsoft.com/office/drawing/2014/main" id="{E4692DA8-B203-4E61-8EA9-94D5C7614BFA}"/>
               </a:ext>
             </a:extLst>
           </p:cNvPr>
@@ -9993,7 +9983,7 @@
     </p:spTree>
     <p:extLst>
       <p:ext uri="{BB962C8B-B14F-4D97-AF65-F5344CB8AC3E}">
-        <p14:creationId xmlns:p14="http://schemas.microsoft.com/office/powerpoint/2010/main" val="1645855691"/>
+        <p14:creationId xmlns:p14="http://schemas.microsoft.com/office/powerpoint/2010/main" val="623801038"/>
       </p:ext>
     </p:extLst>
   </p:cSld>
@@ -10024,7 +10014,7 @@
           <p:cNvPr id="26" name="">
             <a:extLst xmlns:a="http://schemas.openxmlformats.org/drawingml/2006/main">
               <a:ext uri="{FF2B5EF4-FFF2-40B4-BE49-F238E27FC236}">
-                <a16:creationId xmlns:a16="http://schemas.microsoft.com/office/drawing/2014/main" id="{FABCC522-F2B8-47C2-B28D-F0930B398609}"/>
+                <a16:creationId xmlns:a16="http://schemas.microsoft.com/office/drawing/2014/main" id="{DBE876C1-DEA0-49E6-92D7-99E4F562EBAD}"/>
               </a:ext>
             </a:extLst>
           </p:cNvPr>
@@ -10082,7 +10072,7 @@
           <p:cNvPr id="2" name="">
             <a:extLst xmlns:a="http://schemas.openxmlformats.org/drawingml/2006/main">
               <a:ext uri="{FF2B5EF4-FFF2-40B4-BE49-F238E27FC236}">
-                <a16:creationId xmlns:a16="http://schemas.microsoft.com/office/drawing/2014/main" id="{B6F77BD2-6FA4-4277-877A-D33EE72B8138}"/>
+                <a16:creationId xmlns:a16="http://schemas.microsoft.com/office/drawing/2014/main" id="{E9C6A8F7-2678-4F0B-B7BB-788B3E0617E9}"/>
               </a:ext>
             </a:extLst>
           </p:cNvPr>
@@ -10140,7 +10130,7 @@
           <p:cNvPr id="3" name="">
             <a:extLst xmlns:a="http://schemas.openxmlformats.org/drawingml/2006/main">
               <a:ext uri="{FF2B5EF4-FFF2-40B4-BE49-F238E27FC236}">
-                <a16:creationId xmlns:a16="http://schemas.microsoft.com/office/drawing/2014/main" id="{5CFCC700-996C-47E7-BFAF-F74CCDA9992E}"/>
+                <a16:creationId xmlns:a16="http://schemas.microsoft.com/office/drawing/2014/main" id="{D8932AD4-D60C-450B-BA59-36BB2F4777B6}"/>
               </a:ext>
             </a:extLst>
           </p:cNvPr>
@@ -10198,7 +10188,7 @@
           <p:cNvPr id="4" name="">
             <a:extLst xmlns:a="http://schemas.openxmlformats.org/drawingml/2006/main">
               <a:ext uri="{FF2B5EF4-FFF2-40B4-BE49-F238E27FC236}">
-                <a16:creationId xmlns:a16="http://schemas.microsoft.com/office/drawing/2014/main" id="{9FBDFEFF-C04B-43CE-A88B-E5262DB64A82}"/>
+                <a16:creationId xmlns:a16="http://schemas.microsoft.com/office/drawing/2014/main" id="{B74C6630-F218-456A-B617-323B24C759D3}"/>
               </a:ext>
             </a:extLst>
           </p:cNvPr>
@@ -10231,7 +10221,7 @@
           <p:cNvPr id="5" name="">
             <a:extLst xmlns:a="http://schemas.openxmlformats.org/drawingml/2006/main">
               <a:ext uri="{FF2B5EF4-FFF2-40B4-BE49-F238E27FC236}">
-                <a16:creationId xmlns:a16="http://schemas.microsoft.com/office/drawing/2014/main" id="{A1BF2801-F605-4766-A884-3A32F6C9D36E}"/>
+                <a16:creationId xmlns:a16="http://schemas.microsoft.com/office/drawing/2014/main" id="{089D03F0-0BD6-44D8-9A33-56492B344B7C}"/>
               </a:ext>
             </a:extLst>
           </p:cNvPr>
@@ -10264,7 +10254,7 @@
           <p:cNvPr id="6" name="">
             <a:extLst xmlns:a="http://schemas.openxmlformats.org/drawingml/2006/main">
               <a:ext uri="{FF2B5EF4-FFF2-40B4-BE49-F238E27FC236}">
-                <a16:creationId xmlns:a16="http://schemas.microsoft.com/office/drawing/2014/main" id="{BB351DD1-2403-41C5-83FD-F2930EB76899}"/>
+                <a16:creationId xmlns:a16="http://schemas.microsoft.com/office/drawing/2014/main" id="{AF1FFE6A-F993-472A-988A-EED27B61FE15}"/>
               </a:ext>
             </a:extLst>
           </p:cNvPr>
@@ -10299,7 +10289,7 @@
           <p:cNvPr id="7" name="">
             <a:extLst xmlns:a="http://schemas.openxmlformats.org/drawingml/2006/main">
               <a:ext uri="{FF2B5EF4-FFF2-40B4-BE49-F238E27FC236}">
-                <a16:creationId xmlns:a16="http://schemas.microsoft.com/office/drawing/2014/main" id="{1499AFDB-78FC-4427-A4D4-66F01B4B59E6}"/>
+                <a16:creationId xmlns:a16="http://schemas.microsoft.com/office/drawing/2014/main" id="{542DAC2D-5094-4F98-91A9-A7760BE2393D}"/>
               </a:ext>
             </a:extLst>
           </p:cNvPr>
@@ -10357,7 +10347,7 @@
           <p:cNvPr id="8" name="">
             <a:extLst xmlns:a="http://schemas.openxmlformats.org/drawingml/2006/main">
               <a:ext uri="{FF2B5EF4-FFF2-40B4-BE49-F238E27FC236}">
-                <a16:creationId xmlns:a16="http://schemas.microsoft.com/office/drawing/2014/main" id="{FA8FC00C-74AF-468E-9F77-4E624CE0F38F}"/>
+                <a16:creationId xmlns:a16="http://schemas.microsoft.com/office/drawing/2014/main" id="{F2B9EE29-2B17-438C-A3DE-2C063A203178}"/>
               </a:ext>
             </a:extLst>
           </p:cNvPr>
@@ -10415,7 +10405,7 @@
           <p:cNvPr id="9" name="">
             <a:extLst xmlns:a="http://schemas.openxmlformats.org/drawingml/2006/main">
               <a:ext uri="{FF2B5EF4-FFF2-40B4-BE49-F238E27FC236}">
-                <a16:creationId xmlns:a16="http://schemas.microsoft.com/office/drawing/2014/main" id="{B9B0B67A-F634-4FE0-A72F-0668EA692111}"/>
+                <a16:creationId xmlns:a16="http://schemas.microsoft.com/office/drawing/2014/main" id="{E47DE3A9-6AAE-4466-9A3C-4E3DAEBDD2F8}"/>
               </a:ext>
             </a:extLst>
           </p:cNvPr>
@@ -10473,7 +10463,7 @@
           <p:cNvPr id="10" name="">
             <a:extLst xmlns:a="http://schemas.openxmlformats.org/drawingml/2006/main">
               <a:ext uri="{FF2B5EF4-FFF2-40B4-BE49-F238E27FC236}">
-                <a16:creationId xmlns:a16="http://schemas.microsoft.com/office/drawing/2014/main" id="{6981B745-08A8-4FE0-B732-57D0C5F9499D}"/>
+                <a16:creationId xmlns:a16="http://schemas.microsoft.com/office/drawing/2014/main" id="{4D49CD56-D009-4FF8-8086-7A7F3CCC419D}"/>
               </a:ext>
             </a:extLst>
           </p:cNvPr>
@@ -10508,7 +10498,7 @@
           <p:cNvPr id="11" name="">
             <a:extLst xmlns:a="http://schemas.openxmlformats.org/drawingml/2006/main">
               <a:ext uri="{FF2B5EF4-FFF2-40B4-BE49-F238E27FC236}">
-                <a16:creationId xmlns:a16="http://schemas.microsoft.com/office/drawing/2014/main" id="{F74E7C06-E3FB-4579-838E-A827E5E24B4A}"/>
+                <a16:creationId xmlns:a16="http://schemas.microsoft.com/office/drawing/2014/main" id="{3B02769C-91A7-42B9-ADF3-276F3D2CDE42}"/>
               </a:ext>
             </a:extLst>
           </p:cNvPr>
@@ -10566,7 +10556,7 @@
           <p:cNvPr id="12" name="">
             <a:extLst xmlns:a="http://schemas.openxmlformats.org/drawingml/2006/main">
               <a:ext uri="{FF2B5EF4-FFF2-40B4-BE49-F238E27FC236}">
-                <a16:creationId xmlns:a16="http://schemas.microsoft.com/office/drawing/2014/main" id="{410ED084-A9A7-481B-801A-1981D8937700}"/>
+                <a16:creationId xmlns:a16="http://schemas.microsoft.com/office/drawing/2014/main" id="{D1B94B37-4E27-4F4E-98EB-ED7C258F1B9C}"/>
               </a:ext>
             </a:extLst>
           </p:cNvPr>
@@ -10624,7 +10614,7 @@
           <p:cNvPr id="13" name="">
             <a:extLst xmlns:a="http://schemas.openxmlformats.org/drawingml/2006/main">
               <a:ext uri="{FF2B5EF4-FFF2-40B4-BE49-F238E27FC236}">
-                <a16:creationId xmlns:a16="http://schemas.microsoft.com/office/drawing/2014/main" id="{4E98C3B3-8ED5-4DF4-B570-D908BCEC5044}"/>
+                <a16:creationId xmlns:a16="http://schemas.microsoft.com/office/drawing/2014/main" id="{85E758D7-D04E-4438-BFA2-5C5B99D0877C}"/>
               </a:ext>
             </a:extLst>
           </p:cNvPr>
@@ -10682,7 +10672,7 @@
           <p:cNvPr id="14" name="">
             <a:extLst xmlns:a="http://schemas.openxmlformats.org/drawingml/2006/main">
               <a:ext uri="{FF2B5EF4-FFF2-40B4-BE49-F238E27FC236}">
-                <a16:creationId xmlns:a16="http://schemas.microsoft.com/office/drawing/2014/main" id="{B90998AB-9981-4C66-AF06-1A9E49F1C556}"/>
+                <a16:creationId xmlns:a16="http://schemas.microsoft.com/office/drawing/2014/main" id="{BBC0C924-DB7D-430C-8FAE-F36F04F72CE1}"/>
               </a:ext>
             </a:extLst>
           </p:cNvPr>
@@ -10717,7 +10707,7 @@
           <p:cNvPr id="15" name="">
             <a:extLst xmlns:a="http://schemas.openxmlformats.org/drawingml/2006/main">
               <a:ext uri="{FF2B5EF4-FFF2-40B4-BE49-F238E27FC236}">
-                <a16:creationId xmlns:a16="http://schemas.microsoft.com/office/drawing/2014/main" id="{BB277143-D74D-4E17-9E6B-2C67063299FB}"/>
+                <a16:creationId xmlns:a16="http://schemas.microsoft.com/office/drawing/2014/main" id="{1AC5F1A9-5837-4C63-851F-3816D6683F01}"/>
               </a:ext>
             </a:extLst>
           </p:cNvPr>
@@ -10775,7 +10765,7 @@
           <p:cNvPr id="16" name="">
             <a:extLst xmlns:a="http://schemas.openxmlformats.org/drawingml/2006/main">
               <a:ext uri="{FF2B5EF4-FFF2-40B4-BE49-F238E27FC236}">
-                <a16:creationId xmlns:a16="http://schemas.microsoft.com/office/drawing/2014/main" id="{D4A4FD1C-04D8-4837-9870-3BEEF7DA3E0A}"/>
+                <a16:creationId xmlns:a16="http://schemas.microsoft.com/office/drawing/2014/main" id="{401F95B8-0270-4E42-BF24-421A186346D1}"/>
               </a:ext>
             </a:extLst>
           </p:cNvPr>
@@ -10833,7 +10823,7 @@
           <p:cNvPr id="17" name="">
             <a:extLst xmlns:a="http://schemas.openxmlformats.org/drawingml/2006/main">
               <a:ext uri="{FF2B5EF4-FFF2-40B4-BE49-F238E27FC236}">
-                <a16:creationId xmlns:a16="http://schemas.microsoft.com/office/drawing/2014/main" id="{E8C0144D-2DC4-4291-807B-1F666A246297}"/>
+                <a16:creationId xmlns:a16="http://schemas.microsoft.com/office/drawing/2014/main" id="{45C2D36B-316C-484E-A192-CFA9F41AE7A7}"/>
               </a:ext>
             </a:extLst>
           </p:cNvPr>
@@ -10891,7 +10881,7 @@
           <p:cNvPr id="18" name="">
             <a:extLst xmlns:a="http://schemas.openxmlformats.org/drawingml/2006/main">
               <a:ext uri="{FF2B5EF4-FFF2-40B4-BE49-F238E27FC236}">
-                <a16:creationId xmlns:a16="http://schemas.microsoft.com/office/drawing/2014/main" id="{D2A1948F-FC2B-418A-820C-385A269A0C35}"/>
+                <a16:creationId xmlns:a16="http://schemas.microsoft.com/office/drawing/2014/main" id="{1151892F-AF7B-451D-9765-2960CF6BCEAA}"/>
               </a:ext>
             </a:extLst>
           </p:cNvPr>
@@ -10926,7 +10916,7 @@
           <p:cNvPr id="19" name="">
             <a:extLst xmlns:a="http://schemas.openxmlformats.org/drawingml/2006/main">
               <a:ext uri="{FF2B5EF4-FFF2-40B4-BE49-F238E27FC236}">
-                <a16:creationId xmlns:a16="http://schemas.microsoft.com/office/drawing/2014/main" id="{D9D467D0-0DBD-419D-92BF-736C8EFB9837}"/>
+                <a16:creationId xmlns:a16="http://schemas.microsoft.com/office/drawing/2014/main" id="{821879C1-2326-46CB-98AF-28B3B35876FB}"/>
               </a:ext>
             </a:extLst>
           </p:cNvPr>
@@ -10984,7 +10974,7 @@
           <p:cNvPr id="20" name="">
             <a:extLst xmlns:a="http://schemas.openxmlformats.org/drawingml/2006/main">
               <a:ext uri="{FF2B5EF4-FFF2-40B4-BE49-F238E27FC236}">
-                <a16:creationId xmlns:a16="http://schemas.microsoft.com/office/drawing/2014/main" id="{340428CF-012A-4EC3-B6C9-DE1E17E69142}"/>
+                <a16:creationId xmlns:a16="http://schemas.microsoft.com/office/drawing/2014/main" id="{7CFB58B8-AD58-49D9-A265-78CA34CD6181}"/>
               </a:ext>
             </a:extLst>
           </p:cNvPr>
@@ -11042,7 +11032,7 @@
           <p:cNvPr id="21" name="">
             <a:extLst xmlns:a="http://schemas.openxmlformats.org/drawingml/2006/main">
               <a:ext uri="{FF2B5EF4-FFF2-40B4-BE49-F238E27FC236}">
-                <a16:creationId xmlns:a16="http://schemas.microsoft.com/office/drawing/2014/main" id="{3381A733-E30B-4BF6-B100-F0B8B5410721}"/>
+                <a16:creationId xmlns:a16="http://schemas.microsoft.com/office/drawing/2014/main" id="{463F4696-85AF-42F3-B53D-F00F5A7DD18F}"/>
               </a:ext>
             </a:extLst>
           </p:cNvPr>
@@ -11100,7 +11090,7 @@
           <p:cNvPr id="22" name="">
             <a:extLst xmlns:a="http://schemas.openxmlformats.org/drawingml/2006/main">
               <a:ext uri="{FF2B5EF4-FFF2-40B4-BE49-F238E27FC236}">
-                <a16:creationId xmlns:a16="http://schemas.microsoft.com/office/drawing/2014/main" id="{21796CC6-3C29-4969-9D0A-A806609E3325}"/>
+                <a16:creationId xmlns:a16="http://schemas.microsoft.com/office/drawing/2014/main" id="{DF1DF559-3F1C-4FE1-92F3-EB7BE5DF96B6}"/>
               </a:ext>
             </a:extLst>
           </p:cNvPr>
@@ -11135,7 +11125,7 @@
           <p:cNvPr id="23" name="">
             <a:extLst xmlns:a="http://schemas.openxmlformats.org/drawingml/2006/main">
               <a:ext uri="{FF2B5EF4-FFF2-40B4-BE49-F238E27FC236}">
-                <a16:creationId xmlns:a16="http://schemas.microsoft.com/office/drawing/2014/main" id="{B7B9F595-3BEB-4098-BB7F-FEEEA6186D53}"/>
+                <a16:creationId xmlns:a16="http://schemas.microsoft.com/office/drawing/2014/main" id="{CF69D2D8-73FA-41E1-9435-ED98F42C568D}"/>
               </a:ext>
             </a:extLst>
           </p:cNvPr>
@@ -11193,7 +11183,7 @@
           <p:cNvPr id="24" name="">
             <a:extLst xmlns:a="http://schemas.openxmlformats.org/drawingml/2006/main">
               <a:ext uri="{FF2B5EF4-FFF2-40B4-BE49-F238E27FC236}">
-                <a16:creationId xmlns:a16="http://schemas.microsoft.com/office/drawing/2014/main" id="{5622BE43-1BF1-4AAF-B12D-046524832F4F}"/>
+                <a16:creationId xmlns:a16="http://schemas.microsoft.com/office/drawing/2014/main" id="{3EA8480E-9546-4DE7-9876-14F2684D641E}"/>
               </a:ext>
             </a:extLst>
           </p:cNvPr>
@@ -11241,7 +11231,7 @@
                 <a:ea typeface="Aptos"/>
                 <a:cs typeface="Aptos"/>
               </a:rPr>
-              <a:t>WATERS NEXT GEN COMPETITIVE INTELLIGENCE · 23 AUG 2026 · waters-ci-20260820104036</a:t>
+              <a:t>WATERS NEXT GEN COMPETITIVE INTELLIGENCE · 08 SEP 2026 · waters-ci-20260909030324</a:t>
             </a:r>
           </a:p>
         </p:txBody>
@@ -11251,7 +11241,7 @@
           <p:cNvPr id="25" name="">
             <a:extLst xmlns:a="http://schemas.openxmlformats.org/drawingml/2006/main">
               <a:ext uri="{FF2B5EF4-FFF2-40B4-BE49-F238E27FC236}">
-                <a16:creationId xmlns:a16="http://schemas.microsoft.com/office/drawing/2014/main" id="{863D6332-71AA-44B6-B810-95D8348CCF86}"/>
+                <a16:creationId xmlns:a16="http://schemas.microsoft.com/office/drawing/2014/main" id="{7B5C0FD5-1630-4322-9FAE-295ABB7B8D12}"/>
               </a:ext>
             </a:extLst>
           </p:cNvPr>
@@ -11307,7 +11297,7 @@
     </p:spTree>
     <p:extLst>
       <p:ext uri="{BB962C8B-B14F-4D97-AF65-F5344CB8AC3E}">
-        <p14:creationId xmlns:p14="http://schemas.microsoft.com/office/powerpoint/2010/main" val="2136145895"/>
+        <p14:creationId xmlns:p14="http://schemas.microsoft.com/office/powerpoint/2010/main" val="855869423"/>
       </p:ext>
     </p:extLst>
   </p:cSld>
@@ -11338,7 +11328,7 @@
           <p:cNvPr id="38" name="">
             <a:extLst xmlns:a="http://schemas.openxmlformats.org/drawingml/2006/main">
               <a:ext uri="{FF2B5EF4-FFF2-40B4-BE49-F238E27FC236}">
-                <a16:creationId xmlns:a16="http://schemas.microsoft.com/office/drawing/2014/main" id="{32491075-96E1-4E9C-83A1-3C48CD4F6DE4}"/>
+                <a16:creationId xmlns:a16="http://schemas.microsoft.com/office/drawing/2014/main" id="{2B34001B-37D5-4DDE-A2FE-B115842AABD4}"/>
               </a:ext>
             </a:extLst>
           </p:cNvPr>
@@ -11396,7 +11386,7 @@
           <p:cNvPr id="2" name="">
             <a:extLst xmlns:a="http://schemas.openxmlformats.org/drawingml/2006/main">
               <a:ext uri="{FF2B5EF4-FFF2-40B4-BE49-F238E27FC236}">
-                <a16:creationId xmlns:a16="http://schemas.microsoft.com/office/drawing/2014/main" id="{A0DC2777-05ED-427F-927D-078309AF7075}"/>
+                <a16:creationId xmlns:a16="http://schemas.microsoft.com/office/drawing/2014/main" id="{D029DA22-E448-4F93-B162-2987E77F6D3C}"/>
               </a:ext>
             </a:extLst>
           </p:cNvPr>
@@ -11454,7 +11444,7 @@
           <p:cNvPr id="3" name="">
             <a:extLst xmlns:a="http://schemas.openxmlformats.org/drawingml/2006/main">
               <a:ext uri="{FF2B5EF4-FFF2-40B4-BE49-F238E27FC236}">
-                <a16:creationId xmlns:a16="http://schemas.microsoft.com/office/drawing/2014/main" id="{E3F7F93C-B89D-48DA-9C05-72DACCAE9841}"/>
+                <a16:creationId xmlns:a16="http://schemas.microsoft.com/office/drawing/2014/main" id="{1D325306-0835-4A4E-8EFF-8FBC09EF1CF1}"/>
               </a:ext>
             </a:extLst>
           </p:cNvPr>
@@ -11512,7 +11502,7 @@
           <p:cNvPr id="4" name="">
             <a:extLst xmlns:a="http://schemas.openxmlformats.org/drawingml/2006/main">
               <a:ext uri="{FF2B5EF4-FFF2-40B4-BE49-F238E27FC236}">
-                <a16:creationId xmlns:a16="http://schemas.microsoft.com/office/drawing/2014/main" id="{0F8CC259-5D9F-45A2-B8A0-B58EE0473F9F}"/>
+                <a16:creationId xmlns:a16="http://schemas.microsoft.com/office/drawing/2014/main" id="{8B56ACB4-80E5-4FEB-8EE7-6187D2E4E0E5}"/>
               </a:ext>
             </a:extLst>
           </p:cNvPr>
@@ -11545,7 +11535,7 @@
           <p:cNvPr id="5" name="">
             <a:extLst xmlns:a="http://schemas.openxmlformats.org/drawingml/2006/main">
               <a:ext uri="{FF2B5EF4-FFF2-40B4-BE49-F238E27FC236}">
-                <a16:creationId xmlns:a16="http://schemas.microsoft.com/office/drawing/2014/main" id="{74E8428C-85FC-4278-89F0-E740F2DA887F}"/>
+                <a16:creationId xmlns:a16="http://schemas.microsoft.com/office/drawing/2014/main" id="{CA5CC138-DA37-4DB2-B049-185F85BA56B4}"/>
               </a:ext>
             </a:extLst>
           </p:cNvPr>
@@ -11603,7 +11593,7 @@
           <p:cNvPr id="6" name="">
             <a:extLst xmlns:a="http://schemas.openxmlformats.org/drawingml/2006/main">
               <a:ext uri="{FF2B5EF4-FFF2-40B4-BE49-F238E27FC236}">
-                <a16:creationId xmlns:a16="http://schemas.microsoft.com/office/drawing/2014/main" id="{0F3C4232-F48C-4BC3-A764-A8F2C6403E11}"/>
+                <a16:creationId xmlns:a16="http://schemas.microsoft.com/office/drawing/2014/main" id="{C6696588-180B-4516-9895-E2189E4E45BF}"/>
               </a:ext>
             </a:extLst>
           </p:cNvPr>
@@ -11661,7 +11651,7 @@
           <p:cNvPr id="7" name="">
             <a:extLst xmlns:a="http://schemas.openxmlformats.org/drawingml/2006/main">
               <a:ext uri="{FF2B5EF4-FFF2-40B4-BE49-F238E27FC236}">
-                <a16:creationId xmlns:a16="http://schemas.microsoft.com/office/drawing/2014/main" id="{EE81E1D4-A92F-4F82-8245-EBD738E39A74}"/>
+                <a16:creationId xmlns:a16="http://schemas.microsoft.com/office/drawing/2014/main" id="{3D54FA00-847F-4719-B819-CFF6CD3BAC1A}"/>
               </a:ext>
             </a:extLst>
           </p:cNvPr>
@@ -11717,10 +11707,10 @@
       <p:sp>
         <p:nvSpPr>
           <p:cNvPr id="8" name="">
-            <a:hlinkClick xmlns:r="http://schemas.openxmlformats.org/officeDocument/2006/relationships" xmlns:a="http://schemas.openxmlformats.org/drawingml/2006/main" r:id="R2346898bc55f48e4"/>
-            <a:extLst xmlns:a="http://schemas.openxmlformats.org/drawingml/2006/main">
-              <a:ext uri="{FF2B5EF4-FFF2-40B4-BE49-F238E27FC236}">
-                <a16:creationId xmlns:a16="http://schemas.microsoft.com/office/drawing/2014/main" id="{C37BDD27-CC13-4FEF-9A93-1E213C7DF097}"/>
+            <a:hlinkClick xmlns:r="http://schemas.openxmlformats.org/officeDocument/2006/relationships" xmlns:a="http://schemas.openxmlformats.org/drawingml/2006/main" r:id="R486445a988b2490a"/>
+            <a:extLst xmlns:a="http://schemas.openxmlformats.org/drawingml/2006/main">
+              <a:ext uri="{FF2B5EF4-FFF2-40B4-BE49-F238E27FC236}">
+                <a16:creationId xmlns:a16="http://schemas.microsoft.com/office/drawing/2014/main" id="{673FA212-499E-460D-9F35-25DAEEC39585}"/>
               </a:ext>
             </a:extLst>
           </p:cNvPr>
@@ -11768,7 +11758,7 @@
                 <a:ea typeface="Aptos"/>
                 <a:cs typeface="Aptos"/>
               </a:rPr>
-              <a:t>https://pubmed.ncbi.nlm.nih.gov/?term=%28%28PFAS+OR+%22per-+and+polyfluoroalkyl%22%29+AND+%28%22LC-MS%22+OR+%22LC-MS%2FMS%22+OR+chromatography%29%29+AND+%28%222025%2F08%2F20%22%5BDate+-+Publication%5D+%3A+%222026%2F08%2F20%22%5BDate+-+Publication%5D%29</a:t>
+              <a:t>https://pubmed.ncbi.nlm.nih.gov/?term=%28%28PFAS+OR+%22per-+and+polyfluoroalkyl%22%29+AND+%28%22LC-MS%22+OR+%22LC-MS%2FMS%22+OR+chromatography%29%29+AND+%28%222025%2F09%2F08%22%5BDate+-+Publication%5D+%3A+%222026%2F09%2F08%22%5BDate+-+Publication%5D%29</a:t>
             </a:r>
           </a:p>
         </p:txBody>
@@ -11778,7 +11768,7 @@
           <p:cNvPr id="9" name="">
             <a:extLst xmlns:a="http://schemas.openxmlformats.org/drawingml/2006/main">
               <a:ext uri="{FF2B5EF4-FFF2-40B4-BE49-F238E27FC236}">
-                <a16:creationId xmlns:a16="http://schemas.microsoft.com/office/drawing/2014/main" id="{6E465B59-718E-424C-B6E0-813ED6835AE1}"/>
+                <a16:creationId xmlns:a16="http://schemas.microsoft.com/office/drawing/2014/main" id="{AB9087C8-0DA7-4BB1-BCD9-CB26ACDCAED9}"/>
               </a:ext>
             </a:extLst>
           </p:cNvPr>
@@ -11811,7 +11801,7 @@
           <p:cNvPr id="10" name="">
             <a:extLst xmlns:a="http://schemas.openxmlformats.org/drawingml/2006/main">
               <a:ext uri="{FF2B5EF4-FFF2-40B4-BE49-F238E27FC236}">
-                <a16:creationId xmlns:a16="http://schemas.microsoft.com/office/drawing/2014/main" id="{1F12CAD0-707C-4C22-9528-14CCA1949692}"/>
+                <a16:creationId xmlns:a16="http://schemas.microsoft.com/office/drawing/2014/main" id="{06FA2B1C-9256-4B6B-AD65-4A4728978C29}"/>
               </a:ext>
             </a:extLst>
           </p:cNvPr>
@@ -11869,7 +11859,7 @@
           <p:cNvPr id="11" name="">
             <a:extLst xmlns:a="http://schemas.openxmlformats.org/drawingml/2006/main">
               <a:ext uri="{FF2B5EF4-FFF2-40B4-BE49-F238E27FC236}">
-                <a16:creationId xmlns:a16="http://schemas.microsoft.com/office/drawing/2014/main" id="{A7EAAA8C-C0E5-4E59-95CA-D93407B067CD}"/>
+                <a16:creationId xmlns:a16="http://schemas.microsoft.com/office/drawing/2014/main" id="{7FC6BB11-89D4-46D3-814A-8DE339A15DE5}"/>
               </a:ext>
             </a:extLst>
           </p:cNvPr>
@@ -11927,7 +11917,7 @@
           <p:cNvPr id="12" name="">
             <a:extLst xmlns:a="http://schemas.openxmlformats.org/drawingml/2006/main">
               <a:ext uri="{FF2B5EF4-FFF2-40B4-BE49-F238E27FC236}">
-                <a16:creationId xmlns:a16="http://schemas.microsoft.com/office/drawing/2014/main" id="{FAE38FBF-33BE-47E7-8FF9-979347A16E22}"/>
+                <a16:creationId xmlns:a16="http://schemas.microsoft.com/office/drawing/2014/main" id="{5219D96D-130F-48FE-8EFF-8A69C44C2793}"/>
               </a:ext>
             </a:extLst>
           </p:cNvPr>
@@ -11983,10 +11973,10 @@
       <p:sp>
         <p:nvSpPr>
           <p:cNvPr id="13" name="">
-            <a:hlinkClick xmlns:r="http://schemas.openxmlformats.org/officeDocument/2006/relationships" xmlns:a="http://schemas.openxmlformats.org/drawingml/2006/main" r:id="R823171ce63a3433a"/>
-            <a:extLst xmlns:a="http://schemas.openxmlformats.org/drawingml/2006/main">
-              <a:ext uri="{FF2B5EF4-FFF2-40B4-BE49-F238E27FC236}">
-                <a16:creationId xmlns:a16="http://schemas.microsoft.com/office/drawing/2014/main" id="{ABA52872-7257-4B9A-99A0-26B001349AD8}"/>
+            <a:hlinkClick xmlns:r="http://schemas.openxmlformats.org/officeDocument/2006/relationships" xmlns:a="http://schemas.openxmlformats.org/drawingml/2006/main" r:id="R920f1152316349fc"/>
+            <a:extLst xmlns:a="http://schemas.openxmlformats.org/drawingml/2006/main">
+              <a:ext uri="{FF2B5EF4-FFF2-40B4-BE49-F238E27FC236}">
+                <a16:creationId xmlns:a16="http://schemas.microsoft.com/office/drawing/2014/main" id="{A03B8DB9-94CD-4345-8FFB-043BB56258D5}"/>
               </a:ext>
             </a:extLst>
           </p:cNvPr>
@@ -12044,7 +12034,7 @@
           <p:cNvPr id="14" name="">
             <a:extLst xmlns:a="http://schemas.openxmlformats.org/drawingml/2006/main">
               <a:ext uri="{FF2B5EF4-FFF2-40B4-BE49-F238E27FC236}">
-                <a16:creationId xmlns:a16="http://schemas.microsoft.com/office/drawing/2014/main" id="{2E38276C-A5FD-44D7-BC15-571F52DE82CD}"/>
+                <a16:creationId xmlns:a16="http://schemas.microsoft.com/office/drawing/2014/main" id="{9104B4B1-255D-4EEF-823B-BB8CAFEBF84E}"/>
               </a:ext>
             </a:extLst>
           </p:cNvPr>
@@ -12077,7 +12067,7 @@
           <p:cNvPr id="15" name="">
             <a:extLst xmlns:a="http://schemas.openxmlformats.org/drawingml/2006/main">
               <a:ext uri="{FF2B5EF4-FFF2-40B4-BE49-F238E27FC236}">
-                <a16:creationId xmlns:a16="http://schemas.microsoft.com/office/drawing/2014/main" id="{6AF7692C-5EA9-4031-8140-CA1C7F0C9E30}"/>
+                <a16:creationId xmlns:a16="http://schemas.microsoft.com/office/drawing/2014/main" id="{649B88B2-FD87-42AB-980B-9E4C3A2DD58F}"/>
               </a:ext>
             </a:extLst>
           </p:cNvPr>
@@ -12135,7 +12125,7 @@
           <p:cNvPr id="16" name="">
             <a:extLst xmlns:a="http://schemas.openxmlformats.org/drawingml/2006/main">
               <a:ext uri="{FF2B5EF4-FFF2-40B4-BE49-F238E27FC236}">
-                <a16:creationId xmlns:a16="http://schemas.microsoft.com/office/drawing/2014/main" id="{FE989846-97D1-4497-8813-317104443FD6}"/>
+                <a16:creationId xmlns:a16="http://schemas.microsoft.com/office/drawing/2014/main" id="{B84B4B30-8BEA-4ACB-9930-F483DA9926CC}"/>
               </a:ext>
             </a:extLst>
           </p:cNvPr>
@@ -12193,7 +12183,7 @@
           <p:cNvPr id="17" name="">
             <a:extLst xmlns:a="http://schemas.openxmlformats.org/drawingml/2006/main">
               <a:ext uri="{FF2B5EF4-FFF2-40B4-BE49-F238E27FC236}">
-                <a16:creationId xmlns:a16="http://schemas.microsoft.com/office/drawing/2014/main" id="{2E746D48-99CC-414D-BD0B-C1AA8E2303EB}"/>
+                <a16:creationId xmlns:a16="http://schemas.microsoft.com/office/drawing/2014/main" id="{3F5E6AFA-54F7-4A8C-B69F-B13E6B5B2575}"/>
               </a:ext>
             </a:extLst>
           </p:cNvPr>
@@ -12249,10 +12239,10 @@
       <p:sp>
         <p:nvSpPr>
           <p:cNvPr id="18" name="">
-            <a:hlinkClick xmlns:r="http://schemas.openxmlformats.org/officeDocument/2006/relationships" xmlns:a="http://schemas.openxmlformats.org/drawingml/2006/main" r:id="Redf15c6127f04896"/>
-            <a:extLst xmlns:a="http://schemas.openxmlformats.org/drawingml/2006/main">
-              <a:ext uri="{FF2B5EF4-FFF2-40B4-BE49-F238E27FC236}">
-                <a16:creationId xmlns:a16="http://schemas.microsoft.com/office/drawing/2014/main" id="{243FFF72-06F7-4474-BDBC-81CD7780A0C9}"/>
+            <a:hlinkClick xmlns:r="http://schemas.openxmlformats.org/officeDocument/2006/relationships" xmlns:a="http://schemas.openxmlformats.org/drawingml/2006/main" r:id="Rd3b9d96a0d1e4c9f"/>
+            <a:extLst xmlns:a="http://schemas.openxmlformats.org/drawingml/2006/main">
+              <a:ext uri="{FF2B5EF4-FFF2-40B4-BE49-F238E27FC236}">
+                <a16:creationId xmlns:a16="http://schemas.microsoft.com/office/drawing/2014/main" id="{7362A52C-4D71-4B11-BA8D-E001BEEA3DBE}"/>
               </a:ext>
             </a:extLst>
           </p:cNvPr>
@@ -12310,7 +12300,7 @@
           <p:cNvPr id="19" name="">
             <a:extLst xmlns:a="http://schemas.openxmlformats.org/drawingml/2006/main">
               <a:ext uri="{FF2B5EF4-FFF2-40B4-BE49-F238E27FC236}">
-                <a16:creationId xmlns:a16="http://schemas.microsoft.com/office/drawing/2014/main" id="{AEE82383-587B-4A01-92D3-FDC602C26807}"/>
+                <a16:creationId xmlns:a16="http://schemas.microsoft.com/office/drawing/2014/main" id="{B0564032-3F59-4AAE-8BA0-F14315F51F1C}"/>
               </a:ext>
             </a:extLst>
           </p:cNvPr>
@@ -12343,7 +12333,7 @@
           <p:cNvPr id="20" name="">
             <a:extLst xmlns:a="http://schemas.openxmlformats.org/drawingml/2006/main">
               <a:ext uri="{FF2B5EF4-FFF2-40B4-BE49-F238E27FC236}">
-                <a16:creationId xmlns:a16="http://schemas.microsoft.com/office/drawing/2014/main" id="{FCA3D1DA-1B34-4654-9980-C5F427588649}"/>
+                <a16:creationId xmlns:a16="http://schemas.microsoft.com/office/drawing/2014/main" id="{8CA2CEB3-17AE-46A2-B365-201616996630}"/>
               </a:ext>
             </a:extLst>
           </p:cNvPr>
@@ -12401,7 +12391,7 @@
           <p:cNvPr id="21" name="">
             <a:extLst xmlns:a="http://schemas.openxmlformats.org/drawingml/2006/main">
               <a:ext uri="{FF2B5EF4-FFF2-40B4-BE49-F238E27FC236}">
-                <a16:creationId xmlns:a16="http://schemas.microsoft.com/office/drawing/2014/main" id="{9F3B95C4-E608-4F20-A785-73D2562B6622}"/>
+                <a16:creationId xmlns:a16="http://schemas.microsoft.com/office/drawing/2014/main" id="{4219B944-13C6-430E-B3D6-16D9A769F3A2}"/>
               </a:ext>
             </a:extLst>
           </p:cNvPr>
@@ -12459,7 +12449,7 @@
           <p:cNvPr id="22" name="">
             <a:extLst xmlns:a="http://schemas.openxmlformats.org/drawingml/2006/main">
               <a:ext uri="{FF2B5EF4-FFF2-40B4-BE49-F238E27FC236}">
-                <a16:creationId xmlns:a16="http://schemas.microsoft.com/office/drawing/2014/main" id="{16535C97-E7D5-49D2-8FD6-BC6B5EE0B9F9}"/>
+                <a16:creationId xmlns:a16="http://schemas.microsoft.com/office/drawing/2014/main" id="{CC7E0013-C9F9-4E25-A972-A09C1104FFE0}"/>
               </a:ext>
             </a:extLst>
           </p:cNvPr>
@@ -12515,10 +12505,10 @@
       <p:sp>
         <p:nvSpPr>
           <p:cNvPr id="23" name="">
-            <a:hlinkClick xmlns:r="http://schemas.openxmlformats.org/officeDocument/2006/relationships" xmlns:a="http://schemas.openxmlformats.org/drawingml/2006/main" r:id="Ra61963531b1a40d3"/>
-            <a:extLst xmlns:a="http://schemas.openxmlformats.org/drawingml/2006/main">
-              <a:ext uri="{FF2B5EF4-FFF2-40B4-BE49-F238E27FC236}">
-                <a16:creationId xmlns:a16="http://schemas.microsoft.com/office/drawing/2014/main" id="{0D569E55-CBDE-4C9F-94EC-4B2E9AC05F93}"/>
+            <a:hlinkClick xmlns:r="http://schemas.openxmlformats.org/officeDocument/2006/relationships" xmlns:a="http://schemas.openxmlformats.org/drawingml/2006/main" r:id="Rb00ad112b305496e"/>
+            <a:extLst xmlns:a="http://schemas.openxmlformats.org/drawingml/2006/main">
+              <a:ext uri="{FF2B5EF4-FFF2-40B4-BE49-F238E27FC236}">
+                <a16:creationId xmlns:a16="http://schemas.microsoft.com/office/drawing/2014/main" id="{610ED8F1-B5AD-4337-8AD7-4ACDD0EFFBB8}"/>
               </a:ext>
             </a:extLst>
           </p:cNvPr>
@@ -12576,7 +12566,7 @@
           <p:cNvPr id="24" name="">
             <a:extLst xmlns:a="http://schemas.openxmlformats.org/drawingml/2006/main">
               <a:ext uri="{FF2B5EF4-FFF2-40B4-BE49-F238E27FC236}">
-                <a16:creationId xmlns:a16="http://schemas.microsoft.com/office/drawing/2014/main" id="{0EC2ABC2-FBED-4A34-A2C2-7A754A769AF8}"/>
+                <a16:creationId xmlns:a16="http://schemas.microsoft.com/office/drawing/2014/main" id="{9FD3DA43-07D1-41AA-9454-512346D3C5E1}"/>
               </a:ext>
             </a:extLst>
           </p:cNvPr>
@@ -12609,7 +12599,7 @@
           <p:cNvPr id="25" name="">
             <a:extLst xmlns:a="http://schemas.openxmlformats.org/drawingml/2006/main">
               <a:ext uri="{FF2B5EF4-FFF2-40B4-BE49-F238E27FC236}">
-                <a16:creationId xmlns:a16="http://schemas.microsoft.com/office/drawing/2014/main" id="{D04BEFF4-C479-4EDF-BEF8-6D5945ECFB5F}"/>
+                <a16:creationId xmlns:a16="http://schemas.microsoft.com/office/drawing/2014/main" id="{30AE0E8E-4152-410E-9610-0F5D14C54E1F}"/>
               </a:ext>
             </a:extLst>
           </p:cNvPr>
@@ -12667,7 +12657,7 @@
           <p:cNvPr id="26" name="">
             <a:extLst xmlns:a="http://schemas.openxmlformats.org/drawingml/2006/main">
               <a:ext uri="{FF2B5EF4-FFF2-40B4-BE49-F238E27FC236}">
-                <a16:creationId xmlns:a16="http://schemas.microsoft.com/office/drawing/2014/main" id="{6FED93DD-3747-44CA-9EF7-325830D91F4C}"/>
+                <a16:creationId xmlns:a16="http://schemas.microsoft.com/office/drawing/2014/main" id="{D4A19F2C-4930-45A4-A240-2D4241DCCFE5}"/>
               </a:ext>
             </a:extLst>
           </p:cNvPr>
@@ -12725,7 +12715,7 @@
           <p:cNvPr id="27" name="">
             <a:extLst xmlns:a="http://schemas.openxmlformats.org/drawingml/2006/main">
               <a:ext uri="{FF2B5EF4-FFF2-40B4-BE49-F238E27FC236}">
-                <a16:creationId xmlns:a16="http://schemas.microsoft.com/office/drawing/2014/main" id="{BDD27345-9BE2-4518-904F-2C0721A04023}"/>
+                <a16:creationId xmlns:a16="http://schemas.microsoft.com/office/drawing/2014/main" id="{4C1FCFDA-A06C-4F9D-AD9C-90F2511BBF36}"/>
               </a:ext>
             </a:extLst>
           </p:cNvPr>
@@ -12781,10 +12771,10 @@
       <p:sp>
         <p:nvSpPr>
           <p:cNvPr id="28" name="">
-            <a:hlinkClick xmlns:r="http://schemas.openxmlformats.org/officeDocument/2006/relationships" xmlns:a="http://schemas.openxmlformats.org/drawingml/2006/main" r:id="R65b5227a71434014"/>
-            <a:extLst xmlns:a="http://schemas.openxmlformats.org/drawingml/2006/main">
-              <a:ext uri="{FF2B5EF4-FFF2-40B4-BE49-F238E27FC236}">
-                <a16:creationId xmlns:a16="http://schemas.microsoft.com/office/drawing/2014/main" id="{6E6AD32A-881E-4C8D-9579-C656FF3C9A99}"/>
+            <a:hlinkClick xmlns:r="http://schemas.openxmlformats.org/officeDocument/2006/relationships" xmlns:a="http://schemas.openxmlformats.org/drawingml/2006/main" r:id="Rb245d4684f934e38"/>
+            <a:extLst xmlns:a="http://schemas.openxmlformats.org/drawingml/2006/main">
+              <a:ext uri="{FF2B5EF4-FFF2-40B4-BE49-F238E27FC236}">
+                <a16:creationId xmlns:a16="http://schemas.microsoft.com/office/drawing/2014/main" id="{CA43CB49-1E53-4D44-A986-64386F7FDAAC}"/>
               </a:ext>
             </a:extLst>
           </p:cNvPr>
@@ -12842,7 +12832,7 @@
           <p:cNvPr id="29" name="">
             <a:extLst xmlns:a="http://schemas.openxmlformats.org/drawingml/2006/main">
               <a:ext uri="{FF2B5EF4-FFF2-40B4-BE49-F238E27FC236}">
-                <a16:creationId xmlns:a16="http://schemas.microsoft.com/office/drawing/2014/main" id="{EC42AFDD-98BC-46EB-9568-B1C10D590218}"/>
+                <a16:creationId xmlns:a16="http://schemas.microsoft.com/office/drawing/2014/main" id="{CAE4953A-0E76-4BA3-8DDD-0E0460CA1518}"/>
               </a:ext>
             </a:extLst>
           </p:cNvPr>
@@ -12875,7 +12865,7 @@
           <p:cNvPr id="30" name="">
             <a:extLst xmlns:a="http://schemas.openxmlformats.org/drawingml/2006/main">
               <a:ext uri="{FF2B5EF4-FFF2-40B4-BE49-F238E27FC236}">
-                <a16:creationId xmlns:a16="http://schemas.microsoft.com/office/drawing/2014/main" id="{ACFC0F7B-6407-43FD-B7E4-C543CFCF1068}"/>
+                <a16:creationId xmlns:a16="http://schemas.microsoft.com/office/drawing/2014/main" id="{E66633F9-7F48-4A68-B486-79FBAE4DF341}"/>
               </a:ext>
             </a:extLst>
           </p:cNvPr>
@@ -12933,7 +12923,7 @@
           <p:cNvPr id="31" name="">
             <a:extLst xmlns:a="http://schemas.openxmlformats.org/drawingml/2006/main">
               <a:ext uri="{FF2B5EF4-FFF2-40B4-BE49-F238E27FC236}">
-                <a16:creationId xmlns:a16="http://schemas.microsoft.com/office/drawing/2014/main" id="{1D57072D-7B28-4261-B9A3-0D981453BED3}"/>
+                <a16:creationId xmlns:a16="http://schemas.microsoft.com/office/drawing/2014/main" id="{3A01B2F7-1049-44E0-95B3-525F720FCA14}"/>
               </a:ext>
             </a:extLst>
           </p:cNvPr>
@@ -12991,7 +12981,7 @@
           <p:cNvPr id="32" name="">
             <a:extLst xmlns:a="http://schemas.openxmlformats.org/drawingml/2006/main">
               <a:ext uri="{FF2B5EF4-FFF2-40B4-BE49-F238E27FC236}">
-                <a16:creationId xmlns:a16="http://schemas.microsoft.com/office/drawing/2014/main" id="{290BAB12-301E-4491-A09C-5C71C834FA24}"/>
+                <a16:creationId xmlns:a16="http://schemas.microsoft.com/office/drawing/2014/main" id="{D13897DF-CB69-4298-B224-DDED01FB5B57}"/>
               </a:ext>
             </a:extLst>
           </p:cNvPr>
@@ -13047,10 +13037,10 @@
       <p:sp>
         <p:nvSpPr>
           <p:cNvPr id="33" name="">
-            <a:hlinkClick xmlns:r="http://schemas.openxmlformats.org/officeDocument/2006/relationships" xmlns:a="http://schemas.openxmlformats.org/drawingml/2006/main" r:id="Rcfc2d21479ad49e5"/>
-            <a:extLst xmlns:a="http://schemas.openxmlformats.org/drawingml/2006/main">
-              <a:ext uri="{FF2B5EF4-FFF2-40B4-BE49-F238E27FC236}">
-                <a16:creationId xmlns:a16="http://schemas.microsoft.com/office/drawing/2014/main" id="{A1C737B3-0B23-433A-BA1E-B50128336299}"/>
+            <a:hlinkClick xmlns:r="http://schemas.openxmlformats.org/officeDocument/2006/relationships" xmlns:a="http://schemas.openxmlformats.org/drawingml/2006/main" r:id="R5769aac7b70f4b85"/>
+            <a:extLst xmlns:a="http://schemas.openxmlformats.org/drawingml/2006/main">
+              <a:ext uri="{FF2B5EF4-FFF2-40B4-BE49-F238E27FC236}">
+                <a16:creationId xmlns:a16="http://schemas.microsoft.com/office/drawing/2014/main" id="{56AF48F1-DDDF-4602-A4E5-3AE986AFD8BC}"/>
               </a:ext>
             </a:extLst>
           </p:cNvPr>
@@ -13108,7 +13098,7 @@
           <p:cNvPr id="34" name="">
             <a:extLst xmlns:a="http://schemas.openxmlformats.org/drawingml/2006/main">
               <a:ext uri="{FF2B5EF4-FFF2-40B4-BE49-F238E27FC236}">
-                <a16:creationId xmlns:a16="http://schemas.microsoft.com/office/drawing/2014/main" id="{E94198B0-1900-4B9A-A2E8-CEF01C7F3DED}"/>
+                <a16:creationId xmlns:a16="http://schemas.microsoft.com/office/drawing/2014/main" id="{C620BC8E-6104-4408-940B-4DD277BE0C8F}"/>
               </a:ext>
             </a:extLst>
           </p:cNvPr>
@@ -13143,7 +13133,7 @@
           <p:cNvPr id="35" name="">
             <a:extLst xmlns:a="http://schemas.openxmlformats.org/drawingml/2006/main">
               <a:ext uri="{FF2B5EF4-FFF2-40B4-BE49-F238E27FC236}">
-                <a16:creationId xmlns:a16="http://schemas.microsoft.com/office/drawing/2014/main" id="{E6767625-79E4-4C9B-B2BF-A61622D2CAFA}"/>
+                <a16:creationId xmlns:a16="http://schemas.microsoft.com/office/drawing/2014/main" id="{82DC02CC-D036-4A46-9A7C-C57D6549250A}"/>
               </a:ext>
             </a:extLst>
           </p:cNvPr>
@@ -13191,7 +13181,7 @@
                 <a:ea typeface="Aptos"/>
                 <a:cs typeface="Aptos"/>
               </a:rPr>
-              <a:t>Snapshot: waters-ci-20260820104036 · As of 2026-08-23 · Business magnitude requires Waters internal data.</a:t>
+              <a:t>Snapshot: waters-ci-20260909030324 · As of 2026-09-08 · Business magnitude requires Waters internal data.</a:t>
             </a:r>
           </a:p>
         </p:txBody>
@@ -13201,7 +13191,7 @@
           <p:cNvPr id="36" name="">
             <a:extLst xmlns:a="http://schemas.openxmlformats.org/drawingml/2006/main">
               <a:ext uri="{FF2B5EF4-FFF2-40B4-BE49-F238E27FC236}">
-                <a16:creationId xmlns:a16="http://schemas.microsoft.com/office/drawing/2014/main" id="{5E59F4DA-6118-49F7-B412-678E1CC7E67F}"/>
+                <a16:creationId xmlns:a16="http://schemas.microsoft.com/office/drawing/2014/main" id="{22CF4588-AA3E-44E1-9D6B-B139DC0D7FAE}"/>
               </a:ext>
             </a:extLst>
           </p:cNvPr>
@@ -13249,7 +13239,7 @@
                 <a:ea typeface="Aptos"/>
                 <a:cs typeface="Aptos"/>
               </a:rPr>
-              <a:t>WATERS NEXT GEN COMPETITIVE INTELLIGENCE · 23 AUG 2026 · waters-ci-20260820104036</a:t>
+              <a:t>WATERS NEXT GEN COMPETITIVE INTELLIGENCE · 08 SEP 2026 · waters-ci-20260909030324</a:t>
             </a:r>
           </a:p>
         </p:txBody>
@@ -13259,7 +13249,7 @@
           <p:cNvPr id="37" name="">
             <a:extLst xmlns:a="http://schemas.openxmlformats.org/drawingml/2006/main">
               <a:ext uri="{FF2B5EF4-FFF2-40B4-BE49-F238E27FC236}">
-                <a16:creationId xmlns:a16="http://schemas.microsoft.com/office/drawing/2014/main" id="{DA42734A-D3CF-465C-8CD3-5F9F2877839C}"/>
+                <a16:creationId xmlns:a16="http://schemas.microsoft.com/office/drawing/2014/main" id="{23B96A0A-B6B0-47CC-A2A7-39D7316BF824}"/>
               </a:ext>
             </a:extLst>
           </p:cNvPr>
@@ -13315,7 +13305,7 @@
     </p:spTree>
     <p:extLst>
       <p:ext uri="{BB962C8B-B14F-4D97-AF65-F5344CB8AC3E}">
-        <p14:creationId xmlns:p14="http://schemas.microsoft.com/office/powerpoint/2010/main" val="1418829203"/>
+        <p14:creationId xmlns:p14="http://schemas.microsoft.com/office/powerpoint/2010/main" val="1732690402"/>
       </p:ext>
     </p:extLst>
   </p:cSld>

</xml_diff>

<commit_message>
Regenerate refreshed deployment after site integration
</commit_message>
<xml_diff>
--- a/deploy-site/exports/waters-nextgen-leadership-brief.pptx
+++ b/deploy-site/exports/waters-nextgen-leadership-brief.pptx
@@ -2,20 +2,20 @@
 <file path=ppt/presentation.xml><?xml version="1.0" encoding="utf-8"?>
 <p:presentation xmlns:p="http://schemas.openxmlformats.org/presentationml/2006/main">
   <p:sldMasterIdLst>
-    <p:sldMasterId xmlns:r="http://schemas.openxmlformats.org/officeDocument/2006/relationships" id="2147483648" r:id="R05da7cc905b64ff5"/>
+    <p:sldMasterId xmlns:r="http://schemas.openxmlformats.org/officeDocument/2006/relationships" id="2147483648" r:id="R0e38ff0edf624438"/>
   </p:sldMasterIdLst>
   <p:notesMasterIdLst>
-    <p:notesMasterId xmlns:r="http://schemas.openxmlformats.org/officeDocument/2006/relationships" r:id="Rb544a85706c54157"/>
+    <p:notesMasterId xmlns:r="http://schemas.openxmlformats.org/officeDocument/2006/relationships" r:id="R08a34c76c76b4b79"/>
   </p:notesMasterIdLst>
   <p:sldIdLst>
-    <p:sldId xmlns:r="http://schemas.openxmlformats.org/officeDocument/2006/relationships" id="256" r:id="R071aa9813b4b4b31"/>
-    <p:sldId xmlns:r="http://schemas.openxmlformats.org/officeDocument/2006/relationships" id="257" r:id="R9e3b7c803930429b"/>
-    <p:sldId xmlns:r="http://schemas.openxmlformats.org/officeDocument/2006/relationships" id="258" r:id="R0e85141eda3b4ad1"/>
-    <p:sldId xmlns:r="http://schemas.openxmlformats.org/officeDocument/2006/relationships" id="259" r:id="R6ed19f9d9c5242e9"/>
-    <p:sldId xmlns:r="http://schemas.openxmlformats.org/officeDocument/2006/relationships" id="260" r:id="R2ade433dfa8c4ffa"/>
-    <p:sldId xmlns:r="http://schemas.openxmlformats.org/officeDocument/2006/relationships" id="261" r:id="Rd937389090654348"/>
-    <p:sldId xmlns:r="http://schemas.openxmlformats.org/officeDocument/2006/relationships" id="262" r:id="Rbf5174700954410a"/>
-    <p:sldId xmlns:r="http://schemas.openxmlformats.org/officeDocument/2006/relationships" id="263" r:id="Rf8bb5d70a61e4a73"/>
+    <p:sldId xmlns:r="http://schemas.openxmlformats.org/officeDocument/2006/relationships" id="256" r:id="R37bf0251fe374de9"/>
+    <p:sldId xmlns:r="http://schemas.openxmlformats.org/officeDocument/2006/relationships" id="257" r:id="Raaab027362ad493c"/>
+    <p:sldId xmlns:r="http://schemas.openxmlformats.org/officeDocument/2006/relationships" id="258" r:id="Rb86fc8e5568349df"/>
+    <p:sldId xmlns:r="http://schemas.openxmlformats.org/officeDocument/2006/relationships" id="259" r:id="Re26cdbe0c2d44cf4"/>
+    <p:sldId xmlns:r="http://schemas.openxmlformats.org/officeDocument/2006/relationships" id="260" r:id="Rf6056467bad3424f"/>
+    <p:sldId xmlns:r="http://schemas.openxmlformats.org/officeDocument/2006/relationships" id="261" r:id="R659bb247a1414e6a"/>
+    <p:sldId xmlns:r="http://schemas.openxmlformats.org/officeDocument/2006/relationships" id="262" r:id="R3c9f6ed48d2e4ab7"/>
+    <p:sldId xmlns:r="http://schemas.openxmlformats.org/officeDocument/2006/relationships" id="263" r:id="R33e87f5247b74814"/>
   </p:sldIdLst>
   <p:sldSz cx="12192000" cy="6858000"/>
   <p:notesSz cx="6858000" cy="9144000"/>
@@ -1282,7 +1282,7 @@
   </p:cSld>
   <p:clrMap bg1="lt1" tx1="dk1" bg2="lt2" tx2="dk2" accent1="accent1" accent2="accent2" accent3="accent3" accent4="accent4" accent5="accent5" accent6="accent6" hlink="hlink" folHlink="folHlink"/>
   <p:sldLayoutIdLst>
-    <p:sldLayoutId xmlns:r="http://schemas.openxmlformats.org/officeDocument/2006/relationships" id="2147483649" r:id="Re62b86348e90434d"/>
+    <p:sldLayoutId xmlns:r="http://schemas.openxmlformats.org/officeDocument/2006/relationships" id="2147483649" r:id="R41653649745e43a5"/>
   </p:sldLayoutIdLst>
   <p:txStyles>
     <p:titleStyle>
@@ -1833,7 +1833,7 @@
           <p:cNvPr id="14" name="">
             <a:extLst xmlns:a="http://schemas.openxmlformats.org/drawingml/2006/main">
               <a:ext uri="{FF2B5EF4-FFF2-40B4-BE49-F238E27FC236}">
-                <a16:creationId xmlns:a16="http://schemas.microsoft.com/office/drawing/2014/main" id="{816D2D08-6F2D-4889-AAA8-65A1395F956B}"/>
+                <a16:creationId xmlns:a16="http://schemas.microsoft.com/office/drawing/2014/main" id="{6E70AD7D-679A-4B2A-BD14-EBD3E10E2BDC}"/>
               </a:ext>
             </a:extLst>
           </p:cNvPr>
@@ -1866,7 +1866,7 @@
           <p:cNvPr id="2" name="">
             <a:extLst xmlns:a="http://schemas.openxmlformats.org/drawingml/2006/main">
               <a:ext uri="{FF2B5EF4-FFF2-40B4-BE49-F238E27FC236}">
-                <a16:creationId xmlns:a16="http://schemas.microsoft.com/office/drawing/2014/main" id="{42FA9606-F7D9-4D7F-9A59-211D867BD9D5}"/>
+                <a16:creationId xmlns:a16="http://schemas.microsoft.com/office/drawing/2014/main" id="{B8080F9F-A128-47F1-9939-3A5591E33E41}"/>
               </a:ext>
             </a:extLst>
           </p:cNvPr>
@@ -1924,7 +1924,7 @@
           <p:cNvPr id="3" name="">
             <a:extLst xmlns:a="http://schemas.openxmlformats.org/drawingml/2006/main">
               <a:ext uri="{FF2B5EF4-FFF2-40B4-BE49-F238E27FC236}">
-                <a16:creationId xmlns:a16="http://schemas.microsoft.com/office/drawing/2014/main" id="{7FF306E3-6204-48E7-A41B-42A387AF0314}"/>
+                <a16:creationId xmlns:a16="http://schemas.microsoft.com/office/drawing/2014/main" id="{99C84A39-7869-4658-9220-DF7C57160B9A}"/>
               </a:ext>
             </a:extLst>
           </p:cNvPr>
@@ -1982,7 +1982,7 @@
           <p:cNvPr id="4" name="">
             <a:extLst xmlns:a="http://schemas.openxmlformats.org/drawingml/2006/main">
               <a:ext uri="{FF2B5EF4-FFF2-40B4-BE49-F238E27FC236}">
-                <a16:creationId xmlns:a16="http://schemas.microsoft.com/office/drawing/2014/main" id="{CE7AF293-9AA1-4087-8250-F17C490C6EFB}"/>
+                <a16:creationId xmlns:a16="http://schemas.microsoft.com/office/drawing/2014/main" id="{537E89F2-B447-4D63-8F30-1CB6162EDB34}"/>
               </a:ext>
             </a:extLst>
           </p:cNvPr>
@@ -2040,7 +2040,7 @@
           <p:cNvPr id="5" name="">
             <a:extLst xmlns:a="http://schemas.openxmlformats.org/drawingml/2006/main">
               <a:ext uri="{FF2B5EF4-FFF2-40B4-BE49-F238E27FC236}">
-                <a16:creationId xmlns:a16="http://schemas.microsoft.com/office/drawing/2014/main" id="{CD67FCB9-CB51-4008-814B-EFF8563052B2}"/>
+                <a16:creationId xmlns:a16="http://schemas.microsoft.com/office/drawing/2014/main" id="{49AFCA01-254A-4F0C-A5A8-86E0B7A72F1A}"/>
               </a:ext>
             </a:extLst>
           </p:cNvPr>
@@ -2098,7 +2098,7 @@
           <p:cNvPr id="6" name="">
             <a:extLst xmlns:a="http://schemas.openxmlformats.org/drawingml/2006/main">
               <a:ext uri="{FF2B5EF4-FFF2-40B4-BE49-F238E27FC236}">
-                <a16:creationId xmlns:a16="http://schemas.microsoft.com/office/drawing/2014/main" id="{960AE30F-AC74-4350-9CD4-DA5C1A7E017D}"/>
+                <a16:creationId xmlns:a16="http://schemas.microsoft.com/office/drawing/2014/main" id="{B982A1A1-A3C6-45D6-8698-E8DE306071F3}"/>
               </a:ext>
             </a:extLst>
           </p:cNvPr>
@@ -2133,7 +2133,7 @@
           <p:cNvPr id="7" name="">
             <a:extLst xmlns:a="http://schemas.openxmlformats.org/drawingml/2006/main">
               <a:ext uri="{FF2B5EF4-FFF2-40B4-BE49-F238E27FC236}">
-                <a16:creationId xmlns:a16="http://schemas.microsoft.com/office/drawing/2014/main" id="{05A125CC-F6EF-4407-A457-DB7A7BE70548}"/>
+                <a16:creationId xmlns:a16="http://schemas.microsoft.com/office/drawing/2014/main" id="{30E5C8FF-3D48-437A-AE70-CA6C61882D7F}"/>
               </a:ext>
             </a:extLst>
           </p:cNvPr>
@@ -2191,7 +2191,7 @@
           <p:cNvPr id="8" name="">
             <a:extLst xmlns:a="http://schemas.openxmlformats.org/drawingml/2006/main">
               <a:ext uri="{FF2B5EF4-FFF2-40B4-BE49-F238E27FC236}">
-                <a16:creationId xmlns:a16="http://schemas.microsoft.com/office/drawing/2014/main" id="{078FF3E4-DC10-4EC6-AE4B-BB933704C6D0}"/>
+                <a16:creationId xmlns:a16="http://schemas.microsoft.com/office/drawing/2014/main" id="{E333436E-1613-4B36-B1CE-6454CE96BD6B}"/>
               </a:ext>
             </a:extLst>
           </p:cNvPr>
@@ -2249,7 +2249,7 @@
           <p:cNvPr id="9" name="">
             <a:extLst xmlns:a="http://schemas.openxmlformats.org/drawingml/2006/main">
               <a:ext uri="{FF2B5EF4-FFF2-40B4-BE49-F238E27FC236}">
-                <a16:creationId xmlns:a16="http://schemas.microsoft.com/office/drawing/2014/main" id="{18F4EBAD-50BD-4D92-9D2D-3FE7340F18CB}"/>
+                <a16:creationId xmlns:a16="http://schemas.microsoft.com/office/drawing/2014/main" id="{A21C5B79-DA65-4B09-9A6B-A095D1653FC6}"/>
               </a:ext>
             </a:extLst>
           </p:cNvPr>
@@ -2307,7 +2307,7 @@
           <p:cNvPr id="10" name="">
             <a:extLst xmlns:a="http://schemas.openxmlformats.org/drawingml/2006/main">
               <a:ext uri="{FF2B5EF4-FFF2-40B4-BE49-F238E27FC236}">
-                <a16:creationId xmlns:a16="http://schemas.microsoft.com/office/drawing/2014/main" id="{19D4478D-71F0-44F6-9CE1-4D1E519A15F1}"/>
+                <a16:creationId xmlns:a16="http://schemas.microsoft.com/office/drawing/2014/main" id="{747CF960-8082-4ADA-B4A5-CCC337420D85}"/>
               </a:ext>
             </a:extLst>
           </p:cNvPr>
@@ -2340,7 +2340,7 @@
           <p:cNvPr id="11" name="">
             <a:extLst xmlns:a="http://schemas.openxmlformats.org/drawingml/2006/main">
               <a:ext uri="{FF2B5EF4-FFF2-40B4-BE49-F238E27FC236}">
-                <a16:creationId xmlns:a16="http://schemas.microsoft.com/office/drawing/2014/main" id="{5E3536DE-33C2-4D43-9256-AE8DD3032AB9}"/>
+                <a16:creationId xmlns:a16="http://schemas.microsoft.com/office/drawing/2014/main" id="{114E57F4-754B-44C9-8071-38A3AB76BBC8}"/>
               </a:ext>
             </a:extLst>
           </p:cNvPr>
@@ -2398,7 +2398,7 @@
           <p:cNvPr id="12" name="">
             <a:extLst xmlns:a="http://schemas.openxmlformats.org/drawingml/2006/main">
               <a:ext uri="{FF2B5EF4-FFF2-40B4-BE49-F238E27FC236}">
-                <a16:creationId xmlns:a16="http://schemas.microsoft.com/office/drawing/2014/main" id="{2E5C39BE-3E6D-48DD-880E-2988F6892C4B}"/>
+                <a16:creationId xmlns:a16="http://schemas.microsoft.com/office/drawing/2014/main" id="{4784AB74-515C-4434-B7CF-8B21573746C4}"/>
               </a:ext>
             </a:extLst>
           </p:cNvPr>
@@ -2446,7 +2446,7 @@
                 <a:ea typeface="Aptos"/>
                 <a:cs typeface="Aptos"/>
               </a:rPr>
-              <a:t>Prepared for roadmap review · waters-ci-20260909030324</a:t>
+              <a:t>Prepared for roadmap review · waters-ci-20260909033329</a:t>
             </a:r>
           </a:p>
         </p:txBody>
@@ -2456,7 +2456,7 @@
           <p:cNvPr id="13" name="">
             <a:extLst xmlns:a="http://schemas.openxmlformats.org/drawingml/2006/main">
               <a:ext uri="{FF2B5EF4-FFF2-40B4-BE49-F238E27FC236}">
-                <a16:creationId xmlns:a16="http://schemas.microsoft.com/office/drawing/2014/main" id="{3912F3CA-BF8D-4DC8-A2C3-2C0D15883682}"/>
+                <a16:creationId xmlns:a16="http://schemas.microsoft.com/office/drawing/2014/main" id="{E58E29F6-005B-4DDB-8B3F-E4AD2AF2E493}"/>
               </a:ext>
             </a:extLst>
           </p:cNvPr>
@@ -2512,7 +2512,7 @@
     </p:spTree>
     <p:extLst>
       <p:ext uri="{BB962C8B-B14F-4D97-AF65-F5344CB8AC3E}">
-        <p14:creationId xmlns:p14="http://schemas.microsoft.com/office/powerpoint/2010/main" val="1230188574"/>
+        <p14:creationId xmlns:p14="http://schemas.microsoft.com/office/powerpoint/2010/main" val="258356643"/>
       </p:ext>
     </p:extLst>
   </p:cSld>
@@ -2543,7 +2543,7 @@
           <p:cNvPr id="25" name="">
             <a:extLst xmlns:a="http://schemas.openxmlformats.org/drawingml/2006/main">
               <a:ext uri="{FF2B5EF4-FFF2-40B4-BE49-F238E27FC236}">
-                <a16:creationId xmlns:a16="http://schemas.microsoft.com/office/drawing/2014/main" id="{16E3C63B-074B-4A6C-9474-3614B144AD78}"/>
+                <a16:creationId xmlns:a16="http://schemas.microsoft.com/office/drawing/2014/main" id="{E7A0F1EE-7FF6-4287-B414-EDA279C419C9}"/>
               </a:ext>
             </a:extLst>
           </p:cNvPr>
@@ -2601,7 +2601,7 @@
           <p:cNvPr id="2" name="">
             <a:extLst xmlns:a="http://schemas.openxmlformats.org/drawingml/2006/main">
               <a:ext uri="{FF2B5EF4-FFF2-40B4-BE49-F238E27FC236}">
-                <a16:creationId xmlns:a16="http://schemas.microsoft.com/office/drawing/2014/main" id="{573A4362-C2EA-47AB-B259-49BCE6BD3295}"/>
+                <a16:creationId xmlns:a16="http://schemas.microsoft.com/office/drawing/2014/main" id="{AD9493A7-AFF2-4B0D-BCEF-E09B427B1628}"/>
               </a:ext>
             </a:extLst>
           </p:cNvPr>
@@ -2659,7 +2659,7 @@
           <p:cNvPr id="3" name="">
             <a:extLst xmlns:a="http://schemas.openxmlformats.org/drawingml/2006/main">
               <a:ext uri="{FF2B5EF4-FFF2-40B4-BE49-F238E27FC236}">
-                <a16:creationId xmlns:a16="http://schemas.microsoft.com/office/drawing/2014/main" id="{B33A178A-A323-4921-A7D5-2B8B1C4C13BB}"/>
+                <a16:creationId xmlns:a16="http://schemas.microsoft.com/office/drawing/2014/main" id="{DF1F0119-3448-4DA7-888D-819805440C46}"/>
               </a:ext>
             </a:extLst>
           </p:cNvPr>
@@ -2717,7 +2717,7 @@
           <p:cNvPr id="4" name="">
             <a:extLst xmlns:a="http://schemas.openxmlformats.org/drawingml/2006/main">
               <a:ext uri="{FF2B5EF4-FFF2-40B4-BE49-F238E27FC236}">
-                <a16:creationId xmlns:a16="http://schemas.microsoft.com/office/drawing/2014/main" id="{83CC72B2-E6DB-4E94-837B-FE918204D40A}"/>
+                <a16:creationId xmlns:a16="http://schemas.microsoft.com/office/drawing/2014/main" id="{ADB5C068-F7B9-4041-B1BB-34585CEB747B}"/>
               </a:ext>
             </a:extLst>
           </p:cNvPr>
@@ -2750,7 +2750,7 @@
           <p:cNvPr id="5" name="">
             <a:extLst xmlns:a="http://schemas.openxmlformats.org/drawingml/2006/main">
               <a:ext uri="{FF2B5EF4-FFF2-40B4-BE49-F238E27FC236}">
-                <a16:creationId xmlns:a16="http://schemas.microsoft.com/office/drawing/2014/main" id="{ABFCCA17-7506-41FF-854B-A24E60B435F2}"/>
+                <a16:creationId xmlns:a16="http://schemas.microsoft.com/office/drawing/2014/main" id="{0549E2C8-576B-4904-B6CA-FB29AD2465DE}"/>
               </a:ext>
             </a:extLst>
           </p:cNvPr>
@@ -2785,7 +2785,7 @@
           <p:cNvPr id="6" name="">
             <a:extLst xmlns:a="http://schemas.openxmlformats.org/drawingml/2006/main">
               <a:ext uri="{FF2B5EF4-FFF2-40B4-BE49-F238E27FC236}">
-                <a16:creationId xmlns:a16="http://schemas.microsoft.com/office/drawing/2014/main" id="{BDE935D3-A634-4F3A-AA56-96E008EEDAA1}"/>
+                <a16:creationId xmlns:a16="http://schemas.microsoft.com/office/drawing/2014/main" id="{E9B7E26B-EFAC-4B5B-846B-5C1768F2A990}"/>
               </a:ext>
             </a:extLst>
           </p:cNvPr>
@@ -2843,7 +2843,7 @@
           <p:cNvPr id="7" name="">
             <a:extLst xmlns:a="http://schemas.openxmlformats.org/drawingml/2006/main">
               <a:ext uri="{FF2B5EF4-FFF2-40B4-BE49-F238E27FC236}">
-                <a16:creationId xmlns:a16="http://schemas.microsoft.com/office/drawing/2014/main" id="{AA523CBE-C2C9-421F-B0A4-A1E464172DAD}"/>
+                <a16:creationId xmlns:a16="http://schemas.microsoft.com/office/drawing/2014/main" id="{1B14667A-F0FE-4E83-AF54-296F4430D4E0}"/>
               </a:ext>
             </a:extLst>
           </p:cNvPr>
@@ -2901,7 +2901,7 @@
           <p:cNvPr id="8" name="">
             <a:extLst xmlns:a="http://schemas.openxmlformats.org/drawingml/2006/main">
               <a:ext uri="{FF2B5EF4-FFF2-40B4-BE49-F238E27FC236}">
-                <a16:creationId xmlns:a16="http://schemas.microsoft.com/office/drawing/2014/main" id="{8A2B7C99-EC7F-400C-B0B0-33067C876E8E}"/>
+                <a16:creationId xmlns:a16="http://schemas.microsoft.com/office/drawing/2014/main" id="{F4337989-85F4-4896-A248-DA90DE5F08BE}"/>
               </a:ext>
             </a:extLst>
           </p:cNvPr>
@@ -2936,7 +2936,7 @@
           <p:cNvPr id="9" name="">
             <a:extLst xmlns:a="http://schemas.openxmlformats.org/drawingml/2006/main">
               <a:ext uri="{FF2B5EF4-FFF2-40B4-BE49-F238E27FC236}">
-                <a16:creationId xmlns:a16="http://schemas.microsoft.com/office/drawing/2014/main" id="{70AFA9D7-D6D0-4858-BC11-02309F81A155}"/>
+                <a16:creationId xmlns:a16="http://schemas.microsoft.com/office/drawing/2014/main" id="{A7585685-78D9-4DC5-926E-B7A268E7A395}"/>
               </a:ext>
             </a:extLst>
           </p:cNvPr>
@@ -2969,7 +2969,7 @@
           <p:cNvPr id="10" name="">
             <a:extLst xmlns:a="http://schemas.openxmlformats.org/drawingml/2006/main">
               <a:ext uri="{FF2B5EF4-FFF2-40B4-BE49-F238E27FC236}">
-                <a16:creationId xmlns:a16="http://schemas.microsoft.com/office/drawing/2014/main" id="{F9D0E9CC-C2B2-4436-B76E-C963CE1945C8}"/>
+                <a16:creationId xmlns:a16="http://schemas.microsoft.com/office/drawing/2014/main" id="{8A2B9E18-CCC1-441D-9B4D-E53656A8862D}"/>
               </a:ext>
             </a:extLst>
           </p:cNvPr>
@@ -3027,7 +3027,7 @@
           <p:cNvPr id="11" name="">
             <a:extLst xmlns:a="http://schemas.openxmlformats.org/drawingml/2006/main">
               <a:ext uri="{FF2B5EF4-FFF2-40B4-BE49-F238E27FC236}">
-                <a16:creationId xmlns:a16="http://schemas.microsoft.com/office/drawing/2014/main" id="{C3332E5E-0781-42EB-B7F7-BCC63FBF059D}"/>
+                <a16:creationId xmlns:a16="http://schemas.microsoft.com/office/drawing/2014/main" id="{5C106D7B-98EC-47B0-8FC1-A716C4247B3D}"/>
               </a:ext>
             </a:extLst>
           </p:cNvPr>
@@ -3085,7 +3085,7 @@
           <p:cNvPr id="12" name="">
             <a:extLst xmlns:a="http://schemas.openxmlformats.org/drawingml/2006/main">
               <a:ext uri="{FF2B5EF4-FFF2-40B4-BE49-F238E27FC236}">
-                <a16:creationId xmlns:a16="http://schemas.microsoft.com/office/drawing/2014/main" id="{0FD549D2-8D15-43BE-9B76-DE308CE232D7}"/>
+                <a16:creationId xmlns:a16="http://schemas.microsoft.com/office/drawing/2014/main" id="{599D01C2-E250-465D-B9A4-ACC352BEF5A9}"/>
               </a:ext>
             </a:extLst>
           </p:cNvPr>
@@ -3143,7 +3143,7 @@
           <p:cNvPr id="13" name="">
             <a:extLst xmlns:a="http://schemas.openxmlformats.org/drawingml/2006/main">
               <a:ext uri="{FF2B5EF4-FFF2-40B4-BE49-F238E27FC236}">
-                <a16:creationId xmlns:a16="http://schemas.microsoft.com/office/drawing/2014/main" id="{4A0B9265-2E17-4CAC-9338-DB3E2E057C57}"/>
+                <a16:creationId xmlns:a16="http://schemas.microsoft.com/office/drawing/2014/main" id="{80B7A1F2-33E0-4334-816B-7D152D62A748}"/>
               </a:ext>
             </a:extLst>
           </p:cNvPr>
@@ -3178,7 +3178,7 @@
           <p:cNvPr id="14" name="">
             <a:extLst xmlns:a="http://schemas.openxmlformats.org/drawingml/2006/main">
               <a:ext uri="{FF2B5EF4-FFF2-40B4-BE49-F238E27FC236}">
-                <a16:creationId xmlns:a16="http://schemas.microsoft.com/office/drawing/2014/main" id="{ABD57E74-3415-4636-8795-12F821449460}"/>
+                <a16:creationId xmlns:a16="http://schemas.microsoft.com/office/drawing/2014/main" id="{FEE8A953-7F4F-4C9F-9FD4-D0158D89150B}"/>
               </a:ext>
             </a:extLst>
           </p:cNvPr>
@@ -3211,7 +3211,7 @@
           <p:cNvPr id="15" name="">
             <a:extLst xmlns:a="http://schemas.openxmlformats.org/drawingml/2006/main">
               <a:ext uri="{FF2B5EF4-FFF2-40B4-BE49-F238E27FC236}">
-                <a16:creationId xmlns:a16="http://schemas.microsoft.com/office/drawing/2014/main" id="{13E89803-C0EE-40AF-BC1B-65B2EECCEC16}"/>
+                <a16:creationId xmlns:a16="http://schemas.microsoft.com/office/drawing/2014/main" id="{9489E2C8-A92F-4BD7-81D2-0ABC55BD91AF}"/>
               </a:ext>
             </a:extLst>
           </p:cNvPr>
@@ -3269,7 +3269,7 @@
           <p:cNvPr id="16" name="">
             <a:extLst xmlns:a="http://schemas.openxmlformats.org/drawingml/2006/main">
               <a:ext uri="{FF2B5EF4-FFF2-40B4-BE49-F238E27FC236}">
-                <a16:creationId xmlns:a16="http://schemas.microsoft.com/office/drawing/2014/main" id="{B6CFCD61-349F-4774-9BC6-FB6B27E6967A}"/>
+                <a16:creationId xmlns:a16="http://schemas.microsoft.com/office/drawing/2014/main" id="{96F92583-EAB6-484C-AC3B-26DC0F62E5F0}"/>
               </a:ext>
             </a:extLst>
           </p:cNvPr>
@@ -3327,7 +3327,7 @@
           <p:cNvPr id="17" name="">
             <a:extLst xmlns:a="http://schemas.openxmlformats.org/drawingml/2006/main">
               <a:ext uri="{FF2B5EF4-FFF2-40B4-BE49-F238E27FC236}">
-                <a16:creationId xmlns:a16="http://schemas.microsoft.com/office/drawing/2014/main" id="{25616117-AA9F-4631-B695-23F56103E07A}"/>
+                <a16:creationId xmlns:a16="http://schemas.microsoft.com/office/drawing/2014/main" id="{77C0FD2A-C462-442E-9940-18FC818E6B5A}"/>
               </a:ext>
             </a:extLst>
           </p:cNvPr>
@@ -3385,7 +3385,7 @@
           <p:cNvPr id="18" name="">
             <a:extLst xmlns:a="http://schemas.openxmlformats.org/drawingml/2006/main">
               <a:ext uri="{FF2B5EF4-FFF2-40B4-BE49-F238E27FC236}">
-                <a16:creationId xmlns:a16="http://schemas.microsoft.com/office/drawing/2014/main" id="{0993A712-A51D-4656-85DD-4C5F48FFCA27}"/>
+                <a16:creationId xmlns:a16="http://schemas.microsoft.com/office/drawing/2014/main" id="{5A918AA5-CD5F-49AE-91C7-D1BCD04E4EAF}"/>
               </a:ext>
             </a:extLst>
           </p:cNvPr>
@@ -3420,7 +3420,7 @@
           <p:cNvPr id="19" name="">
             <a:extLst xmlns:a="http://schemas.openxmlformats.org/drawingml/2006/main">
               <a:ext uri="{FF2B5EF4-FFF2-40B4-BE49-F238E27FC236}">
-                <a16:creationId xmlns:a16="http://schemas.microsoft.com/office/drawing/2014/main" id="{C492CB43-95A8-473F-8C29-A92803FF777F}"/>
+                <a16:creationId xmlns:a16="http://schemas.microsoft.com/office/drawing/2014/main" id="{C0730A31-AB83-4CD1-9ECF-056DB2C90084}"/>
               </a:ext>
             </a:extLst>
           </p:cNvPr>
@@ -3453,7 +3453,7 @@
           <p:cNvPr id="20" name="">
             <a:extLst xmlns:a="http://schemas.openxmlformats.org/drawingml/2006/main">
               <a:ext uri="{FF2B5EF4-FFF2-40B4-BE49-F238E27FC236}">
-                <a16:creationId xmlns:a16="http://schemas.microsoft.com/office/drawing/2014/main" id="{87BB350F-3F22-4970-A84D-B9A14BF5D1CC}"/>
+                <a16:creationId xmlns:a16="http://schemas.microsoft.com/office/drawing/2014/main" id="{0E3AA352-93E2-433A-B6EC-6918DDC104CE}"/>
               </a:ext>
             </a:extLst>
           </p:cNvPr>
@@ -3511,7 +3511,7 @@
           <p:cNvPr id="21" name="">
             <a:extLst xmlns:a="http://schemas.openxmlformats.org/drawingml/2006/main">
               <a:ext uri="{FF2B5EF4-FFF2-40B4-BE49-F238E27FC236}">
-                <a16:creationId xmlns:a16="http://schemas.microsoft.com/office/drawing/2014/main" id="{82C883BA-45CE-488F-9B75-C413A7A0D1FA}"/>
+                <a16:creationId xmlns:a16="http://schemas.microsoft.com/office/drawing/2014/main" id="{CC424962-F0FD-4159-9BE7-E375E65D6BB4}"/>
               </a:ext>
             </a:extLst>
           </p:cNvPr>
@@ -3569,7 +3569,7 @@
           <p:cNvPr id="22" name="">
             <a:extLst xmlns:a="http://schemas.openxmlformats.org/drawingml/2006/main">
               <a:ext uri="{FF2B5EF4-FFF2-40B4-BE49-F238E27FC236}">
-                <a16:creationId xmlns:a16="http://schemas.microsoft.com/office/drawing/2014/main" id="{234BB85C-1403-4811-A8E5-4EB403B9AB32}"/>
+                <a16:creationId xmlns:a16="http://schemas.microsoft.com/office/drawing/2014/main" id="{FE3C8808-D8D9-4A90-9BD9-D47D7D6CC502}"/>
               </a:ext>
             </a:extLst>
           </p:cNvPr>
@@ -3627,7 +3627,7 @@
           <p:cNvPr id="23" name="">
             <a:extLst xmlns:a="http://schemas.openxmlformats.org/drawingml/2006/main">
               <a:ext uri="{FF2B5EF4-FFF2-40B4-BE49-F238E27FC236}">
-                <a16:creationId xmlns:a16="http://schemas.microsoft.com/office/drawing/2014/main" id="{DAC5DA38-DC6D-4CBA-81C3-64498A7145AE}"/>
+                <a16:creationId xmlns:a16="http://schemas.microsoft.com/office/drawing/2014/main" id="{E7F026A0-2BFE-4EF0-B301-F8AD173C8386}"/>
               </a:ext>
             </a:extLst>
           </p:cNvPr>
@@ -3675,7 +3675,7 @@
                 <a:ea typeface="Aptos"/>
                 <a:cs typeface="Aptos"/>
               </a:rPr>
-              <a:t>WATERS NEXT GEN COMPETITIVE INTELLIGENCE · 08 SEP 2026 · waters-ci-20260909030324</a:t>
+              <a:t>WATERS NEXT GEN COMPETITIVE INTELLIGENCE · 08 SEP 2026 · waters-ci-20260909033329</a:t>
             </a:r>
           </a:p>
         </p:txBody>
@@ -3685,7 +3685,7 @@
           <p:cNvPr id="24" name="">
             <a:extLst xmlns:a="http://schemas.openxmlformats.org/drawingml/2006/main">
               <a:ext uri="{FF2B5EF4-FFF2-40B4-BE49-F238E27FC236}">
-                <a16:creationId xmlns:a16="http://schemas.microsoft.com/office/drawing/2014/main" id="{21EBE62A-93EE-4FE7-8207-FF5CC31CEABB}"/>
+                <a16:creationId xmlns:a16="http://schemas.microsoft.com/office/drawing/2014/main" id="{6BE9A191-746C-4717-ACF6-6D6C4A169AF7}"/>
               </a:ext>
             </a:extLst>
           </p:cNvPr>
@@ -3741,7 +3741,7 @@
     </p:spTree>
     <p:extLst>
       <p:ext uri="{BB962C8B-B14F-4D97-AF65-F5344CB8AC3E}">
-        <p14:creationId xmlns:p14="http://schemas.microsoft.com/office/powerpoint/2010/main" val="1529244957"/>
+        <p14:creationId xmlns:p14="http://schemas.microsoft.com/office/powerpoint/2010/main" val="171937496"/>
       </p:ext>
     </p:extLst>
   </p:cSld>
@@ -3772,7 +3772,7 @@
           <p:cNvPr id="37" name="">
             <a:extLst xmlns:a="http://schemas.openxmlformats.org/drawingml/2006/main">
               <a:ext uri="{FF2B5EF4-FFF2-40B4-BE49-F238E27FC236}">
-                <a16:creationId xmlns:a16="http://schemas.microsoft.com/office/drawing/2014/main" id="{9425EAD0-0B98-47C4-9660-1F0874DC6417}"/>
+                <a16:creationId xmlns:a16="http://schemas.microsoft.com/office/drawing/2014/main" id="{9D69CCB1-2394-4F71-9D2F-D5B5426DC969}"/>
               </a:ext>
             </a:extLst>
           </p:cNvPr>
@@ -3830,7 +3830,7 @@
           <p:cNvPr id="2" name="">
             <a:extLst xmlns:a="http://schemas.openxmlformats.org/drawingml/2006/main">
               <a:ext uri="{FF2B5EF4-FFF2-40B4-BE49-F238E27FC236}">
-                <a16:creationId xmlns:a16="http://schemas.microsoft.com/office/drawing/2014/main" id="{601A4FFF-43C8-471A-82CF-6E5F49550703}"/>
+                <a16:creationId xmlns:a16="http://schemas.microsoft.com/office/drawing/2014/main" id="{935E4A8B-FCAC-4733-8551-21F9DF4C03AA}"/>
               </a:ext>
             </a:extLst>
           </p:cNvPr>
@@ -3888,7 +3888,7 @@
           <p:cNvPr id="3" name="">
             <a:extLst xmlns:a="http://schemas.openxmlformats.org/drawingml/2006/main">
               <a:ext uri="{FF2B5EF4-FFF2-40B4-BE49-F238E27FC236}">
-                <a16:creationId xmlns:a16="http://schemas.microsoft.com/office/drawing/2014/main" id="{4CBDF04D-F667-4A44-BBE6-F481007CD14B}"/>
+                <a16:creationId xmlns:a16="http://schemas.microsoft.com/office/drawing/2014/main" id="{3C511CCF-7DD0-4484-B1A2-251A7248E241}"/>
               </a:ext>
             </a:extLst>
           </p:cNvPr>
@@ -3946,7 +3946,7 @@
           <p:cNvPr id="4" name="">
             <a:extLst xmlns:a="http://schemas.openxmlformats.org/drawingml/2006/main">
               <a:ext uri="{FF2B5EF4-FFF2-40B4-BE49-F238E27FC236}">
-                <a16:creationId xmlns:a16="http://schemas.microsoft.com/office/drawing/2014/main" id="{90E84CCE-7291-4692-B093-036E5EE7CC8A}"/>
+                <a16:creationId xmlns:a16="http://schemas.microsoft.com/office/drawing/2014/main" id="{414BCBB4-A836-4021-8D0D-764243421EA1}"/>
               </a:ext>
             </a:extLst>
           </p:cNvPr>
@@ -3979,7 +3979,7 @@
           <p:cNvPr id="5" name="">
             <a:extLst xmlns:a="http://schemas.openxmlformats.org/drawingml/2006/main">
               <a:ext uri="{FF2B5EF4-FFF2-40B4-BE49-F238E27FC236}">
-                <a16:creationId xmlns:a16="http://schemas.microsoft.com/office/drawing/2014/main" id="{E2174DD5-851D-44EC-B06F-1C2224CADB86}"/>
+                <a16:creationId xmlns:a16="http://schemas.microsoft.com/office/drawing/2014/main" id="{67B6E5FA-19EF-4A30-B3AC-873D0BC9304F}"/>
               </a:ext>
             </a:extLst>
           </p:cNvPr>
@@ -4014,7 +4014,7 @@
           <p:cNvPr id="6" name="">
             <a:extLst xmlns:a="http://schemas.openxmlformats.org/drawingml/2006/main">
               <a:ext uri="{FF2B5EF4-FFF2-40B4-BE49-F238E27FC236}">
-                <a16:creationId xmlns:a16="http://schemas.microsoft.com/office/drawing/2014/main" id="{52BBAAA9-51D3-4D0A-8679-8F30DDCE1BAD}"/>
+                <a16:creationId xmlns:a16="http://schemas.microsoft.com/office/drawing/2014/main" id="{21030392-8EE1-4814-8615-95A0812F8C66}"/>
               </a:ext>
             </a:extLst>
           </p:cNvPr>
@@ -4049,7 +4049,7 @@
           <p:cNvPr id="7" name="">
             <a:extLst xmlns:a="http://schemas.openxmlformats.org/drawingml/2006/main">
               <a:ext uri="{FF2B5EF4-FFF2-40B4-BE49-F238E27FC236}">
-                <a16:creationId xmlns:a16="http://schemas.microsoft.com/office/drawing/2014/main" id="{623C7E45-EDC6-49D6-9613-0DC0975F2D59}"/>
+                <a16:creationId xmlns:a16="http://schemas.microsoft.com/office/drawing/2014/main" id="{1B8721D9-8E5B-49EB-A3DA-15956B8949A8}"/>
               </a:ext>
             </a:extLst>
           </p:cNvPr>
@@ -4107,7 +4107,7 @@
           <p:cNvPr id="8" name="">
             <a:extLst xmlns:a="http://schemas.openxmlformats.org/drawingml/2006/main">
               <a:ext uri="{FF2B5EF4-FFF2-40B4-BE49-F238E27FC236}">
-                <a16:creationId xmlns:a16="http://schemas.microsoft.com/office/drawing/2014/main" id="{907EF886-7C34-47FE-8954-DF82A024ADD1}"/>
+                <a16:creationId xmlns:a16="http://schemas.microsoft.com/office/drawing/2014/main" id="{A9971885-18EC-4EAB-8A21-17B08976910D}"/>
               </a:ext>
             </a:extLst>
           </p:cNvPr>
@@ -4165,7 +4165,7 @@
           <p:cNvPr id="9" name="">
             <a:extLst xmlns:a="http://schemas.openxmlformats.org/drawingml/2006/main">
               <a:ext uri="{FF2B5EF4-FFF2-40B4-BE49-F238E27FC236}">
-                <a16:creationId xmlns:a16="http://schemas.microsoft.com/office/drawing/2014/main" id="{F4A780A3-42DA-456B-B398-B64B70F06286}"/>
+                <a16:creationId xmlns:a16="http://schemas.microsoft.com/office/drawing/2014/main" id="{C4953A38-8BCC-4FE0-90B9-F9757A2E88BC}"/>
               </a:ext>
             </a:extLst>
           </p:cNvPr>
@@ -4223,7 +4223,7 @@
           <p:cNvPr id="10" name="">
             <a:extLst xmlns:a="http://schemas.openxmlformats.org/drawingml/2006/main">
               <a:ext uri="{FF2B5EF4-FFF2-40B4-BE49-F238E27FC236}">
-                <a16:creationId xmlns:a16="http://schemas.microsoft.com/office/drawing/2014/main" id="{57FB0847-9391-494C-B5DB-F8AD03A9699E}"/>
+                <a16:creationId xmlns:a16="http://schemas.microsoft.com/office/drawing/2014/main" id="{EEC4E999-C4EE-47C8-8E3A-385E8B25E9AA}"/>
               </a:ext>
             </a:extLst>
           </p:cNvPr>
@@ -4281,7 +4281,7 @@
           <p:cNvPr id="11" name="">
             <a:extLst xmlns:a="http://schemas.openxmlformats.org/drawingml/2006/main">
               <a:ext uri="{FF2B5EF4-FFF2-40B4-BE49-F238E27FC236}">
-                <a16:creationId xmlns:a16="http://schemas.microsoft.com/office/drawing/2014/main" id="{478CA587-974B-4005-B484-B200669144BD}"/>
+                <a16:creationId xmlns:a16="http://schemas.microsoft.com/office/drawing/2014/main" id="{E3BE882A-88DC-4344-AEDF-1B141FE7C699}"/>
               </a:ext>
             </a:extLst>
           </p:cNvPr>
@@ -4316,7 +4316,7 @@
           <p:cNvPr id="12" name="">
             <a:extLst xmlns:a="http://schemas.openxmlformats.org/drawingml/2006/main">
               <a:ext uri="{FF2B5EF4-FFF2-40B4-BE49-F238E27FC236}">
-                <a16:creationId xmlns:a16="http://schemas.microsoft.com/office/drawing/2014/main" id="{5ACC7C2B-C10F-4F12-819E-B8B10E552375}"/>
+                <a16:creationId xmlns:a16="http://schemas.microsoft.com/office/drawing/2014/main" id="{8E4F8789-55DA-4724-B924-235FD6B24098}"/>
               </a:ext>
             </a:extLst>
           </p:cNvPr>
@@ -4351,7 +4351,7 @@
           <p:cNvPr id="13" name="">
             <a:extLst xmlns:a="http://schemas.openxmlformats.org/drawingml/2006/main">
               <a:ext uri="{FF2B5EF4-FFF2-40B4-BE49-F238E27FC236}">
-                <a16:creationId xmlns:a16="http://schemas.microsoft.com/office/drawing/2014/main" id="{9A764D32-CF35-4E61-A0B6-34DBF55E19F4}"/>
+                <a16:creationId xmlns:a16="http://schemas.microsoft.com/office/drawing/2014/main" id="{4D677E31-07BA-44B6-96AF-6802190688E7}"/>
               </a:ext>
             </a:extLst>
           </p:cNvPr>
@@ -4409,7 +4409,7 @@
           <p:cNvPr id="14" name="">
             <a:extLst xmlns:a="http://schemas.openxmlformats.org/drawingml/2006/main">
               <a:ext uri="{FF2B5EF4-FFF2-40B4-BE49-F238E27FC236}">
-                <a16:creationId xmlns:a16="http://schemas.microsoft.com/office/drawing/2014/main" id="{F4EF14DD-4DAD-4162-960E-B18F46A8E75D}"/>
+                <a16:creationId xmlns:a16="http://schemas.microsoft.com/office/drawing/2014/main" id="{19B07A82-A481-4EEA-A5DC-A1889B2210C4}"/>
               </a:ext>
             </a:extLst>
           </p:cNvPr>
@@ -4467,7 +4467,7 @@
           <p:cNvPr id="15" name="">
             <a:extLst xmlns:a="http://schemas.openxmlformats.org/drawingml/2006/main">
               <a:ext uri="{FF2B5EF4-FFF2-40B4-BE49-F238E27FC236}">
-                <a16:creationId xmlns:a16="http://schemas.microsoft.com/office/drawing/2014/main" id="{B0F8340B-F6A3-48EF-85F7-EC4243EC1C53}"/>
+                <a16:creationId xmlns:a16="http://schemas.microsoft.com/office/drawing/2014/main" id="{4DB39DFA-4D2C-483D-AC86-FEC7AF095A05}"/>
               </a:ext>
             </a:extLst>
           </p:cNvPr>
@@ -4525,7 +4525,7 @@
           <p:cNvPr id="16" name="">
             <a:extLst xmlns:a="http://schemas.openxmlformats.org/drawingml/2006/main">
               <a:ext uri="{FF2B5EF4-FFF2-40B4-BE49-F238E27FC236}">
-                <a16:creationId xmlns:a16="http://schemas.microsoft.com/office/drawing/2014/main" id="{6151D791-763B-44B1-860F-BD36A9D116AA}"/>
+                <a16:creationId xmlns:a16="http://schemas.microsoft.com/office/drawing/2014/main" id="{D418BB43-D6DC-4923-8E34-31AD34E60934}"/>
               </a:ext>
             </a:extLst>
           </p:cNvPr>
@@ -4583,7 +4583,7 @@
           <p:cNvPr id="17" name="">
             <a:extLst xmlns:a="http://schemas.openxmlformats.org/drawingml/2006/main">
               <a:ext uri="{FF2B5EF4-FFF2-40B4-BE49-F238E27FC236}">
-                <a16:creationId xmlns:a16="http://schemas.microsoft.com/office/drawing/2014/main" id="{21545107-47C7-4EE4-9B5D-D67EC128FE7A}"/>
+                <a16:creationId xmlns:a16="http://schemas.microsoft.com/office/drawing/2014/main" id="{CCDE55E1-BE43-49A2-96DF-F36772C095D4}"/>
               </a:ext>
             </a:extLst>
           </p:cNvPr>
@@ -4618,7 +4618,7 @@
           <p:cNvPr id="18" name="">
             <a:extLst xmlns:a="http://schemas.openxmlformats.org/drawingml/2006/main">
               <a:ext uri="{FF2B5EF4-FFF2-40B4-BE49-F238E27FC236}">
-                <a16:creationId xmlns:a16="http://schemas.microsoft.com/office/drawing/2014/main" id="{56CCD6D8-4F68-40EB-932C-703DC72D5033}"/>
+                <a16:creationId xmlns:a16="http://schemas.microsoft.com/office/drawing/2014/main" id="{9C49BB8C-84A5-4DF4-86C0-B187B4DF2721}"/>
               </a:ext>
             </a:extLst>
           </p:cNvPr>
@@ -4653,7 +4653,7 @@
           <p:cNvPr id="19" name="">
             <a:extLst xmlns:a="http://schemas.openxmlformats.org/drawingml/2006/main">
               <a:ext uri="{FF2B5EF4-FFF2-40B4-BE49-F238E27FC236}">
-                <a16:creationId xmlns:a16="http://schemas.microsoft.com/office/drawing/2014/main" id="{4442EB07-8367-4A84-92AA-4C5AAC993089}"/>
+                <a16:creationId xmlns:a16="http://schemas.microsoft.com/office/drawing/2014/main" id="{B18EA12C-C6AA-47F3-8374-2C00368A07B0}"/>
               </a:ext>
             </a:extLst>
           </p:cNvPr>
@@ -4711,7 +4711,7 @@
           <p:cNvPr id="20" name="">
             <a:extLst xmlns:a="http://schemas.openxmlformats.org/drawingml/2006/main">
               <a:ext uri="{FF2B5EF4-FFF2-40B4-BE49-F238E27FC236}">
-                <a16:creationId xmlns:a16="http://schemas.microsoft.com/office/drawing/2014/main" id="{D2D2D592-EB6F-44BE-BFE8-24CFB0CC8584}"/>
+                <a16:creationId xmlns:a16="http://schemas.microsoft.com/office/drawing/2014/main" id="{CB013B14-BCE9-4DAB-BC8B-922AB8E804B0}"/>
               </a:ext>
             </a:extLst>
           </p:cNvPr>
@@ -4769,7 +4769,7 @@
           <p:cNvPr id="21" name="">
             <a:extLst xmlns:a="http://schemas.openxmlformats.org/drawingml/2006/main">
               <a:ext uri="{FF2B5EF4-FFF2-40B4-BE49-F238E27FC236}">
-                <a16:creationId xmlns:a16="http://schemas.microsoft.com/office/drawing/2014/main" id="{2BDAC30F-A7A7-4555-B2F1-0AAB164CC9FF}"/>
+                <a16:creationId xmlns:a16="http://schemas.microsoft.com/office/drawing/2014/main" id="{1E02C6B2-CD89-4477-BF9B-C41D45623624}"/>
               </a:ext>
             </a:extLst>
           </p:cNvPr>
@@ -4827,7 +4827,7 @@
           <p:cNvPr id="22" name="">
             <a:extLst xmlns:a="http://schemas.openxmlformats.org/drawingml/2006/main">
               <a:ext uri="{FF2B5EF4-FFF2-40B4-BE49-F238E27FC236}">
-                <a16:creationId xmlns:a16="http://schemas.microsoft.com/office/drawing/2014/main" id="{4A0DC9ED-FE92-4006-B546-BC5E7EAC0458}"/>
+                <a16:creationId xmlns:a16="http://schemas.microsoft.com/office/drawing/2014/main" id="{ABD25DA1-B891-43F3-8323-3A4B016C4BB0}"/>
               </a:ext>
             </a:extLst>
           </p:cNvPr>
@@ -4885,7 +4885,7 @@
           <p:cNvPr id="23" name="">
             <a:extLst xmlns:a="http://schemas.openxmlformats.org/drawingml/2006/main">
               <a:ext uri="{FF2B5EF4-FFF2-40B4-BE49-F238E27FC236}">
-                <a16:creationId xmlns:a16="http://schemas.microsoft.com/office/drawing/2014/main" id="{34D20631-22E7-484C-B149-B6CA98C5246D}"/>
+                <a16:creationId xmlns:a16="http://schemas.microsoft.com/office/drawing/2014/main" id="{AC8CADDD-6B36-4895-80FC-CFCBEE3BA58E}"/>
               </a:ext>
             </a:extLst>
           </p:cNvPr>
@@ -4920,7 +4920,7 @@
           <p:cNvPr id="24" name="">
             <a:extLst xmlns:a="http://schemas.openxmlformats.org/drawingml/2006/main">
               <a:ext uri="{FF2B5EF4-FFF2-40B4-BE49-F238E27FC236}">
-                <a16:creationId xmlns:a16="http://schemas.microsoft.com/office/drawing/2014/main" id="{2D478D25-69C8-483B-923B-D2EB33D8373A}"/>
+                <a16:creationId xmlns:a16="http://schemas.microsoft.com/office/drawing/2014/main" id="{76504289-06DB-4E25-9871-F4BE813AB370}"/>
               </a:ext>
             </a:extLst>
           </p:cNvPr>
@@ -4955,7 +4955,7 @@
           <p:cNvPr id="25" name="">
             <a:extLst xmlns:a="http://schemas.openxmlformats.org/drawingml/2006/main">
               <a:ext uri="{FF2B5EF4-FFF2-40B4-BE49-F238E27FC236}">
-                <a16:creationId xmlns:a16="http://schemas.microsoft.com/office/drawing/2014/main" id="{7088377D-7ACD-4D03-BCB4-96415ECB522F}"/>
+                <a16:creationId xmlns:a16="http://schemas.microsoft.com/office/drawing/2014/main" id="{99993548-8395-414F-9BCA-E11712A74A0B}"/>
               </a:ext>
             </a:extLst>
           </p:cNvPr>
@@ -5013,7 +5013,7 @@
           <p:cNvPr id="26" name="">
             <a:extLst xmlns:a="http://schemas.openxmlformats.org/drawingml/2006/main">
               <a:ext uri="{FF2B5EF4-FFF2-40B4-BE49-F238E27FC236}">
-                <a16:creationId xmlns:a16="http://schemas.microsoft.com/office/drawing/2014/main" id="{5CF28A4E-8B80-4DD0-B3E7-E315F383693E}"/>
+                <a16:creationId xmlns:a16="http://schemas.microsoft.com/office/drawing/2014/main" id="{BFD6E7C3-A604-4A73-B0BA-C21F5969739A}"/>
               </a:ext>
             </a:extLst>
           </p:cNvPr>
@@ -5071,7 +5071,7 @@
           <p:cNvPr id="27" name="">
             <a:extLst xmlns:a="http://schemas.openxmlformats.org/drawingml/2006/main">
               <a:ext uri="{FF2B5EF4-FFF2-40B4-BE49-F238E27FC236}">
-                <a16:creationId xmlns:a16="http://schemas.microsoft.com/office/drawing/2014/main" id="{E4D2A87E-8A07-43B0-B6B3-6552BE9B6529}"/>
+                <a16:creationId xmlns:a16="http://schemas.microsoft.com/office/drawing/2014/main" id="{4F0D75EC-44D8-4A74-B240-9316FCB270C3}"/>
               </a:ext>
             </a:extLst>
           </p:cNvPr>
@@ -5129,7 +5129,7 @@
           <p:cNvPr id="28" name="">
             <a:extLst xmlns:a="http://schemas.openxmlformats.org/drawingml/2006/main">
               <a:ext uri="{FF2B5EF4-FFF2-40B4-BE49-F238E27FC236}">
-                <a16:creationId xmlns:a16="http://schemas.microsoft.com/office/drawing/2014/main" id="{215F3F96-28E4-4810-A520-9FA8A4E8B0A0}"/>
+                <a16:creationId xmlns:a16="http://schemas.microsoft.com/office/drawing/2014/main" id="{AB9DFF78-6A12-4D44-9B7A-3BE665CC35B7}"/>
               </a:ext>
             </a:extLst>
           </p:cNvPr>
@@ -5187,7 +5187,7 @@
           <p:cNvPr id="29" name="">
             <a:extLst xmlns:a="http://schemas.openxmlformats.org/drawingml/2006/main">
               <a:ext uri="{FF2B5EF4-FFF2-40B4-BE49-F238E27FC236}">
-                <a16:creationId xmlns:a16="http://schemas.microsoft.com/office/drawing/2014/main" id="{5CD85CE6-35A5-44C9-90E7-2403C6118B28}"/>
+                <a16:creationId xmlns:a16="http://schemas.microsoft.com/office/drawing/2014/main" id="{274BB05A-26AA-494B-A671-2D40CF38EF8B}"/>
               </a:ext>
             </a:extLst>
           </p:cNvPr>
@@ -5222,7 +5222,7 @@
           <p:cNvPr id="30" name="">
             <a:extLst xmlns:a="http://schemas.openxmlformats.org/drawingml/2006/main">
               <a:ext uri="{FF2B5EF4-FFF2-40B4-BE49-F238E27FC236}">
-                <a16:creationId xmlns:a16="http://schemas.microsoft.com/office/drawing/2014/main" id="{F82A22EC-D696-48D7-A3CA-2D39A7CC10EE}"/>
+                <a16:creationId xmlns:a16="http://schemas.microsoft.com/office/drawing/2014/main" id="{2353455C-53C0-4EEF-B5A6-13B7639213A5}"/>
               </a:ext>
             </a:extLst>
           </p:cNvPr>
@@ -5257,7 +5257,7 @@
           <p:cNvPr id="31" name="">
             <a:extLst xmlns:a="http://schemas.openxmlformats.org/drawingml/2006/main">
               <a:ext uri="{FF2B5EF4-FFF2-40B4-BE49-F238E27FC236}">
-                <a16:creationId xmlns:a16="http://schemas.microsoft.com/office/drawing/2014/main" id="{D65E0F88-1921-416F-A849-C19218E2EA3E}"/>
+                <a16:creationId xmlns:a16="http://schemas.microsoft.com/office/drawing/2014/main" id="{65EB8257-0674-405D-B271-9E1B1CB0D4C2}"/>
               </a:ext>
             </a:extLst>
           </p:cNvPr>
@@ -5315,7 +5315,7 @@
           <p:cNvPr id="32" name="">
             <a:extLst xmlns:a="http://schemas.openxmlformats.org/drawingml/2006/main">
               <a:ext uri="{FF2B5EF4-FFF2-40B4-BE49-F238E27FC236}">
-                <a16:creationId xmlns:a16="http://schemas.microsoft.com/office/drawing/2014/main" id="{2AED8A8F-93C9-496C-A3AA-F01FA24F3633}"/>
+                <a16:creationId xmlns:a16="http://schemas.microsoft.com/office/drawing/2014/main" id="{2E1851A7-3203-4FA6-A8E9-3CBA29654C4F}"/>
               </a:ext>
             </a:extLst>
           </p:cNvPr>
@@ -5373,7 +5373,7 @@
           <p:cNvPr id="33" name="">
             <a:extLst xmlns:a="http://schemas.openxmlformats.org/drawingml/2006/main">
               <a:ext uri="{FF2B5EF4-FFF2-40B4-BE49-F238E27FC236}">
-                <a16:creationId xmlns:a16="http://schemas.microsoft.com/office/drawing/2014/main" id="{FCA21FB7-68C2-4C57-8FCA-C1F3FF925838}"/>
+                <a16:creationId xmlns:a16="http://schemas.microsoft.com/office/drawing/2014/main" id="{4C2B5F8C-9640-4AB0-BABC-E454653C15A8}"/>
               </a:ext>
             </a:extLst>
           </p:cNvPr>
@@ -5431,7 +5431,7 @@
           <p:cNvPr id="34" name="">
             <a:extLst xmlns:a="http://schemas.openxmlformats.org/drawingml/2006/main">
               <a:ext uri="{FF2B5EF4-FFF2-40B4-BE49-F238E27FC236}">
-                <a16:creationId xmlns:a16="http://schemas.microsoft.com/office/drawing/2014/main" id="{0B9544B1-CF45-453F-AF30-662CC03CF390}"/>
+                <a16:creationId xmlns:a16="http://schemas.microsoft.com/office/drawing/2014/main" id="{FF688005-DBFE-4CB8-95D7-783D3F6ED833}"/>
               </a:ext>
             </a:extLst>
           </p:cNvPr>
@@ -5489,7 +5489,7 @@
           <p:cNvPr id="35" name="">
             <a:extLst xmlns:a="http://schemas.openxmlformats.org/drawingml/2006/main">
               <a:ext uri="{FF2B5EF4-FFF2-40B4-BE49-F238E27FC236}">
-                <a16:creationId xmlns:a16="http://schemas.microsoft.com/office/drawing/2014/main" id="{E8524B9F-4F33-4940-8610-86B9CE3B113F}"/>
+                <a16:creationId xmlns:a16="http://schemas.microsoft.com/office/drawing/2014/main" id="{6FB8B9A4-AC3F-4E7D-8E89-E4E8847A41D4}"/>
               </a:ext>
             </a:extLst>
           </p:cNvPr>
@@ -5537,7 +5537,7 @@
                 <a:ea typeface="Aptos"/>
                 <a:cs typeface="Aptos"/>
               </a:rPr>
-              <a:t>WATERS NEXT GEN COMPETITIVE INTELLIGENCE · 08 SEP 2026 · waters-ci-20260909030324</a:t>
+              <a:t>WATERS NEXT GEN COMPETITIVE INTELLIGENCE · 08 SEP 2026 · waters-ci-20260909033329</a:t>
             </a:r>
           </a:p>
         </p:txBody>
@@ -5547,7 +5547,7 @@
           <p:cNvPr id="36" name="">
             <a:extLst xmlns:a="http://schemas.openxmlformats.org/drawingml/2006/main">
               <a:ext uri="{FF2B5EF4-FFF2-40B4-BE49-F238E27FC236}">
-                <a16:creationId xmlns:a16="http://schemas.microsoft.com/office/drawing/2014/main" id="{AE06BF92-3B9A-48E0-86DA-957808508729}"/>
+                <a16:creationId xmlns:a16="http://schemas.microsoft.com/office/drawing/2014/main" id="{B5606852-6206-4BBC-B101-0B9D747E41E6}"/>
               </a:ext>
             </a:extLst>
           </p:cNvPr>
@@ -5603,7 +5603,7 @@
     </p:spTree>
     <p:extLst>
       <p:ext uri="{BB962C8B-B14F-4D97-AF65-F5344CB8AC3E}">
-        <p14:creationId xmlns:p14="http://schemas.microsoft.com/office/powerpoint/2010/main" val="1499131285"/>
+        <p14:creationId xmlns:p14="http://schemas.microsoft.com/office/powerpoint/2010/main" val="1339230356"/>
       </p:ext>
     </p:extLst>
   </p:cSld>
@@ -5634,7 +5634,7 @@
           <p:cNvPr id="31" name="">
             <a:extLst xmlns:a="http://schemas.openxmlformats.org/drawingml/2006/main">
               <a:ext uri="{FF2B5EF4-FFF2-40B4-BE49-F238E27FC236}">
-                <a16:creationId xmlns:a16="http://schemas.microsoft.com/office/drawing/2014/main" id="{BEE9F860-65BB-452B-B65A-BB7746E13674}"/>
+                <a16:creationId xmlns:a16="http://schemas.microsoft.com/office/drawing/2014/main" id="{BA447E1A-7AF2-44AD-9337-2AE603EDDBC3}"/>
               </a:ext>
             </a:extLst>
           </p:cNvPr>
@@ -5692,7 +5692,7 @@
           <p:cNvPr id="2" name="">
             <a:extLst xmlns:a="http://schemas.openxmlformats.org/drawingml/2006/main">
               <a:ext uri="{FF2B5EF4-FFF2-40B4-BE49-F238E27FC236}">
-                <a16:creationId xmlns:a16="http://schemas.microsoft.com/office/drawing/2014/main" id="{3EEE5DF6-451B-4ECA-A489-5EC355AA3915}"/>
+                <a16:creationId xmlns:a16="http://schemas.microsoft.com/office/drawing/2014/main" id="{B241D11D-99F1-4AA7-A8A5-ADEE5FA75E9D}"/>
               </a:ext>
             </a:extLst>
           </p:cNvPr>
@@ -5750,7 +5750,7 @@
           <p:cNvPr id="3" name="">
             <a:extLst xmlns:a="http://schemas.openxmlformats.org/drawingml/2006/main">
               <a:ext uri="{FF2B5EF4-FFF2-40B4-BE49-F238E27FC236}">
-                <a16:creationId xmlns:a16="http://schemas.microsoft.com/office/drawing/2014/main" id="{76660F28-755B-405D-AD0D-320679E4BA32}"/>
+                <a16:creationId xmlns:a16="http://schemas.microsoft.com/office/drawing/2014/main" id="{133E0156-A08A-428E-A31D-E42D4A442B79}"/>
               </a:ext>
             </a:extLst>
           </p:cNvPr>
@@ -5808,7 +5808,7 @@
           <p:cNvPr id="4" name="">
             <a:extLst xmlns:a="http://schemas.openxmlformats.org/drawingml/2006/main">
               <a:ext uri="{FF2B5EF4-FFF2-40B4-BE49-F238E27FC236}">
-                <a16:creationId xmlns:a16="http://schemas.microsoft.com/office/drawing/2014/main" id="{B84531C1-7D57-4060-9C7B-37F0D6596D35}"/>
+                <a16:creationId xmlns:a16="http://schemas.microsoft.com/office/drawing/2014/main" id="{51835774-A68F-4359-BE7B-ADC647E6AC9E}"/>
               </a:ext>
             </a:extLst>
           </p:cNvPr>
@@ -5841,7 +5841,7 @@
           <p:cNvPr id="5" name="">
             <a:extLst xmlns:a="http://schemas.openxmlformats.org/drawingml/2006/main">
               <a:ext uri="{FF2B5EF4-FFF2-40B4-BE49-F238E27FC236}">
-                <a16:creationId xmlns:a16="http://schemas.microsoft.com/office/drawing/2014/main" id="{39E73918-46AC-4CA6-8D4D-BD88C8C16D0D}"/>
+                <a16:creationId xmlns:a16="http://schemas.microsoft.com/office/drawing/2014/main" id="{A41F4022-2D0C-4CF8-A0C4-4BA07D21C951}"/>
               </a:ext>
             </a:extLst>
           </p:cNvPr>
@@ -5876,7 +5876,7 @@
           <p:cNvPr id="6" name="">
             <a:extLst xmlns:a="http://schemas.openxmlformats.org/drawingml/2006/main">
               <a:ext uri="{FF2B5EF4-FFF2-40B4-BE49-F238E27FC236}">
-                <a16:creationId xmlns:a16="http://schemas.microsoft.com/office/drawing/2014/main" id="{DD45F7C3-309E-4A7E-AB73-05BF33533144}"/>
+                <a16:creationId xmlns:a16="http://schemas.microsoft.com/office/drawing/2014/main" id="{E6DDF04F-7F3F-42CF-883C-88144EBC911E}"/>
               </a:ext>
             </a:extLst>
           </p:cNvPr>
@@ -5909,7 +5909,7 @@
           <p:cNvPr id="7" name="">
             <a:extLst xmlns:a="http://schemas.openxmlformats.org/drawingml/2006/main">
               <a:ext uri="{FF2B5EF4-FFF2-40B4-BE49-F238E27FC236}">
-                <a16:creationId xmlns:a16="http://schemas.microsoft.com/office/drawing/2014/main" id="{C5543680-B2AB-4681-B464-9850161FA28A}"/>
+                <a16:creationId xmlns:a16="http://schemas.microsoft.com/office/drawing/2014/main" id="{4AEC8449-454E-41A3-9342-4D8576453587}"/>
               </a:ext>
             </a:extLst>
           </p:cNvPr>
@@ -5967,7 +5967,7 @@
           <p:cNvPr id="8" name="">
             <a:extLst xmlns:a="http://schemas.openxmlformats.org/drawingml/2006/main">
               <a:ext uri="{FF2B5EF4-FFF2-40B4-BE49-F238E27FC236}">
-                <a16:creationId xmlns:a16="http://schemas.microsoft.com/office/drawing/2014/main" id="{7CE639CC-44AC-48CC-A655-B1405ED4A165}"/>
+                <a16:creationId xmlns:a16="http://schemas.microsoft.com/office/drawing/2014/main" id="{4B7CACF7-55C5-4B2F-99DA-D451B982EA81}"/>
               </a:ext>
             </a:extLst>
           </p:cNvPr>
@@ -6025,7 +6025,7 @@
           <p:cNvPr id="9" name="">
             <a:extLst xmlns:a="http://schemas.openxmlformats.org/drawingml/2006/main">
               <a:ext uri="{FF2B5EF4-FFF2-40B4-BE49-F238E27FC236}">
-                <a16:creationId xmlns:a16="http://schemas.microsoft.com/office/drawing/2014/main" id="{076CEBCA-5B75-40EC-BFE6-2C84A193350A}"/>
+                <a16:creationId xmlns:a16="http://schemas.microsoft.com/office/drawing/2014/main" id="{C5B02608-3CEF-46B3-82C7-20540163A0E3}"/>
               </a:ext>
             </a:extLst>
           </p:cNvPr>
@@ -6083,7 +6083,7 @@
           <p:cNvPr id="10" name="">
             <a:extLst xmlns:a="http://schemas.openxmlformats.org/drawingml/2006/main">
               <a:ext uri="{FF2B5EF4-FFF2-40B4-BE49-F238E27FC236}">
-                <a16:creationId xmlns:a16="http://schemas.microsoft.com/office/drawing/2014/main" id="{53413D71-4E44-4ECC-BB05-B7D53F11AE89}"/>
+                <a16:creationId xmlns:a16="http://schemas.microsoft.com/office/drawing/2014/main" id="{B364A1C4-890A-418C-B99A-FDFC29BEE320}"/>
               </a:ext>
             </a:extLst>
           </p:cNvPr>
@@ -6141,7 +6141,7 @@
           <p:cNvPr id="11" name="">
             <a:extLst xmlns:a="http://schemas.openxmlformats.org/drawingml/2006/main">
               <a:ext uri="{FF2B5EF4-FFF2-40B4-BE49-F238E27FC236}">
-                <a16:creationId xmlns:a16="http://schemas.microsoft.com/office/drawing/2014/main" id="{0CBF8771-AE4B-4855-8419-3176707D06CF}"/>
+                <a16:creationId xmlns:a16="http://schemas.microsoft.com/office/drawing/2014/main" id="{E7F2EADB-D067-417F-B952-257EA69BE878}"/>
               </a:ext>
             </a:extLst>
           </p:cNvPr>
@@ -6176,7 +6176,7 @@
           <p:cNvPr id="12" name="">
             <a:extLst xmlns:a="http://schemas.openxmlformats.org/drawingml/2006/main">
               <a:ext uri="{FF2B5EF4-FFF2-40B4-BE49-F238E27FC236}">
-                <a16:creationId xmlns:a16="http://schemas.microsoft.com/office/drawing/2014/main" id="{82E6B103-08D7-487B-8436-98C9EC2F9F48}"/>
+                <a16:creationId xmlns:a16="http://schemas.microsoft.com/office/drawing/2014/main" id="{0BA76A01-8E76-413C-BF31-C7F405E1969E}"/>
               </a:ext>
             </a:extLst>
           </p:cNvPr>
@@ -6209,7 +6209,7 @@
           <p:cNvPr id="13" name="">
             <a:extLst xmlns:a="http://schemas.openxmlformats.org/drawingml/2006/main">
               <a:ext uri="{FF2B5EF4-FFF2-40B4-BE49-F238E27FC236}">
-                <a16:creationId xmlns:a16="http://schemas.microsoft.com/office/drawing/2014/main" id="{354A54C4-8F80-4027-8CF7-F371D089E841}"/>
+                <a16:creationId xmlns:a16="http://schemas.microsoft.com/office/drawing/2014/main" id="{53FB2D83-FE83-4098-A917-1AC30BFA401C}"/>
               </a:ext>
             </a:extLst>
           </p:cNvPr>
@@ -6267,7 +6267,7 @@
           <p:cNvPr id="14" name="">
             <a:extLst xmlns:a="http://schemas.openxmlformats.org/drawingml/2006/main">
               <a:ext uri="{FF2B5EF4-FFF2-40B4-BE49-F238E27FC236}">
-                <a16:creationId xmlns:a16="http://schemas.microsoft.com/office/drawing/2014/main" id="{A779A06A-9BFA-440C-9F0F-966C5EABD2F5}"/>
+                <a16:creationId xmlns:a16="http://schemas.microsoft.com/office/drawing/2014/main" id="{48A8B969-5819-40EF-A344-61BFE299CC67}"/>
               </a:ext>
             </a:extLst>
           </p:cNvPr>
@@ -6325,7 +6325,7 @@
           <p:cNvPr id="15" name="">
             <a:extLst xmlns:a="http://schemas.openxmlformats.org/drawingml/2006/main">
               <a:ext uri="{FF2B5EF4-FFF2-40B4-BE49-F238E27FC236}">
-                <a16:creationId xmlns:a16="http://schemas.microsoft.com/office/drawing/2014/main" id="{6BAB717E-2D81-4201-BC4F-177FFF50C9D6}"/>
+                <a16:creationId xmlns:a16="http://schemas.microsoft.com/office/drawing/2014/main" id="{68690501-C9A7-4441-8FF9-E1C3275BD544}"/>
               </a:ext>
             </a:extLst>
           </p:cNvPr>
@@ -6383,7 +6383,7 @@
           <p:cNvPr id="16" name="">
             <a:extLst xmlns:a="http://schemas.openxmlformats.org/drawingml/2006/main">
               <a:ext uri="{FF2B5EF4-FFF2-40B4-BE49-F238E27FC236}">
-                <a16:creationId xmlns:a16="http://schemas.microsoft.com/office/drawing/2014/main" id="{BB9FB638-3744-4BD1-BC04-E9099C803369}"/>
+                <a16:creationId xmlns:a16="http://schemas.microsoft.com/office/drawing/2014/main" id="{E2DA80BA-B1AF-4B69-9EC4-39F8AF7D551A}"/>
               </a:ext>
             </a:extLst>
           </p:cNvPr>
@@ -6441,7 +6441,7 @@
           <p:cNvPr id="17" name="">
             <a:extLst xmlns:a="http://schemas.openxmlformats.org/drawingml/2006/main">
               <a:ext uri="{FF2B5EF4-FFF2-40B4-BE49-F238E27FC236}">
-                <a16:creationId xmlns:a16="http://schemas.microsoft.com/office/drawing/2014/main" id="{3175898F-958F-468C-A9D9-AC2CB6624632}"/>
+                <a16:creationId xmlns:a16="http://schemas.microsoft.com/office/drawing/2014/main" id="{6438C60F-79A9-4436-970B-F314DB2C39BC}"/>
               </a:ext>
             </a:extLst>
           </p:cNvPr>
@@ -6476,7 +6476,7 @@
           <p:cNvPr id="18" name="">
             <a:extLst xmlns:a="http://schemas.openxmlformats.org/drawingml/2006/main">
               <a:ext uri="{FF2B5EF4-FFF2-40B4-BE49-F238E27FC236}">
-                <a16:creationId xmlns:a16="http://schemas.microsoft.com/office/drawing/2014/main" id="{EEC97B05-9CE3-4D3A-9786-A0D700A9073F}"/>
+                <a16:creationId xmlns:a16="http://schemas.microsoft.com/office/drawing/2014/main" id="{6EE78BF8-1E2F-4E66-ADC0-A5CFD60FD9D5}"/>
               </a:ext>
             </a:extLst>
           </p:cNvPr>
@@ -6509,7 +6509,7 @@
           <p:cNvPr id="19" name="">
             <a:extLst xmlns:a="http://schemas.openxmlformats.org/drawingml/2006/main">
               <a:ext uri="{FF2B5EF4-FFF2-40B4-BE49-F238E27FC236}">
-                <a16:creationId xmlns:a16="http://schemas.microsoft.com/office/drawing/2014/main" id="{08F7440B-4F75-48AA-91FA-AB5506E9131F}"/>
+                <a16:creationId xmlns:a16="http://schemas.microsoft.com/office/drawing/2014/main" id="{79DB8D9A-5D39-4858-B4CE-3916916DEBB9}"/>
               </a:ext>
             </a:extLst>
           </p:cNvPr>
@@ -6567,7 +6567,7 @@
           <p:cNvPr id="20" name="">
             <a:extLst xmlns:a="http://schemas.openxmlformats.org/drawingml/2006/main">
               <a:ext uri="{FF2B5EF4-FFF2-40B4-BE49-F238E27FC236}">
-                <a16:creationId xmlns:a16="http://schemas.microsoft.com/office/drawing/2014/main" id="{2D6420C3-9C48-4838-BC6E-DF48B6BB5571}"/>
+                <a16:creationId xmlns:a16="http://schemas.microsoft.com/office/drawing/2014/main" id="{C593AEEF-1C68-49AF-91F9-5CD667A326F9}"/>
               </a:ext>
             </a:extLst>
           </p:cNvPr>
@@ -6625,7 +6625,7 @@
           <p:cNvPr id="21" name="">
             <a:extLst xmlns:a="http://schemas.openxmlformats.org/drawingml/2006/main">
               <a:ext uri="{FF2B5EF4-FFF2-40B4-BE49-F238E27FC236}">
-                <a16:creationId xmlns:a16="http://schemas.microsoft.com/office/drawing/2014/main" id="{72186550-ED95-49DB-B622-0E1C6DB91E33}"/>
+                <a16:creationId xmlns:a16="http://schemas.microsoft.com/office/drawing/2014/main" id="{4B1969CE-CE02-4E74-A373-2D14F7752328}"/>
               </a:ext>
             </a:extLst>
           </p:cNvPr>
@@ -6683,7 +6683,7 @@
           <p:cNvPr id="22" name="">
             <a:extLst xmlns:a="http://schemas.openxmlformats.org/drawingml/2006/main">
               <a:ext uri="{FF2B5EF4-FFF2-40B4-BE49-F238E27FC236}">
-                <a16:creationId xmlns:a16="http://schemas.microsoft.com/office/drawing/2014/main" id="{E930D6A5-1D84-4740-AF24-21BE5A94F548}"/>
+                <a16:creationId xmlns:a16="http://schemas.microsoft.com/office/drawing/2014/main" id="{B54D9D68-1252-4214-8264-481CF5F22C43}"/>
               </a:ext>
             </a:extLst>
           </p:cNvPr>
@@ -6741,7 +6741,7 @@
           <p:cNvPr id="23" name="">
             <a:extLst xmlns:a="http://schemas.openxmlformats.org/drawingml/2006/main">
               <a:ext uri="{FF2B5EF4-FFF2-40B4-BE49-F238E27FC236}">
-                <a16:creationId xmlns:a16="http://schemas.microsoft.com/office/drawing/2014/main" id="{5F1A57C7-741E-4A05-9B89-31BE777B9CDA}"/>
+                <a16:creationId xmlns:a16="http://schemas.microsoft.com/office/drawing/2014/main" id="{961AAA09-EC21-49C7-AD6A-759AE6160A1A}"/>
               </a:ext>
             </a:extLst>
           </p:cNvPr>
@@ -6776,7 +6776,7 @@
           <p:cNvPr id="24" name="">
             <a:extLst xmlns:a="http://schemas.openxmlformats.org/drawingml/2006/main">
               <a:ext uri="{FF2B5EF4-FFF2-40B4-BE49-F238E27FC236}">
-                <a16:creationId xmlns:a16="http://schemas.microsoft.com/office/drawing/2014/main" id="{181E2AC3-FEC6-453B-BE08-A46195B4743A}"/>
+                <a16:creationId xmlns:a16="http://schemas.microsoft.com/office/drawing/2014/main" id="{0ACD9308-33AD-457A-B72E-CA5C7027F130}"/>
               </a:ext>
             </a:extLst>
           </p:cNvPr>
@@ -6809,7 +6809,7 @@
           <p:cNvPr id="25" name="">
             <a:extLst xmlns:a="http://schemas.openxmlformats.org/drawingml/2006/main">
               <a:ext uri="{FF2B5EF4-FFF2-40B4-BE49-F238E27FC236}">
-                <a16:creationId xmlns:a16="http://schemas.microsoft.com/office/drawing/2014/main" id="{72733955-385A-4B0E-99ED-E0E844561BB8}"/>
+                <a16:creationId xmlns:a16="http://schemas.microsoft.com/office/drawing/2014/main" id="{1F27F885-4CAF-4E50-B85C-78D2854BC2AB}"/>
               </a:ext>
             </a:extLst>
           </p:cNvPr>
@@ -6867,7 +6867,7 @@
           <p:cNvPr id="26" name="">
             <a:extLst xmlns:a="http://schemas.openxmlformats.org/drawingml/2006/main">
               <a:ext uri="{FF2B5EF4-FFF2-40B4-BE49-F238E27FC236}">
-                <a16:creationId xmlns:a16="http://schemas.microsoft.com/office/drawing/2014/main" id="{3133330A-9D1C-4C97-8E7F-BE0361FC3F87}"/>
+                <a16:creationId xmlns:a16="http://schemas.microsoft.com/office/drawing/2014/main" id="{0478950E-08A4-4436-B2C0-E0C6DF1C9047}"/>
               </a:ext>
             </a:extLst>
           </p:cNvPr>
@@ -6925,7 +6925,7 @@
           <p:cNvPr id="27" name="">
             <a:extLst xmlns:a="http://schemas.openxmlformats.org/drawingml/2006/main">
               <a:ext uri="{FF2B5EF4-FFF2-40B4-BE49-F238E27FC236}">
-                <a16:creationId xmlns:a16="http://schemas.microsoft.com/office/drawing/2014/main" id="{0F8D5872-5D3E-4B59-8B2D-222CE6343FCD}"/>
+                <a16:creationId xmlns:a16="http://schemas.microsoft.com/office/drawing/2014/main" id="{154810B7-8F12-4753-886F-CE265D4DF242}"/>
               </a:ext>
             </a:extLst>
           </p:cNvPr>
@@ -6983,7 +6983,7 @@
           <p:cNvPr id="28" name="">
             <a:extLst xmlns:a="http://schemas.openxmlformats.org/drawingml/2006/main">
               <a:ext uri="{FF2B5EF4-FFF2-40B4-BE49-F238E27FC236}">
-                <a16:creationId xmlns:a16="http://schemas.microsoft.com/office/drawing/2014/main" id="{8B75211D-09F5-43DF-B768-1D94B47AB425}"/>
+                <a16:creationId xmlns:a16="http://schemas.microsoft.com/office/drawing/2014/main" id="{76C5A189-7948-4C30-BB47-FD4F5E469217}"/>
               </a:ext>
             </a:extLst>
           </p:cNvPr>
@@ -7041,7 +7041,7 @@
           <p:cNvPr id="29" name="">
             <a:extLst xmlns:a="http://schemas.openxmlformats.org/drawingml/2006/main">
               <a:ext uri="{FF2B5EF4-FFF2-40B4-BE49-F238E27FC236}">
-                <a16:creationId xmlns:a16="http://schemas.microsoft.com/office/drawing/2014/main" id="{9D3805F9-3486-4FA1-B441-E988BEFBC7C6}"/>
+                <a16:creationId xmlns:a16="http://schemas.microsoft.com/office/drawing/2014/main" id="{E09CA38B-9E01-478D-ABBD-08F06AC44C74}"/>
               </a:ext>
             </a:extLst>
           </p:cNvPr>
@@ -7089,7 +7089,7 @@
                 <a:ea typeface="Aptos"/>
                 <a:cs typeface="Aptos"/>
               </a:rPr>
-              <a:t>WATERS NEXT GEN COMPETITIVE INTELLIGENCE · 08 SEP 2026 · waters-ci-20260909030324</a:t>
+              <a:t>WATERS NEXT GEN COMPETITIVE INTELLIGENCE · 08 SEP 2026 · waters-ci-20260909033329</a:t>
             </a:r>
           </a:p>
         </p:txBody>
@@ -7099,7 +7099,7 @@
           <p:cNvPr id="30" name="">
             <a:extLst xmlns:a="http://schemas.openxmlformats.org/drawingml/2006/main">
               <a:ext uri="{FF2B5EF4-FFF2-40B4-BE49-F238E27FC236}">
-                <a16:creationId xmlns:a16="http://schemas.microsoft.com/office/drawing/2014/main" id="{0546C7E6-58B9-448D-AB3D-A6BD3DE592B0}"/>
+                <a16:creationId xmlns:a16="http://schemas.microsoft.com/office/drawing/2014/main" id="{16315626-9F40-4588-B384-90DC4B928390}"/>
               </a:ext>
             </a:extLst>
           </p:cNvPr>
@@ -7155,7 +7155,7 @@
     </p:spTree>
     <p:extLst>
       <p:ext uri="{BB962C8B-B14F-4D97-AF65-F5344CB8AC3E}">
-        <p14:creationId xmlns:p14="http://schemas.microsoft.com/office/powerpoint/2010/main" val="597419331"/>
+        <p14:creationId xmlns:p14="http://schemas.microsoft.com/office/powerpoint/2010/main" val="578227406"/>
       </p:ext>
     </p:extLst>
   </p:cSld>
@@ -7186,7 +7186,7 @@
           <p:cNvPr id="17" name="">
             <a:extLst xmlns:a="http://schemas.openxmlformats.org/drawingml/2006/main">
               <a:ext uri="{FF2B5EF4-FFF2-40B4-BE49-F238E27FC236}">
-                <a16:creationId xmlns:a16="http://schemas.microsoft.com/office/drawing/2014/main" id="{812C675F-A60F-4BDC-8A5B-5CE95F98819F}"/>
+                <a16:creationId xmlns:a16="http://schemas.microsoft.com/office/drawing/2014/main" id="{B8FE596E-E36A-4FAF-AA78-24EFC7C6B396}"/>
               </a:ext>
             </a:extLst>
           </p:cNvPr>
@@ -7244,7 +7244,7 @@
           <p:cNvPr id="2" name="">
             <a:extLst xmlns:a="http://schemas.openxmlformats.org/drawingml/2006/main">
               <a:ext uri="{FF2B5EF4-FFF2-40B4-BE49-F238E27FC236}">
-                <a16:creationId xmlns:a16="http://schemas.microsoft.com/office/drawing/2014/main" id="{0E4E539D-C354-420D-B2EF-A7E8482859C3}"/>
+                <a16:creationId xmlns:a16="http://schemas.microsoft.com/office/drawing/2014/main" id="{E93B0DAA-5C94-48CB-A9C1-37FA3888EDB8}"/>
               </a:ext>
             </a:extLst>
           </p:cNvPr>
@@ -7302,7 +7302,7 @@
           <p:cNvPr id="3" name="">
             <a:extLst xmlns:a="http://schemas.openxmlformats.org/drawingml/2006/main">
               <a:ext uri="{FF2B5EF4-FFF2-40B4-BE49-F238E27FC236}">
-                <a16:creationId xmlns:a16="http://schemas.microsoft.com/office/drawing/2014/main" id="{187B6C6B-8B84-434F-9A90-0FEEE9162425}"/>
+                <a16:creationId xmlns:a16="http://schemas.microsoft.com/office/drawing/2014/main" id="{44C31844-5BDD-4DA2-8B86-7D6871E754E4}"/>
               </a:ext>
             </a:extLst>
           </p:cNvPr>
@@ -7360,7 +7360,7 @@
           <p:cNvPr id="4" name="">
             <a:extLst xmlns:a="http://schemas.openxmlformats.org/drawingml/2006/main">
               <a:ext uri="{FF2B5EF4-FFF2-40B4-BE49-F238E27FC236}">
-                <a16:creationId xmlns:a16="http://schemas.microsoft.com/office/drawing/2014/main" id="{2CB0DFC1-95AA-4571-BFB1-0CE7DD808D2E}"/>
+                <a16:creationId xmlns:a16="http://schemas.microsoft.com/office/drawing/2014/main" id="{0D6C669C-8690-42C4-80CC-1017FC9E32A5}"/>
               </a:ext>
             </a:extLst>
           </p:cNvPr>
@@ -7393,7 +7393,7 @@
           <p:cNvPr id="5" name="">
             <a:extLst xmlns:a="http://schemas.openxmlformats.org/drawingml/2006/main">
               <a:ext uri="{FF2B5EF4-FFF2-40B4-BE49-F238E27FC236}">
-                <a16:creationId xmlns:a16="http://schemas.microsoft.com/office/drawing/2014/main" id="{98586857-327A-4266-B333-25105DFD5CE2}"/>
+                <a16:creationId xmlns:a16="http://schemas.microsoft.com/office/drawing/2014/main" id="{44FAB620-B148-418A-A920-4DB56EF19BDD}"/>
               </a:ext>
             </a:extLst>
           </p:cNvPr>
@@ -7428,7 +7428,7 @@
           <p:cNvPr id="6" name="">
             <a:extLst xmlns:a="http://schemas.openxmlformats.org/drawingml/2006/main">
               <a:ext uri="{FF2B5EF4-FFF2-40B4-BE49-F238E27FC236}">
-                <a16:creationId xmlns:a16="http://schemas.microsoft.com/office/drawing/2014/main" id="{8C8648ED-BFB2-4C1F-AD01-81BA6A6E0B6E}"/>
+                <a16:creationId xmlns:a16="http://schemas.microsoft.com/office/drawing/2014/main" id="{34930036-A65E-4F27-AF85-2B5982C29D8F}"/>
               </a:ext>
             </a:extLst>
           </p:cNvPr>
@@ -7486,7 +7486,7 @@
           <p:cNvPr id="7" name="">
             <a:extLst xmlns:a="http://schemas.openxmlformats.org/drawingml/2006/main">
               <a:ext uri="{FF2B5EF4-FFF2-40B4-BE49-F238E27FC236}">
-                <a16:creationId xmlns:a16="http://schemas.microsoft.com/office/drawing/2014/main" id="{4919631C-C2AD-4557-AA4D-AC040C2371D7}"/>
+                <a16:creationId xmlns:a16="http://schemas.microsoft.com/office/drawing/2014/main" id="{69052C87-8CC2-494B-8A4A-EAB28D93E29D}"/>
               </a:ext>
             </a:extLst>
           </p:cNvPr>
@@ -7544,7 +7544,7 @@
           <p:cNvPr id="8" name="">
             <a:extLst xmlns:a="http://schemas.openxmlformats.org/drawingml/2006/main">
               <a:ext uri="{FF2B5EF4-FFF2-40B4-BE49-F238E27FC236}">
-                <a16:creationId xmlns:a16="http://schemas.microsoft.com/office/drawing/2014/main" id="{D77E9DC8-B3BE-4ADC-8E97-8542C6C70AA7}"/>
+                <a16:creationId xmlns:a16="http://schemas.microsoft.com/office/drawing/2014/main" id="{EF8D1EB3-4B28-44B2-8909-EBD4411E0454}"/>
               </a:ext>
             </a:extLst>
           </p:cNvPr>
@@ -7602,7 +7602,7 @@
           <p:cNvPr id="9" name="">
             <a:extLst xmlns:a="http://schemas.openxmlformats.org/drawingml/2006/main">
               <a:ext uri="{FF2B5EF4-FFF2-40B4-BE49-F238E27FC236}">
-                <a16:creationId xmlns:a16="http://schemas.microsoft.com/office/drawing/2014/main" id="{C8F991A1-EF10-4379-AC86-1F5716361A04}"/>
+                <a16:creationId xmlns:a16="http://schemas.microsoft.com/office/drawing/2014/main" id="{868148B5-041B-4C86-B4E9-8611D40B215E}"/>
               </a:ext>
             </a:extLst>
           </p:cNvPr>
@@ -7683,7 +7683,7 @@
           <p:cNvPr id="10" name="">
             <a:extLst xmlns:a="http://schemas.openxmlformats.org/drawingml/2006/main">
               <a:ext uri="{FF2B5EF4-FFF2-40B4-BE49-F238E27FC236}">
-                <a16:creationId xmlns:a16="http://schemas.microsoft.com/office/drawing/2014/main" id="{56E32CD9-2944-4A68-8D6C-9585B853FC5E}"/>
+                <a16:creationId xmlns:a16="http://schemas.microsoft.com/office/drawing/2014/main" id="{356993B4-BC5E-4490-BEDB-B1DDEFC0AF20}"/>
               </a:ext>
             </a:extLst>
           </p:cNvPr>
@@ -7718,7 +7718,7 @@
           <p:cNvPr id="11" name="">
             <a:extLst xmlns:a="http://schemas.openxmlformats.org/drawingml/2006/main">
               <a:ext uri="{FF2B5EF4-FFF2-40B4-BE49-F238E27FC236}">
-                <a16:creationId xmlns:a16="http://schemas.microsoft.com/office/drawing/2014/main" id="{BD94B9FE-1302-4EA6-8C64-890E4CE4F4B3}"/>
+                <a16:creationId xmlns:a16="http://schemas.microsoft.com/office/drawing/2014/main" id="{1C6E25FD-F4A6-4AD0-B2A9-8308759012AC}"/>
               </a:ext>
             </a:extLst>
           </p:cNvPr>
@@ -7776,7 +7776,7 @@
           <p:cNvPr id="12" name="">
             <a:extLst xmlns:a="http://schemas.openxmlformats.org/drawingml/2006/main">
               <a:ext uri="{FF2B5EF4-FFF2-40B4-BE49-F238E27FC236}">
-                <a16:creationId xmlns:a16="http://schemas.microsoft.com/office/drawing/2014/main" id="{1B6DFD02-542C-4729-A600-4086F6CAF1E2}"/>
+                <a16:creationId xmlns:a16="http://schemas.microsoft.com/office/drawing/2014/main" id="{32237271-FF0F-4E73-BB3E-9BFCF0B603F0}"/>
               </a:ext>
             </a:extLst>
           </p:cNvPr>
@@ -7834,7 +7834,7 @@
           <p:cNvPr id="13" name="">
             <a:extLst xmlns:a="http://schemas.openxmlformats.org/drawingml/2006/main">
               <a:ext uri="{FF2B5EF4-FFF2-40B4-BE49-F238E27FC236}">
-                <a16:creationId xmlns:a16="http://schemas.microsoft.com/office/drawing/2014/main" id="{5481FC40-EC03-4935-9E0F-8DF5CCD5D00E}"/>
+                <a16:creationId xmlns:a16="http://schemas.microsoft.com/office/drawing/2014/main" id="{5C02628D-DD7E-445B-AA82-9C529FFCFA50}"/>
               </a:ext>
             </a:extLst>
           </p:cNvPr>
@@ -7892,7 +7892,7 @@
           <p:cNvPr id="14" name="">
             <a:extLst xmlns:a="http://schemas.openxmlformats.org/drawingml/2006/main">
               <a:ext uri="{FF2B5EF4-FFF2-40B4-BE49-F238E27FC236}">
-                <a16:creationId xmlns:a16="http://schemas.microsoft.com/office/drawing/2014/main" id="{89A84237-4DD5-4C1B-8D56-84F42D0A7FDD}"/>
+                <a16:creationId xmlns:a16="http://schemas.microsoft.com/office/drawing/2014/main" id="{3F0A9B4C-52E5-4438-A72E-1EBFFFF0B912}"/>
               </a:ext>
             </a:extLst>
           </p:cNvPr>
@@ -7996,7 +7996,7 @@
           <p:cNvPr id="15" name="">
             <a:extLst xmlns:a="http://schemas.openxmlformats.org/drawingml/2006/main">
               <a:ext uri="{FF2B5EF4-FFF2-40B4-BE49-F238E27FC236}">
-                <a16:creationId xmlns:a16="http://schemas.microsoft.com/office/drawing/2014/main" id="{C3028690-D994-4E73-9C7B-F3D8DE864F4B}"/>
+                <a16:creationId xmlns:a16="http://schemas.microsoft.com/office/drawing/2014/main" id="{650E41D6-4E56-487A-809E-CD5AC583618E}"/>
               </a:ext>
             </a:extLst>
           </p:cNvPr>
@@ -8044,7 +8044,7 @@
                 <a:ea typeface="Aptos"/>
                 <a:cs typeface="Aptos"/>
               </a:rPr>
-              <a:t>WATERS NEXT GEN COMPETITIVE INTELLIGENCE · 08 SEP 2026 · waters-ci-20260909030324</a:t>
+              <a:t>WATERS NEXT GEN COMPETITIVE INTELLIGENCE · 08 SEP 2026 · waters-ci-20260909033329</a:t>
             </a:r>
           </a:p>
         </p:txBody>
@@ -8054,7 +8054,7 @@
           <p:cNvPr id="16" name="">
             <a:extLst xmlns:a="http://schemas.openxmlformats.org/drawingml/2006/main">
               <a:ext uri="{FF2B5EF4-FFF2-40B4-BE49-F238E27FC236}">
-                <a16:creationId xmlns:a16="http://schemas.microsoft.com/office/drawing/2014/main" id="{8CA19DED-5AC6-4C8C-A158-50900A0E45D0}"/>
+                <a16:creationId xmlns:a16="http://schemas.microsoft.com/office/drawing/2014/main" id="{6AF1C375-FC9A-463E-9AE6-A1BACBF729BD}"/>
               </a:ext>
             </a:extLst>
           </p:cNvPr>
@@ -8110,7 +8110,7 @@
     </p:spTree>
     <p:extLst>
       <p:ext uri="{BB962C8B-B14F-4D97-AF65-F5344CB8AC3E}">
-        <p14:creationId xmlns:p14="http://schemas.microsoft.com/office/powerpoint/2010/main" val="1640282933"/>
+        <p14:creationId xmlns:p14="http://schemas.microsoft.com/office/powerpoint/2010/main" val="1714244118"/>
       </p:ext>
     </p:extLst>
   </p:cSld>
@@ -8141,7 +8141,7 @@
           <p:cNvPr id="37" name="">
             <a:extLst xmlns:a="http://schemas.openxmlformats.org/drawingml/2006/main">
               <a:ext uri="{FF2B5EF4-FFF2-40B4-BE49-F238E27FC236}">
-                <a16:creationId xmlns:a16="http://schemas.microsoft.com/office/drawing/2014/main" id="{DD36E7DF-A606-425A-981C-2E05398B2551}"/>
+                <a16:creationId xmlns:a16="http://schemas.microsoft.com/office/drawing/2014/main" id="{2BD487BC-C7CF-4712-B8E5-4BA019B1EA3E}"/>
               </a:ext>
             </a:extLst>
           </p:cNvPr>
@@ -8199,7 +8199,7 @@
           <p:cNvPr id="2" name="">
             <a:extLst xmlns:a="http://schemas.openxmlformats.org/drawingml/2006/main">
               <a:ext uri="{FF2B5EF4-FFF2-40B4-BE49-F238E27FC236}">
-                <a16:creationId xmlns:a16="http://schemas.microsoft.com/office/drawing/2014/main" id="{F598DCF4-11D6-4C25-BF6E-0FEFF8A0C1E6}"/>
+                <a16:creationId xmlns:a16="http://schemas.microsoft.com/office/drawing/2014/main" id="{A9CE2B34-CF10-4941-9381-6D3AA90AA496}"/>
               </a:ext>
             </a:extLst>
           </p:cNvPr>
@@ -8257,7 +8257,7 @@
           <p:cNvPr id="3" name="">
             <a:extLst xmlns:a="http://schemas.openxmlformats.org/drawingml/2006/main">
               <a:ext uri="{FF2B5EF4-FFF2-40B4-BE49-F238E27FC236}">
-                <a16:creationId xmlns:a16="http://schemas.microsoft.com/office/drawing/2014/main" id="{DA8B72B2-A7A7-40D1-9470-2767EC1CA8EF}"/>
+                <a16:creationId xmlns:a16="http://schemas.microsoft.com/office/drawing/2014/main" id="{AFF4FBB0-ACD3-4174-A5ED-6883F3998D63}"/>
               </a:ext>
             </a:extLst>
           </p:cNvPr>
@@ -8315,7 +8315,7 @@
           <p:cNvPr id="4" name="">
             <a:extLst xmlns:a="http://schemas.openxmlformats.org/drawingml/2006/main">
               <a:ext uri="{FF2B5EF4-FFF2-40B4-BE49-F238E27FC236}">
-                <a16:creationId xmlns:a16="http://schemas.microsoft.com/office/drawing/2014/main" id="{1B9CD9A9-21B1-462B-80F9-E328FC585CE0}"/>
+                <a16:creationId xmlns:a16="http://schemas.microsoft.com/office/drawing/2014/main" id="{78246CB1-6AFC-4F81-9FEB-163B3F2565EC}"/>
               </a:ext>
             </a:extLst>
           </p:cNvPr>
@@ -8348,7 +8348,7 @@
           <p:cNvPr id="5" name="">
             <a:extLst xmlns:a="http://schemas.openxmlformats.org/drawingml/2006/main">
               <a:ext uri="{FF2B5EF4-FFF2-40B4-BE49-F238E27FC236}">
-                <a16:creationId xmlns:a16="http://schemas.microsoft.com/office/drawing/2014/main" id="{6D6821B2-744A-4028-A819-B729183EE17D}"/>
+                <a16:creationId xmlns:a16="http://schemas.microsoft.com/office/drawing/2014/main" id="{5129777B-A53B-4839-82DC-5A4D11B731D7}"/>
               </a:ext>
             </a:extLst>
           </p:cNvPr>
@@ -8383,7 +8383,7 @@
           <p:cNvPr id="6" name="">
             <a:extLst xmlns:a="http://schemas.openxmlformats.org/drawingml/2006/main">
               <a:ext uri="{FF2B5EF4-FFF2-40B4-BE49-F238E27FC236}">
-                <a16:creationId xmlns:a16="http://schemas.microsoft.com/office/drawing/2014/main" id="{54585FE8-04A7-4987-A477-422B5DCD6829}"/>
+                <a16:creationId xmlns:a16="http://schemas.microsoft.com/office/drawing/2014/main" id="{1887D913-D209-487F-A0C3-3C7F8867D5A2}"/>
               </a:ext>
             </a:extLst>
           </p:cNvPr>
@@ -8416,7 +8416,7 @@
           <p:cNvPr id="7" name="">
             <a:extLst xmlns:a="http://schemas.openxmlformats.org/drawingml/2006/main">
               <a:ext uri="{FF2B5EF4-FFF2-40B4-BE49-F238E27FC236}">
-                <a16:creationId xmlns:a16="http://schemas.microsoft.com/office/drawing/2014/main" id="{7994E29C-23C6-41C5-A113-6250C6E24274}"/>
+                <a16:creationId xmlns:a16="http://schemas.microsoft.com/office/drawing/2014/main" id="{38C2F228-C04C-40F3-801D-4B809286C2ED}"/>
               </a:ext>
             </a:extLst>
           </p:cNvPr>
@@ -8474,7 +8474,7 @@
           <p:cNvPr id="8" name="">
             <a:extLst xmlns:a="http://schemas.openxmlformats.org/drawingml/2006/main">
               <a:ext uri="{FF2B5EF4-FFF2-40B4-BE49-F238E27FC236}">
-                <a16:creationId xmlns:a16="http://schemas.microsoft.com/office/drawing/2014/main" id="{56E87CD3-9A04-44A6-8F03-DCFC8911B429}"/>
+                <a16:creationId xmlns:a16="http://schemas.microsoft.com/office/drawing/2014/main" id="{0AD65584-33B5-47DD-BDBE-0E653052F3F2}"/>
               </a:ext>
             </a:extLst>
           </p:cNvPr>
@@ -8532,7 +8532,7 @@
           <p:cNvPr id="9" name="">
             <a:extLst xmlns:a="http://schemas.openxmlformats.org/drawingml/2006/main">
               <a:ext uri="{FF2B5EF4-FFF2-40B4-BE49-F238E27FC236}">
-                <a16:creationId xmlns:a16="http://schemas.microsoft.com/office/drawing/2014/main" id="{DA15368F-63B9-4C0F-885E-D8E055647BFF}"/>
+                <a16:creationId xmlns:a16="http://schemas.microsoft.com/office/drawing/2014/main" id="{55BAFC10-2013-4657-ADDA-34B0CC96E2C5}"/>
               </a:ext>
             </a:extLst>
           </p:cNvPr>
@@ -8590,7 +8590,7 @@
           <p:cNvPr id="10" name="">
             <a:extLst xmlns:a="http://schemas.openxmlformats.org/drawingml/2006/main">
               <a:ext uri="{FF2B5EF4-FFF2-40B4-BE49-F238E27FC236}">
-                <a16:creationId xmlns:a16="http://schemas.microsoft.com/office/drawing/2014/main" id="{0AFCA8E5-4599-4967-8BA5-39DA0B3726B7}"/>
+                <a16:creationId xmlns:a16="http://schemas.microsoft.com/office/drawing/2014/main" id="{3C5F7795-F20F-4543-9ED3-220E9028F042}"/>
               </a:ext>
             </a:extLst>
           </p:cNvPr>
@@ -8648,7 +8648,7 @@
           <p:cNvPr id="11" name="">
             <a:extLst xmlns:a="http://schemas.openxmlformats.org/drawingml/2006/main">
               <a:ext uri="{FF2B5EF4-FFF2-40B4-BE49-F238E27FC236}">
-                <a16:creationId xmlns:a16="http://schemas.microsoft.com/office/drawing/2014/main" id="{69C790FF-3F5D-4981-A581-E7C5E3353F5D}"/>
+                <a16:creationId xmlns:a16="http://schemas.microsoft.com/office/drawing/2014/main" id="{6D062D0D-D5CA-4397-90EE-66812F312942}"/>
               </a:ext>
             </a:extLst>
           </p:cNvPr>
@@ -8681,7 +8681,7 @@
           <p:cNvPr id="12" name="">
             <a:extLst xmlns:a="http://schemas.openxmlformats.org/drawingml/2006/main">
               <a:ext uri="{FF2B5EF4-FFF2-40B4-BE49-F238E27FC236}">
-                <a16:creationId xmlns:a16="http://schemas.microsoft.com/office/drawing/2014/main" id="{6129B736-5AFB-4DAE-970F-0F599A86926D}"/>
+                <a16:creationId xmlns:a16="http://schemas.microsoft.com/office/drawing/2014/main" id="{FEF49B06-187C-490F-AC77-66CF4E85E2E9}"/>
               </a:ext>
             </a:extLst>
           </p:cNvPr>
@@ -8739,7 +8739,7 @@
           <p:cNvPr id="13" name="">
             <a:extLst xmlns:a="http://schemas.openxmlformats.org/drawingml/2006/main">
               <a:ext uri="{FF2B5EF4-FFF2-40B4-BE49-F238E27FC236}">
-                <a16:creationId xmlns:a16="http://schemas.microsoft.com/office/drawing/2014/main" id="{59AC6582-D35D-48BC-8744-D5F4F620559F}"/>
+                <a16:creationId xmlns:a16="http://schemas.microsoft.com/office/drawing/2014/main" id="{18150EB9-BE6A-4638-A2DF-B37BBD09F5EB}"/>
               </a:ext>
             </a:extLst>
           </p:cNvPr>
@@ -8797,7 +8797,7 @@
           <p:cNvPr id="14" name="">
             <a:extLst xmlns:a="http://schemas.openxmlformats.org/drawingml/2006/main">
               <a:ext uri="{FF2B5EF4-FFF2-40B4-BE49-F238E27FC236}">
-                <a16:creationId xmlns:a16="http://schemas.microsoft.com/office/drawing/2014/main" id="{32A08DE1-1483-4214-A80D-E60AF4287535}"/>
+                <a16:creationId xmlns:a16="http://schemas.microsoft.com/office/drawing/2014/main" id="{3563E79A-2949-45FC-A3BB-A5922BEAABE7}"/>
               </a:ext>
             </a:extLst>
           </p:cNvPr>
@@ -8855,7 +8855,7 @@
           <p:cNvPr id="15" name="">
             <a:extLst xmlns:a="http://schemas.openxmlformats.org/drawingml/2006/main">
               <a:ext uri="{FF2B5EF4-FFF2-40B4-BE49-F238E27FC236}">
-                <a16:creationId xmlns:a16="http://schemas.microsoft.com/office/drawing/2014/main" id="{A3F74913-A3EF-4359-8C66-30F8CDAA79EC}"/>
+                <a16:creationId xmlns:a16="http://schemas.microsoft.com/office/drawing/2014/main" id="{C85BFAF1-7209-4272-A594-73BAA6CE9377}"/>
               </a:ext>
             </a:extLst>
           </p:cNvPr>
@@ -8890,7 +8890,7 @@
           <p:cNvPr id="16" name="">
             <a:extLst xmlns:a="http://schemas.openxmlformats.org/drawingml/2006/main">
               <a:ext uri="{FF2B5EF4-FFF2-40B4-BE49-F238E27FC236}">
-                <a16:creationId xmlns:a16="http://schemas.microsoft.com/office/drawing/2014/main" id="{79651A8C-9692-4C48-955C-D3185BBD8D09}"/>
+                <a16:creationId xmlns:a16="http://schemas.microsoft.com/office/drawing/2014/main" id="{9661EF5B-A562-41A3-81E4-807040C9FC2B}"/>
               </a:ext>
             </a:extLst>
           </p:cNvPr>
@@ -8923,7 +8923,7 @@
           <p:cNvPr id="17" name="">
             <a:extLst xmlns:a="http://schemas.openxmlformats.org/drawingml/2006/main">
               <a:ext uri="{FF2B5EF4-FFF2-40B4-BE49-F238E27FC236}">
-                <a16:creationId xmlns:a16="http://schemas.microsoft.com/office/drawing/2014/main" id="{70F4C76E-03D9-4F38-A342-91A9563745C3}"/>
+                <a16:creationId xmlns:a16="http://schemas.microsoft.com/office/drawing/2014/main" id="{8A5B41BF-3FE1-495C-8543-17903D3D3483}"/>
               </a:ext>
             </a:extLst>
           </p:cNvPr>
@@ -8981,7 +8981,7 @@
           <p:cNvPr id="18" name="">
             <a:extLst xmlns:a="http://schemas.openxmlformats.org/drawingml/2006/main">
               <a:ext uri="{FF2B5EF4-FFF2-40B4-BE49-F238E27FC236}">
-                <a16:creationId xmlns:a16="http://schemas.microsoft.com/office/drawing/2014/main" id="{D0A8FD67-73AB-4449-B89B-DA8231560B67}"/>
+                <a16:creationId xmlns:a16="http://schemas.microsoft.com/office/drawing/2014/main" id="{F7582849-EDEF-4E00-AC33-B1E63DB50082}"/>
               </a:ext>
             </a:extLst>
           </p:cNvPr>
@@ -9039,7 +9039,7 @@
           <p:cNvPr id="19" name="">
             <a:extLst xmlns:a="http://schemas.openxmlformats.org/drawingml/2006/main">
               <a:ext uri="{FF2B5EF4-FFF2-40B4-BE49-F238E27FC236}">
-                <a16:creationId xmlns:a16="http://schemas.microsoft.com/office/drawing/2014/main" id="{B11AC53B-136F-459E-852E-0365BCB9D797}"/>
+                <a16:creationId xmlns:a16="http://schemas.microsoft.com/office/drawing/2014/main" id="{F368836A-0F2E-4A18-A1CF-F29F9770C546}"/>
               </a:ext>
             </a:extLst>
           </p:cNvPr>
@@ -9097,7 +9097,7 @@
           <p:cNvPr id="20" name="">
             <a:extLst xmlns:a="http://schemas.openxmlformats.org/drawingml/2006/main">
               <a:ext uri="{FF2B5EF4-FFF2-40B4-BE49-F238E27FC236}">
-                <a16:creationId xmlns:a16="http://schemas.microsoft.com/office/drawing/2014/main" id="{29F92417-F2A9-4D24-9D92-B622581FC1E9}"/>
+                <a16:creationId xmlns:a16="http://schemas.microsoft.com/office/drawing/2014/main" id="{A1493443-DB71-4E1E-89D5-732C517364C2}"/>
               </a:ext>
             </a:extLst>
           </p:cNvPr>
@@ -9155,7 +9155,7 @@
           <p:cNvPr id="21" name="">
             <a:extLst xmlns:a="http://schemas.openxmlformats.org/drawingml/2006/main">
               <a:ext uri="{FF2B5EF4-FFF2-40B4-BE49-F238E27FC236}">
-                <a16:creationId xmlns:a16="http://schemas.microsoft.com/office/drawing/2014/main" id="{97539F60-52AA-4F52-81F6-CBD87819AE52}"/>
+                <a16:creationId xmlns:a16="http://schemas.microsoft.com/office/drawing/2014/main" id="{739396E5-4810-4DE3-A616-3F9BEF875201}"/>
               </a:ext>
             </a:extLst>
           </p:cNvPr>
@@ -9188,7 +9188,7 @@
           <p:cNvPr id="22" name="">
             <a:extLst xmlns:a="http://schemas.openxmlformats.org/drawingml/2006/main">
               <a:ext uri="{FF2B5EF4-FFF2-40B4-BE49-F238E27FC236}">
-                <a16:creationId xmlns:a16="http://schemas.microsoft.com/office/drawing/2014/main" id="{181B8002-8459-485F-81A8-A6D705D038D3}"/>
+                <a16:creationId xmlns:a16="http://schemas.microsoft.com/office/drawing/2014/main" id="{02AE3F13-3D27-42BD-82DA-21F3EDB6508F}"/>
               </a:ext>
             </a:extLst>
           </p:cNvPr>
@@ -9246,7 +9246,7 @@
           <p:cNvPr id="23" name="">
             <a:extLst xmlns:a="http://schemas.openxmlformats.org/drawingml/2006/main">
               <a:ext uri="{FF2B5EF4-FFF2-40B4-BE49-F238E27FC236}">
-                <a16:creationId xmlns:a16="http://schemas.microsoft.com/office/drawing/2014/main" id="{C6399A75-23D9-4984-B962-620498BBC0FD}"/>
+                <a16:creationId xmlns:a16="http://schemas.microsoft.com/office/drawing/2014/main" id="{9E2E487B-2B6F-43FB-9BE3-76BDC4955ACC}"/>
               </a:ext>
             </a:extLst>
           </p:cNvPr>
@@ -9304,7 +9304,7 @@
           <p:cNvPr id="24" name="">
             <a:extLst xmlns:a="http://schemas.openxmlformats.org/drawingml/2006/main">
               <a:ext uri="{FF2B5EF4-FFF2-40B4-BE49-F238E27FC236}">
-                <a16:creationId xmlns:a16="http://schemas.microsoft.com/office/drawing/2014/main" id="{E4AAAC38-6634-4A03-BBDC-CC1894B4A38B}"/>
+                <a16:creationId xmlns:a16="http://schemas.microsoft.com/office/drawing/2014/main" id="{FE463942-FC38-43C6-AE02-01829A67AD73}"/>
               </a:ext>
             </a:extLst>
           </p:cNvPr>
@@ -9362,7 +9362,7 @@
           <p:cNvPr id="25" name="">
             <a:extLst xmlns:a="http://schemas.openxmlformats.org/drawingml/2006/main">
               <a:ext uri="{FF2B5EF4-FFF2-40B4-BE49-F238E27FC236}">
-                <a16:creationId xmlns:a16="http://schemas.microsoft.com/office/drawing/2014/main" id="{8B81254A-B588-46E3-A6E2-DAF711551FE3}"/>
+                <a16:creationId xmlns:a16="http://schemas.microsoft.com/office/drawing/2014/main" id="{1BB02B50-A2BF-43C5-9355-1CC43862D5DF}"/>
               </a:ext>
             </a:extLst>
           </p:cNvPr>
@@ -9397,7 +9397,7 @@
           <p:cNvPr id="26" name="">
             <a:extLst xmlns:a="http://schemas.openxmlformats.org/drawingml/2006/main">
               <a:ext uri="{FF2B5EF4-FFF2-40B4-BE49-F238E27FC236}">
-                <a16:creationId xmlns:a16="http://schemas.microsoft.com/office/drawing/2014/main" id="{E5FAE185-9AE1-4FA3-A70C-EFACE3939BC4}"/>
+                <a16:creationId xmlns:a16="http://schemas.microsoft.com/office/drawing/2014/main" id="{60626ABB-C9DB-4AF3-82D3-60C6CD090673}"/>
               </a:ext>
             </a:extLst>
           </p:cNvPr>
@@ -9430,7 +9430,7 @@
           <p:cNvPr id="27" name="">
             <a:extLst xmlns:a="http://schemas.openxmlformats.org/drawingml/2006/main">
               <a:ext uri="{FF2B5EF4-FFF2-40B4-BE49-F238E27FC236}">
-                <a16:creationId xmlns:a16="http://schemas.microsoft.com/office/drawing/2014/main" id="{33DDB467-432E-4992-82A8-51108E762B12}"/>
+                <a16:creationId xmlns:a16="http://schemas.microsoft.com/office/drawing/2014/main" id="{62003C73-F81A-4B25-88B8-FA24FE58DAAD}"/>
               </a:ext>
             </a:extLst>
           </p:cNvPr>
@@ -9488,7 +9488,7 @@
           <p:cNvPr id="28" name="">
             <a:extLst xmlns:a="http://schemas.openxmlformats.org/drawingml/2006/main">
               <a:ext uri="{FF2B5EF4-FFF2-40B4-BE49-F238E27FC236}">
-                <a16:creationId xmlns:a16="http://schemas.microsoft.com/office/drawing/2014/main" id="{30B8A807-11FD-4BAA-9B6A-23B465515274}"/>
+                <a16:creationId xmlns:a16="http://schemas.microsoft.com/office/drawing/2014/main" id="{1EA0EDE9-F84A-4895-B91E-02AB807BBE11}"/>
               </a:ext>
             </a:extLst>
           </p:cNvPr>
@@ -9546,7 +9546,7 @@
           <p:cNvPr id="29" name="">
             <a:extLst xmlns:a="http://schemas.openxmlformats.org/drawingml/2006/main">
               <a:ext uri="{FF2B5EF4-FFF2-40B4-BE49-F238E27FC236}">
-                <a16:creationId xmlns:a16="http://schemas.microsoft.com/office/drawing/2014/main" id="{3EB68402-E958-403D-9BEA-DC61D96AF2EB}"/>
+                <a16:creationId xmlns:a16="http://schemas.microsoft.com/office/drawing/2014/main" id="{967C336A-F499-4922-B9AE-21EB10AF23F6}"/>
               </a:ext>
             </a:extLst>
           </p:cNvPr>
@@ -9604,7 +9604,7 @@
           <p:cNvPr id="30" name="">
             <a:extLst xmlns:a="http://schemas.openxmlformats.org/drawingml/2006/main">
               <a:ext uri="{FF2B5EF4-FFF2-40B4-BE49-F238E27FC236}">
-                <a16:creationId xmlns:a16="http://schemas.microsoft.com/office/drawing/2014/main" id="{D10167B4-38B5-4636-8538-8DE79E0D1B95}"/>
+                <a16:creationId xmlns:a16="http://schemas.microsoft.com/office/drawing/2014/main" id="{103DFC0C-431A-4E63-8BDC-C4291C2DE39D}"/>
               </a:ext>
             </a:extLst>
           </p:cNvPr>
@@ -9662,7 +9662,7 @@
           <p:cNvPr id="31" name="">
             <a:extLst xmlns:a="http://schemas.openxmlformats.org/drawingml/2006/main">
               <a:ext uri="{FF2B5EF4-FFF2-40B4-BE49-F238E27FC236}">
-                <a16:creationId xmlns:a16="http://schemas.microsoft.com/office/drawing/2014/main" id="{3A1A602A-F0B9-4AAF-9B8D-A9570F1C5BC2}"/>
+                <a16:creationId xmlns:a16="http://schemas.microsoft.com/office/drawing/2014/main" id="{5C8E11BC-FD51-429A-8F15-BE7A3E4E396F}"/>
               </a:ext>
             </a:extLst>
           </p:cNvPr>
@@ -9695,7 +9695,7 @@
           <p:cNvPr id="32" name="">
             <a:extLst xmlns:a="http://schemas.openxmlformats.org/drawingml/2006/main">
               <a:ext uri="{FF2B5EF4-FFF2-40B4-BE49-F238E27FC236}">
-                <a16:creationId xmlns:a16="http://schemas.microsoft.com/office/drawing/2014/main" id="{B571B3C7-69F2-4A8F-8F75-787C13F65EBD}"/>
+                <a16:creationId xmlns:a16="http://schemas.microsoft.com/office/drawing/2014/main" id="{B061CC56-3246-4EDC-9C38-5AE6F6A4A1F9}"/>
               </a:ext>
             </a:extLst>
           </p:cNvPr>
@@ -9753,7 +9753,7 @@
           <p:cNvPr id="33" name="">
             <a:extLst xmlns:a="http://schemas.openxmlformats.org/drawingml/2006/main">
               <a:ext uri="{FF2B5EF4-FFF2-40B4-BE49-F238E27FC236}">
-                <a16:creationId xmlns:a16="http://schemas.microsoft.com/office/drawing/2014/main" id="{3F88E60B-E992-4A56-AC5B-82A9B5763815}"/>
+                <a16:creationId xmlns:a16="http://schemas.microsoft.com/office/drawing/2014/main" id="{C778481C-77A0-4F93-B986-421A1F3B6448}"/>
               </a:ext>
             </a:extLst>
           </p:cNvPr>
@@ -9811,7 +9811,7 @@
           <p:cNvPr id="34" name="">
             <a:extLst xmlns:a="http://schemas.openxmlformats.org/drawingml/2006/main">
               <a:ext uri="{FF2B5EF4-FFF2-40B4-BE49-F238E27FC236}">
-                <a16:creationId xmlns:a16="http://schemas.microsoft.com/office/drawing/2014/main" id="{3488CE9E-87EC-4719-8BDC-146A101F120E}"/>
+                <a16:creationId xmlns:a16="http://schemas.microsoft.com/office/drawing/2014/main" id="{E7AAB4BB-6ED7-41BE-BB05-B9F2DBAB45D8}"/>
               </a:ext>
             </a:extLst>
           </p:cNvPr>
@@ -9869,7 +9869,7 @@
           <p:cNvPr id="35" name="">
             <a:extLst xmlns:a="http://schemas.openxmlformats.org/drawingml/2006/main">
               <a:ext uri="{FF2B5EF4-FFF2-40B4-BE49-F238E27FC236}">
-                <a16:creationId xmlns:a16="http://schemas.microsoft.com/office/drawing/2014/main" id="{B9F06C0D-FAD7-47D3-AA5A-CC3D520FAB3E}"/>
+                <a16:creationId xmlns:a16="http://schemas.microsoft.com/office/drawing/2014/main" id="{10346DCD-7B15-423C-8F1A-AFB925D697A5}"/>
               </a:ext>
             </a:extLst>
           </p:cNvPr>
@@ -9917,7 +9917,7 @@
                 <a:ea typeface="Aptos"/>
                 <a:cs typeface="Aptos"/>
               </a:rPr>
-              <a:t>WATERS NEXT GEN COMPETITIVE INTELLIGENCE · 08 SEP 2026 · waters-ci-20260909030324</a:t>
+              <a:t>WATERS NEXT GEN COMPETITIVE INTELLIGENCE · 08 SEP 2026 · waters-ci-20260909033329</a:t>
             </a:r>
           </a:p>
         </p:txBody>
@@ -9927,7 +9927,7 @@
           <p:cNvPr id="36" name="">
             <a:extLst xmlns:a="http://schemas.openxmlformats.org/drawingml/2006/main">
               <a:ext uri="{FF2B5EF4-FFF2-40B4-BE49-F238E27FC236}">
-                <a16:creationId xmlns:a16="http://schemas.microsoft.com/office/drawing/2014/main" id="{E4692DA8-B203-4E61-8EA9-94D5C7614BFA}"/>
+                <a16:creationId xmlns:a16="http://schemas.microsoft.com/office/drawing/2014/main" id="{A1C43314-0335-4E22-8597-4A637AC7312C}"/>
               </a:ext>
             </a:extLst>
           </p:cNvPr>
@@ -9983,7 +9983,7 @@
     </p:spTree>
     <p:extLst>
       <p:ext uri="{BB962C8B-B14F-4D97-AF65-F5344CB8AC3E}">
-        <p14:creationId xmlns:p14="http://schemas.microsoft.com/office/powerpoint/2010/main" val="623801038"/>
+        <p14:creationId xmlns:p14="http://schemas.microsoft.com/office/powerpoint/2010/main" val="2019903095"/>
       </p:ext>
     </p:extLst>
   </p:cSld>
@@ -10014,7 +10014,7 @@
           <p:cNvPr id="26" name="">
             <a:extLst xmlns:a="http://schemas.openxmlformats.org/drawingml/2006/main">
               <a:ext uri="{FF2B5EF4-FFF2-40B4-BE49-F238E27FC236}">
-                <a16:creationId xmlns:a16="http://schemas.microsoft.com/office/drawing/2014/main" id="{DBE876C1-DEA0-49E6-92D7-99E4F562EBAD}"/>
+                <a16:creationId xmlns:a16="http://schemas.microsoft.com/office/drawing/2014/main" id="{48E8FD3A-8459-4A61-AC79-840276A4E988}"/>
               </a:ext>
             </a:extLst>
           </p:cNvPr>
@@ -10072,7 +10072,7 @@
           <p:cNvPr id="2" name="">
             <a:extLst xmlns:a="http://schemas.openxmlformats.org/drawingml/2006/main">
               <a:ext uri="{FF2B5EF4-FFF2-40B4-BE49-F238E27FC236}">
-                <a16:creationId xmlns:a16="http://schemas.microsoft.com/office/drawing/2014/main" id="{E9C6A8F7-2678-4F0B-B7BB-788B3E0617E9}"/>
+                <a16:creationId xmlns:a16="http://schemas.microsoft.com/office/drawing/2014/main" id="{9CB88D58-408A-4FD8-9301-6B91076B91F6}"/>
               </a:ext>
             </a:extLst>
           </p:cNvPr>
@@ -10130,7 +10130,7 @@
           <p:cNvPr id="3" name="">
             <a:extLst xmlns:a="http://schemas.openxmlformats.org/drawingml/2006/main">
               <a:ext uri="{FF2B5EF4-FFF2-40B4-BE49-F238E27FC236}">
-                <a16:creationId xmlns:a16="http://schemas.microsoft.com/office/drawing/2014/main" id="{D8932AD4-D60C-450B-BA59-36BB2F4777B6}"/>
+                <a16:creationId xmlns:a16="http://schemas.microsoft.com/office/drawing/2014/main" id="{194C8058-4B3F-47DA-93BB-6EFD08D6A5F0}"/>
               </a:ext>
             </a:extLst>
           </p:cNvPr>
@@ -10188,7 +10188,7 @@
           <p:cNvPr id="4" name="">
             <a:extLst xmlns:a="http://schemas.openxmlformats.org/drawingml/2006/main">
               <a:ext uri="{FF2B5EF4-FFF2-40B4-BE49-F238E27FC236}">
-                <a16:creationId xmlns:a16="http://schemas.microsoft.com/office/drawing/2014/main" id="{B74C6630-F218-456A-B617-323B24C759D3}"/>
+                <a16:creationId xmlns:a16="http://schemas.microsoft.com/office/drawing/2014/main" id="{E011E1A5-D574-408F-AACD-4617C9169719}"/>
               </a:ext>
             </a:extLst>
           </p:cNvPr>
@@ -10221,7 +10221,7 @@
           <p:cNvPr id="5" name="">
             <a:extLst xmlns:a="http://schemas.openxmlformats.org/drawingml/2006/main">
               <a:ext uri="{FF2B5EF4-FFF2-40B4-BE49-F238E27FC236}">
-                <a16:creationId xmlns:a16="http://schemas.microsoft.com/office/drawing/2014/main" id="{089D03F0-0BD6-44D8-9A33-56492B344B7C}"/>
+                <a16:creationId xmlns:a16="http://schemas.microsoft.com/office/drawing/2014/main" id="{C8329E57-F4A7-462E-8574-9F8DD7581055}"/>
               </a:ext>
             </a:extLst>
           </p:cNvPr>
@@ -10254,7 +10254,7 @@
           <p:cNvPr id="6" name="">
             <a:extLst xmlns:a="http://schemas.openxmlformats.org/drawingml/2006/main">
               <a:ext uri="{FF2B5EF4-FFF2-40B4-BE49-F238E27FC236}">
-                <a16:creationId xmlns:a16="http://schemas.microsoft.com/office/drawing/2014/main" id="{AF1FFE6A-F993-472A-988A-EED27B61FE15}"/>
+                <a16:creationId xmlns:a16="http://schemas.microsoft.com/office/drawing/2014/main" id="{2F09599B-1CB3-414A-86DF-3124925F9E59}"/>
               </a:ext>
             </a:extLst>
           </p:cNvPr>
@@ -10289,7 +10289,7 @@
           <p:cNvPr id="7" name="">
             <a:extLst xmlns:a="http://schemas.openxmlformats.org/drawingml/2006/main">
               <a:ext uri="{FF2B5EF4-FFF2-40B4-BE49-F238E27FC236}">
-                <a16:creationId xmlns:a16="http://schemas.microsoft.com/office/drawing/2014/main" id="{542DAC2D-5094-4F98-91A9-A7760BE2393D}"/>
+                <a16:creationId xmlns:a16="http://schemas.microsoft.com/office/drawing/2014/main" id="{B6755A14-971A-4BBD-840D-478B85FB90F7}"/>
               </a:ext>
             </a:extLst>
           </p:cNvPr>
@@ -10347,7 +10347,7 @@
           <p:cNvPr id="8" name="">
             <a:extLst xmlns:a="http://schemas.openxmlformats.org/drawingml/2006/main">
               <a:ext uri="{FF2B5EF4-FFF2-40B4-BE49-F238E27FC236}">
-                <a16:creationId xmlns:a16="http://schemas.microsoft.com/office/drawing/2014/main" id="{F2B9EE29-2B17-438C-A3DE-2C063A203178}"/>
+                <a16:creationId xmlns:a16="http://schemas.microsoft.com/office/drawing/2014/main" id="{7663F259-ED01-4648-987C-58844A6F2BC8}"/>
               </a:ext>
             </a:extLst>
           </p:cNvPr>
@@ -10405,7 +10405,7 @@
           <p:cNvPr id="9" name="">
             <a:extLst xmlns:a="http://schemas.openxmlformats.org/drawingml/2006/main">
               <a:ext uri="{FF2B5EF4-FFF2-40B4-BE49-F238E27FC236}">
-                <a16:creationId xmlns:a16="http://schemas.microsoft.com/office/drawing/2014/main" id="{E47DE3A9-6AAE-4466-9A3C-4E3DAEBDD2F8}"/>
+                <a16:creationId xmlns:a16="http://schemas.microsoft.com/office/drawing/2014/main" id="{F44AE6A1-45C5-46CE-9179-3BE438455231}"/>
               </a:ext>
             </a:extLst>
           </p:cNvPr>
@@ -10463,7 +10463,7 @@
           <p:cNvPr id="10" name="">
             <a:extLst xmlns:a="http://schemas.openxmlformats.org/drawingml/2006/main">
               <a:ext uri="{FF2B5EF4-FFF2-40B4-BE49-F238E27FC236}">
-                <a16:creationId xmlns:a16="http://schemas.microsoft.com/office/drawing/2014/main" id="{4D49CD56-D009-4FF8-8086-7A7F3CCC419D}"/>
+                <a16:creationId xmlns:a16="http://schemas.microsoft.com/office/drawing/2014/main" id="{CE36B55A-8849-488B-A2E5-C42DD6293BE3}"/>
               </a:ext>
             </a:extLst>
           </p:cNvPr>
@@ -10498,7 +10498,7 @@
           <p:cNvPr id="11" name="">
             <a:extLst xmlns:a="http://schemas.openxmlformats.org/drawingml/2006/main">
               <a:ext uri="{FF2B5EF4-FFF2-40B4-BE49-F238E27FC236}">
-                <a16:creationId xmlns:a16="http://schemas.microsoft.com/office/drawing/2014/main" id="{3B02769C-91A7-42B9-ADF3-276F3D2CDE42}"/>
+                <a16:creationId xmlns:a16="http://schemas.microsoft.com/office/drawing/2014/main" id="{5C193B86-78B2-432D-B377-490A6E2C67BB}"/>
               </a:ext>
             </a:extLst>
           </p:cNvPr>
@@ -10556,7 +10556,7 @@
           <p:cNvPr id="12" name="">
             <a:extLst xmlns:a="http://schemas.openxmlformats.org/drawingml/2006/main">
               <a:ext uri="{FF2B5EF4-FFF2-40B4-BE49-F238E27FC236}">
-                <a16:creationId xmlns:a16="http://schemas.microsoft.com/office/drawing/2014/main" id="{D1B94B37-4E27-4F4E-98EB-ED7C258F1B9C}"/>
+                <a16:creationId xmlns:a16="http://schemas.microsoft.com/office/drawing/2014/main" id="{ED6BB2CC-A721-46F1-9ACF-76DB3C8EEA96}"/>
               </a:ext>
             </a:extLst>
           </p:cNvPr>
@@ -10614,7 +10614,7 @@
           <p:cNvPr id="13" name="">
             <a:extLst xmlns:a="http://schemas.openxmlformats.org/drawingml/2006/main">
               <a:ext uri="{FF2B5EF4-FFF2-40B4-BE49-F238E27FC236}">
-                <a16:creationId xmlns:a16="http://schemas.microsoft.com/office/drawing/2014/main" id="{85E758D7-D04E-4438-BFA2-5C5B99D0877C}"/>
+                <a16:creationId xmlns:a16="http://schemas.microsoft.com/office/drawing/2014/main" id="{245B3890-1EF4-477F-A404-9E965686182B}"/>
               </a:ext>
             </a:extLst>
           </p:cNvPr>
@@ -10672,7 +10672,7 @@
           <p:cNvPr id="14" name="">
             <a:extLst xmlns:a="http://schemas.openxmlformats.org/drawingml/2006/main">
               <a:ext uri="{FF2B5EF4-FFF2-40B4-BE49-F238E27FC236}">
-                <a16:creationId xmlns:a16="http://schemas.microsoft.com/office/drawing/2014/main" id="{BBC0C924-DB7D-430C-8FAE-F36F04F72CE1}"/>
+                <a16:creationId xmlns:a16="http://schemas.microsoft.com/office/drawing/2014/main" id="{27F2A9E6-2414-417C-8686-9D884EA1CEEC}"/>
               </a:ext>
             </a:extLst>
           </p:cNvPr>
@@ -10707,7 +10707,7 @@
           <p:cNvPr id="15" name="">
             <a:extLst xmlns:a="http://schemas.openxmlformats.org/drawingml/2006/main">
               <a:ext uri="{FF2B5EF4-FFF2-40B4-BE49-F238E27FC236}">
-                <a16:creationId xmlns:a16="http://schemas.microsoft.com/office/drawing/2014/main" id="{1AC5F1A9-5837-4C63-851F-3816D6683F01}"/>
+                <a16:creationId xmlns:a16="http://schemas.microsoft.com/office/drawing/2014/main" id="{93662EA4-4B38-45D4-BE86-34E021F1C414}"/>
               </a:ext>
             </a:extLst>
           </p:cNvPr>
@@ -10765,7 +10765,7 @@
           <p:cNvPr id="16" name="">
             <a:extLst xmlns:a="http://schemas.openxmlformats.org/drawingml/2006/main">
               <a:ext uri="{FF2B5EF4-FFF2-40B4-BE49-F238E27FC236}">
-                <a16:creationId xmlns:a16="http://schemas.microsoft.com/office/drawing/2014/main" id="{401F95B8-0270-4E42-BF24-421A186346D1}"/>
+                <a16:creationId xmlns:a16="http://schemas.microsoft.com/office/drawing/2014/main" id="{9B0DFC29-9618-4DD9-A849-2B3FFD6F65B5}"/>
               </a:ext>
             </a:extLst>
           </p:cNvPr>
@@ -10823,7 +10823,7 @@
           <p:cNvPr id="17" name="">
             <a:extLst xmlns:a="http://schemas.openxmlformats.org/drawingml/2006/main">
               <a:ext uri="{FF2B5EF4-FFF2-40B4-BE49-F238E27FC236}">
-                <a16:creationId xmlns:a16="http://schemas.microsoft.com/office/drawing/2014/main" id="{45C2D36B-316C-484E-A192-CFA9F41AE7A7}"/>
+                <a16:creationId xmlns:a16="http://schemas.microsoft.com/office/drawing/2014/main" id="{A692ED1F-AFDE-4323-9AD6-4AF85D75DF4B}"/>
               </a:ext>
             </a:extLst>
           </p:cNvPr>
@@ -10881,7 +10881,7 @@
           <p:cNvPr id="18" name="">
             <a:extLst xmlns:a="http://schemas.openxmlformats.org/drawingml/2006/main">
               <a:ext uri="{FF2B5EF4-FFF2-40B4-BE49-F238E27FC236}">
-                <a16:creationId xmlns:a16="http://schemas.microsoft.com/office/drawing/2014/main" id="{1151892F-AF7B-451D-9765-2960CF6BCEAA}"/>
+                <a16:creationId xmlns:a16="http://schemas.microsoft.com/office/drawing/2014/main" id="{6DBA1503-A82B-4AF3-A33D-B7D8336211F5}"/>
               </a:ext>
             </a:extLst>
           </p:cNvPr>
@@ -10916,7 +10916,7 @@
           <p:cNvPr id="19" name="">
             <a:extLst xmlns:a="http://schemas.openxmlformats.org/drawingml/2006/main">
               <a:ext uri="{FF2B5EF4-FFF2-40B4-BE49-F238E27FC236}">
-                <a16:creationId xmlns:a16="http://schemas.microsoft.com/office/drawing/2014/main" id="{821879C1-2326-46CB-98AF-28B3B35876FB}"/>
+                <a16:creationId xmlns:a16="http://schemas.microsoft.com/office/drawing/2014/main" id="{B6918A57-460E-45DF-817D-99694494E06B}"/>
               </a:ext>
             </a:extLst>
           </p:cNvPr>
@@ -10974,7 +10974,7 @@
           <p:cNvPr id="20" name="">
             <a:extLst xmlns:a="http://schemas.openxmlformats.org/drawingml/2006/main">
               <a:ext uri="{FF2B5EF4-FFF2-40B4-BE49-F238E27FC236}">
-                <a16:creationId xmlns:a16="http://schemas.microsoft.com/office/drawing/2014/main" id="{7CFB58B8-AD58-49D9-A265-78CA34CD6181}"/>
+                <a16:creationId xmlns:a16="http://schemas.microsoft.com/office/drawing/2014/main" id="{F08AD090-1542-48A2-A230-E1420DFD2E58}"/>
               </a:ext>
             </a:extLst>
           </p:cNvPr>
@@ -11032,7 +11032,7 @@
           <p:cNvPr id="21" name="">
             <a:extLst xmlns:a="http://schemas.openxmlformats.org/drawingml/2006/main">
               <a:ext uri="{FF2B5EF4-FFF2-40B4-BE49-F238E27FC236}">
-                <a16:creationId xmlns:a16="http://schemas.microsoft.com/office/drawing/2014/main" id="{463F4696-85AF-42F3-B53D-F00F5A7DD18F}"/>
+                <a16:creationId xmlns:a16="http://schemas.microsoft.com/office/drawing/2014/main" id="{4A33DD07-DAF7-44B5-AF6A-558BBE047AFE}"/>
               </a:ext>
             </a:extLst>
           </p:cNvPr>
@@ -11090,7 +11090,7 @@
           <p:cNvPr id="22" name="">
             <a:extLst xmlns:a="http://schemas.openxmlformats.org/drawingml/2006/main">
               <a:ext uri="{FF2B5EF4-FFF2-40B4-BE49-F238E27FC236}">
-                <a16:creationId xmlns:a16="http://schemas.microsoft.com/office/drawing/2014/main" id="{DF1DF559-3F1C-4FE1-92F3-EB7BE5DF96B6}"/>
+                <a16:creationId xmlns:a16="http://schemas.microsoft.com/office/drawing/2014/main" id="{D0A4EBCE-3389-45D6-935C-669879730089}"/>
               </a:ext>
             </a:extLst>
           </p:cNvPr>
@@ -11125,7 +11125,7 @@
           <p:cNvPr id="23" name="">
             <a:extLst xmlns:a="http://schemas.openxmlformats.org/drawingml/2006/main">
               <a:ext uri="{FF2B5EF4-FFF2-40B4-BE49-F238E27FC236}">
-                <a16:creationId xmlns:a16="http://schemas.microsoft.com/office/drawing/2014/main" id="{CF69D2D8-73FA-41E1-9435-ED98F42C568D}"/>
+                <a16:creationId xmlns:a16="http://schemas.microsoft.com/office/drawing/2014/main" id="{D473ECCB-CDF4-4591-A874-C060D896827D}"/>
               </a:ext>
             </a:extLst>
           </p:cNvPr>
@@ -11183,7 +11183,7 @@
           <p:cNvPr id="24" name="">
             <a:extLst xmlns:a="http://schemas.openxmlformats.org/drawingml/2006/main">
               <a:ext uri="{FF2B5EF4-FFF2-40B4-BE49-F238E27FC236}">
-                <a16:creationId xmlns:a16="http://schemas.microsoft.com/office/drawing/2014/main" id="{3EA8480E-9546-4DE7-9876-14F2684D641E}"/>
+                <a16:creationId xmlns:a16="http://schemas.microsoft.com/office/drawing/2014/main" id="{EC75E46C-8CBE-4552-83EC-3DBC1744A8D9}"/>
               </a:ext>
             </a:extLst>
           </p:cNvPr>
@@ -11231,7 +11231,7 @@
                 <a:ea typeface="Aptos"/>
                 <a:cs typeface="Aptos"/>
               </a:rPr>
-              <a:t>WATERS NEXT GEN COMPETITIVE INTELLIGENCE · 08 SEP 2026 · waters-ci-20260909030324</a:t>
+              <a:t>WATERS NEXT GEN COMPETITIVE INTELLIGENCE · 08 SEP 2026 · waters-ci-20260909033329</a:t>
             </a:r>
           </a:p>
         </p:txBody>
@@ -11241,7 +11241,7 @@
           <p:cNvPr id="25" name="">
             <a:extLst xmlns:a="http://schemas.openxmlformats.org/drawingml/2006/main">
               <a:ext uri="{FF2B5EF4-FFF2-40B4-BE49-F238E27FC236}">
-                <a16:creationId xmlns:a16="http://schemas.microsoft.com/office/drawing/2014/main" id="{7B5C0FD5-1630-4322-9FAE-295ABB7B8D12}"/>
+                <a16:creationId xmlns:a16="http://schemas.microsoft.com/office/drawing/2014/main" id="{005754BA-37DC-4CC3-AF58-3499C75FD2A5}"/>
               </a:ext>
             </a:extLst>
           </p:cNvPr>
@@ -11297,7 +11297,7 @@
     </p:spTree>
     <p:extLst>
       <p:ext uri="{BB962C8B-B14F-4D97-AF65-F5344CB8AC3E}">
-        <p14:creationId xmlns:p14="http://schemas.microsoft.com/office/powerpoint/2010/main" val="855869423"/>
+        <p14:creationId xmlns:p14="http://schemas.microsoft.com/office/powerpoint/2010/main" val="2086102211"/>
       </p:ext>
     </p:extLst>
   </p:cSld>
@@ -11328,7 +11328,7 @@
           <p:cNvPr id="38" name="">
             <a:extLst xmlns:a="http://schemas.openxmlformats.org/drawingml/2006/main">
               <a:ext uri="{FF2B5EF4-FFF2-40B4-BE49-F238E27FC236}">
-                <a16:creationId xmlns:a16="http://schemas.microsoft.com/office/drawing/2014/main" id="{2B34001B-37D5-4DDE-A2FE-B115842AABD4}"/>
+                <a16:creationId xmlns:a16="http://schemas.microsoft.com/office/drawing/2014/main" id="{B55D4D5C-9F5C-4EEE-A38B-44BD138132E7}"/>
               </a:ext>
             </a:extLst>
           </p:cNvPr>
@@ -11386,7 +11386,7 @@
           <p:cNvPr id="2" name="">
             <a:extLst xmlns:a="http://schemas.openxmlformats.org/drawingml/2006/main">
               <a:ext uri="{FF2B5EF4-FFF2-40B4-BE49-F238E27FC236}">
-                <a16:creationId xmlns:a16="http://schemas.microsoft.com/office/drawing/2014/main" id="{D029DA22-E448-4F93-B162-2987E77F6D3C}"/>
+                <a16:creationId xmlns:a16="http://schemas.microsoft.com/office/drawing/2014/main" id="{DEF4FC47-B810-4F48-B5F6-94990B506996}"/>
               </a:ext>
             </a:extLst>
           </p:cNvPr>
@@ -11444,7 +11444,7 @@
           <p:cNvPr id="3" name="">
             <a:extLst xmlns:a="http://schemas.openxmlformats.org/drawingml/2006/main">
               <a:ext uri="{FF2B5EF4-FFF2-40B4-BE49-F238E27FC236}">
-                <a16:creationId xmlns:a16="http://schemas.microsoft.com/office/drawing/2014/main" id="{1D325306-0835-4A4E-8EFF-8FBC09EF1CF1}"/>
+                <a16:creationId xmlns:a16="http://schemas.microsoft.com/office/drawing/2014/main" id="{CD501A0C-71B7-45A0-B0FE-6616EDAC4EB4}"/>
               </a:ext>
             </a:extLst>
           </p:cNvPr>
@@ -11502,7 +11502,7 @@
           <p:cNvPr id="4" name="">
             <a:extLst xmlns:a="http://schemas.openxmlformats.org/drawingml/2006/main">
               <a:ext uri="{FF2B5EF4-FFF2-40B4-BE49-F238E27FC236}">
-                <a16:creationId xmlns:a16="http://schemas.microsoft.com/office/drawing/2014/main" id="{8B56ACB4-80E5-4FEB-8EE7-6187D2E4E0E5}"/>
+                <a16:creationId xmlns:a16="http://schemas.microsoft.com/office/drawing/2014/main" id="{650997A8-C8B5-4370-9354-A45E307436A1}"/>
               </a:ext>
             </a:extLst>
           </p:cNvPr>
@@ -11535,7 +11535,7 @@
           <p:cNvPr id="5" name="">
             <a:extLst xmlns:a="http://schemas.openxmlformats.org/drawingml/2006/main">
               <a:ext uri="{FF2B5EF4-FFF2-40B4-BE49-F238E27FC236}">
-                <a16:creationId xmlns:a16="http://schemas.microsoft.com/office/drawing/2014/main" id="{CA5CC138-DA37-4DB2-B049-185F85BA56B4}"/>
+                <a16:creationId xmlns:a16="http://schemas.microsoft.com/office/drawing/2014/main" id="{6737013B-51EA-4B3F-8932-4E087CF2AB24}"/>
               </a:ext>
             </a:extLst>
           </p:cNvPr>
@@ -11593,7 +11593,7 @@
           <p:cNvPr id="6" name="">
             <a:extLst xmlns:a="http://schemas.openxmlformats.org/drawingml/2006/main">
               <a:ext uri="{FF2B5EF4-FFF2-40B4-BE49-F238E27FC236}">
-                <a16:creationId xmlns:a16="http://schemas.microsoft.com/office/drawing/2014/main" id="{C6696588-180B-4516-9895-E2189E4E45BF}"/>
+                <a16:creationId xmlns:a16="http://schemas.microsoft.com/office/drawing/2014/main" id="{D50B1FE5-3DBD-46CB-BBF4-D990892E0D4B}"/>
               </a:ext>
             </a:extLst>
           </p:cNvPr>
@@ -11651,7 +11651,7 @@
           <p:cNvPr id="7" name="">
             <a:extLst xmlns:a="http://schemas.openxmlformats.org/drawingml/2006/main">
               <a:ext uri="{FF2B5EF4-FFF2-40B4-BE49-F238E27FC236}">
-                <a16:creationId xmlns:a16="http://schemas.microsoft.com/office/drawing/2014/main" id="{3D54FA00-847F-4719-B819-CFF6CD3BAC1A}"/>
+                <a16:creationId xmlns:a16="http://schemas.microsoft.com/office/drawing/2014/main" id="{59712450-3082-4E76-ADB6-E3F9FD5E60CA}"/>
               </a:ext>
             </a:extLst>
           </p:cNvPr>
@@ -11707,10 +11707,10 @@
       <p:sp>
         <p:nvSpPr>
           <p:cNvPr id="8" name="">
-            <a:hlinkClick xmlns:r="http://schemas.openxmlformats.org/officeDocument/2006/relationships" xmlns:a="http://schemas.openxmlformats.org/drawingml/2006/main" r:id="R486445a988b2490a"/>
-            <a:extLst xmlns:a="http://schemas.openxmlformats.org/drawingml/2006/main">
-              <a:ext uri="{FF2B5EF4-FFF2-40B4-BE49-F238E27FC236}">
-                <a16:creationId xmlns:a16="http://schemas.microsoft.com/office/drawing/2014/main" id="{673FA212-499E-460D-9F35-25DAEEC39585}"/>
+            <a:hlinkClick xmlns:r="http://schemas.openxmlformats.org/officeDocument/2006/relationships" xmlns:a="http://schemas.openxmlformats.org/drawingml/2006/main" r:id="R6d4c323dd6574944"/>
+            <a:extLst xmlns:a="http://schemas.openxmlformats.org/drawingml/2006/main">
+              <a:ext uri="{FF2B5EF4-FFF2-40B4-BE49-F238E27FC236}">
+                <a16:creationId xmlns:a16="http://schemas.microsoft.com/office/drawing/2014/main" id="{C4D6D21B-F745-4658-B49C-2F500345988F}"/>
               </a:ext>
             </a:extLst>
           </p:cNvPr>
@@ -11768,7 +11768,7 @@
           <p:cNvPr id="9" name="">
             <a:extLst xmlns:a="http://schemas.openxmlformats.org/drawingml/2006/main">
               <a:ext uri="{FF2B5EF4-FFF2-40B4-BE49-F238E27FC236}">
-                <a16:creationId xmlns:a16="http://schemas.microsoft.com/office/drawing/2014/main" id="{AB9087C8-0DA7-4BB1-BCD9-CB26ACDCAED9}"/>
+                <a16:creationId xmlns:a16="http://schemas.microsoft.com/office/drawing/2014/main" id="{5FBBAE10-AB06-45F3-8BE7-89E5D3B13A2E}"/>
               </a:ext>
             </a:extLst>
           </p:cNvPr>
@@ -11801,7 +11801,7 @@
           <p:cNvPr id="10" name="">
             <a:extLst xmlns:a="http://schemas.openxmlformats.org/drawingml/2006/main">
               <a:ext uri="{FF2B5EF4-FFF2-40B4-BE49-F238E27FC236}">
-                <a16:creationId xmlns:a16="http://schemas.microsoft.com/office/drawing/2014/main" id="{06FA2B1C-9256-4B6B-AD65-4A4728978C29}"/>
+                <a16:creationId xmlns:a16="http://schemas.microsoft.com/office/drawing/2014/main" id="{F18BB141-BF28-469E-BF19-28700BAFC16A}"/>
               </a:ext>
             </a:extLst>
           </p:cNvPr>
@@ -11859,7 +11859,7 @@
           <p:cNvPr id="11" name="">
             <a:extLst xmlns:a="http://schemas.openxmlformats.org/drawingml/2006/main">
               <a:ext uri="{FF2B5EF4-FFF2-40B4-BE49-F238E27FC236}">
-                <a16:creationId xmlns:a16="http://schemas.microsoft.com/office/drawing/2014/main" id="{7FC6BB11-89D4-46D3-814A-8DE339A15DE5}"/>
+                <a16:creationId xmlns:a16="http://schemas.microsoft.com/office/drawing/2014/main" id="{D80319B6-5A09-4197-867E-92E1F95F56A7}"/>
               </a:ext>
             </a:extLst>
           </p:cNvPr>
@@ -11917,7 +11917,7 @@
           <p:cNvPr id="12" name="">
             <a:extLst xmlns:a="http://schemas.openxmlformats.org/drawingml/2006/main">
               <a:ext uri="{FF2B5EF4-FFF2-40B4-BE49-F238E27FC236}">
-                <a16:creationId xmlns:a16="http://schemas.microsoft.com/office/drawing/2014/main" id="{5219D96D-130F-48FE-8EFF-8A69C44C2793}"/>
+                <a16:creationId xmlns:a16="http://schemas.microsoft.com/office/drawing/2014/main" id="{F13A2F36-3617-4766-AF0E-05E0051577A2}"/>
               </a:ext>
             </a:extLst>
           </p:cNvPr>
@@ -11973,10 +11973,10 @@
       <p:sp>
         <p:nvSpPr>
           <p:cNvPr id="13" name="">
-            <a:hlinkClick xmlns:r="http://schemas.openxmlformats.org/officeDocument/2006/relationships" xmlns:a="http://schemas.openxmlformats.org/drawingml/2006/main" r:id="R920f1152316349fc"/>
-            <a:extLst xmlns:a="http://schemas.openxmlformats.org/drawingml/2006/main">
-              <a:ext uri="{FF2B5EF4-FFF2-40B4-BE49-F238E27FC236}">
-                <a16:creationId xmlns:a16="http://schemas.microsoft.com/office/drawing/2014/main" id="{A03B8DB9-94CD-4345-8FFB-043BB56258D5}"/>
+            <a:hlinkClick xmlns:r="http://schemas.openxmlformats.org/officeDocument/2006/relationships" xmlns:a="http://schemas.openxmlformats.org/drawingml/2006/main" r:id="R8e289cb36d114974"/>
+            <a:extLst xmlns:a="http://schemas.openxmlformats.org/drawingml/2006/main">
+              <a:ext uri="{FF2B5EF4-FFF2-40B4-BE49-F238E27FC236}">
+                <a16:creationId xmlns:a16="http://schemas.microsoft.com/office/drawing/2014/main" id="{B4397338-7A21-4C4B-85A7-0D2F2735A6BE}"/>
               </a:ext>
             </a:extLst>
           </p:cNvPr>
@@ -12034,7 +12034,7 @@
           <p:cNvPr id="14" name="">
             <a:extLst xmlns:a="http://schemas.openxmlformats.org/drawingml/2006/main">
               <a:ext uri="{FF2B5EF4-FFF2-40B4-BE49-F238E27FC236}">
-                <a16:creationId xmlns:a16="http://schemas.microsoft.com/office/drawing/2014/main" id="{9104B4B1-255D-4EEF-823B-BB8CAFEBF84E}"/>
+                <a16:creationId xmlns:a16="http://schemas.microsoft.com/office/drawing/2014/main" id="{CF320426-18D8-4A5E-B243-5411941C6C59}"/>
               </a:ext>
             </a:extLst>
           </p:cNvPr>
@@ -12067,7 +12067,7 @@
           <p:cNvPr id="15" name="">
             <a:extLst xmlns:a="http://schemas.openxmlformats.org/drawingml/2006/main">
               <a:ext uri="{FF2B5EF4-FFF2-40B4-BE49-F238E27FC236}">
-                <a16:creationId xmlns:a16="http://schemas.microsoft.com/office/drawing/2014/main" id="{649B88B2-FD87-42AB-980B-9E4C3A2DD58F}"/>
+                <a16:creationId xmlns:a16="http://schemas.microsoft.com/office/drawing/2014/main" id="{7F3C5C9B-6119-4EC9-8B3A-D5EAFD361881}"/>
               </a:ext>
             </a:extLst>
           </p:cNvPr>
@@ -12125,7 +12125,7 @@
           <p:cNvPr id="16" name="">
             <a:extLst xmlns:a="http://schemas.openxmlformats.org/drawingml/2006/main">
               <a:ext uri="{FF2B5EF4-FFF2-40B4-BE49-F238E27FC236}">
-                <a16:creationId xmlns:a16="http://schemas.microsoft.com/office/drawing/2014/main" id="{B84B4B30-8BEA-4ACB-9930-F483DA9926CC}"/>
+                <a16:creationId xmlns:a16="http://schemas.microsoft.com/office/drawing/2014/main" id="{6AA737F2-EFE9-4237-9A1A-BBD5C825C55E}"/>
               </a:ext>
             </a:extLst>
           </p:cNvPr>
@@ -12183,7 +12183,7 @@
           <p:cNvPr id="17" name="">
             <a:extLst xmlns:a="http://schemas.openxmlformats.org/drawingml/2006/main">
               <a:ext uri="{FF2B5EF4-FFF2-40B4-BE49-F238E27FC236}">
-                <a16:creationId xmlns:a16="http://schemas.microsoft.com/office/drawing/2014/main" id="{3F5E6AFA-54F7-4A8C-B69F-B13E6B5B2575}"/>
+                <a16:creationId xmlns:a16="http://schemas.microsoft.com/office/drawing/2014/main" id="{84B0A9A5-E369-41A1-B7F5-362145FBDCA9}"/>
               </a:ext>
             </a:extLst>
           </p:cNvPr>
@@ -12239,10 +12239,10 @@
       <p:sp>
         <p:nvSpPr>
           <p:cNvPr id="18" name="">
-            <a:hlinkClick xmlns:r="http://schemas.openxmlformats.org/officeDocument/2006/relationships" xmlns:a="http://schemas.openxmlformats.org/drawingml/2006/main" r:id="Rd3b9d96a0d1e4c9f"/>
-            <a:extLst xmlns:a="http://schemas.openxmlformats.org/drawingml/2006/main">
-              <a:ext uri="{FF2B5EF4-FFF2-40B4-BE49-F238E27FC236}">
-                <a16:creationId xmlns:a16="http://schemas.microsoft.com/office/drawing/2014/main" id="{7362A52C-4D71-4B11-BA8D-E001BEEA3DBE}"/>
+            <a:hlinkClick xmlns:r="http://schemas.openxmlformats.org/officeDocument/2006/relationships" xmlns:a="http://schemas.openxmlformats.org/drawingml/2006/main" r:id="R64748f282f2e4f8c"/>
+            <a:extLst xmlns:a="http://schemas.openxmlformats.org/drawingml/2006/main">
+              <a:ext uri="{FF2B5EF4-FFF2-40B4-BE49-F238E27FC236}">
+                <a16:creationId xmlns:a16="http://schemas.microsoft.com/office/drawing/2014/main" id="{459E757F-93D4-4E2F-81B5-F75D55F90BF1}"/>
               </a:ext>
             </a:extLst>
           </p:cNvPr>
@@ -12300,7 +12300,7 @@
           <p:cNvPr id="19" name="">
             <a:extLst xmlns:a="http://schemas.openxmlformats.org/drawingml/2006/main">
               <a:ext uri="{FF2B5EF4-FFF2-40B4-BE49-F238E27FC236}">
-                <a16:creationId xmlns:a16="http://schemas.microsoft.com/office/drawing/2014/main" id="{B0564032-3F59-4AAE-8BA0-F14315F51F1C}"/>
+                <a16:creationId xmlns:a16="http://schemas.microsoft.com/office/drawing/2014/main" id="{F4593171-80DF-4507-B4F9-5A247E7944FA}"/>
               </a:ext>
             </a:extLst>
           </p:cNvPr>
@@ -12333,7 +12333,7 @@
           <p:cNvPr id="20" name="">
             <a:extLst xmlns:a="http://schemas.openxmlformats.org/drawingml/2006/main">
               <a:ext uri="{FF2B5EF4-FFF2-40B4-BE49-F238E27FC236}">
-                <a16:creationId xmlns:a16="http://schemas.microsoft.com/office/drawing/2014/main" id="{8CA2CEB3-17AE-46A2-B365-201616996630}"/>
+                <a16:creationId xmlns:a16="http://schemas.microsoft.com/office/drawing/2014/main" id="{320992BA-864D-4626-95C5-7D1480A3DFFC}"/>
               </a:ext>
             </a:extLst>
           </p:cNvPr>
@@ -12391,7 +12391,7 @@
           <p:cNvPr id="21" name="">
             <a:extLst xmlns:a="http://schemas.openxmlformats.org/drawingml/2006/main">
               <a:ext uri="{FF2B5EF4-FFF2-40B4-BE49-F238E27FC236}">
-                <a16:creationId xmlns:a16="http://schemas.microsoft.com/office/drawing/2014/main" id="{4219B944-13C6-430E-B3D6-16D9A769F3A2}"/>
+                <a16:creationId xmlns:a16="http://schemas.microsoft.com/office/drawing/2014/main" id="{256586F5-6E56-490A-8620-258E1A32AC68}"/>
               </a:ext>
             </a:extLst>
           </p:cNvPr>
@@ -12449,7 +12449,7 @@
           <p:cNvPr id="22" name="">
             <a:extLst xmlns:a="http://schemas.openxmlformats.org/drawingml/2006/main">
               <a:ext uri="{FF2B5EF4-FFF2-40B4-BE49-F238E27FC236}">
-                <a16:creationId xmlns:a16="http://schemas.microsoft.com/office/drawing/2014/main" id="{CC7E0013-C9F9-4E25-A972-A09C1104FFE0}"/>
+                <a16:creationId xmlns:a16="http://schemas.microsoft.com/office/drawing/2014/main" id="{0C17563F-820F-4F7B-9C41-4519FE5B8CC7}"/>
               </a:ext>
             </a:extLst>
           </p:cNvPr>
@@ -12505,10 +12505,10 @@
       <p:sp>
         <p:nvSpPr>
           <p:cNvPr id="23" name="">
-            <a:hlinkClick xmlns:r="http://schemas.openxmlformats.org/officeDocument/2006/relationships" xmlns:a="http://schemas.openxmlformats.org/drawingml/2006/main" r:id="Rb00ad112b305496e"/>
-            <a:extLst xmlns:a="http://schemas.openxmlformats.org/drawingml/2006/main">
-              <a:ext uri="{FF2B5EF4-FFF2-40B4-BE49-F238E27FC236}">
-                <a16:creationId xmlns:a16="http://schemas.microsoft.com/office/drawing/2014/main" id="{610ED8F1-B5AD-4337-8AD7-4ACDD0EFFBB8}"/>
+            <a:hlinkClick xmlns:r="http://schemas.openxmlformats.org/officeDocument/2006/relationships" xmlns:a="http://schemas.openxmlformats.org/drawingml/2006/main" r:id="Rb5dd03906cc546f3"/>
+            <a:extLst xmlns:a="http://schemas.openxmlformats.org/drawingml/2006/main">
+              <a:ext uri="{FF2B5EF4-FFF2-40B4-BE49-F238E27FC236}">
+                <a16:creationId xmlns:a16="http://schemas.microsoft.com/office/drawing/2014/main" id="{EEAC1A9B-9A3C-4E34-B877-2EE0E3122EBC}"/>
               </a:ext>
             </a:extLst>
           </p:cNvPr>
@@ -12566,7 +12566,7 @@
           <p:cNvPr id="24" name="">
             <a:extLst xmlns:a="http://schemas.openxmlformats.org/drawingml/2006/main">
               <a:ext uri="{FF2B5EF4-FFF2-40B4-BE49-F238E27FC236}">
-                <a16:creationId xmlns:a16="http://schemas.microsoft.com/office/drawing/2014/main" id="{9FD3DA43-07D1-41AA-9454-512346D3C5E1}"/>
+                <a16:creationId xmlns:a16="http://schemas.microsoft.com/office/drawing/2014/main" id="{0E1EEA08-E535-44FD-9864-0795DE064C9A}"/>
               </a:ext>
             </a:extLst>
           </p:cNvPr>
@@ -12599,7 +12599,7 @@
           <p:cNvPr id="25" name="">
             <a:extLst xmlns:a="http://schemas.openxmlformats.org/drawingml/2006/main">
               <a:ext uri="{FF2B5EF4-FFF2-40B4-BE49-F238E27FC236}">
-                <a16:creationId xmlns:a16="http://schemas.microsoft.com/office/drawing/2014/main" id="{30AE0E8E-4152-410E-9610-0F5D14C54E1F}"/>
+                <a16:creationId xmlns:a16="http://schemas.microsoft.com/office/drawing/2014/main" id="{92424298-2677-4DDF-8C69-ED0288777EB6}"/>
               </a:ext>
             </a:extLst>
           </p:cNvPr>
@@ -12657,7 +12657,7 @@
           <p:cNvPr id="26" name="">
             <a:extLst xmlns:a="http://schemas.openxmlformats.org/drawingml/2006/main">
               <a:ext uri="{FF2B5EF4-FFF2-40B4-BE49-F238E27FC236}">
-                <a16:creationId xmlns:a16="http://schemas.microsoft.com/office/drawing/2014/main" id="{D4A19F2C-4930-45A4-A240-2D4241DCCFE5}"/>
+                <a16:creationId xmlns:a16="http://schemas.microsoft.com/office/drawing/2014/main" id="{68AA7128-F203-4D74-B1D0-0C2480CD8D8E}"/>
               </a:ext>
             </a:extLst>
           </p:cNvPr>
@@ -12715,7 +12715,7 @@
           <p:cNvPr id="27" name="">
             <a:extLst xmlns:a="http://schemas.openxmlformats.org/drawingml/2006/main">
               <a:ext uri="{FF2B5EF4-FFF2-40B4-BE49-F238E27FC236}">
-                <a16:creationId xmlns:a16="http://schemas.microsoft.com/office/drawing/2014/main" id="{4C1FCFDA-A06C-4F9D-AD9C-90F2511BBF36}"/>
+                <a16:creationId xmlns:a16="http://schemas.microsoft.com/office/drawing/2014/main" id="{88E2878D-EAE5-41AD-A791-B7C1A842E452}"/>
               </a:ext>
             </a:extLst>
           </p:cNvPr>
@@ -12771,10 +12771,10 @@
       <p:sp>
         <p:nvSpPr>
           <p:cNvPr id="28" name="">
-            <a:hlinkClick xmlns:r="http://schemas.openxmlformats.org/officeDocument/2006/relationships" xmlns:a="http://schemas.openxmlformats.org/drawingml/2006/main" r:id="Rb245d4684f934e38"/>
-            <a:extLst xmlns:a="http://schemas.openxmlformats.org/drawingml/2006/main">
-              <a:ext uri="{FF2B5EF4-FFF2-40B4-BE49-F238E27FC236}">
-                <a16:creationId xmlns:a16="http://schemas.microsoft.com/office/drawing/2014/main" id="{CA43CB49-1E53-4D44-A986-64386F7FDAAC}"/>
+            <a:hlinkClick xmlns:r="http://schemas.openxmlformats.org/officeDocument/2006/relationships" xmlns:a="http://schemas.openxmlformats.org/drawingml/2006/main" r:id="Ree4171d3a6de4212"/>
+            <a:extLst xmlns:a="http://schemas.openxmlformats.org/drawingml/2006/main">
+              <a:ext uri="{FF2B5EF4-FFF2-40B4-BE49-F238E27FC236}">
+                <a16:creationId xmlns:a16="http://schemas.microsoft.com/office/drawing/2014/main" id="{94848DB2-01AA-4C19-9BAA-B53CFC50763C}"/>
               </a:ext>
             </a:extLst>
           </p:cNvPr>
@@ -12832,7 +12832,7 @@
           <p:cNvPr id="29" name="">
             <a:extLst xmlns:a="http://schemas.openxmlformats.org/drawingml/2006/main">
               <a:ext uri="{FF2B5EF4-FFF2-40B4-BE49-F238E27FC236}">
-                <a16:creationId xmlns:a16="http://schemas.microsoft.com/office/drawing/2014/main" id="{CAE4953A-0E76-4BA3-8DDD-0E0460CA1518}"/>
+                <a16:creationId xmlns:a16="http://schemas.microsoft.com/office/drawing/2014/main" id="{9A262735-2670-495D-B2AC-B8FC9B5C6CA7}"/>
               </a:ext>
             </a:extLst>
           </p:cNvPr>
@@ -12865,7 +12865,7 @@
           <p:cNvPr id="30" name="">
             <a:extLst xmlns:a="http://schemas.openxmlformats.org/drawingml/2006/main">
               <a:ext uri="{FF2B5EF4-FFF2-40B4-BE49-F238E27FC236}">
-                <a16:creationId xmlns:a16="http://schemas.microsoft.com/office/drawing/2014/main" id="{E66633F9-7F48-4A68-B486-79FBAE4DF341}"/>
+                <a16:creationId xmlns:a16="http://schemas.microsoft.com/office/drawing/2014/main" id="{E23B7785-AEA4-4C19-80FA-B1DA1933FF8F}"/>
               </a:ext>
             </a:extLst>
           </p:cNvPr>
@@ -12923,7 +12923,7 @@
           <p:cNvPr id="31" name="">
             <a:extLst xmlns:a="http://schemas.openxmlformats.org/drawingml/2006/main">
               <a:ext uri="{FF2B5EF4-FFF2-40B4-BE49-F238E27FC236}">
-                <a16:creationId xmlns:a16="http://schemas.microsoft.com/office/drawing/2014/main" id="{3A01B2F7-1049-44E0-95B3-525F720FCA14}"/>
+                <a16:creationId xmlns:a16="http://schemas.microsoft.com/office/drawing/2014/main" id="{4D7A5080-46B8-4957-BE69-B25785CAE615}"/>
               </a:ext>
             </a:extLst>
           </p:cNvPr>
@@ -12981,7 +12981,7 @@
           <p:cNvPr id="32" name="">
             <a:extLst xmlns:a="http://schemas.openxmlformats.org/drawingml/2006/main">
               <a:ext uri="{FF2B5EF4-FFF2-40B4-BE49-F238E27FC236}">
-                <a16:creationId xmlns:a16="http://schemas.microsoft.com/office/drawing/2014/main" id="{D13897DF-CB69-4298-B224-DDED01FB5B57}"/>
+                <a16:creationId xmlns:a16="http://schemas.microsoft.com/office/drawing/2014/main" id="{40859E58-D390-4860-BDA8-0F8A1BA661C5}"/>
               </a:ext>
             </a:extLst>
           </p:cNvPr>
@@ -13037,10 +13037,10 @@
       <p:sp>
         <p:nvSpPr>
           <p:cNvPr id="33" name="">
-            <a:hlinkClick xmlns:r="http://schemas.openxmlformats.org/officeDocument/2006/relationships" xmlns:a="http://schemas.openxmlformats.org/drawingml/2006/main" r:id="R5769aac7b70f4b85"/>
-            <a:extLst xmlns:a="http://schemas.openxmlformats.org/drawingml/2006/main">
-              <a:ext uri="{FF2B5EF4-FFF2-40B4-BE49-F238E27FC236}">
-                <a16:creationId xmlns:a16="http://schemas.microsoft.com/office/drawing/2014/main" id="{56AF48F1-DDDF-4602-A4E5-3AE986AFD8BC}"/>
+            <a:hlinkClick xmlns:r="http://schemas.openxmlformats.org/officeDocument/2006/relationships" xmlns:a="http://schemas.openxmlformats.org/drawingml/2006/main" r:id="R806c102c64dd43b2"/>
+            <a:extLst xmlns:a="http://schemas.openxmlformats.org/drawingml/2006/main">
+              <a:ext uri="{FF2B5EF4-FFF2-40B4-BE49-F238E27FC236}">
+                <a16:creationId xmlns:a16="http://schemas.microsoft.com/office/drawing/2014/main" id="{D597BD6C-FD26-4E82-9DF5-96ACED0FB9E9}"/>
               </a:ext>
             </a:extLst>
           </p:cNvPr>
@@ -13098,7 +13098,7 @@
           <p:cNvPr id="34" name="">
             <a:extLst xmlns:a="http://schemas.openxmlformats.org/drawingml/2006/main">
               <a:ext uri="{FF2B5EF4-FFF2-40B4-BE49-F238E27FC236}">
-                <a16:creationId xmlns:a16="http://schemas.microsoft.com/office/drawing/2014/main" id="{C620BC8E-6104-4408-940B-4DD277BE0C8F}"/>
+                <a16:creationId xmlns:a16="http://schemas.microsoft.com/office/drawing/2014/main" id="{48027D20-B576-4DF9-8733-485424D71C61}"/>
               </a:ext>
             </a:extLst>
           </p:cNvPr>
@@ -13133,7 +13133,7 @@
           <p:cNvPr id="35" name="">
             <a:extLst xmlns:a="http://schemas.openxmlformats.org/drawingml/2006/main">
               <a:ext uri="{FF2B5EF4-FFF2-40B4-BE49-F238E27FC236}">
-                <a16:creationId xmlns:a16="http://schemas.microsoft.com/office/drawing/2014/main" id="{82DC02CC-D036-4A46-9A7C-C57D6549250A}"/>
+                <a16:creationId xmlns:a16="http://schemas.microsoft.com/office/drawing/2014/main" id="{656E13B7-4749-4FFB-A475-658A53D90A3A}"/>
               </a:ext>
             </a:extLst>
           </p:cNvPr>
@@ -13181,7 +13181,7 @@
                 <a:ea typeface="Aptos"/>
                 <a:cs typeface="Aptos"/>
               </a:rPr>
-              <a:t>Snapshot: waters-ci-20260909030324 · As of 2026-09-08 · Business magnitude requires Waters internal data.</a:t>
+              <a:t>Snapshot: waters-ci-20260909033329 · As of 2026-09-08 · Business magnitude requires Waters internal data.</a:t>
             </a:r>
           </a:p>
         </p:txBody>
@@ -13191,7 +13191,7 @@
           <p:cNvPr id="36" name="">
             <a:extLst xmlns:a="http://schemas.openxmlformats.org/drawingml/2006/main">
               <a:ext uri="{FF2B5EF4-FFF2-40B4-BE49-F238E27FC236}">
-                <a16:creationId xmlns:a16="http://schemas.microsoft.com/office/drawing/2014/main" id="{22CF4588-AA3E-44E1-9D6B-B139DC0D7FAE}"/>
+                <a16:creationId xmlns:a16="http://schemas.microsoft.com/office/drawing/2014/main" id="{930BF492-16D0-4068-9F45-2F0994597587}"/>
               </a:ext>
             </a:extLst>
           </p:cNvPr>
@@ -13239,7 +13239,7 @@
                 <a:ea typeface="Aptos"/>
                 <a:cs typeface="Aptos"/>
               </a:rPr>
-              <a:t>WATERS NEXT GEN COMPETITIVE INTELLIGENCE · 08 SEP 2026 · waters-ci-20260909030324</a:t>
+              <a:t>WATERS NEXT GEN COMPETITIVE INTELLIGENCE · 08 SEP 2026 · waters-ci-20260909033329</a:t>
             </a:r>
           </a:p>
         </p:txBody>
@@ -13249,7 +13249,7 @@
           <p:cNvPr id="37" name="">
             <a:extLst xmlns:a="http://schemas.openxmlformats.org/drawingml/2006/main">
               <a:ext uri="{FF2B5EF4-FFF2-40B4-BE49-F238E27FC236}">
-                <a16:creationId xmlns:a16="http://schemas.microsoft.com/office/drawing/2014/main" id="{23B96A0A-B6B0-47CC-A2A7-39D7316BF824}"/>
+                <a16:creationId xmlns:a16="http://schemas.microsoft.com/office/drawing/2014/main" id="{A57D99CE-148E-41E9-85F1-731ED4F14F69}"/>
               </a:ext>
             </a:extLst>
           </p:cNvPr>
@@ -13305,7 +13305,7 @@
     </p:spTree>
     <p:extLst>
       <p:ext uri="{BB962C8B-B14F-4D97-AF65-F5344CB8AC3E}">
-        <p14:creationId xmlns:p14="http://schemas.microsoft.com/office/powerpoint/2010/main" val="1732690402"/>
+        <p14:creationId xmlns:p14="http://schemas.microsoft.com/office/powerpoint/2010/main" val="1596368821"/>
       </p:ext>
     </p:extLst>
   </p:cSld>

</xml_diff>

<commit_message>
Refresh September 9 intelligence and repair source freshness
</commit_message>
<xml_diff>
--- a/deploy-site/exports/waters-nextgen-leadership-brief.pptx
+++ b/deploy-site/exports/waters-nextgen-leadership-brief.pptx
@@ -2,20 +2,20 @@
 <file path=ppt/presentation.xml><?xml version="1.0" encoding="utf-8"?>
 <p:presentation xmlns:p="http://schemas.openxmlformats.org/presentationml/2006/main">
   <p:sldMasterIdLst>
-    <p:sldMasterId xmlns:r="http://schemas.openxmlformats.org/officeDocument/2006/relationships" id="2147483648" r:id="R0e38ff0edf624438"/>
+    <p:sldMasterId xmlns:r="http://schemas.openxmlformats.org/officeDocument/2006/relationships" id="2147483648" r:id="R271cffb010344991"/>
   </p:sldMasterIdLst>
   <p:notesMasterIdLst>
-    <p:notesMasterId xmlns:r="http://schemas.openxmlformats.org/officeDocument/2006/relationships" r:id="R08a34c76c76b4b79"/>
+    <p:notesMasterId xmlns:r="http://schemas.openxmlformats.org/officeDocument/2006/relationships" r:id="R5df3b5a2f91440cf"/>
   </p:notesMasterIdLst>
   <p:sldIdLst>
-    <p:sldId xmlns:r="http://schemas.openxmlformats.org/officeDocument/2006/relationships" id="256" r:id="R37bf0251fe374de9"/>
-    <p:sldId xmlns:r="http://schemas.openxmlformats.org/officeDocument/2006/relationships" id="257" r:id="Raaab027362ad493c"/>
-    <p:sldId xmlns:r="http://schemas.openxmlformats.org/officeDocument/2006/relationships" id="258" r:id="Rb86fc8e5568349df"/>
-    <p:sldId xmlns:r="http://schemas.openxmlformats.org/officeDocument/2006/relationships" id="259" r:id="Re26cdbe0c2d44cf4"/>
-    <p:sldId xmlns:r="http://schemas.openxmlformats.org/officeDocument/2006/relationships" id="260" r:id="Rf6056467bad3424f"/>
-    <p:sldId xmlns:r="http://schemas.openxmlformats.org/officeDocument/2006/relationships" id="261" r:id="R659bb247a1414e6a"/>
-    <p:sldId xmlns:r="http://schemas.openxmlformats.org/officeDocument/2006/relationships" id="262" r:id="R3c9f6ed48d2e4ab7"/>
-    <p:sldId xmlns:r="http://schemas.openxmlformats.org/officeDocument/2006/relationships" id="263" r:id="R33e87f5247b74814"/>
+    <p:sldId xmlns:r="http://schemas.openxmlformats.org/officeDocument/2006/relationships" id="256" r:id="R310060d6e99345a8"/>
+    <p:sldId xmlns:r="http://schemas.openxmlformats.org/officeDocument/2006/relationships" id="257" r:id="R0ffaf92ce50843c0"/>
+    <p:sldId xmlns:r="http://schemas.openxmlformats.org/officeDocument/2006/relationships" id="258" r:id="Ra3ab73da68e94ce2"/>
+    <p:sldId xmlns:r="http://schemas.openxmlformats.org/officeDocument/2006/relationships" id="259" r:id="R86092c59df9247e8"/>
+    <p:sldId xmlns:r="http://schemas.openxmlformats.org/officeDocument/2006/relationships" id="260" r:id="Rcdbf9c8451834300"/>
+    <p:sldId xmlns:r="http://schemas.openxmlformats.org/officeDocument/2006/relationships" id="261" r:id="Rd6c1d4321af24cc2"/>
+    <p:sldId xmlns:r="http://schemas.openxmlformats.org/officeDocument/2006/relationships" id="262" r:id="R3b22aa68c9684e1f"/>
+    <p:sldId xmlns:r="http://schemas.openxmlformats.org/officeDocument/2006/relationships" id="263" r:id="Rd54c489790e04100"/>
   </p:sldIdLst>
   <p:sldSz cx="12192000" cy="6858000"/>
   <p:notesSz cx="6858000" cy="9144000"/>
@@ -529,17 +529,17 @@
           </a:p>
           <a:p xmlns:a="http://schemas.openxmlformats.org/drawingml/2006/main">
             <a:r>
-              <a:t>- https://pubmed.ncbi.nlm.nih.gov/?term=%28%28%22laboratory+automation%22+OR+%22workflow+software%22+OR+%22AI%22%29+AND+%28%22LC-MS%22+OR+chromatography+OR+%22mass+spectrometry%22%29%29+AND+%28%222025%2F09%2F08%22%5BDate+-+Publication%5D+%3A+%222026%2F09%2F08%22%5BDate+-+Publication%5D%29</a:t>
-            </a:r>
-          </a:p>
-          <a:p xmlns:a="http://schemas.openxmlformats.org/drawingml/2006/main">
-            <a:r>
-              <a:t>- https://pubmed.ncbi.nlm.nih.gov/?term=%28%28PFAS+OR+%22per-+and+polyfluoroalkyl%22%29+AND+%28%22LC-MS%22+OR+%22LC-MS%2FMS%22+OR+chromatography%29%29+AND+%28%222025%2F09%2F08%22%5BDate+-+Publication%5D+%3A+%222026%2F09%2F08%22%5BDate+-+Publication%5D%29</a:t>
-            </a:r>
-          </a:p>
-          <a:p xmlns:a="http://schemas.openxmlformats.org/drawingml/2006/main">
-            <a:r>
-              <a:t>- https://pubmed.ncbi.nlm.nih.gov/?term=%28%28oligonucleotide+OR+%22nucleic+acid%22+OR+siRNA%29+AND+%28%22LC-MS%22+OR+chromatography+OR+%22mass+spectrometry%22%29%29+AND+%28%222025%2F09%2F08%22%5BDate+-+Publication%5D+%3A+%222026%2F09%2F08%22%5BDate+-+Publication%5D%29</a:t>
+              <a:t>- https://pubmed.ncbi.nlm.nih.gov/?term=%28%28%22laboratory+automation%22+OR+%22workflow+software%22+OR+%22AI%22%29+AND+%28%22LC-MS%22+OR+chromatography+OR+%22mass+spectrometry%22%29%29+AND+%28%222025%2F09%2F09%22%5BDate+-+Publication%5D+%3A+%222026%2F09%2F09%22%5BDate+-+Publication%5D%29</a:t>
+            </a:r>
+          </a:p>
+          <a:p xmlns:a="http://schemas.openxmlformats.org/drawingml/2006/main">
+            <a:r>
+              <a:t>- https://pubmed.ncbi.nlm.nih.gov/?term=%28%28PFAS+OR+%22per-+and+polyfluoroalkyl%22%29+AND+%28%22LC-MS%22+OR+%22LC-MS%2FMS%22+OR+chromatography%29%29+AND+%28%222025%2F09%2F09%22%5BDate+-+Publication%5D+%3A+%222026%2F09%2F09%22%5BDate+-+Publication%5D%29</a:t>
+            </a:r>
+          </a:p>
+          <a:p xmlns:a="http://schemas.openxmlformats.org/drawingml/2006/main">
+            <a:r>
+              <a:t>- https://pubmed.ncbi.nlm.nih.gov/?term=%28%28oligonucleotide+OR+%22nucleic+acid%22+OR+siRNA%29+AND+%28%22LC-MS%22+OR+chromatography+OR+%22mass+spectrometry%22%29%29+AND+%28%222025%2F09%2F09%22%5BDate+-+Publication%5D+%3A+%222026%2F09%2F09%22%5BDate+-+Publication%5D%29</a:t>
             </a:r>
           </a:p>
           <a:p xmlns:a="http://schemas.openxmlformats.org/drawingml/2006/main">
@@ -619,7 +619,7 @@
           </a:p>
           <a:p xmlns:a="http://schemas.openxmlformats.org/drawingml/2006/main">
             <a:r>
-              <a:t>- https://pubmed.ncbi.nlm.nih.gov/?term=%28%28PFAS+OR+%22per-+and+polyfluoroalkyl%22%29+AND+%28%22LC-MS%22+OR+%22LC-MS%2FMS%22+OR+chromatography%29%29+AND+%28%222025%2F09%2F08%22%5BDate+-+Publication%5D+%3A+%222026%2F09%2F08%22%5BDate+-+Publication%5D%29</a:t>
+              <a:t>- https://pubmed.ncbi.nlm.nih.gov/?term=%28%28PFAS+OR+%22per-+and+polyfluoroalkyl%22%29+AND+%28%22LC-MS%22+OR+%22LC-MS%2FMS%22+OR+chromatography%29%29+AND+%28%222025%2F09%2F09%22%5BDate+-+Publication%5D+%3A+%222026%2F09%2F09%22%5BDate+-+Publication%5D%29</a:t>
             </a:r>
           </a:p>
           <a:p xmlns:a="http://schemas.openxmlformats.org/drawingml/2006/main">
@@ -949,7 +949,7 @@
           </a:p>
           <a:p xmlns:a="http://schemas.openxmlformats.org/drawingml/2006/main">
             <a:r>
-              <a:t>- https://pubmed.ncbi.nlm.nih.gov/?term=%28%28PFAS+OR+%22per-+and+polyfluoroalkyl%22%29+AND+%28%22LC-MS%22+OR+%22LC-MS%2FMS%22+OR+chromatography%29%29+AND+%28%222025%2F09%2F08%22%5BDate+-+Publication%5D+%3A+%222026%2F09%2F08%22%5BDate+-+Publication%5D%29</a:t>
+              <a:t>- https://pubmed.ncbi.nlm.nih.gov/?term=%28%28PFAS+OR+%22per-+and+polyfluoroalkyl%22%29+AND+%28%22LC-MS%22+OR+%22LC-MS%2FMS%22+OR+chromatography%29%29+AND+%28%222025%2F09%2F09%22%5BDate+-+Publication%5D+%3A+%222026%2F09%2F09%22%5BDate+-+Publication%5D%29</a:t>
             </a:r>
           </a:p>
           <a:p xmlns:a="http://schemas.openxmlformats.org/drawingml/2006/main">
@@ -969,7 +969,7 @@
           </a:p>
           <a:p xmlns:a="http://schemas.openxmlformats.org/drawingml/2006/main">
             <a:r>
-              <a:t>- https://pubmed.ncbi.nlm.nih.gov/?term=%28%28%22laboratory+automation%22+OR+%22workflow+software%22+OR+%22AI%22%29+AND+%28%22LC-MS%22+OR+chromatography+OR+%22mass+spectrometry%22%29%29+AND+%28%222025%2F09%2F08%22%5BDate+-+Publication%5D+%3A+%222026%2F09%2F08%22%5BDate+-+Publication%5D%29</a:t>
+              <a:t>- https://pubmed.ncbi.nlm.nih.gov/?term=%28%28%22laboratory+automation%22+OR+%22workflow+software%22+OR+%22AI%22%29+AND+%28%22LC-MS%22+OR+chromatography+OR+%22mass+spectrometry%22%29%29+AND+%28%222025%2F09%2F09%22%5BDate+-+Publication%5D+%3A+%222026%2F09%2F09%22%5BDate+-+Publication%5D%29</a:t>
             </a:r>
           </a:p>
           <a:p xmlns:a="http://schemas.openxmlformats.org/drawingml/2006/main">
@@ -979,7 +979,7 @@
           </a:p>
           <a:p xmlns:a="http://schemas.openxmlformats.org/drawingml/2006/main">
             <a:r>
-              <a:t>- https://pubmed.ncbi.nlm.nih.gov/?term=%28%28oligonucleotide+OR+%22nucleic+acid%22+OR+siRNA%29+AND+%28%22LC-MS%22+OR+chromatography+OR+%22mass+spectrometry%22%29%29+AND+%28%222025%2F09%2F08%22%5BDate+-+Publication%5D+%3A+%222026%2F09%2F08%22%5BDate+-+Publication%5D%29</a:t>
+              <a:t>- https://pubmed.ncbi.nlm.nih.gov/?term=%28%28oligonucleotide+OR+%22nucleic+acid%22+OR+siRNA%29+AND+%28%22LC-MS%22+OR+chromatography+OR+%22mass+spectrometry%22%29%29+AND+%28%222025%2F09%2F09%22%5BDate+-+Publication%5D+%3A+%222026%2F09%2F09%22%5BDate+-+Publication%5D%29</a:t>
             </a:r>
           </a:p>
           <a:p xmlns:a="http://schemas.openxmlformats.org/drawingml/2006/main">
@@ -1074,7 +1074,7 @@
           </a:p>
           <a:p xmlns:a="http://schemas.openxmlformats.org/drawingml/2006/main">
             <a:r>
-              <a:t>- https://pubmed.ncbi.nlm.nih.gov/?term=%28%28PFAS+OR+%22per-+and+polyfluoroalkyl%22%29+AND+%28%22LC-MS%22+OR+%22LC-MS%2FMS%22+OR+chromatography%29%29+AND+%28%222025%2F09%2F08%22%5BDate+-+Publication%5D+%3A+%222026%2F09%2F08%22%5BDate+-+Publication%5D%29</a:t>
+              <a:t>- https://pubmed.ncbi.nlm.nih.gov/?term=%28%28PFAS+OR+%22per-+and+polyfluoroalkyl%22%29+AND+%28%22LC-MS%22+OR+%22LC-MS%2FMS%22+OR+chromatography%29%29+AND+%28%222025%2F09%2F09%22%5BDate+-+Publication%5D+%3A+%222026%2F09%2F09%22%5BDate+-+Publication%5D%29</a:t>
             </a:r>
           </a:p>
           <a:p xmlns:a="http://schemas.openxmlformats.org/drawingml/2006/main">
@@ -1094,7 +1094,7 @@
           </a:p>
           <a:p xmlns:a="http://schemas.openxmlformats.org/drawingml/2006/main">
             <a:r>
-              <a:t>- https://pubmed.ncbi.nlm.nih.gov/?term=%28%28%22laboratory+automation%22+OR+%22workflow+software%22+OR+%22AI%22%29+AND+%28%22LC-MS%22+OR+chromatography+OR+%22mass+spectrometry%22%29%29+AND+%28%222025%2F09%2F08%22%5BDate+-+Publication%5D+%3A+%222026%2F09%2F08%22%5BDate+-+Publication%5D%29</a:t>
+              <a:t>- https://pubmed.ncbi.nlm.nih.gov/?term=%28%28%22laboratory+automation%22+OR+%22workflow+software%22+OR+%22AI%22%29+AND+%28%22LC-MS%22+OR+chromatography+OR+%22mass+spectrometry%22%29%29+AND+%28%222025%2F09%2F09%22%5BDate+-+Publication%5D+%3A+%222026%2F09%2F09%22%5BDate+-+Publication%5D%29</a:t>
             </a:r>
           </a:p>
           <a:p xmlns:a="http://schemas.openxmlformats.org/drawingml/2006/main">
@@ -1104,7 +1104,7 @@
           </a:p>
           <a:p xmlns:a="http://schemas.openxmlformats.org/drawingml/2006/main">
             <a:r>
-              <a:t>- https://pubmed.ncbi.nlm.nih.gov/?term=%28%28oligonucleotide+OR+%22nucleic+acid%22+OR+siRNA%29+AND+%28%22LC-MS%22+OR+chromatography+OR+%22mass+spectrometry%22%29%29+AND+%28%222025%2F09%2F08%22%5BDate+-+Publication%5D+%3A+%222026%2F09%2F08%22%5BDate+-+Publication%5D%29</a:t>
+              <a:t>- https://pubmed.ncbi.nlm.nih.gov/?term=%28%28oligonucleotide+OR+%22nucleic+acid%22+OR+siRNA%29+AND+%28%22LC-MS%22+OR+chromatography+OR+%22mass+spectrometry%22%29%29+AND+%28%222025%2F09%2F09%22%5BDate+-+Publication%5D+%3A+%222026%2F09%2F09%22%5BDate+-+Publication%5D%29</a:t>
             </a:r>
           </a:p>
           <a:p xmlns:a="http://schemas.openxmlformats.org/drawingml/2006/main">
@@ -1184,7 +1184,7 @@
           </a:p>
           <a:p xmlns:a="http://schemas.openxmlformats.org/drawingml/2006/main">
             <a:r>
-              <a:t>- https://pubmed.ncbi.nlm.nih.gov/?term=%28%28PFAS+OR+%22per-+and+polyfluoroalkyl%22%29+AND+%28%22LC-MS%22+OR+%22LC-MS%2FMS%22+OR+chromatography%29%29+AND+%28%222025%2F09%2F08%22%5BDate+-+Publication%5D+%3A+%222026%2F09%2F08%22%5BDate+-+Publication%5D%29</a:t>
+              <a:t>- https://pubmed.ncbi.nlm.nih.gov/?term=%28%28PFAS+OR+%22per-+and+polyfluoroalkyl%22%29+AND+%28%22LC-MS%22+OR+%22LC-MS%2FMS%22+OR+chromatography%29%29+AND+%28%222025%2F09%2F09%22%5BDate+-+Publication%5D+%3A+%222026%2F09%2F09%22%5BDate+-+Publication%5D%29</a:t>
             </a:r>
           </a:p>
           <a:p xmlns:a="http://schemas.openxmlformats.org/drawingml/2006/main">
@@ -1282,7 +1282,7 @@
   </p:cSld>
   <p:clrMap bg1="lt1" tx1="dk1" bg2="lt2" tx2="dk2" accent1="accent1" accent2="accent2" accent3="accent3" accent4="accent4" accent5="accent5" accent6="accent6" hlink="hlink" folHlink="folHlink"/>
   <p:sldLayoutIdLst>
-    <p:sldLayoutId xmlns:r="http://schemas.openxmlformats.org/officeDocument/2006/relationships" id="2147483649" r:id="R41653649745e43a5"/>
+    <p:sldLayoutId xmlns:r="http://schemas.openxmlformats.org/officeDocument/2006/relationships" id="2147483649" r:id="R3babc0b8e5844f74"/>
   </p:sldLayoutIdLst>
   <p:txStyles>
     <p:titleStyle>
@@ -1833,7 +1833,7 @@
           <p:cNvPr id="14" name="">
             <a:extLst xmlns:a="http://schemas.openxmlformats.org/drawingml/2006/main">
               <a:ext uri="{FF2B5EF4-FFF2-40B4-BE49-F238E27FC236}">
-                <a16:creationId xmlns:a16="http://schemas.microsoft.com/office/drawing/2014/main" id="{6E70AD7D-679A-4B2A-BD14-EBD3E10E2BDC}"/>
+                <a16:creationId xmlns:a16="http://schemas.microsoft.com/office/drawing/2014/main" id="{C62340F1-FC31-432C-AB16-5616B206F07E}"/>
               </a:ext>
             </a:extLst>
           </p:cNvPr>
@@ -1866,7 +1866,7 @@
           <p:cNvPr id="2" name="">
             <a:extLst xmlns:a="http://schemas.openxmlformats.org/drawingml/2006/main">
               <a:ext uri="{FF2B5EF4-FFF2-40B4-BE49-F238E27FC236}">
-                <a16:creationId xmlns:a16="http://schemas.microsoft.com/office/drawing/2014/main" id="{B8080F9F-A128-47F1-9939-3A5591E33E41}"/>
+                <a16:creationId xmlns:a16="http://schemas.microsoft.com/office/drawing/2014/main" id="{0DDDB182-977F-4221-A460-BE7CBD5C2E52}"/>
               </a:ext>
             </a:extLst>
           </p:cNvPr>
@@ -1924,7 +1924,7 @@
           <p:cNvPr id="3" name="">
             <a:extLst xmlns:a="http://schemas.openxmlformats.org/drawingml/2006/main">
               <a:ext uri="{FF2B5EF4-FFF2-40B4-BE49-F238E27FC236}">
-                <a16:creationId xmlns:a16="http://schemas.microsoft.com/office/drawing/2014/main" id="{99C84A39-7869-4658-9220-DF7C57160B9A}"/>
+                <a16:creationId xmlns:a16="http://schemas.microsoft.com/office/drawing/2014/main" id="{C18DAF57-CA7B-43E0-B17F-5012C2631A24}"/>
               </a:ext>
             </a:extLst>
           </p:cNvPr>
@@ -1982,7 +1982,7 @@
           <p:cNvPr id="4" name="">
             <a:extLst xmlns:a="http://schemas.openxmlformats.org/drawingml/2006/main">
               <a:ext uri="{FF2B5EF4-FFF2-40B4-BE49-F238E27FC236}">
-                <a16:creationId xmlns:a16="http://schemas.microsoft.com/office/drawing/2014/main" id="{537E89F2-B447-4D63-8F30-1CB6162EDB34}"/>
+                <a16:creationId xmlns:a16="http://schemas.microsoft.com/office/drawing/2014/main" id="{8646CBA2-B02F-4382-BBB5-BBB0F708FCC0}"/>
               </a:ext>
             </a:extLst>
           </p:cNvPr>
@@ -2040,7 +2040,7 @@
           <p:cNvPr id="5" name="">
             <a:extLst xmlns:a="http://schemas.openxmlformats.org/drawingml/2006/main">
               <a:ext uri="{FF2B5EF4-FFF2-40B4-BE49-F238E27FC236}">
-                <a16:creationId xmlns:a16="http://schemas.microsoft.com/office/drawing/2014/main" id="{49AFCA01-254A-4F0C-A5A8-86E0B7A72F1A}"/>
+                <a16:creationId xmlns:a16="http://schemas.microsoft.com/office/drawing/2014/main" id="{31BEF88F-5921-44F2-BE09-4B13E5D30BA7}"/>
               </a:ext>
             </a:extLst>
           </p:cNvPr>
@@ -2098,7 +2098,7 @@
           <p:cNvPr id="6" name="">
             <a:extLst xmlns:a="http://schemas.openxmlformats.org/drawingml/2006/main">
               <a:ext uri="{FF2B5EF4-FFF2-40B4-BE49-F238E27FC236}">
-                <a16:creationId xmlns:a16="http://schemas.microsoft.com/office/drawing/2014/main" id="{B982A1A1-A3C6-45D6-8698-E8DE306071F3}"/>
+                <a16:creationId xmlns:a16="http://schemas.microsoft.com/office/drawing/2014/main" id="{A369DA15-54A5-4AAC-A056-8E130C6252EF}"/>
               </a:ext>
             </a:extLst>
           </p:cNvPr>
@@ -2133,7 +2133,7 @@
           <p:cNvPr id="7" name="">
             <a:extLst xmlns:a="http://schemas.openxmlformats.org/drawingml/2006/main">
               <a:ext uri="{FF2B5EF4-FFF2-40B4-BE49-F238E27FC236}">
-                <a16:creationId xmlns:a16="http://schemas.microsoft.com/office/drawing/2014/main" id="{30E5C8FF-3D48-437A-AE70-CA6C61882D7F}"/>
+                <a16:creationId xmlns:a16="http://schemas.microsoft.com/office/drawing/2014/main" id="{BC2AC289-40A3-48C6-833C-2E00F94744FA}"/>
               </a:ext>
             </a:extLst>
           </p:cNvPr>
@@ -2191,7 +2191,7 @@
           <p:cNvPr id="8" name="">
             <a:extLst xmlns:a="http://schemas.openxmlformats.org/drawingml/2006/main">
               <a:ext uri="{FF2B5EF4-FFF2-40B4-BE49-F238E27FC236}">
-                <a16:creationId xmlns:a16="http://schemas.microsoft.com/office/drawing/2014/main" id="{E333436E-1613-4B36-B1CE-6454CE96BD6B}"/>
+                <a16:creationId xmlns:a16="http://schemas.microsoft.com/office/drawing/2014/main" id="{9F6AB1FE-0A61-44E2-9B07-4A7BEF50E984}"/>
               </a:ext>
             </a:extLst>
           </p:cNvPr>
@@ -2239,7 +2239,7 @@
                 <a:ea typeface="Aptos"/>
                 <a:cs typeface="Aptos"/>
               </a:rPr>
-              <a:t>08</a:t>
+              <a:t>09</a:t>
             </a:r>
           </a:p>
         </p:txBody>
@@ -2249,7 +2249,7 @@
           <p:cNvPr id="9" name="">
             <a:extLst xmlns:a="http://schemas.openxmlformats.org/drawingml/2006/main">
               <a:ext uri="{FF2B5EF4-FFF2-40B4-BE49-F238E27FC236}">
-                <a16:creationId xmlns:a16="http://schemas.microsoft.com/office/drawing/2014/main" id="{A21C5B79-DA65-4B09-9A6B-A095D1653FC6}"/>
+                <a16:creationId xmlns:a16="http://schemas.microsoft.com/office/drawing/2014/main" id="{043354ED-E682-490B-B288-AE0792D9DBD5}"/>
               </a:ext>
             </a:extLst>
           </p:cNvPr>
@@ -2307,7 +2307,7 @@
           <p:cNvPr id="10" name="">
             <a:extLst xmlns:a="http://schemas.openxmlformats.org/drawingml/2006/main">
               <a:ext uri="{FF2B5EF4-FFF2-40B4-BE49-F238E27FC236}">
-                <a16:creationId xmlns:a16="http://schemas.microsoft.com/office/drawing/2014/main" id="{747CF960-8082-4ADA-B4A5-CCC337420D85}"/>
+                <a16:creationId xmlns:a16="http://schemas.microsoft.com/office/drawing/2014/main" id="{0F357B13-2D0F-4C03-9B97-61E80E2A4BC5}"/>
               </a:ext>
             </a:extLst>
           </p:cNvPr>
@@ -2340,7 +2340,7 @@
           <p:cNvPr id="11" name="">
             <a:extLst xmlns:a="http://schemas.openxmlformats.org/drawingml/2006/main">
               <a:ext uri="{FF2B5EF4-FFF2-40B4-BE49-F238E27FC236}">
-                <a16:creationId xmlns:a16="http://schemas.microsoft.com/office/drawing/2014/main" id="{114E57F4-754B-44C9-8071-38A3AB76BBC8}"/>
+                <a16:creationId xmlns:a16="http://schemas.microsoft.com/office/drawing/2014/main" id="{BE163B6B-3EC0-4BF9-AFCB-C2C2F053224B}"/>
               </a:ext>
             </a:extLst>
           </p:cNvPr>
@@ -2398,7 +2398,7 @@
           <p:cNvPr id="12" name="">
             <a:extLst xmlns:a="http://schemas.openxmlformats.org/drawingml/2006/main">
               <a:ext uri="{FF2B5EF4-FFF2-40B4-BE49-F238E27FC236}">
-                <a16:creationId xmlns:a16="http://schemas.microsoft.com/office/drawing/2014/main" id="{4784AB74-515C-4434-B7CF-8B21573746C4}"/>
+                <a16:creationId xmlns:a16="http://schemas.microsoft.com/office/drawing/2014/main" id="{E8BDC085-31E1-4B43-B0B8-AEADD383D4FB}"/>
               </a:ext>
             </a:extLst>
           </p:cNvPr>
@@ -2446,7 +2446,7 @@
                 <a:ea typeface="Aptos"/>
                 <a:cs typeface="Aptos"/>
               </a:rPr>
-              <a:t>Prepared for roadmap review · waters-ci-20260909033329</a:t>
+              <a:t>Prepared for roadmap review · waters-ci-20260909112945</a:t>
             </a:r>
           </a:p>
         </p:txBody>
@@ -2456,7 +2456,7 @@
           <p:cNvPr id="13" name="">
             <a:extLst xmlns:a="http://schemas.openxmlformats.org/drawingml/2006/main">
               <a:ext uri="{FF2B5EF4-FFF2-40B4-BE49-F238E27FC236}">
-                <a16:creationId xmlns:a16="http://schemas.microsoft.com/office/drawing/2014/main" id="{E58E29F6-005B-4DDB-8B3F-E4AD2AF2E493}"/>
+                <a16:creationId xmlns:a16="http://schemas.microsoft.com/office/drawing/2014/main" id="{1B14847F-FCA7-408D-8567-A2ACCCCCACC7}"/>
               </a:ext>
             </a:extLst>
           </p:cNvPr>
@@ -2512,7 +2512,7 @@
     </p:spTree>
     <p:extLst>
       <p:ext uri="{BB962C8B-B14F-4D97-AF65-F5344CB8AC3E}">
-        <p14:creationId xmlns:p14="http://schemas.microsoft.com/office/powerpoint/2010/main" val="258356643"/>
+        <p14:creationId xmlns:p14="http://schemas.microsoft.com/office/powerpoint/2010/main" val="1552316189"/>
       </p:ext>
     </p:extLst>
   </p:cSld>
@@ -2543,7 +2543,7 @@
           <p:cNvPr id="25" name="">
             <a:extLst xmlns:a="http://schemas.openxmlformats.org/drawingml/2006/main">
               <a:ext uri="{FF2B5EF4-FFF2-40B4-BE49-F238E27FC236}">
-                <a16:creationId xmlns:a16="http://schemas.microsoft.com/office/drawing/2014/main" id="{E7A0F1EE-7FF6-4287-B414-EDA279C419C9}"/>
+                <a16:creationId xmlns:a16="http://schemas.microsoft.com/office/drawing/2014/main" id="{FD89D103-D39D-40A2-87C0-FCA11F6461D1}"/>
               </a:ext>
             </a:extLst>
           </p:cNvPr>
@@ -2601,7 +2601,7 @@
           <p:cNvPr id="2" name="">
             <a:extLst xmlns:a="http://schemas.openxmlformats.org/drawingml/2006/main">
               <a:ext uri="{FF2B5EF4-FFF2-40B4-BE49-F238E27FC236}">
-                <a16:creationId xmlns:a16="http://schemas.microsoft.com/office/drawing/2014/main" id="{AD9493A7-AFF2-4B0D-BCEF-E09B427B1628}"/>
+                <a16:creationId xmlns:a16="http://schemas.microsoft.com/office/drawing/2014/main" id="{4130E08A-1EB7-4588-A382-8CE73391E471}"/>
               </a:ext>
             </a:extLst>
           </p:cNvPr>
@@ -2659,7 +2659,7 @@
           <p:cNvPr id="3" name="">
             <a:extLst xmlns:a="http://schemas.openxmlformats.org/drawingml/2006/main">
               <a:ext uri="{FF2B5EF4-FFF2-40B4-BE49-F238E27FC236}">
-                <a16:creationId xmlns:a16="http://schemas.microsoft.com/office/drawing/2014/main" id="{DF1F0119-3448-4DA7-888D-819805440C46}"/>
+                <a16:creationId xmlns:a16="http://schemas.microsoft.com/office/drawing/2014/main" id="{3E3B26C0-2CC1-4731-A64A-BA84D985CF9F}"/>
               </a:ext>
             </a:extLst>
           </p:cNvPr>
@@ -2717,7 +2717,7 @@
           <p:cNvPr id="4" name="">
             <a:extLst xmlns:a="http://schemas.openxmlformats.org/drawingml/2006/main">
               <a:ext uri="{FF2B5EF4-FFF2-40B4-BE49-F238E27FC236}">
-                <a16:creationId xmlns:a16="http://schemas.microsoft.com/office/drawing/2014/main" id="{ADB5C068-F7B9-4041-B1BB-34585CEB747B}"/>
+                <a16:creationId xmlns:a16="http://schemas.microsoft.com/office/drawing/2014/main" id="{5A7CA80B-2475-4C1C-9FA6-3CC1317CD433}"/>
               </a:ext>
             </a:extLst>
           </p:cNvPr>
@@ -2750,7 +2750,7 @@
           <p:cNvPr id="5" name="">
             <a:extLst xmlns:a="http://schemas.openxmlformats.org/drawingml/2006/main">
               <a:ext uri="{FF2B5EF4-FFF2-40B4-BE49-F238E27FC236}">
-                <a16:creationId xmlns:a16="http://schemas.microsoft.com/office/drawing/2014/main" id="{0549E2C8-576B-4904-B6CA-FB29AD2465DE}"/>
+                <a16:creationId xmlns:a16="http://schemas.microsoft.com/office/drawing/2014/main" id="{51AB222A-7265-47BC-B217-E52EAB026C34}"/>
               </a:ext>
             </a:extLst>
           </p:cNvPr>
@@ -2785,7 +2785,7 @@
           <p:cNvPr id="6" name="">
             <a:extLst xmlns:a="http://schemas.openxmlformats.org/drawingml/2006/main">
               <a:ext uri="{FF2B5EF4-FFF2-40B4-BE49-F238E27FC236}">
-                <a16:creationId xmlns:a16="http://schemas.microsoft.com/office/drawing/2014/main" id="{E9B7E26B-EFAC-4B5B-846B-5C1768F2A990}"/>
+                <a16:creationId xmlns:a16="http://schemas.microsoft.com/office/drawing/2014/main" id="{E9508E6B-5953-4A4B-A0DF-B30DC6653CD7}"/>
               </a:ext>
             </a:extLst>
           </p:cNvPr>
@@ -2843,7 +2843,7 @@
           <p:cNvPr id="7" name="">
             <a:extLst xmlns:a="http://schemas.openxmlformats.org/drawingml/2006/main">
               <a:ext uri="{FF2B5EF4-FFF2-40B4-BE49-F238E27FC236}">
-                <a16:creationId xmlns:a16="http://schemas.microsoft.com/office/drawing/2014/main" id="{1B14667A-F0FE-4E83-AF54-296F4430D4E0}"/>
+                <a16:creationId xmlns:a16="http://schemas.microsoft.com/office/drawing/2014/main" id="{8925766A-6F4D-424C-93AF-4B9C919E3E37}"/>
               </a:ext>
             </a:extLst>
           </p:cNvPr>
@@ -2901,7 +2901,7 @@
           <p:cNvPr id="8" name="">
             <a:extLst xmlns:a="http://schemas.openxmlformats.org/drawingml/2006/main">
               <a:ext uri="{FF2B5EF4-FFF2-40B4-BE49-F238E27FC236}">
-                <a16:creationId xmlns:a16="http://schemas.microsoft.com/office/drawing/2014/main" id="{F4337989-85F4-4896-A248-DA90DE5F08BE}"/>
+                <a16:creationId xmlns:a16="http://schemas.microsoft.com/office/drawing/2014/main" id="{19CAA47B-F9C3-4507-AD66-1BFD6C43E6CC}"/>
               </a:ext>
             </a:extLst>
           </p:cNvPr>
@@ -2936,7 +2936,7 @@
           <p:cNvPr id="9" name="">
             <a:extLst xmlns:a="http://schemas.openxmlformats.org/drawingml/2006/main">
               <a:ext uri="{FF2B5EF4-FFF2-40B4-BE49-F238E27FC236}">
-                <a16:creationId xmlns:a16="http://schemas.microsoft.com/office/drawing/2014/main" id="{A7585685-78D9-4DC5-926E-B7A268E7A395}"/>
+                <a16:creationId xmlns:a16="http://schemas.microsoft.com/office/drawing/2014/main" id="{E66542DE-1A56-4EE1-B14B-3411F7B8067B}"/>
               </a:ext>
             </a:extLst>
           </p:cNvPr>
@@ -2969,7 +2969,7 @@
           <p:cNvPr id="10" name="">
             <a:extLst xmlns:a="http://schemas.openxmlformats.org/drawingml/2006/main">
               <a:ext uri="{FF2B5EF4-FFF2-40B4-BE49-F238E27FC236}">
-                <a16:creationId xmlns:a16="http://schemas.microsoft.com/office/drawing/2014/main" id="{8A2B9E18-CCC1-441D-9B4D-E53656A8862D}"/>
+                <a16:creationId xmlns:a16="http://schemas.microsoft.com/office/drawing/2014/main" id="{A850D6F2-A913-4408-B4DC-88F6653CCCE4}"/>
               </a:ext>
             </a:extLst>
           </p:cNvPr>
@@ -3017,7 +3017,7 @@
                 <a:ea typeface="Aptos"/>
                 <a:cs typeface="Aptos"/>
               </a:rPr>
-              <a:t>1,166</a:t>
+              <a:t>1,167</a:t>
             </a:r>
           </a:p>
         </p:txBody>
@@ -3027,7 +3027,7 @@
           <p:cNvPr id="11" name="">
             <a:extLst xmlns:a="http://schemas.openxmlformats.org/drawingml/2006/main">
               <a:ext uri="{FF2B5EF4-FFF2-40B4-BE49-F238E27FC236}">
-                <a16:creationId xmlns:a16="http://schemas.microsoft.com/office/drawing/2014/main" id="{5C106D7B-98EC-47B0-8FC1-A716C4247B3D}"/>
+                <a16:creationId xmlns:a16="http://schemas.microsoft.com/office/drawing/2014/main" id="{86EB5470-4B90-4607-8324-6A5B002B10A5}"/>
               </a:ext>
             </a:extLst>
           </p:cNvPr>
@@ -3085,7 +3085,7 @@
           <p:cNvPr id="12" name="">
             <a:extLst xmlns:a="http://schemas.openxmlformats.org/drawingml/2006/main">
               <a:ext uri="{FF2B5EF4-FFF2-40B4-BE49-F238E27FC236}">
-                <a16:creationId xmlns:a16="http://schemas.microsoft.com/office/drawing/2014/main" id="{599D01C2-E250-465D-B9A4-ACC352BEF5A9}"/>
+                <a16:creationId xmlns:a16="http://schemas.microsoft.com/office/drawing/2014/main" id="{8F8DAFC0-F5F3-4DD7-85E2-3037EE7FF10F}"/>
               </a:ext>
             </a:extLst>
           </p:cNvPr>
@@ -3143,7 +3143,7 @@
           <p:cNvPr id="13" name="">
             <a:extLst xmlns:a="http://schemas.openxmlformats.org/drawingml/2006/main">
               <a:ext uri="{FF2B5EF4-FFF2-40B4-BE49-F238E27FC236}">
-                <a16:creationId xmlns:a16="http://schemas.microsoft.com/office/drawing/2014/main" id="{80B7A1F2-33E0-4334-816B-7D152D62A748}"/>
+                <a16:creationId xmlns:a16="http://schemas.microsoft.com/office/drawing/2014/main" id="{07109A02-B40E-42B3-B939-31FBD9A2CEE2}"/>
               </a:ext>
             </a:extLst>
           </p:cNvPr>
@@ -3178,7 +3178,7 @@
           <p:cNvPr id="14" name="">
             <a:extLst xmlns:a="http://schemas.openxmlformats.org/drawingml/2006/main">
               <a:ext uri="{FF2B5EF4-FFF2-40B4-BE49-F238E27FC236}">
-                <a16:creationId xmlns:a16="http://schemas.microsoft.com/office/drawing/2014/main" id="{FEE8A953-7F4F-4C9F-9FD4-D0158D89150B}"/>
+                <a16:creationId xmlns:a16="http://schemas.microsoft.com/office/drawing/2014/main" id="{E0AB0905-952A-4D16-B3A5-E1671F903391}"/>
               </a:ext>
             </a:extLst>
           </p:cNvPr>
@@ -3211,7 +3211,7 @@
           <p:cNvPr id="15" name="">
             <a:extLst xmlns:a="http://schemas.openxmlformats.org/drawingml/2006/main">
               <a:ext uri="{FF2B5EF4-FFF2-40B4-BE49-F238E27FC236}">
-                <a16:creationId xmlns:a16="http://schemas.microsoft.com/office/drawing/2014/main" id="{9489E2C8-A92F-4BD7-81D2-0ABC55BD91AF}"/>
+                <a16:creationId xmlns:a16="http://schemas.microsoft.com/office/drawing/2014/main" id="{277087F6-0A2D-4B3E-89CC-D4D29A459611}"/>
               </a:ext>
             </a:extLst>
           </p:cNvPr>
@@ -3269,7 +3269,7 @@
           <p:cNvPr id="16" name="">
             <a:extLst xmlns:a="http://schemas.openxmlformats.org/drawingml/2006/main">
               <a:ext uri="{FF2B5EF4-FFF2-40B4-BE49-F238E27FC236}">
-                <a16:creationId xmlns:a16="http://schemas.microsoft.com/office/drawing/2014/main" id="{96F92583-EAB6-484C-AC3B-26DC0F62E5F0}"/>
+                <a16:creationId xmlns:a16="http://schemas.microsoft.com/office/drawing/2014/main" id="{32DEE198-A681-47E6-BDC7-E39BD2D2ED30}"/>
               </a:ext>
             </a:extLst>
           </p:cNvPr>
@@ -3327,7 +3327,7 @@
           <p:cNvPr id="17" name="">
             <a:extLst xmlns:a="http://schemas.openxmlformats.org/drawingml/2006/main">
               <a:ext uri="{FF2B5EF4-FFF2-40B4-BE49-F238E27FC236}">
-                <a16:creationId xmlns:a16="http://schemas.microsoft.com/office/drawing/2014/main" id="{77C0FD2A-C462-442E-9940-18FC818E6B5A}"/>
+                <a16:creationId xmlns:a16="http://schemas.microsoft.com/office/drawing/2014/main" id="{55F85E3F-CB6A-4D91-963A-FD74756CBC84}"/>
               </a:ext>
             </a:extLst>
           </p:cNvPr>
@@ -3385,7 +3385,7 @@
           <p:cNvPr id="18" name="">
             <a:extLst xmlns:a="http://schemas.openxmlformats.org/drawingml/2006/main">
               <a:ext uri="{FF2B5EF4-FFF2-40B4-BE49-F238E27FC236}">
-                <a16:creationId xmlns:a16="http://schemas.microsoft.com/office/drawing/2014/main" id="{5A918AA5-CD5F-49AE-91C7-D1BCD04E4EAF}"/>
+                <a16:creationId xmlns:a16="http://schemas.microsoft.com/office/drawing/2014/main" id="{3C2389B3-2961-4BBE-97B0-2F2B607D6D44}"/>
               </a:ext>
             </a:extLst>
           </p:cNvPr>
@@ -3420,7 +3420,7 @@
           <p:cNvPr id="19" name="">
             <a:extLst xmlns:a="http://schemas.openxmlformats.org/drawingml/2006/main">
               <a:ext uri="{FF2B5EF4-FFF2-40B4-BE49-F238E27FC236}">
-                <a16:creationId xmlns:a16="http://schemas.microsoft.com/office/drawing/2014/main" id="{C0730A31-AB83-4CD1-9ECF-056DB2C90084}"/>
+                <a16:creationId xmlns:a16="http://schemas.microsoft.com/office/drawing/2014/main" id="{78B2089D-0555-4772-B7B8-EE0A1AD9DA05}"/>
               </a:ext>
             </a:extLst>
           </p:cNvPr>
@@ -3453,7 +3453,7 @@
           <p:cNvPr id="20" name="">
             <a:extLst xmlns:a="http://schemas.openxmlformats.org/drawingml/2006/main">
               <a:ext uri="{FF2B5EF4-FFF2-40B4-BE49-F238E27FC236}">
-                <a16:creationId xmlns:a16="http://schemas.microsoft.com/office/drawing/2014/main" id="{0E3AA352-93E2-433A-B6EC-6918DDC104CE}"/>
+                <a16:creationId xmlns:a16="http://schemas.microsoft.com/office/drawing/2014/main" id="{F6E1C802-FFB5-48D0-9F2E-F2519C64FC1E}"/>
               </a:ext>
             </a:extLst>
           </p:cNvPr>
@@ -3511,7 +3511,7 @@
           <p:cNvPr id="21" name="">
             <a:extLst xmlns:a="http://schemas.openxmlformats.org/drawingml/2006/main">
               <a:ext uri="{FF2B5EF4-FFF2-40B4-BE49-F238E27FC236}">
-                <a16:creationId xmlns:a16="http://schemas.microsoft.com/office/drawing/2014/main" id="{CC424962-F0FD-4159-9BE7-E375E65D6BB4}"/>
+                <a16:creationId xmlns:a16="http://schemas.microsoft.com/office/drawing/2014/main" id="{71FEC57E-37D7-4FF4-8841-8F6A3C855CBC}"/>
               </a:ext>
             </a:extLst>
           </p:cNvPr>
@@ -3569,7 +3569,7 @@
           <p:cNvPr id="22" name="">
             <a:extLst xmlns:a="http://schemas.openxmlformats.org/drawingml/2006/main">
               <a:ext uri="{FF2B5EF4-FFF2-40B4-BE49-F238E27FC236}">
-                <a16:creationId xmlns:a16="http://schemas.microsoft.com/office/drawing/2014/main" id="{FE3C8808-D8D9-4A90-9BD9-D47D7D6CC502}"/>
+                <a16:creationId xmlns:a16="http://schemas.microsoft.com/office/drawing/2014/main" id="{96FBB7E2-6B8D-4C21-BA7C-6D1D6B805C87}"/>
               </a:ext>
             </a:extLst>
           </p:cNvPr>
@@ -3627,7 +3627,7 @@
           <p:cNvPr id="23" name="">
             <a:extLst xmlns:a="http://schemas.openxmlformats.org/drawingml/2006/main">
               <a:ext uri="{FF2B5EF4-FFF2-40B4-BE49-F238E27FC236}">
-                <a16:creationId xmlns:a16="http://schemas.microsoft.com/office/drawing/2014/main" id="{E7F026A0-2BFE-4EF0-B301-F8AD173C8386}"/>
+                <a16:creationId xmlns:a16="http://schemas.microsoft.com/office/drawing/2014/main" id="{16BB9E55-56E1-435A-B919-65C71E79DFD8}"/>
               </a:ext>
             </a:extLst>
           </p:cNvPr>
@@ -3675,7 +3675,7 @@
                 <a:ea typeface="Aptos"/>
                 <a:cs typeface="Aptos"/>
               </a:rPr>
-              <a:t>WATERS NEXT GEN COMPETITIVE INTELLIGENCE · 08 SEP 2026 · waters-ci-20260909033329</a:t>
+              <a:t>WATERS NEXT GEN COMPETITIVE INTELLIGENCE · 09 SEP 2026 · waters-ci-20260909112945</a:t>
             </a:r>
           </a:p>
         </p:txBody>
@@ -3685,7 +3685,7 @@
           <p:cNvPr id="24" name="">
             <a:extLst xmlns:a="http://schemas.openxmlformats.org/drawingml/2006/main">
               <a:ext uri="{FF2B5EF4-FFF2-40B4-BE49-F238E27FC236}">
-                <a16:creationId xmlns:a16="http://schemas.microsoft.com/office/drawing/2014/main" id="{6BE9A191-746C-4717-ACF6-6D6C4A169AF7}"/>
+                <a16:creationId xmlns:a16="http://schemas.microsoft.com/office/drawing/2014/main" id="{4DF03679-FB0B-4B25-900A-941ADEFFC978}"/>
               </a:ext>
             </a:extLst>
           </p:cNvPr>
@@ -3741,7 +3741,7 @@
     </p:spTree>
     <p:extLst>
       <p:ext uri="{BB962C8B-B14F-4D97-AF65-F5344CB8AC3E}">
-        <p14:creationId xmlns:p14="http://schemas.microsoft.com/office/powerpoint/2010/main" val="171937496"/>
+        <p14:creationId xmlns:p14="http://schemas.microsoft.com/office/powerpoint/2010/main" val="340963108"/>
       </p:ext>
     </p:extLst>
   </p:cSld>
@@ -3772,7 +3772,7 @@
           <p:cNvPr id="37" name="">
             <a:extLst xmlns:a="http://schemas.openxmlformats.org/drawingml/2006/main">
               <a:ext uri="{FF2B5EF4-FFF2-40B4-BE49-F238E27FC236}">
-                <a16:creationId xmlns:a16="http://schemas.microsoft.com/office/drawing/2014/main" id="{9D69CCB1-2394-4F71-9D2F-D5B5426DC969}"/>
+                <a16:creationId xmlns:a16="http://schemas.microsoft.com/office/drawing/2014/main" id="{003F29AE-875D-485F-A86C-301CF2F5803D}"/>
               </a:ext>
             </a:extLst>
           </p:cNvPr>
@@ -3830,7 +3830,7 @@
           <p:cNvPr id="2" name="">
             <a:extLst xmlns:a="http://schemas.openxmlformats.org/drawingml/2006/main">
               <a:ext uri="{FF2B5EF4-FFF2-40B4-BE49-F238E27FC236}">
-                <a16:creationId xmlns:a16="http://schemas.microsoft.com/office/drawing/2014/main" id="{935E4A8B-FCAC-4733-8551-21F9DF4C03AA}"/>
+                <a16:creationId xmlns:a16="http://schemas.microsoft.com/office/drawing/2014/main" id="{6108350E-AB09-4E30-A435-0520DF6448E1}"/>
               </a:ext>
             </a:extLst>
           </p:cNvPr>
@@ -3888,7 +3888,7 @@
           <p:cNvPr id="3" name="">
             <a:extLst xmlns:a="http://schemas.openxmlformats.org/drawingml/2006/main">
               <a:ext uri="{FF2B5EF4-FFF2-40B4-BE49-F238E27FC236}">
-                <a16:creationId xmlns:a16="http://schemas.microsoft.com/office/drawing/2014/main" id="{3C511CCF-7DD0-4484-B1A2-251A7248E241}"/>
+                <a16:creationId xmlns:a16="http://schemas.microsoft.com/office/drawing/2014/main" id="{B0EBB4C3-DFD3-4F2A-A14C-0ABB9B658DD8}"/>
               </a:ext>
             </a:extLst>
           </p:cNvPr>
@@ -3946,7 +3946,7 @@
           <p:cNvPr id="4" name="">
             <a:extLst xmlns:a="http://schemas.openxmlformats.org/drawingml/2006/main">
               <a:ext uri="{FF2B5EF4-FFF2-40B4-BE49-F238E27FC236}">
-                <a16:creationId xmlns:a16="http://schemas.microsoft.com/office/drawing/2014/main" id="{414BCBB4-A836-4021-8D0D-764243421EA1}"/>
+                <a16:creationId xmlns:a16="http://schemas.microsoft.com/office/drawing/2014/main" id="{306C095C-9616-4863-8D77-0A334611E669}"/>
               </a:ext>
             </a:extLst>
           </p:cNvPr>
@@ -3979,7 +3979,7 @@
           <p:cNvPr id="5" name="">
             <a:extLst xmlns:a="http://schemas.openxmlformats.org/drawingml/2006/main">
               <a:ext uri="{FF2B5EF4-FFF2-40B4-BE49-F238E27FC236}">
-                <a16:creationId xmlns:a16="http://schemas.microsoft.com/office/drawing/2014/main" id="{67B6E5FA-19EF-4A30-B3AC-873D0BC9304F}"/>
+                <a16:creationId xmlns:a16="http://schemas.microsoft.com/office/drawing/2014/main" id="{EB6BF80A-CB43-46F7-9CA2-2FD1E7226B26}"/>
               </a:ext>
             </a:extLst>
           </p:cNvPr>
@@ -4014,7 +4014,7 @@
           <p:cNvPr id="6" name="">
             <a:extLst xmlns:a="http://schemas.openxmlformats.org/drawingml/2006/main">
               <a:ext uri="{FF2B5EF4-FFF2-40B4-BE49-F238E27FC236}">
-                <a16:creationId xmlns:a16="http://schemas.microsoft.com/office/drawing/2014/main" id="{21030392-8EE1-4814-8615-95A0812F8C66}"/>
+                <a16:creationId xmlns:a16="http://schemas.microsoft.com/office/drawing/2014/main" id="{2E496052-54A1-40BC-8796-0A890565E8B7}"/>
               </a:ext>
             </a:extLst>
           </p:cNvPr>
@@ -4049,7 +4049,7 @@
           <p:cNvPr id="7" name="">
             <a:extLst xmlns:a="http://schemas.openxmlformats.org/drawingml/2006/main">
               <a:ext uri="{FF2B5EF4-FFF2-40B4-BE49-F238E27FC236}">
-                <a16:creationId xmlns:a16="http://schemas.microsoft.com/office/drawing/2014/main" id="{1B8721D9-8E5B-49EB-A3DA-15956B8949A8}"/>
+                <a16:creationId xmlns:a16="http://schemas.microsoft.com/office/drawing/2014/main" id="{220001D8-AE90-4675-81A5-6ACE132EBB75}"/>
               </a:ext>
             </a:extLst>
           </p:cNvPr>
@@ -4107,7 +4107,7 @@
           <p:cNvPr id="8" name="">
             <a:extLst xmlns:a="http://schemas.openxmlformats.org/drawingml/2006/main">
               <a:ext uri="{FF2B5EF4-FFF2-40B4-BE49-F238E27FC236}">
-                <a16:creationId xmlns:a16="http://schemas.microsoft.com/office/drawing/2014/main" id="{A9971885-18EC-4EAB-8A21-17B08976910D}"/>
+                <a16:creationId xmlns:a16="http://schemas.microsoft.com/office/drawing/2014/main" id="{93147591-DC18-4C2F-9E14-894401B35E23}"/>
               </a:ext>
             </a:extLst>
           </p:cNvPr>
@@ -4165,7 +4165,7 @@
           <p:cNvPr id="9" name="">
             <a:extLst xmlns:a="http://schemas.openxmlformats.org/drawingml/2006/main">
               <a:ext uri="{FF2B5EF4-FFF2-40B4-BE49-F238E27FC236}">
-                <a16:creationId xmlns:a16="http://schemas.microsoft.com/office/drawing/2014/main" id="{C4953A38-8BCC-4FE0-90B9-F9757A2E88BC}"/>
+                <a16:creationId xmlns:a16="http://schemas.microsoft.com/office/drawing/2014/main" id="{BE136975-7B54-4CA4-BD91-67CA6F7E593F}"/>
               </a:ext>
             </a:extLst>
           </p:cNvPr>
@@ -4223,7 +4223,7 @@
           <p:cNvPr id="10" name="">
             <a:extLst xmlns:a="http://schemas.openxmlformats.org/drawingml/2006/main">
               <a:ext uri="{FF2B5EF4-FFF2-40B4-BE49-F238E27FC236}">
-                <a16:creationId xmlns:a16="http://schemas.microsoft.com/office/drawing/2014/main" id="{EEC4E999-C4EE-47C8-8E3A-385E8B25E9AA}"/>
+                <a16:creationId xmlns:a16="http://schemas.microsoft.com/office/drawing/2014/main" id="{F960E3F8-223F-4258-935F-265DA733AAF7}"/>
               </a:ext>
             </a:extLst>
           </p:cNvPr>
@@ -4281,7 +4281,7 @@
           <p:cNvPr id="11" name="">
             <a:extLst xmlns:a="http://schemas.openxmlformats.org/drawingml/2006/main">
               <a:ext uri="{FF2B5EF4-FFF2-40B4-BE49-F238E27FC236}">
-                <a16:creationId xmlns:a16="http://schemas.microsoft.com/office/drawing/2014/main" id="{E3BE882A-88DC-4344-AEDF-1B141FE7C699}"/>
+                <a16:creationId xmlns:a16="http://schemas.microsoft.com/office/drawing/2014/main" id="{208460AB-B902-429F-A554-F69348667AA0}"/>
               </a:ext>
             </a:extLst>
           </p:cNvPr>
@@ -4316,7 +4316,7 @@
           <p:cNvPr id="12" name="">
             <a:extLst xmlns:a="http://schemas.openxmlformats.org/drawingml/2006/main">
               <a:ext uri="{FF2B5EF4-FFF2-40B4-BE49-F238E27FC236}">
-                <a16:creationId xmlns:a16="http://schemas.microsoft.com/office/drawing/2014/main" id="{8E4F8789-55DA-4724-B924-235FD6B24098}"/>
+                <a16:creationId xmlns:a16="http://schemas.microsoft.com/office/drawing/2014/main" id="{E6B43D1A-0F11-48EB-949D-634534E1113E}"/>
               </a:ext>
             </a:extLst>
           </p:cNvPr>
@@ -4351,7 +4351,7 @@
           <p:cNvPr id="13" name="">
             <a:extLst xmlns:a="http://schemas.openxmlformats.org/drawingml/2006/main">
               <a:ext uri="{FF2B5EF4-FFF2-40B4-BE49-F238E27FC236}">
-                <a16:creationId xmlns:a16="http://schemas.microsoft.com/office/drawing/2014/main" id="{4D677E31-07BA-44B6-96AF-6802190688E7}"/>
+                <a16:creationId xmlns:a16="http://schemas.microsoft.com/office/drawing/2014/main" id="{4EAC3DC5-8B08-4D8A-9E2F-1E9C0CD898FF}"/>
               </a:ext>
             </a:extLst>
           </p:cNvPr>
@@ -4409,7 +4409,7 @@
           <p:cNvPr id="14" name="">
             <a:extLst xmlns:a="http://schemas.openxmlformats.org/drawingml/2006/main">
               <a:ext uri="{FF2B5EF4-FFF2-40B4-BE49-F238E27FC236}">
-                <a16:creationId xmlns:a16="http://schemas.microsoft.com/office/drawing/2014/main" id="{19B07A82-A481-4EEA-A5DC-A1889B2210C4}"/>
+                <a16:creationId xmlns:a16="http://schemas.microsoft.com/office/drawing/2014/main" id="{16EEA57A-9A17-4692-8CF7-E2B3E1861128}"/>
               </a:ext>
             </a:extLst>
           </p:cNvPr>
@@ -4467,7 +4467,7 @@
           <p:cNvPr id="15" name="">
             <a:extLst xmlns:a="http://schemas.openxmlformats.org/drawingml/2006/main">
               <a:ext uri="{FF2B5EF4-FFF2-40B4-BE49-F238E27FC236}">
-                <a16:creationId xmlns:a16="http://schemas.microsoft.com/office/drawing/2014/main" id="{4DB39DFA-4D2C-483D-AC86-FEC7AF095A05}"/>
+                <a16:creationId xmlns:a16="http://schemas.microsoft.com/office/drawing/2014/main" id="{CDDE43FF-2E4C-4BDF-B975-253459051529}"/>
               </a:ext>
             </a:extLst>
           </p:cNvPr>
@@ -4525,7 +4525,7 @@
           <p:cNvPr id="16" name="">
             <a:extLst xmlns:a="http://schemas.openxmlformats.org/drawingml/2006/main">
               <a:ext uri="{FF2B5EF4-FFF2-40B4-BE49-F238E27FC236}">
-                <a16:creationId xmlns:a16="http://schemas.microsoft.com/office/drawing/2014/main" id="{D418BB43-D6DC-4923-8E34-31AD34E60934}"/>
+                <a16:creationId xmlns:a16="http://schemas.microsoft.com/office/drawing/2014/main" id="{845CB96A-7A07-4935-8568-EEE8703FF340}"/>
               </a:ext>
             </a:extLst>
           </p:cNvPr>
@@ -4583,7 +4583,7 @@
           <p:cNvPr id="17" name="">
             <a:extLst xmlns:a="http://schemas.openxmlformats.org/drawingml/2006/main">
               <a:ext uri="{FF2B5EF4-FFF2-40B4-BE49-F238E27FC236}">
-                <a16:creationId xmlns:a16="http://schemas.microsoft.com/office/drawing/2014/main" id="{CCDE55E1-BE43-49A2-96DF-F36772C095D4}"/>
+                <a16:creationId xmlns:a16="http://schemas.microsoft.com/office/drawing/2014/main" id="{9D75738F-517A-49F8-B2B5-0D7AC127A6A0}"/>
               </a:ext>
             </a:extLst>
           </p:cNvPr>
@@ -4618,7 +4618,7 @@
           <p:cNvPr id="18" name="">
             <a:extLst xmlns:a="http://schemas.openxmlformats.org/drawingml/2006/main">
               <a:ext uri="{FF2B5EF4-FFF2-40B4-BE49-F238E27FC236}">
-                <a16:creationId xmlns:a16="http://schemas.microsoft.com/office/drawing/2014/main" id="{9C49BB8C-84A5-4DF4-86C0-B187B4DF2721}"/>
+                <a16:creationId xmlns:a16="http://schemas.microsoft.com/office/drawing/2014/main" id="{696D032C-DB06-44AF-A9F2-CEAF33A897D2}"/>
               </a:ext>
             </a:extLst>
           </p:cNvPr>
@@ -4653,7 +4653,7 @@
           <p:cNvPr id="19" name="">
             <a:extLst xmlns:a="http://schemas.openxmlformats.org/drawingml/2006/main">
               <a:ext uri="{FF2B5EF4-FFF2-40B4-BE49-F238E27FC236}">
-                <a16:creationId xmlns:a16="http://schemas.microsoft.com/office/drawing/2014/main" id="{B18EA12C-C6AA-47F3-8374-2C00368A07B0}"/>
+                <a16:creationId xmlns:a16="http://schemas.microsoft.com/office/drawing/2014/main" id="{DCA462C8-97B2-407D-A76C-2769594D8E77}"/>
               </a:ext>
             </a:extLst>
           </p:cNvPr>
@@ -4711,7 +4711,7 @@
           <p:cNvPr id="20" name="">
             <a:extLst xmlns:a="http://schemas.openxmlformats.org/drawingml/2006/main">
               <a:ext uri="{FF2B5EF4-FFF2-40B4-BE49-F238E27FC236}">
-                <a16:creationId xmlns:a16="http://schemas.microsoft.com/office/drawing/2014/main" id="{CB013B14-BCE9-4DAB-BC8B-922AB8E804B0}"/>
+                <a16:creationId xmlns:a16="http://schemas.microsoft.com/office/drawing/2014/main" id="{374F3372-7A52-4EEC-B4C2-ABCBDF8B69F2}"/>
               </a:ext>
             </a:extLst>
           </p:cNvPr>
@@ -4769,7 +4769,7 @@
           <p:cNvPr id="21" name="">
             <a:extLst xmlns:a="http://schemas.openxmlformats.org/drawingml/2006/main">
               <a:ext uri="{FF2B5EF4-FFF2-40B4-BE49-F238E27FC236}">
-                <a16:creationId xmlns:a16="http://schemas.microsoft.com/office/drawing/2014/main" id="{1E02C6B2-CD89-4477-BF9B-C41D45623624}"/>
+                <a16:creationId xmlns:a16="http://schemas.microsoft.com/office/drawing/2014/main" id="{03659CEE-4785-4406-A97F-C17C5203C7FF}"/>
               </a:ext>
             </a:extLst>
           </p:cNvPr>
@@ -4827,7 +4827,7 @@
           <p:cNvPr id="22" name="">
             <a:extLst xmlns:a="http://schemas.openxmlformats.org/drawingml/2006/main">
               <a:ext uri="{FF2B5EF4-FFF2-40B4-BE49-F238E27FC236}">
-                <a16:creationId xmlns:a16="http://schemas.microsoft.com/office/drawing/2014/main" id="{ABD25DA1-B891-43F3-8323-3A4B016C4BB0}"/>
+                <a16:creationId xmlns:a16="http://schemas.microsoft.com/office/drawing/2014/main" id="{EF4DF4B3-F054-478F-BB21-B23BFC425DAE}"/>
               </a:ext>
             </a:extLst>
           </p:cNvPr>
@@ -4885,7 +4885,7 @@
           <p:cNvPr id="23" name="">
             <a:extLst xmlns:a="http://schemas.openxmlformats.org/drawingml/2006/main">
               <a:ext uri="{FF2B5EF4-FFF2-40B4-BE49-F238E27FC236}">
-                <a16:creationId xmlns:a16="http://schemas.microsoft.com/office/drawing/2014/main" id="{AC8CADDD-6B36-4895-80FC-CFCBEE3BA58E}"/>
+                <a16:creationId xmlns:a16="http://schemas.microsoft.com/office/drawing/2014/main" id="{B12431BF-0E65-4485-94F5-B567642F5102}"/>
               </a:ext>
             </a:extLst>
           </p:cNvPr>
@@ -4920,7 +4920,7 @@
           <p:cNvPr id="24" name="">
             <a:extLst xmlns:a="http://schemas.openxmlformats.org/drawingml/2006/main">
               <a:ext uri="{FF2B5EF4-FFF2-40B4-BE49-F238E27FC236}">
-                <a16:creationId xmlns:a16="http://schemas.microsoft.com/office/drawing/2014/main" id="{76504289-06DB-4E25-9871-F4BE813AB370}"/>
+                <a16:creationId xmlns:a16="http://schemas.microsoft.com/office/drawing/2014/main" id="{D96689AA-282A-4BDF-8ABF-819E23D0E30B}"/>
               </a:ext>
             </a:extLst>
           </p:cNvPr>
@@ -4955,7 +4955,7 @@
           <p:cNvPr id="25" name="">
             <a:extLst xmlns:a="http://schemas.openxmlformats.org/drawingml/2006/main">
               <a:ext uri="{FF2B5EF4-FFF2-40B4-BE49-F238E27FC236}">
-                <a16:creationId xmlns:a16="http://schemas.microsoft.com/office/drawing/2014/main" id="{99993548-8395-414F-9BCA-E11712A74A0B}"/>
+                <a16:creationId xmlns:a16="http://schemas.microsoft.com/office/drawing/2014/main" id="{830F4E57-5983-449C-BC52-9F93CA997FF1}"/>
               </a:ext>
             </a:extLst>
           </p:cNvPr>
@@ -5013,7 +5013,7 @@
           <p:cNvPr id="26" name="">
             <a:extLst xmlns:a="http://schemas.openxmlformats.org/drawingml/2006/main">
               <a:ext uri="{FF2B5EF4-FFF2-40B4-BE49-F238E27FC236}">
-                <a16:creationId xmlns:a16="http://schemas.microsoft.com/office/drawing/2014/main" id="{BFD6E7C3-A604-4A73-B0BA-C21F5969739A}"/>
+                <a16:creationId xmlns:a16="http://schemas.microsoft.com/office/drawing/2014/main" id="{9F1972C4-9D03-45BB-8291-3592AFC8C7B1}"/>
               </a:ext>
             </a:extLst>
           </p:cNvPr>
@@ -5071,7 +5071,7 @@
           <p:cNvPr id="27" name="">
             <a:extLst xmlns:a="http://schemas.openxmlformats.org/drawingml/2006/main">
               <a:ext uri="{FF2B5EF4-FFF2-40B4-BE49-F238E27FC236}">
-                <a16:creationId xmlns:a16="http://schemas.microsoft.com/office/drawing/2014/main" id="{4F0D75EC-44D8-4A74-B240-9316FCB270C3}"/>
+                <a16:creationId xmlns:a16="http://schemas.microsoft.com/office/drawing/2014/main" id="{5E76D97B-41BE-4AD5-820B-FB05926544A9}"/>
               </a:ext>
             </a:extLst>
           </p:cNvPr>
@@ -5129,7 +5129,7 @@
           <p:cNvPr id="28" name="">
             <a:extLst xmlns:a="http://schemas.openxmlformats.org/drawingml/2006/main">
               <a:ext uri="{FF2B5EF4-FFF2-40B4-BE49-F238E27FC236}">
-                <a16:creationId xmlns:a16="http://schemas.microsoft.com/office/drawing/2014/main" id="{AB9DFF78-6A12-4D44-9B7A-3BE665CC35B7}"/>
+                <a16:creationId xmlns:a16="http://schemas.microsoft.com/office/drawing/2014/main" id="{6C813436-73BF-4803-A695-CADA67BA7E28}"/>
               </a:ext>
             </a:extLst>
           </p:cNvPr>
@@ -5187,7 +5187,7 @@
           <p:cNvPr id="29" name="">
             <a:extLst xmlns:a="http://schemas.openxmlformats.org/drawingml/2006/main">
               <a:ext uri="{FF2B5EF4-FFF2-40B4-BE49-F238E27FC236}">
-                <a16:creationId xmlns:a16="http://schemas.microsoft.com/office/drawing/2014/main" id="{274BB05A-26AA-494B-A671-2D40CF38EF8B}"/>
+                <a16:creationId xmlns:a16="http://schemas.microsoft.com/office/drawing/2014/main" id="{98964E11-BD5A-4A40-B456-CE8337B06D85}"/>
               </a:ext>
             </a:extLst>
           </p:cNvPr>
@@ -5222,7 +5222,7 @@
           <p:cNvPr id="30" name="">
             <a:extLst xmlns:a="http://schemas.openxmlformats.org/drawingml/2006/main">
               <a:ext uri="{FF2B5EF4-FFF2-40B4-BE49-F238E27FC236}">
-                <a16:creationId xmlns:a16="http://schemas.microsoft.com/office/drawing/2014/main" id="{2353455C-53C0-4EEF-B5A6-13B7639213A5}"/>
+                <a16:creationId xmlns:a16="http://schemas.microsoft.com/office/drawing/2014/main" id="{8891FCFE-38FB-4ACE-9630-9BE1637D929E}"/>
               </a:ext>
             </a:extLst>
           </p:cNvPr>
@@ -5257,7 +5257,7 @@
           <p:cNvPr id="31" name="">
             <a:extLst xmlns:a="http://schemas.openxmlformats.org/drawingml/2006/main">
               <a:ext uri="{FF2B5EF4-FFF2-40B4-BE49-F238E27FC236}">
-                <a16:creationId xmlns:a16="http://schemas.microsoft.com/office/drawing/2014/main" id="{65EB8257-0674-405D-B271-9E1B1CB0D4C2}"/>
+                <a16:creationId xmlns:a16="http://schemas.microsoft.com/office/drawing/2014/main" id="{740D70BD-9FCE-41BC-9BBD-F9044A876F2C}"/>
               </a:ext>
             </a:extLst>
           </p:cNvPr>
@@ -5315,7 +5315,7 @@
           <p:cNvPr id="32" name="">
             <a:extLst xmlns:a="http://schemas.openxmlformats.org/drawingml/2006/main">
               <a:ext uri="{FF2B5EF4-FFF2-40B4-BE49-F238E27FC236}">
-                <a16:creationId xmlns:a16="http://schemas.microsoft.com/office/drawing/2014/main" id="{2E1851A7-3203-4FA6-A8E9-3CBA29654C4F}"/>
+                <a16:creationId xmlns:a16="http://schemas.microsoft.com/office/drawing/2014/main" id="{8B6D4C6E-CB7A-467A-A754-49E513FDF927}"/>
               </a:ext>
             </a:extLst>
           </p:cNvPr>
@@ -5373,7 +5373,7 @@
           <p:cNvPr id="33" name="">
             <a:extLst xmlns:a="http://schemas.openxmlformats.org/drawingml/2006/main">
               <a:ext uri="{FF2B5EF4-FFF2-40B4-BE49-F238E27FC236}">
-                <a16:creationId xmlns:a16="http://schemas.microsoft.com/office/drawing/2014/main" id="{4C2B5F8C-9640-4AB0-BABC-E454653C15A8}"/>
+                <a16:creationId xmlns:a16="http://schemas.microsoft.com/office/drawing/2014/main" id="{21F50050-EB2C-4D74-A111-60BD0B2621E5}"/>
               </a:ext>
             </a:extLst>
           </p:cNvPr>
@@ -5431,7 +5431,7 @@
           <p:cNvPr id="34" name="">
             <a:extLst xmlns:a="http://schemas.openxmlformats.org/drawingml/2006/main">
               <a:ext uri="{FF2B5EF4-FFF2-40B4-BE49-F238E27FC236}">
-                <a16:creationId xmlns:a16="http://schemas.microsoft.com/office/drawing/2014/main" id="{FF688005-DBFE-4CB8-95D7-783D3F6ED833}"/>
+                <a16:creationId xmlns:a16="http://schemas.microsoft.com/office/drawing/2014/main" id="{80F1FE81-D78E-4137-B5F0-B2CC752F212A}"/>
               </a:ext>
             </a:extLst>
           </p:cNvPr>
@@ -5489,7 +5489,7 @@
           <p:cNvPr id="35" name="">
             <a:extLst xmlns:a="http://schemas.openxmlformats.org/drawingml/2006/main">
               <a:ext uri="{FF2B5EF4-FFF2-40B4-BE49-F238E27FC236}">
-                <a16:creationId xmlns:a16="http://schemas.microsoft.com/office/drawing/2014/main" id="{6FB8B9A4-AC3F-4E7D-8E89-E4E8847A41D4}"/>
+                <a16:creationId xmlns:a16="http://schemas.microsoft.com/office/drawing/2014/main" id="{7BC460F6-320E-4F4C-AF13-43CFFABC0803}"/>
               </a:ext>
             </a:extLst>
           </p:cNvPr>
@@ -5537,7 +5537,7 @@
                 <a:ea typeface="Aptos"/>
                 <a:cs typeface="Aptos"/>
               </a:rPr>
-              <a:t>WATERS NEXT GEN COMPETITIVE INTELLIGENCE · 08 SEP 2026 · waters-ci-20260909033329</a:t>
+              <a:t>WATERS NEXT GEN COMPETITIVE INTELLIGENCE · 09 SEP 2026 · waters-ci-20260909112945</a:t>
             </a:r>
           </a:p>
         </p:txBody>
@@ -5547,7 +5547,7 @@
           <p:cNvPr id="36" name="">
             <a:extLst xmlns:a="http://schemas.openxmlformats.org/drawingml/2006/main">
               <a:ext uri="{FF2B5EF4-FFF2-40B4-BE49-F238E27FC236}">
-                <a16:creationId xmlns:a16="http://schemas.microsoft.com/office/drawing/2014/main" id="{B5606852-6206-4BBC-B101-0B9D747E41E6}"/>
+                <a16:creationId xmlns:a16="http://schemas.microsoft.com/office/drawing/2014/main" id="{675D4DB0-A5ED-4C12-AA92-E37552CB8FD8}"/>
               </a:ext>
             </a:extLst>
           </p:cNvPr>
@@ -5603,7 +5603,7 @@
     </p:spTree>
     <p:extLst>
       <p:ext uri="{BB962C8B-B14F-4D97-AF65-F5344CB8AC3E}">
-        <p14:creationId xmlns:p14="http://schemas.microsoft.com/office/powerpoint/2010/main" val="1339230356"/>
+        <p14:creationId xmlns:p14="http://schemas.microsoft.com/office/powerpoint/2010/main" val="644380637"/>
       </p:ext>
     </p:extLst>
   </p:cSld>
@@ -5634,7 +5634,7 @@
           <p:cNvPr id="31" name="">
             <a:extLst xmlns:a="http://schemas.openxmlformats.org/drawingml/2006/main">
               <a:ext uri="{FF2B5EF4-FFF2-40B4-BE49-F238E27FC236}">
-                <a16:creationId xmlns:a16="http://schemas.microsoft.com/office/drawing/2014/main" id="{BA447E1A-7AF2-44AD-9337-2AE603EDDBC3}"/>
+                <a16:creationId xmlns:a16="http://schemas.microsoft.com/office/drawing/2014/main" id="{A602E93E-06A6-4F3C-BFDA-0FC197D91887}"/>
               </a:ext>
             </a:extLst>
           </p:cNvPr>
@@ -5692,7 +5692,7 @@
           <p:cNvPr id="2" name="">
             <a:extLst xmlns:a="http://schemas.openxmlformats.org/drawingml/2006/main">
               <a:ext uri="{FF2B5EF4-FFF2-40B4-BE49-F238E27FC236}">
-                <a16:creationId xmlns:a16="http://schemas.microsoft.com/office/drawing/2014/main" id="{B241D11D-99F1-4AA7-A8A5-ADEE5FA75E9D}"/>
+                <a16:creationId xmlns:a16="http://schemas.microsoft.com/office/drawing/2014/main" id="{2A3066EB-891F-46E2-86A6-F6699BC9D4FC}"/>
               </a:ext>
             </a:extLst>
           </p:cNvPr>
@@ -5750,7 +5750,7 @@
           <p:cNvPr id="3" name="">
             <a:extLst xmlns:a="http://schemas.openxmlformats.org/drawingml/2006/main">
               <a:ext uri="{FF2B5EF4-FFF2-40B4-BE49-F238E27FC236}">
-                <a16:creationId xmlns:a16="http://schemas.microsoft.com/office/drawing/2014/main" id="{133E0156-A08A-428E-A31D-E42D4A442B79}"/>
+                <a16:creationId xmlns:a16="http://schemas.microsoft.com/office/drawing/2014/main" id="{FF661B67-2B47-47B4-AED3-63A7C2901005}"/>
               </a:ext>
             </a:extLst>
           </p:cNvPr>
@@ -5808,7 +5808,7 @@
           <p:cNvPr id="4" name="">
             <a:extLst xmlns:a="http://schemas.openxmlformats.org/drawingml/2006/main">
               <a:ext uri="{FF2B5EF4-FFF2-40B4-BE49-F238E27FC236}">
-                <a16:creationId xmlns:a16="http://schemas.microsoft.com/office/drawing/2014/main" id="{51835774-A68F-4359-BE7B-ADC647E6AC9E}"/>
+                <a16:creationId xmlns:a16="http://schemas.microsoft.com/office/drawing/2014/main" id="{4737CFB6-30EC-44B4-A98E-28633123D79B}"/>
               </a:ext>
             </a:extLst>
           </p:cNvPr>
@@ -5841,7 +5841,7 @@
           <p:cNvPr id="5" name="">
             <a:extLst xmlns:a="http://schemas.openxmlformats.org/drawingml/2006/main">
               <a:ext uri="{FF2B5EF4-FFF2-40B4-BE49-F238E27FC236}">
-                <a16:creationId xmlns:a16="http://schemas.microsoft.com/office/drawing/2014/main" id="{A41F4022-2D0C-4CF8-A0C4-4BA07D21C951}"/>
+                <a16:creationId xmlns:a16="http://schemas.microsoft.com/office/drawing/2014/main" id="{D2D97D41-482D-4D1B-AED9-D0029B2952A9}"/>
               </a:ext>
             </a:extLst>
           </p:cNvPr>
@@ -5876,7 +5876,7 @@
           <p:cNvPr id="6" name="">
             <a:extLst xmlns:a="http://schemas.openxmlformats.org/drawingml/2006/main">
               <a:ext uri="{FF2B5EF4-FFF2-40B4-BE49-F238E27FC236}">
-                <a16:creationId xmlns:a16="http://schemas.microsoft.com/office/drawing/2014/main" id="{E6DDF04F-7F3F-42CF-883C-88144EBC911E}"/>
+                <a16:creationId xmlns:a16="http://schemas.microsoft.com/office/drawing/2014/main" id="{6E9B15CC-CA92-4DD7-90F9-65BF7A5EB9E3}"/>
               </a:ext>
             </a:extLst>
           </p:cNvPr>
@@ -5909,7 +5909,7 @@
           <p:cNvPr id="7" name="">
             <a:extLst xmlns:a="http://schemas.openxmlformats.org/drawingml/2006/main">
               <a:ext uri="{FF2B5EF4-FFF2-40B4-BE49-F238E27FC236}">
-                <a16:creationId xmlns:a16="http://schemas.microsoft.com/office/drawing/2014/main" id="{4AEC8449-454E-41A3-9342-4D8576453587}"/>
+                <a16:creationId xmlns:a16="http://schemas.microsoft.com/office/drawing/2014/main" id="{3EBFF141-7D84-426F-99E1-C26AFC6F1C08}"/>
               </a:ext>
             </a:extLst>
           </p:cNvPr>
@@ -5967,7 +5967,7 @@
           <p:cNvPr id="8" name="">
             <a:extLst xmlns:a="http://schemas.openxmlformats.org/drawingml/2006/main">
               <a:ext uri="{FF2B5EF4-FFF2-40B4-BE49-F238E27FC236}">
-                <a16:creationId xmlns:a16="http://schemas.microsoft.com/office/drawing/2014/main" id="{4B7CACF7-55C5-4B2F-99DA-D451B982EA81}"/>
+                <a16:creationId xmlns:a16="http://schemas.microsoft.com/office/drawing/2014/main" id="{C97A2655-B9ED-4756-A7F7-C4DA1816E69D}"/>
               </a:ext>
             </a:extLst>
           </p:cNvPr>
@@ -6025,7 +6025,7 @@
           <p:cNvPr id="9" name="">
             <a:extLst xmlns:a="http://schemas.openxmlformats.org/drawingml/2006/main">
               <a:ext uri="{FF2B5EF4-FFF2-40B4-BE49-F238E27FC236}">
-                <a16:creationId xmlns:a16="http://schemas.microsoft.com/office/drawing/2014/main" id="{C5B02608-3CEF-46B3-82C7-20540163A0E3}"/>
+                <a16:creationId xmlns:a16="http://schemas.microsoft.com/office/drawing/2014/main" id="{A183D680-D68F-4AD5-B15F-3C7D87430E0C}"/>
               </a:ext>
             </a:extLst>
           </p:cNvPr>
@@ -6083,7 +6083,7 @@
           <p:cNvPr id="10" name="">
             <a:extLst xmlns:a="http://schemas.openxmlformats.org/drawingml/2006/main">
               <a:ext uri="{FF2B5EF4-FFF2-40B4-BE49-F238E27FC236}">
-                <a16:creationId xmlns:a16="http://schemas.microsoft.com/office/drawing/2014/main" id="{B364A1C4-890A-418C-B99A-FDFC29BEE320}"/>
+                <a16:creationId xmlns:a16="http://schemas.microsoft.com/office/drawing/2014/main" id="{284BC3D0-968C-44E8-A670-0366EC18F5CB}"/>
               </a:ext>
             </a:extLst>
           </p:cNvPr>
@@ -6141,7 +6141,7 @@
           <p:cNvPr id="11" name="">
             <a:extLst xmlns:a="http://schemas.openxmlformats.org/drawingml/2006/main">
               <a:ext uri="{FF2B5EF4-FFF2-40B4-BE49-F238E27FC236}">
-                <a16:creationId xmlns:a16="http://schemas.microsoft.com/office/drawing/2014/main" id="{E7F2EADB-D067-417F-B952-257EA69BE878}"/>
+                <a16:creationId xmlns:a16="http://schemas.microsoft.com/office/drawing/2014/main" id="{B0C73C5C-689C-4CC0-AD3D-880EF8FF3524}"/>
               </a:ext>
             </a:extLst>
           </p:cNvPr>
@@ -6176,7 +6176,7 @@
           <p:cNvPr id="12" name="">
             <a:extLst xmlns:a="http://schemas.openxmlformats.org/drawingml/2006/main">
               <a:ext uri="{FF2B5EF4-FFF2-40B4-BE49-F238E27FC236}">
-                <a16:creationId xmlns:a16="http://schemas.microsoft.com/office/drawing/2014/main" id="{0BA76A01-8E76-413C-BF31-C7F405E1969E}"/>
+                <a16:creationId xmlns:a16="http://schemas.microsoft.com/office/drawing/2014/main" id="{109B73A7-800B-4612-AC28-7C70E80C477A}"/>
               </a:ext>
             </a:extLst>
           </p:cNvPr>
@@ -6209,7 +6209,7 @@
           <p:cNvPr id="13" name="">
             <a:extLst xmlns:a="http://schemas.openxmlformats.org/drawingml/2006/main">
               <a:ext uri="{FF2B5EF4-FFF2-40B4-BE49-F238E27FC236}">
-                <a16:creationId xmlns:a16="http://schemas.microsoft.com/office/drawing/2014/main" id="{53FB2D83-FE83-4098-A917-1AC30BFA401C}"/>
+                <a16:creationId xmlns:a16="http://schemas.microsoft.com/office/drawing/2014/main" id="{33DC6C0B-850F-4668-969E-A5113FB94C22}"/>
               </a:ext>
             </a:extLst>
           </p:cNvPr>
@@ -6267,7 +6267,7 @@
           <p:cNvPr id="14" name="">
             <a:extLst xmlns:a="http://schemas.openxmlformats.org/drawingml/2006/main">
               <a:ext uri="{FF2B5EF4-FFF2-40B4-BE49-F238E27FC236}">
-                <a16:creationId xmlns:a16="http://schemas.microsoft.com/office/drawing/2014/main" id="{48A8B969-5819-40EF-A344-61BFE299CC67}"/>
+                <a16:creationId xmlns:a16="http://schemas.microsoft.com/office/drawing/2014/main" id="{561F2D01-5F88-4EC7-B87F-22D09C3E302F}"/>
               </a:ext>
             </a:extLst>
           </p:cNvPr>
@@ -6325,7 +6325,7 @@
           <p:cNvPr id="15" name="">
             <a:extLst xmlns:a="http://schemas.openxmlformats.org/drawingml/2006/main">
               <a:ext uri="{FF2B5EF4-FFF2-40B4-BE49-F238E27FC236}">
-                <a16:creationId xmlns:a16="http://schemas.microsoft.com/office/drawing/2014/main" id="{68690501-C9A7-4441-8FF9-E1C3275BD544}"/>
+                <a16:creationId xmlns:a16="http://schemas.microsoft.com/office/drawing/2014/main" id="{B418B1CD-F765-4E40-86CA-E67458144360}"/>
               </a:ext>
             </a:extLst>
           </p:cNvPr>
@@ -6383,7 +6383,7 @@
           <p:cNvPr id="16" name="">
             <a:extLst xmlns:a="http://schemas.openxmlformats.org/drawingml/2006/main">
               <a:ext uri="{FF2B5EF4-FFF2-40B4-BE49-F238E27FC236}">
-                <a16:creationId xmlns:a16="http://schemas.microsoft.com/office/drawing/2014/main" id="{E2DA80BA-B1AF-4B69-9EC4-39F8AF7D551A}"/>
+                <a16:creationId xmlns:a16="http://schemas.microsoft.com/office/drawing/2014/main" id="{D073F833-B6EF-4758-B97D-A5C31E585CA6}"/>
               </a:ext>
             </a:extLst>
           </p:cNvPr>
@@ -6441,7 +6441,7 @@
           <p:cNvPr id="17" name="">
             <a:extLst xmlns:a="http://schemas.openxmlformats.org/drawingml/2006/main">
               <a:ext uri="{FF2B5EF4-FFF2-40B4-BE49-F238E27FC236}">
-                <a16:creationId xmlns:a16="http://schemas.microsoft.com/office/drawing/2014/main" id="{6438C60F-79A9-4436-970B-F314DB2C39BC}"/>
+                <a16:creationId xmlns:a16="http://schemas.microsoft.com/office/drawing/2014/main" id="{EA719B8C-08CE-4593-94E2-92F2A6237F9D}"/>
               </a:ext>
             </a:extLst>
           </p:cNvPr>
@@ -6476,7 +6476,7 @@
           <p:cNvPr id="18" name="">
             <a:extLst xmlns:a="http://schemas.openxmlformats.org/drawingml/2006/main">
               <a:ext uri="{FF2B5EF4-FFF2-40B4-BE49-F238E27FC236}">
-                <a16:creationId xmlns:a16="http://schemas.microsoft.com/office/drawing/2014/main" id="{6EE78BF8-1E2F-4E66-ADC0-A5CFD60FD9D5}"/>
+                <a16:creationId xmlns:a16="http://schemas.microsoft.com/office/drawing/2014/main" id="{3359F255-1004-4739-9269-8942F5917EC8}"/>
               </a:ext>
             </a:extLst>
           </p:cNvPr>
@@ -6509,7 +6509,7 @@
           <p:cNvPr id="19" name="">
             <a:extLst xmlns:a="http://schemas.openxmlformats.org/drawingml/2006/main">
               <a:ext uri="{FF2B5EF4-FFF2-40B4-BE49-F238E27FC236}">
-                <a16:creationId xmlns:a16="http://schemas.microsoft.com/office/drawing/2014/main" id="{79DB8D9A-5D39-4858-B4CE-3916916DEBB9}"/>
+                <a16:creationId xmlns:a16="http://schemas.microsoft.com/office/drawing/2014/main" id="{2AD1CCB2-FE63-4ACC-919C-5B0F130C1E0F}"/>
               </a:ext>
             </a:extLst>
           </p:cNvPr>
@@ -6567,7 +6567,7 @@
           <p:cNvPr id="20" name="">
             <a:extLst xmlns:a="http://schemas.openxmlformats.org/drawingml/2006/main">
               <a:ext uri="{FF2B5EF4-FFF2-40B4-BE49-F238E27FC236}">
-                <a16:creationId xmlns:a16="http://schemas.microsoft.com/office/drawing/2014/main" id="{C593AEEF-1C68-49AF-91F9-5CD667A326F9}"/>
+                <a16:creationId xmlns:a16="http://schemas.microsoft.com/office/drawing/2014/main" id="{3054B42F-3098-4357-8A8F-5BAA5540EEE7}"/>
               </a:ext>
             </a:extLst>
           </p:cNvPr>
@@ -6625,7 +6625,7 @@
           <p:cNvPr id="21" name="">
             <a:extLst xmlns:a="http://schemas.openxmlformats.org/drawingml/2006/main">
               <a:ext uri="{FF2B5EF4-FFF2-40B4-BE49-F238E27FC236}">
-                <a16:creationId xmlns:a16="http://schemas.microsoft.com/office/drawing/2014/main" id="{4B1969CE-CE02-4E74-A373-2D14F7752328}"/>
+                <a16:creationId xmlns:a16="http://schemas.microsoft.com/office/drawing/2014/main" id="{900D9478-5C40-4EA0-B571-72AB47B33CD1}"/>
               </a:ext>
             </a:extLst>
           </p:cNvPr>
@@ -6683,7 +6683,7 @@
           <p:cNvPr id="22" name="">
             <a:extLst xmlns:a="http://schemas.openxmlformats.org/drawingml/2006/main">
               <a:ext uri="{FF2B5EF4-FFF2-40B4-BE49-F238E27FC236}">
-                <a16:creationId xmlns:a16="http://schemas.microsoft.com/office/drawing/2014/main" id="{B54D9D68-1252-4214-8264-481CF5F22C43}"/>
+                <a16:creationId xmlns:a16="http://schemas.microsoft.com/office/drawing/2014/main" id="{44D55E92-AF9F-4589-9243-D5AF039FC024}"/>
               </a:ext>
             </a:extLst>
           </p:cNvPr>
@@ -6741,7 +6741,7 @@
           <p:cNvPr id="23" name="">
             <a:extLst xmlns:a="http://schemas.openxmlformats.org/drawingml/2006/main">
               <a:ext uri="{FF2B5EF4-FFF2-40B4-BE49-F238E27FC236}">
-                <a16:creationId xmlns:a16="http://schemas.microsoft.com/office/drawing/2014/main" id="{961AAA09-EC21-49C7-AD6A-759AE6160A1A}"/>
+                <a16:creationId xmlns:a16="http://schemas.microsoft.com/office/drawing/2014/main" id="{A1000944-D79A-4692-8070-97F2E3E7863D}"/>
               </a:ext>
             </a:extLst>
           </p:cNvPr>
@@ -6776,7 +6776,7 @@
           <p:cNvPr id="24" name="">
             <a:extLst xmlns:a="http://schemas.openxmlformats.org/drawingml/2006/main">
               <a:ext uri="{FF2B5EF4-FFF2-40B4-BE49-F238E27FC236}">
-                <a16:creationId xmlns:a16="http://schemas.microsoft.com/office/drawing/2014/main" id="{0ACD9308-33AD-457A-B72E-CA5C7027F130}"/>
+                <a16:creationId xmlns:a16="http://schemas.microsoft.com/office/drawing/2014/main" id="{6B85E3AF-2D79-4928-AF3B-B46C331AC18A}"/>
               </a:ext>
             </a:extLst>
           </p:cNvPr>
@@ -6809,7 +6809,7 @@
           <p:cNvPr id="25" name="">
             <a:extLst xmlns:a="http://schemas.openxmlformats.org/drawingml/2006/main">
               <a:ext uri="{FF2B5EF4-FFF2-40B4-BE49-F238E27FC236}">
-                <a16:creationId xmlns:a16="http://schemas.microsoft.com/office/drawing/2014/main" id="{1F27F885-4CAF-4E50-B85C-78D2854BC2AB}"/>
+                <a16:creationId xmlns:a16="http://schemas.microsoft.com/office/drawing/2014/main" id="{72D9C2A5-32EB-459E-972F-F147648E8D61}"/>
               </a:ext>
             </a:extLst>
           </p:cNvPr>
@@ -6867,7 +6867,7 @@
           <p:cNvPr id="26" name="">
             <a:extLst xmlns:a="http://schemas.openxmlformats.org/drawingml/2006/main">
               <a:ext uri="{FF2B5EF4-FFF2-40B4-BE49-F238E27FC236}">
-                <a16:creationId xmlns:a16="http://schemas.microsoft.com/office/drawing/2014/main" id="{0478950E-08A4-4436-B2C0-E0C6DF1C9047}"/>
+                <a16:creationId xmlns:a16="http://schemas.microsoft.com/office/drawing/2014/main" id="{3AF7A319-F30C-4482-AFEE-D5AC798729B5}"/>
               </a:ext>
             </a:extLst>
           </p:cNvPr>
@@ -6925,7 +6925,7 @@
           <p:cNvPr id="27" name="">
             <a:extLst xmlns:a="http://schemas.openxmlformats.org/drawingml/2006/main">
               <a:ext uri="{FF2B5EF4-FFF2-40B4-BE49-F238E27FC236}">
-                <a16:creationId xmlns:a16="http://schemas.microsoft.com/office/drawing/2014/main" id="{154810B7-8F12-4753-886F-CE265D4DF242}"/>
+                <a16:creationId xmlns:a16="http://schemas.microsoft.com/office/drawing/2014/main" id="{7ABDE7BE-324D-423E-89F4-24A7A11A9264}"/>
               </a:ext>
             </a:extLst>
           </p:cNvPr>
@@ -6983,7 +6983,7 @@
           <p:cNvPr id="28" name="">
             <a:extLst xmlns:a="http://schemas.openxmlformats.org/drawingml/2006/main">
               <a:ext uri="{FF2B5EF4-FFF2-40B4-BE49-F238E27FC236}">
-                <a16:creationId xmlns:a16="http://schemas.microsoft.com/office/drawing/2014/main" id="{76C5A189-7948-4C30-BB47-FD4F5E469217}"/>
+                <a16:creationId xmlns:a16="http://schemas.microsoft.com/office/drawing/2014/main" id="{6D58918A-D869-401B-9944-258FD45E5313}"/>
               </a:ext>
             </a:extLst>
           </p:cNvPr>
@@ -7041,7 +7041,7 @@
           <p:cNvPr id="29" name="">
             <a:extLst xmlns:a="http://schemas.openxmlformats.org/drawingml/2006/main">
               <a:ext uri="{FF2B5EF4-FFF2-40B4-BE49-F238E27FC236}">
-                <a16:creationId xmlns:a16="http://schemas.microsoft.com/office/drawing/2014/main" id="{E09CA38B-9E01-478D-ABBD-08F06AC44C74}"/>
+                <a16:creationId xmlns:a16="http://schemas.microsoft.com/office/drawing/2014/main" id="{FDF2646C-59DB-4819-ACDC-B6EE2ED943EC}"/>
               </a:ext>
             </a:extLst>
           </p:cNvPr>
@@ -7089,7 +7089,7 @@
                 <a:ea typeface="Aptos"/>
                 <a:cs typeface="Aptos"/>
               </a:rPr>
-              <a:t>WATERS NEXT GEN COMPETITIVE INTELLIGENCE · 08 SEP 2026 · waters-ci-20260909033329</a:t>
+              <a:t>WATERS NEXT GEN COMPETITIVE INTELLIGENCE · 09 SEP 2026 · waters-ci-20260909112945</a:t>
             </a:r>
           </a:p>
         </p:txBody>
@@ -7099,7 +7099,7 @@
           <p:cNvPr id="30" name="">
             <a:extLst xmlns:a="http://schemas.openxmlformats.org/drawingml/2006/main">
               <a:ext uri="{FF2B5EF4-FFF2-40B4-BE49-F238E27FC236}">
-                <a16:creationId xmlns:a16="http://schemas.microsoft.com/office/drawing/2014/main" id="{16315626-9F40-4588-B384-90DC4B928390}"/>
+                <a16:creationId xmlns:a16="http://schemas.microsoft.com/office/drawing/2014/main" id="{023F1C89-3E61-4A39-B3CA-700F007276EC}"/>
               </a:ext>
             </a:extLst>
           </p:cNvPr>
@@ -7155,7 +7155,7 @@
     </p:spTree>
     <p:extLst>
       <p:ext uri="{BB962C8B-B14F-4D97-AF65-F5344CB8AC3E}">
-        <p14:creationId xmlns:p14="http://schemas.microsoft.com/office/powerpoint/2010/main" val="578227406"/>
+        <p14:creationId xmlns:p14="http://schemas.microsoft.com/office/powerpoint/2010/main" val="1053356057"/>
       </p:ext>
     </p:extLst>
   </p:cSld>
@@ -7186,7 +7186,7 @@
           <p:cNvPr id="17" name="">
             <a:extLst xmlns:a="http://schemas.openxmlformats.org/drawingml/2006/main">
               <a:ext uri="{FF2B5EF4-FFF2-40B4-BE49-F238E27FC236}">
-                <a16:creationId xmlns:a16="http://schemas.microsoft.com/office/drawing/2014/main" id="{B8FE596E-E36A-4FAF-AA78-24EFC7C6B396}"/>
+                <a16:creationId xmlns:a16="http://schemas.microsoft.com/office/drawing/2014/main" id="{9B17873F-3DB6-4CD4-B73E-A55B007A8829}"/>
               </a:ext>
             </a:extLst>
           </p:cNvPr>
@@ -7244,7 +7244,7 @@
           <p:cNvPr id="2" name="">
             <a:extLst xmlns:a="http://schemas.openxmlformats.org/drawingml/2006/main">
               <a:ext uri="{FF2B5EF4-FFF2-40B4-BE49-F238E27FC236}">
-                <a16:creationId xmlns:a16="http://schemas.microsoft.com/office/drawing/2014/main" id="{E93B0DAA-5C94-48CB-A9C1-37FA3888EDB8}"/>
+                <a16:creationId xmlns:a16="http://schemas.microsoft.com/office/drawing/2014/main" id="{A829DDB5-8AE8-4EE2-8DFC-E47C63BC4F18}"/>
               </a:ext>
             </a:extLst>
           </p:cNvPr>
@@ -7302,7 +7302,7 @@
           <p:cNvPr id="3" name="">
             <a:extLst xmlns:a="http://schemas.openxmlformats.org/drawingml/2006/main">
               <a:ext uri="{FF2B5EF4-FFF2-40B4-BE49-F238E27FC236}">
-                <a16:creationId xmlns:a16="http://schemas.microsoft.com/office/drawing/2014/main" id="{44C31844-5BDD-4DA2-8B86-7D6871E754E4}"/>
+                <a16:creationId xmlns:a16="http://schemas.microsoft.com/office/drawing/2014/main" id="{49759280-73A9-4172-9A2A-17162AF3AA63}"/>
               </a:ext>
             </a:extLst>
           </p:cNvPr>
@@ -7360,7 +7360,7 @@
           <p:cNvPr id="4" name="">
             <a:extLst xmlns:a="http://schemas.openxmlformats.org/drawingml/2006/main">
               <a:ext uri="{FF2B5EF4-FFF2-40B4-BE49-F238E27FC236}">
-                <a16:creationId xmlns:a16="http://schemas.microsoft.com/office/drawing/2014/main" id="{0D6C669C-8690-42C4-80CC-1017FC9E32A5}"/>
+                <a16:creationId xmlns:a16="http://schemas.microsoft.com/office/drawing/2014/main" id="{1539661F-1A8E-40D1-9C19-9BE93B56C6E4}"/>
               </a:ext>
             </a:extLst>
           </p:cNvPr>
@@ -7393,7 +7393,7 @@
           <p:cNvPr id="5" name="">
             <a:extLst xmlns:a="http://schemas.openxmlformats.org/drawingml/2006/main">
               <a:ext uri="{FF2B5EF4-FFF2-40B4-BE49-F238E27FC236}">
-                <a16:creationId xmlns:a16="http://schemas.microsoft.com/office/drawing/2014/main" id="{44FAB620-B148-418A-A920-4DB56EF19BDD}"/>
+                <a16:creationId xmlns:a16="http://schemas.microsoft.com/office/drawing/2014/main" id="{3B26024F-B940-4733-B946-703C4A0E051C}"/>
               </a:ext>
             </a:extLst>
           </p:cNvPr>
@@ -7428,7 +7428,7 @@
           <p:cNvPr id="6" name="">
             <a:extLst xmlns:a="http://schemas.openxmlformats.org/drawingml/2006/main">
               <a:ext uri="{FF2B5EF4-FFF2-40B4-BE49-F238E27FC236}">
-                <a16:creationId xmlns:a16="http://schemas.microsoft.com/office/drawing/2014/main" id="{34930036-A65E-4F27-AF85-2B5982C29D8F}"/>
+                <a16:creationId xmlns:a16="http://schemas.microsoft.com/office/drawing/2014/main" id="{1596A643-6A22-486F-AE35-C13155C55CC2}"/>
               </a:ext>
             </a:extLst>
           </p:cNvPr>
@@ -7486,7 +7486,7 @@
           <p:cNvPr id="7" name="">
             <a:extLst xmlns:a="http://schemas.openxmlformats.org/drawingml/2006/main">
               <a:ext uri="{FF2B5EF4-FFF2-40B4-BE49-F238E27FC236}">
-                <a16:creationId xmlns:a16="http://schemas.microsoft.com/office/drawing/2014/main" id="{69052C87-8CC2-494B-8A4A-EAB28D93E29D}"/>
+                <a16:creationId xmlns:a16="http://schemas.microsoft.com/office/drawing/2014/main" id="{F4F370A5-24E6-48BF-8C45-BDBB42BFF50A}"/>
               </a:ext>
             </a:extLst>
           </p:cNvPr>
@@ -7544,7 +7544,7 @@
           <p:cNvPr id="8" name="">
             <a:extLst xmlns:a="http://schemas.openxmlformats.org/drawingml/2006/main">
               <a:ext uri="{FF2B5EF4-FFF2-40B4-BE49-F238E27FC236}">
-                <a16:creationId xmlns:a16="http://schemas.microsoft.com/office/drawing/2014/main" id="{EF8D1EB3-4B28-44B2-8909-EBD4411E0454}"/>
+                <a16:creationId xmlns:a16="http://schemas.microsoft.com/office/drawing/2014/main" id="{4E99C859-AD18-4E64-8AAA-ACDFEEDAB358}"/>
               </a:ext>
             </a:extLst>
           </p:cNvPr>
@@ -7602,7 +7602,7 @@
           <p:cNvPr id="9" name="">
             <a:extLst xmlns:a="http://schemas.openxmlformats.org/drawingml/2006/main">
               <a:ext uri="{FF2B5EF4-FFF2-40B4-BE49-F238E27FC236}">
-                <a16:creationId xmlns:a16="http://schemas.microsoft.com/office/drawing/2014/main" id="{868148B5-041B-4C86-B4E9-8611D40B215E}"/>
+                <a16:creationId xmlns:a16="http://schemas.microsoft.com/office/drawing/2014/main" id="{B8CF2545-E797-4A42-8636-BBAC0B324F04}"/>
               </a:ext>
             </a:extLst>
           </p:cNvPr>
@@ -7683,7 +7683,7 @@
           <p:cNvPr id="10" name="">
             <a:extLst xmlns:a="http://schemas.openxmlformats.org/drawingml/2006/main">
               <a:ext uri="{FF2B5EF4-FFF2-40B4-BE49-F238E27FC236}">
-                <a16:creationId xmlns:a16="http://schemas.microsoft.com/office/drawing/2014/main" id="{356993B4-BC5E-4490-BEDB-B1DDEFC0AF20}"/>
+                <a16:creationId xmlns:a16="http://schemas.microsoft.com/office/drawing/2014/main" id="{3D1D979F-A8D1-42D0-A3C4-39124E511A02}"/>
               </a:ext>
             </a:extLst>
           </p:cNvPr>
@@ -7718,7 +7718,7 @@
           <p:cNvPr id="11" name="">
             <a:extLst xmlns:a="http://schemas.openxmlformats.org/drawingml/2006/main">
               <a:ext uri="{FF2B5EF4-FFF2-40B4-BE49-F238E27FC236}">
-                <a16:creationId xmlns:a16="http://schemas.microsoft.com/office/drawing/2014/main" id="{1C6E25FD-F4A6-4AD0-B2A9-8308759012AC}"/>
+                <a16:creationId xmlns:a16="http://schemas.microsoft.com/office/drawing/2014/main" id="{802AA16E-5DC1-4EAB-89DF-6DFABCA1FB2A}"/>
               </a:ext>
             </a:extLst>
           </p:cNvPr>
@@ -7776,7 +7776,7 @@
           <p:cNvPr id="12" name="">
             <a:extLst xmlns:a="http://schemas.openxmlformats.org/drawingml/2006/main">
               <a:ext uri="{FF2B5EF4-FFF2-40B4-BE49-F238E27FC236}">
-                <a16:creationId xmlns:a16="http://schemas.microsoft.com/office/drawing/2014/main" id="{32237271-FF0F-4E73-BB3E-9BFCF0B603F0}"/>
+                <a16:creationId xmlns:a16="http://schemas.microsoft.com/office/drawing/2014/main" id="{61CB749F-A0E8-467F-906E-DD1CD9DA7C44}"/>
               </a:ext>
             </a:extLst>
           </p:cNvPr>
@@ -7834,7 +7834,7 @@
           <p:cNvPr id="13" name="">
             <a:extLst xmlns:a="http://schemas.openxmlformats.org/drawingml/2006/main">
               <a:ext uri="{FF2B5EF4-FFF2-40B4-BE49-F238E27FC236}">
-                <a16:creationId xmlns:a16="http://schemas.microsoft.com/office/drawing/2014/main" id="{5C02628D-DD7E-445B-AA82-9C529FFCFA50}"/>
+                <a16:creationId xmlns:a16="http://schemas.microsoft.com/office/drawing/2014/main" id="{EAECF090-873B-410E-A8E6-56499C13D5B1}"/>
               </a:ext>
             </a:extLst>
           </p:cNvPr>
@@ -7892,7 +7892,7 @@
           <p:cNvPr id="14" name="">
             <a:extLst xmlns:a="http://schemas.openxmlformats.org/drawingml/2006/main">
               <a:ext uri="{FF2B5EF4-FFF2-40B4-BE49-F238E27FC236}">
-                <a16:creationId xmlns:a16="http://schemas.microsoft.com/office/drawing/2014/main" id="{3F0A9B4C-52E5-4438-A72E-1EBFFFF0B912}"/>
+                <a16:creationId xmlns:a16="http://schemas.microsoft.com/office/drawing/2014/main" id="{5ABF325D-2A17-48FB-8304-EE62056AD290}"/>
               </a:ext>
             </a:extLst>
           </p:cNvPr>
@@ -7996,7 +7996,7 @@
           <p:cNvPr id="15" name="">
             <a:extLst xmlns:a="http://schemas.openxmlformats.org/drawingml/2006/main">
               <a:ext uri="{FF2B5EF4-FFF2-40B4-BE49-F238E27FC236}">
-                <a16:creationId xmlns:a16="http://schemas.microsoft.com/office/drawing/2014/main" id="{650E41D6-4E56-487A-809E-CD5AC583618E}"/>
+                <a16:creationId xmlns:a16="http://schemas.microsoft.com/office/drawing/2014/main" id="{F9B61FB5-C460-46BE-ACDD-8D5824436F7A}"/>
               </a:ext>
             </a:extLst>
           </p:cNvPr>
@@ -8044,7 +8044,7 @@
                 <a:ea typeface="Aptos"/>
                 <a:cs typeface="Aptos"/>
               </a:rPr>
-              <a:t>WATERS NEXT GEN COMPETITIVE INTELLIGENCE · 08 SEP 2026 · waters-ci-20260909033329</a:t>
+              <a:t>WATERS NEXT GEN COMPETITIVE INTELLIGENCE · 09 SEP 2026 · waters-ci-20260909112945</a:t>
             </a:r>
           </a:p>
         </p:txBody>
@@ -8054,7 +8054,7 @@
           <p:cNvPr id="16" name="">
             <a:extLst xmlns:a="http://schemas.openxmlformats.org/drawingml/2006/main">
               <a:ext uri="{FF2B5EF4-FFF2-40B4-BE49-F238E27FC236}">
-                <a16:creationId xmlns:a16="http://schemas.microsoft.com/office/drawing/2014/main" id="{6AF1C375-FC9A-463E-9AE6-A1BACBF729BD}"/>
+                <a16:creationId xmlns:a16="http://schemas.microsoft.com/office/drawing/2014/main" id="{044CD433-27D5-4455-9BF2-43822F4737C3}"/>
               </a:ext>
             </a:extLst>
           </p:cNvPr>
@@ -8110,7 +8110,7 @@
     </p:spTree>
     <p:extLst>
       <p:ext uri="{BB962C8B-B14F-4D97-AF65-F5344CB8AC3E}">
-        <p14:creationId xmlns:p14="http://schemas.microsoft.com/office/powerpoint/2010/main" val="1714244118"/>
+        <p14:creationId xmlns:p14="http://schemas.microsoft.com/office/powerpoint/2010/main" val="129386814"/>
       </p:ext>
     </p:extLst>
   </p:cSld>
@@ -8141,7 +8141,7 @@
           <p:cNvPr id="37" name="">
             <a:extLst xmlns:a="http://schemas.openxmlformats.org/drawingml/2006/main">
               <a:ext uri="{FF2B5EF4-FFF2-40B4-BE49-F238E27FC236}">
-                <a16:creationId xmlns:a16="http://schemas.microsoft.com/office/drawing/2014/main" id="{2BD487BC-C7CF-4712-B8E5-4BA019B1EA3E}"/>
+                <a16:creationId xmlns:a16="http://schemas.microsoft.com/office/drawing/2014/main" id="{0855513E-0D7D-4008-840A-1F4120850647}"/>
               </a:ext>
             </a:extLst>
           </p:cNvPr>
@@ -8199,7 +8199,7 @@
           <p:cNvPr id="2" name="">
             <a:extLst xmlns:a="http://schemas.openxmlformats.org/drawingml/2006/main">
               <a:ext uri="{FF2B5EF4-FFF2-40B4-BE49-F238E27FC236}">
-                <a16:creationId xmlns:a16="http://schemas.microsoft.com/office/drawing/2014/main" id="{A9CE2B34-CF10-4941-9381-6D3AA90AA496}"/>
+                <a16:creationId xmlns:a16="http://schemas.microsoft.com/office/drawing/2014/main" id="{7BFD64A3-BE89-4C94-BAAD-7D41A8A3D551}"/>
               </a:ext>
             </a:extLst>
           </p:cNvPr>
@@ -8257,7 +8257,7 @@
           <p:cNvPr id="3" name="">
             <a:extLst xmlns:a="http://schemas.openxmlformats.org/drawingml/2006/main">
               <a:ext uri="{FF2B5EF4-FFF2-40B4-BE49-F238E27FC236}">
-                <a16:creationId xmlns:a16="http://schemas.microsoft.com/office/drawing/2014/main" id="{AFF4FBB0-ACD3-4174-A5ED-6883F3998D63}"/>
+                <a16:creationId xmlns:a16="http://schemas.microsoft.com/office/drawing/2014/main" id="{CA9AB492-FC90-4818-A582-A0D94830A953}"/>
               </a:ext>
             </a:extLst>
           </p:cNvPr>
@@ -8315,7 +8315,7 @@
           <p:cNvPr id="4" name="">
             <a:extLst xmlns:a="http://schemas.openxmlformats.org/drawingml/2006/main">
               <a:ext uri="{FF2B5EF4-FFF2-40B4-BE49-F238E27FC236}">
-                <a16:creationId xmlns:a16="http://schemas.microsoft.com/office/drawing/2014/main" id="{78246CB1-6AFC-4F81-9FEB-163B3F2565EC}"/>
+                <a16:creationId xmlns:a16="http://schemas.microsoft.com/office/drawing/2014/main" id="{8E8B70D1-E64D-4A78-9B21-743D62656EDF}"/>
               </a:ext>
             </a:extLst>
           </p:cNvPr>
@@ -8348,7 +8348,7 @@
           <p:cNvPr id="5" name="">
             <a:extLst xmlns:a="http://schemas.openxmlformats.org/drawingml/2006/main">
               <a:ext uri="{FF2B5EF4-FFF2-40B4-BE49-F238E27FC236}">
-                <a16:creationId xmlns:a16="http://schemas.microsoft.com/office/drawing/2014/main" id="{5129777B-A53B-4839-82DC-5A4D11B731D7}"/>
+                <a16:creationId xmlns:a16="http://schemas.microsoft.com/office/drawing/2014/main" id="{D0F23227-9CEE-40C9-958C-7DE649031A51}"/>
               </a:ext>
             </a:extLst>
           </p:cNvPr>
@@ -8383,7 +8383,7 @@
           <p:cNvPr id="6" name="">
             <a:extLst xmlns:a="http://schemas.openxmlformats.org/drawingml/2006/main">
               <a:ext uri="{FF2B5EF4-FFF2-40B4-BE49-F238E27FC236}">
-                <a16:creationId xmlns:a16="http://schemas.microsoft.com/office/drawing/2014/main" id="{1887D913-D209-487F-A0C3-3C7F8867D5A2}"/>
+                <a16:creationId xmlns:a16="http://schemas.microsoft.com/office/drawing/2014/main" id="{584D23EA-39A1-49B5-B969-8AC4B88E7E72}"/>
               </a:ext>
             </a:extLst>
           </p:cNvPr>
@@ -8416,7 +8416,7 @@
           <p:cNvPr id="7" name="">
             <a:extLst xmlns:a="http://schemas.openxmlformats.org/drawingml/2006/main">
               <a:ext uri="{FF2B5EF4-FFF2-40B4-BE49-F238E27FC236}">
-                <a16:creationId xmlns:a16="http://schemas.microsoft.com/office/drawing/2014/main" id="{38C2F228-C04C-40F3-801D-4B809286C2ED}"/>
+                <a16:creationId xmlns:a16="http://schemas.microsoft.com/office/drawing/2014/main" id="{A684D5E1-5386-4683-965B-99A100AD900D}"/>
               </a:ext>
             </a:extLst>
           </p:cNvPr>
@@ -8474,7 +8474,7 @@
           <p:cNvPr id="8" name="">
             <a:extLst xmlns:a="http://schemas.openxmlformats.org/drawingml/2006/main">
               <a:ext uri="{FF2B5EF4-FFF2-40B4-BE49-F238E27FC236}">
-                <a16:creationId xmlns:a16="http://schemas.microsoft.com/office/drawing/2014/main" id="{0AD65584-33B5-47DD-BDBE-0E653052F3F2}"/>
+                <a16:creationId xmlns:a16="http://schemas.microsoft.com/office/drawing/2014/main" id="{F1D6C0F1-F159-44A2-8F02-EE42CE91F786}"/>
               </a:ext>
             </a:extLst>
           </p:cNvPr>
@@ -8532,7 +8532,7 @@
           <p:cNvPr id="9" name="">
             <a:extLst xmlns:a="http://schemas.openxmlformats.org/drawingml/2006/main">
               <a:ext uri="{FF2B5EF4-FFF2-40B4-BE49-F238E27FC236}">
-                <a16:creationId xmlns:a16="http://schemas.microsoft.com/office/drawing/2014/main" id="{55BAFC10-2013-4657-ADDA-34B0CC96E2C5}"/>
+                <a16:creationId xmlns:a16="http://schemas.microsoft.com/office/drawing/2014/main" id="{AB98CA39-DE83-4041-AB35-F4A33C7F47BA}"/>
               </a:ext>
             </a:extLst>
           </p:cNvPr>
@@ -8590,7 +8590,7 @@
           <p:cNvPr id="10" name="">
             <a:extLst xmlns:a="http://schemas.openxmlformats.org/drawingml/2006/main">
               <a:ext uri="{FF2B5EF4-FFF2-40B4-BE49-F238E27FC236}">
-                <a16:creationId xmlns:a16="http://schemas.microsoft.com/office/drawing/2014/main" id="{3C5F7795-F20F-4543-9ED3-220E9028F042}"/>
+                <a16:creationId xmlns:a16="http://schemas.microsoft.com/office/drawing/2014/main" id="{09865E78-3ED3-4E90-A863-04E5E36C85A0}"/>
               </a:ext>
             </a:extLst>
           </p:cNvPr>
@@ -8648,7 +8648,7 @@
           <p:cNvPr id="11" name="">
             <a:extLst xmlns:a="http://schemas.openxmlformats.org/drawingml/2006/main">
               <a:ext uri="{FF2B5EF4-FFF2-40B4-BE49-F238E27FC236}">
-                <a16:creationId xmlns:a16="http://schemas.microsoft.com/office/drawing/2014/main" id="{6D062D0D-D5CA-4397-90EE-66812F312942}"/>
+                <a16:creationId xmlns:a16="http://schemas.microsoft.com/office/drawing/2014/main" id="{AD4A7090-D43E-4239-9D8E-D7FFCBAB2469}"/>
               </a:ext>
             </a:extLst>
           </p:cNvPr>
@@ -8681,7 +8681,7 @@
           <p:cNvPr id="12" name="">
             <a:extLst xmlns:a="http://schemas.openxmlformats.org/drawingml/2006/main">
               <a:ext uri="{FF2B5EF4-FFF2-40B4-BE49-F238E27FC236}">
-                <a16:creationId xmlns:a16="http://schemas.microsoft.com/office/drawing/2014/main" id="{FEF49B06-187C-490F-AC77-66CF4E85E2E9}"/>
+                <a16:creationId xmlns:a16="http://schemas.microsoft.com/office/drawing/2014/main" id="{936D3D74-A8B6-44AB-8717-27C046859A92}"/>
               </a:ext>
             </a:extLst>
           </p:cNvPr>
@@ -8739,7 +8739,7 @@
           <p:cNvPr id="13" name="">
             <a:extLst xmlns:a="http://schemas.openxmlformats.org/drawingml/2006/main">
               <a:ext uri="{FF2B5EF4-FFF2-40B4-BE49-F238E27FC236}">
-                <a16:creationId xmlns:a16="http://schemas.microsoft.com/office/drawing/2014/main" id="{18150EB9-BE6A-4638-A2DF-B37BBD09F5EB}"/>
+                <a16:creationId xmlns:a16="http://schemas.microsoft.com/office/drawing/2014/main" id="{CFC65E3D-F0C7-4051-9792-7FD2BD240C9A}"/>
               </a:ext>
             </a:extLst>
           </p:cNvPr>
@@ -8797,7 +8797,7 @@
           <p:cNvPr id="14" name="">
             <a:extLst xmlns:a="http://schemas.openxmlformats.org/drawingml/2006/main">
               <a:ext uri="{FF2B5EF4-FFF2-40B4-BE49-F238E27FC236}">
-                <a16:creationId xmlns:a16="http://schemas.microsoft.com/office/drawing/2014/main" id="{3563E79A-2949-45FC-A3BB-A5922BEAABE7}"/>
+                <a16:creationId xmlns:a16="http://schemas.microsoft.com/office/drawing/2014/main" id="{2F8236CC-E050-46BC-95AD-4DC4EADDCAA4}"/>
               </a:ext>
             </a:extLst>
           </p:cNvPr>
@@ -8855,7 +8855,7 @@
           <p:cNvPr id="15" name="">
             <a:extLst xmlns:a="http://schemas.openxmlformats.org/drawingml/2006/main">
               <a:ext uri="{FF2B5EF4-FFF2-40B4-BE49-F238E27FC236}">
-                <a16:creationId xmlns:a16="http://schemas.microsoft.com/office/drawing/2014/main" id="{C85BFAF1-7209-4272-A594-73BAA6CE9377}"/>
+                <a16:creationId xmlns:a16="http://schemas.microsoft.com/office/drawing/2014/main" id="{4D718464-C75B-46A1-905C-3985491C644C}"/>
               </a:ext>
             </a:extLst>
           </p:cNvPr>
@@ -8890,7 +8890,7 @@
           <p:cNvPr id="16" name="">
             <a:extLst xmlns:a="http://schemas.openxmlformats.org/drawingml/2006/main">
               <a:ext uri="{FF2B5EF4-FFF2-40B4-BE49-F238E27FC236}">
-                <a16:creationId xmlns:a16="http://schemas.microsoft.com/office/drawing/2014/main" id="{9661EF5B-A562-41A3-81E4-807040C9FC2B}"/>
+                <a16:creationId xmlns:a16="http://schemas.microsoft.com/office/drawing/2014/main" id="{CA4CCD55-0D1E-467C-8A24-58626E4C3E82}"/>
               </a:ext>
             </a:extLst>
           </p:cNvPr>
@@ -8923,7 +8923,7 @@
           <p:cNvPr id="17" name="">
             <a:extLst xmlns:a="http://schemas.openxmlformats.org/drawingml/2006/main">
               <a:ext uri="{FF2B5EF4-FFF2-40B4-BE49-F238E27FC236}">
-                <a16:creationId xmlns:a16="http://schemas.microsoft.com/office/drawing/2014/main" id="{8A5B41BF-3FE1-495C-8543-17903D3D3483}"/>
+                <a16:creationId xmlns:a16="http://schemas.microsoft.com/office/drawing/2014/main" id="{BFC9C9D0-3B3A-4F1F-A79D-D95660405843}"/>
               </a:ext>
             </a:extLst>
           </p:cNvPr>
@@ -8981,7 +8981,7 @@
           <p:cNvPr id="18" name="">
             <a:extLst xmlns:a="http://schemas.openxmlformats.org/drawingml/2006/main">
               <a:ext uri="{FF2B5EF4-FFF2-40B4-BE49-F238E27FC236}">
-                <a16:creationId xmlns:a16="http://schemas.microsoft.com/office/drawing/2014/main" id="{F7582849-EDEF-4E00-AC33-B1E63DB50082}"/>
+                <a16:creationId xmlns:a16="http://schemas.microsoft.com/office/drawing/2014/main" id="{4F062ED4-9A04-4E05-9F9C-D06F93AB20B2}"/>
               </a:ext>
             </a:extLst>
           </p:cNvPr>
@@ -9039,7 +9039,7 @@
           <p:cNvPr id="19" name="">
             <a:extLst xmlns:a="http://schemas.openxmlformats.org/drawingml/2006/main">
               <a:ext uri="{FF2B5EF4-FFF2-40B4-BE49-F238E27FC236}">
-                <a16:creationId xmlns:a16="http://schemas.microsoft.com/office/drawing/2014/main" id="{F368836A-0F2E-4A18-A1CF-F29F9770C546}"/>
+                <a16:creationId xmlns:a16="http://schemas.microsoft.com/office/drawing/2014/main" id="{0309E4B3-7D26-4139-AFA2-608869FDC4DB}"/>
               </a:ext>
             </a:extLst>
           </p:cNvPr>
@@ -9087,7 +9087,7 @@
                 <a:ea typeface="Aptos"/>
                 <a:cs typeface="Aptos"/>
               </a:rPr>
-              <a:t>59/100</a:t>
+              <a:t>60/100</a:t>
             </a:r>
           </a:p>
         </p:txBody>
@@ -9097,7 +9097,7 @@
           <p:cNvPr id="20" name="">
             <a:extLst xmlns:a="http://schemas.openxmlformats.org/drawingml/2006/main">
               <a:ext uri="{FF2B5EF4-FFF2-40B4-BE49-F238E27FC236}">
-                <a16:creationId xmlns:a16="http://schemas.microsoft.com/office/drawing/2014/main" id="{A1493443-DB71-4E1E-89D5-732C517364C2}"/>
+                <a16:creationId xmlns:a16="http://schemas.microsoft.com/office/drawing/2014/main" id="{08F23992-85C6-47BB-893A-6F3B39A0B98D}"/>
               </a:ext>
             </a:extLst>
           </p:cNvPr>
@@ -9155,7 +9155,7 @@
           <p:cNvPr id="21" name="">
             <a:extLst xmlns:a="http://schemas.openxmlformats.org/drawingml/2006/main">
               <a:ext uri="{FF2B5EF4-FFF2-40B4-BE49-F238E27FC236}">
-                <a16:creationId xmlns:a16="http://schemas.microsoft.com/office/drawing/2014/main" id="{739396E5-4810-4DE3-A616-3F9BEF875201}"/>
+                <a16:creationId xmlns:a16="http://schemas.microsoft.com/office/drawing/2014/main" id="{4C6559AF-0242-4164-99AB-7844249A4BED}"/>
               </a:ext>
             </a:extLst>
           </p:cNvPr>
@@ -9188,7 +9188,7 @@
           <p:cNvPr id="22" name="">
             <a:extLst xmlns:a="http://schemas.openxmlformats.org/drawingml/2006/main">
               <a:ext uri="{FF2B5EF4-FFF2-40B4-BE49-F238E27FC236}">
-                <a16:creationId xmlns:a16="http://schemas.microsoft.com/office/drawing/2014/main" id="{02AE3F13-3D27-42BD-82DA-21F3EDB6508F}"/>
+                <a16:creationId xmlns:a16="http://schemas.microsoft.com/office/drawing/2014/main" id="{19C733C1-B876-42DE-A2F5-AC3D66055376}"/>
               </a:ext>
             </a:extLst>
           </p:cNvPr>
@@ -9246,7 +9246,7 @@
           <p:cNvPr id="23" name="">
             <a:extLst xmlns:a="http://schemas.openxmlformats.org/drawingml/2006/main">
               <a:ext uri="{FF2B5EF4-FFF2-40B4-BE49-F238E27FC236}">
-                <a16:creationId xmlns:a16="http://schemas.microsoft.com/office/drawing/2014/main" id="{9E2E487B-2B6F-43FB-9BE3-76BDC4955ACC}"/>
+                <a16:creationId xmlns:a16="http://schemas.microsoft.com/office/drawing/2014/main" id="{2A07057B-4E7D-4A5F-924D-DD71190403A3}"/>
               </a:ext>
             </a:extLst>
           </p:cNvPr>
@@ -9304,7 +9304,7 @@
           <p:cNvPr id="24" name="">
             <a:extLst xmlns:a="http://schemas.openxmlformats.org/drawingml/2006/main">
               <a:ext uri="{FF2B5EF4-FFF2-40B4-BE49-F238E27FC236}">
-                <a16:creationId xmlns:a16="http://schemas.microsoft.com/office/drawing/2014/main" id="{FE463942-FC38-43C6-AE02-01829A67AD73}"/>
+                <a16:creationId xmlns:a16="http://schemas.microsoft.com/office/drawing/2014/main" id="{F6C3DB9A-7EF2-4650-BCEC-05C90F738432}"/>
               </a:ext>
             </a:extLst>
           </p:cNvPr>
@@ -9362,7 +9362,7 @@
           <p:cNvPr id="25" name="">
             <a:extLst xmlns:a="http://schemas.openxmlformats.org/drawingml/2006/main">
               <a:ext uri="{FF2B5EF4-FFF2-40B4-BE49-F238E27FC236}">
-                <a16:creationId xmlns:a16="http://schemas.microsoft.com/office/drawing/2014/main" id="{1BB02B50-A2BF-43C5-9355-1CC43862D5DF}"/>
+                <a16:creationId xmlns:a16="http://schemas.microsoft.com/office/drawing/2014/main" id="{AF4BB833-0F60-4E85-9908-73A92E875C44}"/>
               </a:ext>
             </a:extLst>
           </p:cNvPr>
@@ -9397,7 +9397,7 @@
           <p:cNvPr id="26" name="">
             <a:extLst xmlns:a="http://schemas.openxmlformats.org/drawingml/2006/main">
               <a:ext uri="{FF2B5EF4-FFF2-40B4-BE49-F238E27FC236}">
-                <a16:creationId xmlns:a16="http://schemas.microsoft.com/office/drawing/2014/main" id="{60626ABB-C9DB-4AF3-82D3-60C6CD090673}"/>
+                <a16:creationId xmlns:a16="http://schemas.microsoft.com/office/drawing/2014/main" id="{49E6B0E4-519A-4E62-8BAF-558D9273760A}"/>
               </a:ext>
             </a:extLst>
           </p:cNvPr>
@@ -9430,7 +9430,7 @@
           <p:cNvPr id="27" name="">
             <a:extLst xmlns:a="http://schemas.openxmlformats.org/drawingml/2006/main">
               <a:ext uri="{FF2B5EF4-FFF2-40B4-BE49-F238E27FC236}">
-                <a16:creationId xmlns:a16="http://schemas.microsoft.com/office/drawing/2014/main" id="{62003C73-F81A-4B25-88B8-FA24FE58DAAD}"/>
+                <a16:creationId xmlns:a16="http://schemas.microsoft.com/office/drawing/2014/main" id="{205AD7AB-0D9C-483D-B89D-CC62AC13385A}"/>
               </a:ext>
             </a:extLst>
           </p:cNvPr>
@@ -9488,7 +9488,7 @@
           <p:cNvPr id="28" name="">
             <a:extLst xmlns:a="http://schemas.openxmlformats.org/drawingml/2006/main">
               <a:ext uri="{FF2B5EF4-FFF2-40B4-BE49-F238E27FC236}">
-                <a16:creationId xmlns:a16="http://schemas.microsoft.com/office/drawing/2014/main" id="{1EA0EDE9-F84A-4895-B91E-02AB807BBE11}"/>
+                <a16:creationId xmlns:a16="http://schemas.microsoft.com/office/drawing/2014/main" id="{6966B345-492A-4F4E-BC76-8C7CE33FA319}"/>
               </a:ext>
             </a:extLst>
           </p:cNvPr>
@@ -9546,7 +9546,7 @@
           <p:cNvPr id="29" name="">
             <a:extLst xmlns:a="http://schemas.openxmlformats.org/drawingml/2006/main">
               <a:ext uri="{FF2B5EF4-FFF2-40B4-BE49-F238E27FC236}">
-                <a16:creationId xmlns:a16="http://schemas.microsoft.com/office/drawing/2014/main" id="{967C336A-F499-4922-B9AE-21EB10AF23F6}"/>
+                <a16:creationId xmlns:a16="http://schemas.microsoft.com/office/drawing/2014/main" id="{0BC47E0D-D068-4D4E-A077-B46EBF36D03C}"/>
               </a:ext>
             </a:extLst>
           </p:cNvPr>
@@ -9604,7 +9604,7 @@
           <p:cNvPr id="30" name="">
             <a:extLst xmlns:a="http://schemas.openxmlformats.org/drawingml/2006/main">
               <a:ext uri="{FF2B5EF4-FFF2-40B4-BE49-F238E27FC236}">
-                <a16:creationId xmlns:a16="http://schemas.microsoft.com/office/drawing/2014/main" id="{103DFC0C-431A-4E63-8BDC-C4291C2DE39D}"/>
+                <a16:creationId xmlns:a16="http://schemas.microsoft.com/office/drawing/2014/main" id="{9BA4936F-6414-4B07-872E-AD917B43EA8E}"/>
               </a:ext>
             </a:extLst>
           </p:cNvPr>
@@ -9662,7 +9662,7 @@
           <p:cNvPr id="31" name="">
             <a:extLst xmlns:a="http://schemas.openxmlformats.org/drawingml/2006/main">
               <a:ext uri="{FF2B5EF4-FFF2-40B4-BE49-F238E27FC236}">
-                <a16:creationId xmlns:a16="http://schemas.microsoft.com/office/drawing/2014/main" id="{5C8E11BC-FD51-429A-8F15-BE7A3E4E396F}"/>
+                <a16:creationId xmlns:a16="http://schemas.microsoft.com/office/drawing/2014/main" id="{24658716-2310-4626-B092-BD4345805A70}"/>
               </a:ext>
             </a:extLst>
           </p:cNvPr>
@@ -9695,7 +9695,7 @@
           <p:cNvPr id="32" name="">
             <a:extLst xmlns:a="http://schemas.openxmlformats.org/drawingml/2006/main">
               <a:ext uri="{FF2B5EF4-FFF2-40B4-BE49-F238E27FC236}">
-                <a16:creationId xmlns:a16="http://schemas.microsoft.com/office/drawing/2014/main" id="{B061CC56-3246-4EDC-9C38-5AE6F6A4A1F9}"/>
+                <a16:creationId xmlns:a16="http://schemas.microsoft.com/office/drawing/2014/main" id="{A7D27ADA-4553-4D76-B3DC-B3A0683EDE74}"/>
               </a:ext>
             </a:extLst>
           </p:cNvPr>
@@ -9753,7 +9753,7 @@
           <p:cNvPr id="33" name="">
             <a:extLst xmlns:a="http://schemas.openxmlformats.org/drawingml/2006/main">
               <a:ext uri="{FF2B5EF4-FFF2-40B4-BE49-F238E27FC236}">
-                <a16:creationId xmlns:a16="http://schemas.microsoft.com/office/drawing/2014/main" id="{C778481C-77A0-4F93-B986-421A1F3B6448}"/>
+                <a16:creationId xmlns:a16="http://schemas.microsoft.com/office/drawing/2014/main" id="{35906157-844D-461A-815B-DEACE3F7A24B}"/>
               </a:ext>
             </a:extLst>
           </p:cNvPr>
@@ -9811,7 +9811,7 @@
           <p:cNvPr id="34" name="">
             <a:extLst xmlns:a="http://schemas.openxmlformats.org/drawingml/2006/main">
               <a:ext uri="{FF2B5EF4-FFF2-40B4-BE49-F238E27FC236}">
-                <a16:creationId xmlns:a16="http://schemas.microsoft.com/office/drawing/2014/main" id="{E7AAB4BB-6ED7-41BE-BB05-B9F2DBAB45D8}"/>
+                <a16:creationId xmlns:a16="http://schemas.microsoft.com/office/drawing/2014/main" id="{4DB0D7C2-EFAC-4AEB-AF72-D0B32DEC62B4}"/>
               </a:ext>
             </a:extLst>
           </p:cNvPr>
@@ -9869,7 +9869,7 @@
           <p:cNvPr id="35" name="">
             <a:extLst xmlns:a="http://schemas.openxmlformats.org/drawingml/2006/main">
               <a:ext uri="{FF2B5EF4-FFF2-40B4-BE49-F238E27FC236}">
-                <a16:creationId xmlns:a16="http://schemas.microsoft.com/office/drawing/2014/main" id="{10346DCD-7B15-423C-8F1A-AFB925D697A5}"/>
+                <a16:creationId xmlns:a16="http://schemas.microsoft.com/office/drawing/2014/main" id="{53454FCA-1A96-48F8-A5DC-09699CE65248}"/>
               </a:ext>
             </a:extLst>
           </p:cNvPr>
@@ -9917,7 +9917,7 @@
                 <a:ea typeface="Aptos"/>
                 <a:cs typeface="Aptos"/>
               </a:rPr>
-              <a:t>WATERS NEXT GEN COMPETITIVE INTELLIGENCE · 08 SEP 2026 · waters-ci-20260909033329</a:t>
+              <a:t>WATERS NEXT GEN COMPETITIVE INTELLIGENCE · 09 SEP 2026 · waters-ci-20260909112945</a:t>
             </a:r>
           </a:p>
         </p:txBody>
@@ -9927,7 +9927,7 @@
           <p:cNvPr id="36" name="">
             <a:extLst xmlns:a="http://schemas.openxmlformats.org/drawingml/2006/main">
               <a:ext uri="{FF2B5EF4-FFF2-40B4-BE49-F238E27FC236}">
-                <a16:creationId xmlns:a16="http://schemas.microsoft.com/office/drawing/2014/main" id="{A1C43314-0335-4E22-8597-4A637AC7312C}"/>
+                <a16:creationId xmlns:a16="http://schemas.microsoft.com/office/drawing/2014/main" id="{18534EEA-1D10-478A-8F3A-40368BF6B1DC}"/>
               </a:ext>
             </a:extLst>
           </p:cNvPr>
@@ -9983,7 +9983,7 @@
     </p:spTree>
     <p:extLst>
       <p:ext uri="{BB962C8B-B14F-4D97-AF65-F5344CB8AC3E}">
-        <p14:creationId xmlns:p14="http://schemas.microsoft.com/office/powerpoint/2010/main" val="2019903095"/>
+        <p14:creationId xmlns:p14="http://schemas.microsoft.com/office/powerpoint/2010/main" val="1615002033"/>
       </p:ext>
     </p:extLst>
   </p:cSld>
@@ -10014,7 +10014,7 @@
           <p:cNvPr id="26" name="">
             <a:extLst xmlns:a="http://schemas.openxmlformats.org/drawingml/2006/main">
               <a:ext uri="{FF2B5EF4-FFF2-40B4-BE49-F238E27FC236}">
-                <a16:creationId xmlns:a16="http://schemas.microsoft.com/office/drawing/2014/main" id="{48E8FD3A-8459-4A61-AC79-840276A4E988}"/>
+                <a16:creationId xmlns:a16="http://schemas.microsoft.com/office/drawing/2014/main" id="{A85D94E8-0706-4C74-A785-F684C84E0305}"/>
               </a:ext>
             </a:extLst>
           </p:cNvPr>
@@ -10072,7 +10072,7 @@
           <p:cNvPr id="2" name="">
             <a:extLst xmlns:a="http://schemas.openxmlformats.org/drawingml/2006/main">
               <a:ext uri="{FF2B5EF4-FFF2-40B4-BE49-F238E27FC236}">
-                <a16:creationId xmlns:a16="http://schemas.microsoft.com/office/drawing/2014/main" id="{9CB88D58-408A-4FD8-9301-6B91076B91F6}"/>
+                <a16:creationId xmlns:a16="http://schemas.microsoft.com/office/drawing/2014/main" id="{B7E52171-CAB0-4146-956C-0066988585A8}"/>
               </a:ext>
             </a:extLst>
           </p:cNvPr>
@@ -10130,7 +10130,7 @@
           <p:cNvPr id="3" name="">
             <a:extLst xmlns:a="http://schemas.openxmlformats.org/drawingml/2006/main">
               <a:ext uri="{FF2B5EF4-FFF2-40B4-BE49-F238E27FC236}">
-                <a16:creationId xmlns:a16="http://schemas.microsoft.com/office/drawing/2014/main" id="{194C8058-4B3F-47DA-93BB-6EFD08D6A5F0}"/>
+                <a16:creationId xmlns:a16="http://schemas.microsoft.com/office/drawing/2014/main" id="{889C5799-3FDB-461C-9459-2B8B00751D25}"/>
               </a:ext>
             </a:extLst>
           </p:cNvPr>
@@ -10188,7 +10188,7 @@
           <p:cNvPr id="4" name="">
             <a:extLst xmlns:a="http://schemas.openxmlformats.org/drawingml/2006/main">
               <a:ext uri="{FF2B5EF4-FFF2-40B4-BE49-F238E27FC236}">
-                <a16:creationId xmlns:a16="http://schemas.microsoft.com/office/drawing/2014/main" id="{E011E1A5-D574-408F-AACD-4617C9169719}"/>
+                <a16:creationId xmlns:a16="http://schemas.microsoft.com/office/drawing/2014/main" id="{D5CC0E9D-A9D1-4FF3-84AE-4D3B3553037B}"/>
               </a:ext>
             </a:extLst>
           </p:cNvPr>
@@ -10221,7 +10221,7 @@
           <p:cNvPr id="5" name="">
             <a:extLst xmlns:a="http://schemas.openxmlformats.org/drawingml/2006/main">
               <a:ext uri="{FF2B5EF4-FFF2-40B4-BE49-F238E27FC236}">
-                <a16:creationId xmlns:a16="http://schemas.microsoft.com/office/drawing/2014/main" id="{C8329E57-F4A7-462E-8574-9F8DD7581055}"/>
+                <a16:creationId xmlns:a16="http://schemas.microsoft.com/office/drawing/2014/main" id="{624C34B2-54DA-4289-8142-7E1E30D501DC}"/>
               </a:ext>
             </a:extLst>
           </p:cNvPr>
@@ -10254,7 +10254,7 @@
           <p:cNvPr id="6" name="">
             <a:extLst xmlns:a="http://schemas.openxmlformats.org/drawingml/2006/main">
               <a:ext uri="{FF2B5EF4-FFF2-40B4-BE49-F238E27FC236}">
-                <a16:creationId xmlns:a16="http://schemas.microsoft.com/office/drawing/2014/main" id="{2F09599B-1CB3-414A-86DF-3124925F9E59}"/>
+                <a16:creationId xmlns:a16="http://schemas.microsoft.com/office/drawing/2014/main" id="{5015C516-010C-4399-9430-29B930C8A212}"/>
               </a:ext>
             </a:extLst>
           </p:cNvPr>
@@ -10289,7 +10289,7 @@
           <p:cNvPr id="7" name="">
             <a:extLst xmlns:a="http://schemas.openxmlformats.org/drawingml/2006/main">
               <a:ext uri="{FF2B5EF4-FFF2-40B4-BE49-F238E27FC236}">
-                <a16:creationId xmlns:a16="http://schemas.microsoft.com/office/drawing/2014/main" id="{B6755A14-971A-4BBD-840D-478B85FB90F7}"/>
+                <a16:creationId xmlns:a16="http://schemas.microsoft.com/office/drawing/2014/main" id="{C36D0BE3-E389-462E-B4E7-1070490FCC37}"/>
               </a:ext>
             </a:extLst>
           </p:cNvPr>
@@ -10347,7 +10347,7 @@
           <p:cNvPr id="8" name="">
             <a:extLst xmlns:a="http://schemas.openxmlformats.org/drawingml/2006/main">
               <a:ext uri="{FF2B5EF4-FFF2-40B4-BE49-F238E27FC236}">
-                <a16:creationId xmlns:a16="http://schemas.microsoft.com/office/drawing/2014/main" id="{7663F259-ED01-4648-987C-58844A6F2BC8}"/>
+                <a16:creationId xmlns:a16="http://schemas.microsoft.com/office/drawing/2014/main" id="{47061B23-C9E0-41DC-B87D-E9B8CCBE2DC8}"/>
               </a:ext>
             </a:extLst>
           </p:cNvPr>
@@ -10405,7 +10405,7 @@
           <p:cNvPr id="9" name="">
             <a:extLst xmlns:a="http://schemas.openxmlformats.org/drawingml/2006/main">
               <a:ext uri="{FF2B5EF4-FFF2-40B4-BE49-F238E27FC236}">
-                <a16:creationId xmlns:a16="http://schemas.microsoft.com/office/drawing/2014/main" id="{F44AE6A1-45C5-46CE-9179-3BE438455231}"/>
+                <a16:creationId xmlns:a16="http://schemas.microsoft.com/office/drawing/2014/main" id="{BB4E3FD3-C610-49FA-BDEB-1F1896BB0441}"/>
               </a:ext>
             </a:extLst>
           </p:cNvPr>
@@ -10463,7 +10463,7 @@
           <p:cNvPr id="10" name="">
             <a:extLst xmlns:a="http://schemas.openxmlformats.org/drawingml/2006/main">
               <a:ext uri="{FF2B5EF4-FFF2-40B4-BE49-F238E27FC236}">
-                <a16:creationId xmlns:a16="http://schemas.microsoft.com/office/drawing/2014/main" id="{CE36B55A-8849-488B-A2E5-C42DD6293BE3}"/>
+                <a16:creationId xmlns:a16="http://schemas.microsoft.com/office/drawing/2014/main" id="{A7F22FC1-C6A9-48A0-9975-BD4F3F01E8AD}"/>
               </a:ext>
             </a:extLst>
           </p:cNvPr>
@@ -10498,7 +10498,7 @@
           <p:cNvPr id="11" name="">
             <a:extLst xmlns:a="http://schemas.openxmlformats.org/drawingml/2006/main">
               <a:ext uri="{FF2B5EF4-FFF2-40B4-BE49-F238E27FC236}">
-                <a16:creationId xmlns:a16="http://schemas.microsoft.com/office/drawing/2014/main" id="{5C193B86-78B2-432D-B377-490A6E2C67BB}"/>
+                <a16:creationId xmlns:a16="http://schemas.microsoft.com/office/drawing/2014/main" id="{C2C5B95F-A5A9-4B03-80BF-7DA3AFF13A23}"/>
               </a:ext>
             </a:extLst>
           </p:cNvPr>
@@ -10556,7 +10556,7 @@
           <p:cNvPr id="12" name="">
             <a:extLst xmlns:a="http://schemas.openxmlformats.org/drawingml/2006/main">
               <a:ext uri="{FF2B5EF4-FFF2-40B4-BE49-F238E27FC236}">
-                <a16:creationId xmlns:a16="http://schemas.microsoft.com/office/drawing/2014/main" id="{ED6BB2CC-A721-46F1-9ACF-76DB3C8EEA96}"/>
+                <a16:creationId xmlns:a16="http://schemas.microsoft.com/office/drawing/2014/main" id="{AF266151-A88D-4312-AD6B-AEAB0DA130B9}"/>
               </a:ext>
             </a:extLst>
           </p:cNvPr>
@@ -10614,7 +10614,7 @@
           <p:cNvPr id="13" name="">
             <a:extLst xmlns:a="http://schemas.openxmlformats.org/drawingml/2006/main">
               <a:ext uri="{FF2B5EF4-FFF2-40B4-BE49-F238E27FC236}">
-                <a16:creationId xmlns:a16="http://schemas.microsoft.com/office/drawing/2014/main" id="{245B3890-1EF4-477F-A404-9E965686182B}"/>
+                <a16:creationId xmlns:a16="http://schemas.microsoft.com/office/drawing/2014/main" id="{F4E66F71-76D4-4F18-BE52-6B5E91B354B0}"/>
               </a:ext>
             </a:extLst>
           </p:cNvPr>
@@ -10672,7 +10672,7 @@
           <p:cNvPr id="14" name="">
             <a:extLst xmlns:a="http://schemas.openxmlformats.org/drawingml/2006/main">
               <a:ext uri="{FF2B5EF4-FFF2-40B4-BE49-F238E27FC236}">
-                <a16:creationId xmlns:a16="http://schemas.microsoft.com/office/drawing/2014/main" id="{27F2A9E6-2414-417C-8686-9D884EA1CEEC}"/>
+                <a16:creationId xmlns:a16="http://schemas.microsoft.com/office/drawing/2014/main" id="{93166028-BB3F-4AAD-B5BA-435E9E35DE7B}"/>
               </a:ext>
             </a:extLst>
           </p:cNvPr>
@@ -10707,7 +10707,7 @@
           <p:cNvPr id="15" name="">
             <a:extLst xmlns:a="http://schemas.openxmlformats.org/drawingml/2006/main">
               <a:ext uri="{FF2B5EF4-FFF2-40B4-BE49-F238E27FC236}">
-                <a16:creationId xmlns:a16="http://schemas.microsoft.com/office/drawing/2014/main" id="{93662EA4-4B38-45D4-BE86-34E021F1C414}"/>
+                <a16:creationId xmlns:a16="http://schemas.microsoft.com/office/drawing/2014/main" id="{71EDC104-C2B5-4E43-94E2-D75CA8A208B9}"/>
               </a:ext>
             </a:extLst>
           </p:cNvPr>
@@ -10765,7 +10765,7 @@
           <p:cNvPr id="16" name="">
             <a:extLst xmlns:a="http://schemas.openxmlformats.org/drawingml/2006/main">
               <a:ext uri="{FF2B5EF4-FFF2-40B4-BE49-F238E27FC236}">
-                <a16:creationId xmlns:a16="http://schemas.microsoft.com/office/drawing/2014/main" id="{9B0DFC29-9618-4DD9-A849-2B3FFD6F65B5}"/>
+                <a16:creationId xmlns:a16="http://schemas.microsoft.com/office/drawing/2014/main" id="{EB341E2F-F277-400B-B5FA-5596E99966FB}"/>
               </a:ext>
             </a:extLst>
           </p:cNvPr>
@@ -10823,7 +10823,7 @@
           <p:cNvPr id="17" name="">
             <a:extLst xmlns:a="http://schemas.openxmlformats.org/drawingml/2006/main">
               <a:ext uri="{FF2B5EF4-FFF2-40B4-BE49-F238E27FC236}">
-                <a16:creationId xmlns:a16="http://schemas.microsoft.com/office/drawing/2014/main" id="{A692ED1F-AFDE-4323-9AD6-4AF85D75DF4B}"/>
+                <a16:creationId xmlns:a16="http://schemas.microsoft.com/office/drawing/2014/main" id="{96BB9EE6-DAB4-4576-A7C4-FCEA7060BE0A}"/>
               </a:ext>
             </a:extLst>
           </p:cNvPr>
@@ -10881,7 +10881,7 @@
           <p:cNvPr id="18" name="">
             <a:extLst xmlns:a="http://schemas.openxmlformats.org/drawingml/2006/main">
               <a:ext uri="{FF2B5EF4-FFF2-40B4-BE49-F238E27FC236}">
-                <a16:creationId xmlns:a16="http://schemas.microsoft.com/office/drawing/2014/main" id="{6DBA1503-A82B-4AF3-A33D-B7D8336211F5}"/>
+                <a16:creationId xmlns:a16="http://schemas.microsoft.com/office/drawing/2014/main" id="{8250A084-8949-460A-AD34-8BE375A769FF}"/>
               </a:ext>
             </a:extLst>
           </p:cNvPr>
@@ -10916,7 +10916,7 @@
           <p:cNvPr id="19" name="">
             <a:extLst xmlns:a="http://schemas.openxmlformats.org/drawingml/2006/main">
               <a:ext uri="{FF2B5EF4-FFF2-40B4-BE49-F238E27FC236}">
-                <a16:creationId xmlns:a16="http://schemas.microsoft.com/office/drawing/2014/main" id="{B6918A57-460E-45DF-817D-99694494E06B}"/>
+                <a16:creationId xmlns:a16="http://schemas.microsoft.com/office/drawing/2014/main" id="{4305DC72-967E-4A71-81AD-C11E54C53F32}"/>
               </a:ext>
             </a:extLst>
           </p:cNvPr>
@@ -10974,7 +10974,7 @@
           <p:cNvPr id="20" name="">
             <a:extLst xmlns:a="http://schemas.openxmlformats.org/drawingml/2006/main">
               <a:ext uri="{FF2B5EF4-FFF2-40B4-BE49-F238E27FC236}">
-                <a16:creationId xmlns:a16="http://schemas.microsoft.com/office/drawing/2014/main" id="{F08AD090-1542-48A2-A230-E1420DFD2E58}"/>
+                <a16:creationId xmlns:a16="http://schemas.microsoft.com/office/drawing/2014/main" id="{0A306023-12D9-40A7-8616-B394999975AE}"/>
               </a:ext>
             </a:extLst>
           </p:cNvPr>
@@ -11032,7 +11032,7 @@
           <p:cNvPr id="21" name="">
             <a:extLst xmlns:a="http://schemas.openxmlformats.org/drawingml/2006/main">
               <a:ext uri="{FF2B5EF4-FFF2-40B4-BE49-F238E27FC236}">
-                <a16:creationId xmlns:a16="http://schemas.microsoft.com/office/drawing/2014/main" id="{4A33DD07-DAF7-44B5-AF6A-558BBE047AFE}"/>
+                <a16:creationId xmlns:a16="http://schemas.microsoft.com/office/drawing/2014/main" id="{A9C889D2-B363-4F95-9DD5-70B222824EBA}"/>
               </a:ext>
             </a:extLst>
           </p:cNvPr>
@@ -11090,7 +11090,7 @@
           <p:cNvPr id="22" name="">
             <a:extLst xmlns:a="http://schemas.openxmlformats.org/drawingml/2006/main">
               <a:ext uri="{FF2B5EF4-FFF2-40B4-BE49-F238E27FC236}">
-                <a16:creationId xmlns:a16="http://schemas.microsoft.com/office/drawing/2014/main" id="{D0A4EBCE-3389-45D6-935C-669879730089}"/>
+                <a16:creationId xmlns:a16="http://schemas.microsoft.com/office/drawing/2014/main" id="{33139A98-08A1-4BD4-9D86-A6BB93A79607}"/>
               </a:ext>
             </a:extLst>
           </p:cNvPr>
@@ -11125,7 +11125,7 @@
           <p:cNvPr id="23" name="">
             <a:extLst xmlns:a="http://schemas.openxmlformats.org/drawingml/2006/main">
               <a:ext uri="{FF2B5EF4-FFF2-40B4-BE49-F238E27FC236}">
-                <a16:creationId xmlns:a16="http://schemas.microsoft.com/office/drawing/2014/main" id="{D473ECCB-CDF4-4591-A874-C060D896827D}"/>
+                <a16:creationId xmlns:a16="http://schemas.microsoft.com/office/drawing/2014/main" id="{7452B773-978E-42BC-93E3-4D5000696F5E}"/>
               </a:ext>
             </a:extLst>
           </p:cNvPr>
@@ -11183,7 +11183,7 @@
           <p:cNvPr id="24" name="">
             <a:extLst xmlns:a="http://schemas.openxmlformats.org/drawingml/2006/main">
               <a:ext uri="{FF2B5EF4-FFF2-40B4-BE49-F238E27FC236}">
-                <a16:creationId xmlns:a16="http://schemas.microsoft.com/office/drawing/2014/main" id="{EC75E46C-8CBE-4552-83EC-3DBC1744A8D9}"/>
+                <a16:creationId xmlns:a16="http://schemas.microsoft.com/office/drawing/2014/main" id="{D76AC0EC-2E96-4BD4-B5C6-ADDA18D8E821}"/>
               </a:ext>
             </a:extLst>
           </p:cNvPr>
@@ -11231,7 +11231,7 @@
                 <a:ea typeface="Aptos"/>
                 <a:cs typeface="Aptos"/>
               </a:rPr>
-              <a:t>WATERS NEXT GEN COMPETITIVE INTELLIGENCE · 08 SEP 2026 · waters-ci-20260909033329</a:t>
+              <a:t>WATERS NEXT GEN COMPETITIVE INTELLIGENCE · 09 SEP 2026 · waters-ci-20260909112945</a:t>
             </a:r>
           </a:p>
         </p:txBody>
@@ -11241,7 +11241,7 @@
           <p:cNvPr id="25" name="">
             <a:extLst xmlns:a="http://schemas.openxmlformats.org/drawingml/2006/main">
               <a:ext uri="{FF2B5EF4-FFF2-40B4-BE49-F238E27FC236}">
-                <a16:creationId xmlns:a16="http://schemas.microsoft.com/office/drawing/2014/main" id="{005754BA-37DC-4CC3-AF58-3499C75FD2A5}"/>
+                <a16:creationId xmlns:a16="http://schemas.microsoft.com/office/drawing/2014/main" id="{FAC61558-25A3-46D1-A16C-E321F7E5E2CA}"/>
               </a:ext>
             </a:extLst>
           </p:cNvPr>
@@ -11297,7 +11297,7 @@
     </p:spTree>
     <p:extLst>
       <p:ext uri="{BB962C8B-B14F-4D97-AF65-F5344CB8AC3E}">
-        <p14:creationId xmlns:p14="http://schemas.microsoft.com/office/powerpoint/2010/main" val="2086102211"/>
+        <p14:creationId xmlns:p14="http://schemas.microsoft.com/office/powerpoint/2010/main" val="1282611542"/>
       </p:ext>
     </p:extLst>
   </p:cSld>
@@ -11328,7 +11328,7 @@
           <p:cNvPr id="38" name="">
             <a:extLst xmlns:a="http://schemas.openxmlformats.org/drawingml/2006/main">
               <a:ext uri="{FF2B5EF4-FFF2-40B4-BE49-F238E27FC236}">
-                <a16:creationId xmlns:a16="http://schemas.microsoft.com/office/drawing/2014/main" id="{B55D4D5C-9F5C-4EEE-A38B-44BD138132E7}"/>
+                <a16:creationId xmlns:a16="http://schemas.microsoft.com/office/drawing/2014/main" id="{3BAF95BC-20D2-41D4-9B41-7A98B786377F}"/>
               </a:ext>
             </a:extLst>
           </p:cNvPr>
@@ -11386,7 +11386,7 @@
           <p:cNvPr id="2" name="">
             <a:extLst xmlns:a="http://schemas.openxmlformats.org/drawingml/2006/main">
               <a:ext uri="{FF2B5EF4-FFF2-40B4-BE49-F238E27FC236}">
-                <a16:creationId xmlns:a16="http://schemas.microsoft.com/office/drawing/2014/main" id="{DEF4FC47-B810-4F48-B5F6-94990B506996}"/>
+                <a16:creationId xmlns:a16="http://schemas.microsoft.com/office/drawing/2014/main" id="{B6A72877-A5D8-4439-80EA-D21C023C2B2D}"/>
               </a:ext>
             </a:extLst>
           </p:cNvPr>
@@ -11444,7 +11444,7 @@
           <p:cNvPr id="3" name="">
             <a:extLst xmlns:a="http://schemas.openxmlformats.org/drawingml/2006/main">
               <a:ext uri="{FF2B5EF4-FFF2-40B4-BE49-F238E27FC236}">
-                <a16:creationId xmlns:a16="http://schemas.microsoft.com/office/drawing/2014/main" id="{CD501A0C-71B7-45A0-B0FE-6616EDAC4EB4}"/>
+                <a16:creationId xmlns:a16="http://schemas.microsoft.com/office/drawing/2014/main" id="{3A982968-7BAF-45F6-BA4D-4ED4C3A20999}"/>
               </a:ext>
             </a:extLst>
           </p:cNvPr>
@@ -11502,7 +11502,7 @@
           <p:cNvPr id="4" name="">
             <a:extLst xmlns:a="http://schemas.openxmlformats.org/drawingml/2006/main">
               <a:ext uri="{FF2B5EF4-FFF2-40B4-BE49-F238E27FC236}">
-                <a16:creationId xmlns:a16="http://schemas.microsoft.com/office/drawing/2014/main" id="{650997A8-C8B5-4370-9354-A45E307436A1}"/>
+                <a16:creationId xmlns:a16="http://schemas.microsoft.com/office/drawing/2014/main" id="{7EDF386E-C4C6-4188-87B5-49DA9BC4E7FC}"/>
               </a:ext>
             </a:extLst>
           </p:cNvPr>
@@ -11535,7 +11535,7 @@
           <p:cNvPr id="5" name="">
             <a:extLst xmlns:a="http://schemas.openxmlformats.org/drawingml/2006/main">
               <a:ext uri="{FF2B5EF4-FFF2-40B4-BE49-F238E27FC236}">
-                <a16:creationId xmlns:a16="http://schemas.microsoft.com/office/drawing/2014/main" id="{6737013B-51EA-4B3F-8932-4E087CF2AB24}"/>
+                <a16:creationId xmlns:a16="http://schemas.microsoft.com/office/drawing/2014/main" id="{902978F0-7D7E-4FE8-B7E3-B7CE162053D0}"/>
               </a:ext>
             </a:extLst>
           </p:cNvPr>
@@ -11593,7 +11593,7 @@
           <p:cNvPr id="6" name="">
             <a:extLst xmlns:a="http://schemas.openxmlformats.org/drawingml/2006/main">
               <a:ext uri="{FF2B5EF4-FFF2-40B4-BE49-F238E27FC236}">
-                <a16:creationId xmlns:a16="http://schemas.microsoft.com/office/drawing/2014/main" id="{D50B1FE5-3DBD-46CB-BBF4-D990892E0D4B}"/>
+                <a16:creationId xmlns:a16="http://schemas.microsoft.com/office/drawing/2014/main" id="{F50760F0-759E-48D1-A08F-8BEBE7709018}"/>
               </a:ext>
             </a:extLst>
           </p:cNvPr>
@@ -11651,7 +11651,7 @@
           <p:cNvPr id="7" name="">
             <a:extLst xmlns:a="http://schemas.openxmlformats.org/drawingml/2006/main">
               <a:ext uri="{FF2B5EF4-FFF2-40B4-BE49-F238E27FC236}">
-                <a16:creationId xmlns:a16="http://schemas.microsoft.com/office/drawing/2014/main" id="{59712450-3082-4E76-ADB6-E3F9FD5E60CA}"/>
+                <a16:creationId xmlns:a16="http://schemas.microsoft.com/office/drawing/2014/main" id="{F39D8E63-C06C-4AF9-9A57-7F643C1E2F5C}"/>
               </a:ext>
             </a:extLst>
           </p:cNvPr>
@@ -11707,10 +11707,10 @@
       <p:sp>
         <p:nvSpPr>
           <p:cNvPr id="8" name="">
-            <a:hlinkClick xmlns:r="http://schemas.openxmlformats.org/officeDocument/2006/relationships" xmlns:a="http://schemas.openxmlformats.org/drawingml/2006/main" r:id="R6d4c323dd6574944"/>
-            <a:extLst xmlns:a="http://schemas.openxmlformats.org/drawingml/2006/main">
-              <a:ext uri="{FF2B5EF4-FFF2-40B4-BE49-F238E27FC236}">
-                <a16:creationId xmlns:a16="http://schemas.microsoft.com/office/drawing/2014/main" id="{C4D6D21B-F745-4658-B49C-2F500345988F}"/>
+            <a:hlinkClick xmlns:r="http://schemas.openxmlformats.org/officeDocument/2006/relationships" xmlns:a="http://schemas.openxmlformats.org/drawingml/2006/main" r:id="R5ca3a74df9b24f7b"/>
+            <a:extLst xmlns:a="http://schemas.openxmlformats.org/drawingml/2006/main">
+              <a:ext uri="{FF2B5EF4-FFF2-40B4-BE49-F238E27FC236}">
+                <a16:creationId xmlns:a16="http://schemas.microsoft.com/office/drawing/2014/main" id="{C356FB99-75A5-4636-8DB4-6CA98136C0C4}"/>
               </a:ext>
             </a:extLst>
           </p:cNvPr>
@@ -11758,7 +11758,7 @@
                 <a:ea typeface="Aptos"/>
                 <a:cs typeface="Aptos"/>
               </a:rPr>
-              <a:t>https://pubmed.ncbi.nlm.nih.gov/?term=%28%28PFAS+OR+%22per-+and+polyfluoroalkyl%22%29+AND+%28%22LC-MS%22+OR+%22LC-MS%2FMS%22+OR+chromatography%29%29+AND+%28%222025%2F09%2F08%22%5BDate+-+Publication%5D+%3A+%222026%2F09%2F08%22%5BDate+-+Publication%5D%29</a:t>
+              <a:t>https://pubmed.ncbi.nlm.nih.gov/?term=%28%28PFAS+OR+%22per-+and+polyfluoroalkyl%22%29+AND+%28%22LC-MS%22+OR+%22LC-MS%2FMS%22+OR+chromatography%29%29+AND+%28%222025%2F09%2F09%22%5BDate+-+Publication%5D+%3A+%222026%2F09%2F09%22%5BDate+-+Publication%5D%29</a:t>
             </a:r>
           </a:p>
         </p:txBody>
@@ -11768,7 +11768,7 @@
           <p:cNvPr id="9" name="">
             <a:extLst xmlns:a="http://schemas.openxmlformats.org/drawingml/2006/main">
               <a:ext uri="{FF2B5EF4-FFF2-40B4-BE49-F238E27FC236}">
-                <a16:creationId xmlns:a16="http://schemas.microsoft.com/office/drawing/2014/main" id="{5FBBAE10-AB06-45F3-8BE7-89E5D3B13A2E}"/>
+                <a16:creationId xmlns:a16="http://schemas.microsoft.com/office/drawing/2014/main" id="{CE121BEA-204F-436A-98D0-8C9E4D952871}"/>
               </a:ext>
             </a:extLst>
           </p:cNvPr>
@@ -11801,7 +11801,7 @@
           <p:cNvPr id="10" name="">
             <a:extLst xmlns:a="http://schemas.openxmlformats.org/drawingml/2006/main">
               <a:ext uri="{FF2B5EF4-FFF2-40B4-BE49-F238E27FC236}">
-                <a16:creationId xmlns:a16="http://schemas.microsoft.com/office/drawing/2014/main" id="{F18BB141-BF28-469E-BF19-28700BAFC16A}"/>
+                <a16:creationId xmlns:a16="http://schemas.microsoft.com/office/drawing/2014/main" id="{9355D116-6FBB-444E-A8EC-ECDB36BA23C7}"/>
               </a:ext>
             </a:extLst>
           </p:cNvPr>
@@ -11859,7 +11859,7 @@
           <p:cNvPr id="11" name="">
             <a:extLst xmlns:a="http://schemas.openxmlformats.org/drawingml/2006/main">
               <a:ext uri="{FF2B5EF4-FFF2-40B4-BE49-F238E27FC236}">
-                <a16:creationId xmlns:a16="http://schemas.microsoft.com/office/drawing/2014/main" id="{D80319B6-5A09-4197-867E-92E1F95F56A7}"/>
+                <a16:creationId xmlns:a16="http://schemas.microsoft.com/office/drawing/2014/main" id="{53ADC45F-4FE5-4FAB-AACF-8CF76EA77085}"/>
               </a:ext>
             </a:extLst>
           </p:cNvPr>
@@ -11917,7 +11917,7 @@
           <p:cNvPr id="12" name="">
             <a:extLst xmlns:a="http://schemas.openxmlformats.org/drawingml/2006/main">
               <a:ext uri="{FF2B5EF4-FFF2-40B4-BE49-F238E27FC236}">
-                <a16:creationId xmlns:a16="http://schemas.microsoft.com/office/drawing/2014/main" id="{F13A2F36-3617-4766-AF0E-05E0051577A2}"/>
+                <a16:creationId xmlns:a16="http://schemas.microsoft.com/office/drawing/2014/main" id="{7896C773-62A3-40F2-A40A-6D1A2DC9880E}"/>
               </a:ext>
             </a:extLst>
           </p:cNvPr>
@@ -11973,10 +11973,10 @@
       <p:sp>
         <p:nvSpPr>
           <p:cNvPr id="13" name="">
-            <a:hlinkClick xmlns:r="http://schemas.openxmlformats.org/officeDocument/2006/relationships" xmlns:a="http://schemas.openxmlformats.org/drawingml/2006/main" r:id="R8e289cb36d114974"/>
-            <a:extLst xmlns:a="http://schemas.openxmlformats.org/drawingml/2006/main">
-              <a:ext uri="{FF2B5EF4-FFF2-40B4-BE49-F238E27FC236}">
-                <a16:creationId xmlns:a16="http://schemas.microsoft.com/office/drawing/2014/main" id="{B4397338-7A21-4C4B-85A7-0D2F2735A6BE}"/>
+            <a:hlinkClick xmlns:r="http://schemas.openxmlformats.org/officeDocument/2006/relationships" xmlns:a="http://schemas.openxmlformats.org/drawingml/2006/main" r:id="R30c6b86e035c4548"/>
+            <a:extLst xmlns:a="http://schemas.openxmlformats.org/drawingml/2006/main">
+              <a:ext uri="{FF2B5EF4-FFF2-40B4-BE49-F238E27FC236}">
+                <a16:creationId xmlns:a16="http://schemas.microsoft.com/office/drawing/2014/main" id="{1A2BCB05-8143-405A-9553-E07C5DDEBCAD}"/>
               </a:ext>
             </a:extLst>
           </p:cNvPr>
@@ -12034,7 +12034,7 @@
           <p:cNvPr id="14" name="">
             <a:extLst xmlns:a="http://schemas.openxmlformats.org/drawingml/2006/main">
               <a:ext uri="{FF2B5EF4-FFF2-40B4-BE49-F238E27FC236}">
-                <a16:creationId xmlns:a16="http://schemas.microsoft.com/office/drawing/2014/main" id="{CF320426-18D8-4A5E-B243-5411941C6C59}"/>
+                <a16:creationId xmlns:a16="http://schemas.microsoft.com/office/drawing/2014/main" id="{02628B9A-F78C-48C6-ADBE-9EB72D2E57A8}"/>
               </a:ext>
             </a:extLst>
           </p:cNvPr>
@@ -12067,7 +12067,7 @@
           <p:cNvPr id="15" name="">
             <a:extLst xmlns:a="http://schemas.openxmlformats.org/drawingml/2006/main">
               <a:ext uri="{FF2B5EF4-FFF2-40B4-BE49-F238E27FC236}">
-                <a16:creationId xmlns:a16="http://schemas.microsoft.com/office/drawing/2014/main" id="{7F3C5C9B-6119-4EC9-8B3A-D5EAFD361881}"/>
+                <a16:creationId xmlns:a16="http://schemas.microsoft.com/office/drawing/2014/main" id="{6EED42FF-065B-46FF-941C-AA6B88EF402C}"/>
               </a:ext>
             </a:extLst>
           </p:cNvPr>
@@ -12125,7 +12125,7 @@
           <p:cNvPr id="16" name="">
             <a:extLst xmlns:a="http://schemas.openxmlformats.org/drawingml/2006/main">
               <a:ext uri="{FF2B5EF4-FFF2-40B4-BE49-F238E27FC236}">
-                <a16:creationId xmlns:a16="http://schemas.microsoft.com/office/drawing/2014/main" id="{6AA737F2-EFE9-4237-9A1A-BBD5C825C55E}"/>
+                <a16:creationId xmlns:a16="http://schemas.microsoft.com/office/drawing/2014/main" id="{23756B1C-7126-46B8-8D11-AA8EB41E3B61}"/>
               </a:ext>
             </a:extLst>
           </p:cNvPr>
@@ -12183,7 +12183,7 @@
           <p:cNvPr id="17" name="">
             <a:extLst xmlns:a="http://schemas.openxmlformats.org/drawingml/2006/main">
               <a:ext uri="{FF2B5EF4-FFF2-40B4-BE49-F238E27FC236}">
-                <a16:creationId xmlns:a16="http://schemas.microsoft.com/office/drawing/2014/main" id="{84B0A9A5-E369-41A1-B7F5-362145FBDCA9}"/>
+                <a16:creationId xmlns:a16="http://schemas.microsoft.com/office/drawing/2014/main" id="{56C85A41-8BD0-45D6-850B-C0895189756C}"/>
               </a:ext>
             </a:extLst>
           </p:cNvPr>
@@ -12239,10 +12239,10 @@
       <p:sp>
         <p:nvSpPr>
           <p:cNvPr id="18" name="">
-            <a:hlinkClick xmlns:r="http://schemas.openxmlformats.org/officeDocument/2006/relationships" xmlns:a="http://schemas.openxmlformats.org/drawingml/2006/main" r:id="R64748f282f2e4f8c"/>
-            <a:extLst xmlns:a="http://schemas.openxmlformats.org/drawingml/2006/main">
-              <a:ext uri="{FF2B5EF4-FFF2-40B4-BE49-F238E27FC236}">
-                <a16:creationId xmlns:a16="http://schemas.microsoft.com/office/drawing/2014/main" id="{459E757F-93D4-4E2F-81B5-F75D55F90BF1}"/>
+            <a:hlinkClick xmlns:r="http://schemas.openxmlformats.org/officeDocument/2006/relationships" xmlns:a="http://schemas.openxmlformats.org/drawingml/2006/main" r:id="R171e3dc593f54270"/>
+            <a:extLst xmlns:a="http://schemas.openxmlformats.org/drawingml/2006/main">
+              <a:ext uri="{FF2B5EF4-FFF2-40B4-BE49-F238E27FC236}">
+                <a16:creationId xmlns:a16="http://schemas.microsoft.com/office/drawing/2014/main" id="{83F33022-9A1A-4056-9E6E-82601F2F1E07}"/>
               </a:ext>
             </a:extLst>
           </p:cNvPr>
@@ -12300,7 +12300,7 @@
           <p:cNvPr id="19" name="">
             <a:extLst xmlns:a="http://schemas.openxmlformats.org/drawingml/2006/main">
               <a:ext uri="{FF2B5EF4-FFF2-40B4-BE49-F238E27FC236}">
-                <a16:creationId xmlns:a16="http://schemas.microsoft.com/office/drawing/2014/main" id="{F4593171-80DF-4507-B4F9-5A247E7944FA}"/>
+                <a16:creationId xmlns:a16="http://schemas.microsoft.com/office/drawing/2014/main" id="{C5444E43-0506-469B-A870-7480AC9DDA91}"/>
               </a:ext>
             </a:extLst>
           </p:cNvPr>
@@ -12333,7 +12333,7 @@
           <p:cNvPr id="20" name="">
             <a:extLst xmlns:a="http://schemas.openxmlformats.org/drawingml/2006/main">
               <a:ext uri="{FF2B5EF4-FFF2-40B4-BE49-F238E27FC236}">
-                <a16:creationId xmlns:a16="http://schemas.microsoft.com/office/drawing/2014/main" id="{320992BA-864D-4626-95C5-7D1480A3DFFC}"/>
+                <a16:creationId xmlns:a16="http://schemas.microsoft.com/office/drawing/2014/main" id="{FD71A2EE-AEA0-4D42-ACCD-5B99294C6E35}"/>
               </a:ext>
             </a:extLst>
           </p:cNvPr>
@@ -12391,7 +12391,7 @@
           <p:cNvPr id="21" name="">
             <a:extLst xmlns:a="http://schemas.openxmlformats.org/drawingml/2006/main">
               <a:ext uri="{FF2B5EF4-FFF2-40B4-BE49-F238E27FC236}">
-                <a16:creationId xmlns:a16="http://schemas.microsoft.com/office/drawing/2014/main" id="{256586F5-6E56-490A-8620-258E1A32AC68}"/>
+                <a16:creationId xmlns:a16="http://schemas.microsoft.com/office/drawing/2014/main" id="{42E521A3-1440-487C-A2CD-A71BF91DC4B3}"/>
               </a:ext>
             </a:extLst>
           </p:cNvPr>
@@ -12449,7 +12449,7 @@
           <p:cNvPr id="22" name="">
             <a:extLst xmlns:a="http://schemas.openxmlformats.org/drawingml/2006/main">
               <a:ext uri="{FF2B5EF4-FFF2-40B4-BE49-F238E27FC236}">
-                <a16:creationId xmlns:a16="http://schemas.microsoft.com/office/drawing/2014/main" id="{0C17563F-820F-4F7B-9C41-4519FE5B8CC7}"/>
+                <a16:creationId xmlns:a16="http://schemas.microsoft.com/office/drawing/2014/main" id="{86BDE670-2DEB-4E46-AC01-58F7F2D8395E}"/>
               </a:ext>
             </a:extLst>
           </p:cNvPr>
@@ -12505,10 +12505,10 @@
       <p:sp>
         <p:nvSpPr>
           <p:cNvPr id="23" name="">
-            <a:hlinkClick xmlns:r="http://schemas.openxmlformats.org/officeDocument/2006/relationships" xmlns:a="http://schemas.openxmlformats.org/drawingml/2006/main" r:id="Rb5dd03906cc546f3"/>
-            <a:extLst xmlns:a="http://schemas.openxmlformats.org/drawingml/2006/main">
-              <a:ext uri="{FF2B5EF4-FFF2-40B4-BE49-F238E27FC236}">
-                <a16:creationId xmlns:a16="http://schemas.microsoft.com/office/drawing/2014/main" id="{EEAC1A9B-9A3C-4E34-B877-2EE0E3122EBC}"/>
+            <a:hlinkClick xmlns:r="http://schemas.openxmlformats.org/officeDocument/2006/relationships" xmlns:a="http://schemas.openxmlformats.org/drawingml/2006/main" r:id="R76c6eceb8f624ad4"/>
+            <a:extLst xmlns:a="http://schemas.openxmlformats.org/drawingml/2006/main">
+              <a:ext uri="{FF2B5EF4-FFF2-40B4-BE49-F238E27FC236}">
+                <a16:creationId xmlns:a16="http://schemas.microsoft.com/office/drawing/2014/main" id="{CE552775-8184-43C8-A58D-8754BB1B1BB3}"/>
               </a:ext>
             </a:extLst>
           </p:cNvPr>
@@ -12566,7 +12566,7 @@
           <p:cNvPr id="24" name="">
             <a:extLst xmlns:a="http://schemas.openxmlformats.org/drawingml/2006/main">
               <a:ext uri="{FF2B5EF4-FFF2-40B4-BE49-F238E27FC236}">
-                <a16:creationId xmlns:a16="http://schemas.microsoft.com/office/drawing/2014/main" id="{0E1EEA08-E535-44FD-9864-0795DE064C9A}"/>
+                <a16:creationId xmlns:a16="http://schemas.microsoft.com/office/drawing/2014/main" id="{D932D7B9-EE0D-4456-A2F0-2F687099B5A2}"/>
               </a:ext>
             </a:extLst>
           </p:cNvPr>
@@ -12599,7 +12599,7 @@
           <p:cNvPr id="25" name="">
             <a:extLst xmlns:a="http://schemas.openxmlformats.org/drawingml/2006/main">
               <a:ext uri="{FF2B5EF4-FFF2-40B4-BE49-F238E27FC236}">
-                <a16:creationId xmlns:a16="http://schemas.microsoft.com/office/drawing/2014/main" id="{92424298-2677-4DDF-8C69-ED0288777EB6}"/>
+                <a16:creationId xmlns:a16="http://schemas.microsoft.com/office/drawing/2014/main" id="{76EBD36D-B4C5-4E09-B947-EF4866BF86BF}"/>
               </a:ext>
             </a:extLst>
           </p:cNvPr>
@@ -12657,7 +12657,7 @@
           <p:cNvPr id="26" name="">
             <a:extLst xmlns:a="http://schemas.openxmlformats.org/drawingml/2006/main">
               <a:ext uri="{FF2B5EF4-FFF2-40B4-BE49-F238E27FC236}">
-                <a16:creationId xmlns:a16="http://schemas.microsoft.com/office/drawing/2014/main" id="{68AA7128-F203-4D74-B1D0-0C2480CD8D8E}"/>
+                <a16:creationId xmlns:a16="http://schemas.microsoft.com/office/drawing/2014/main" id="{CF64EDA7-67A6-4BF3-906D-F1BC7D7C9604}"/>
               </a:ext>
             </a:extLst>
           </p:cNvPr>
@@ -12715,7 +12715,7 @@
           <p:cNvPr id="27" name="">
             <a:extLst xmlns:a="http://schemas.openxmlformats.org/drawingml/2006/main">
               <a:ext uri="{FF2B5EF4-FFF2-40B4-BE49-F238E27FC236}">
-                <a16:creationId xmlns:a16="http://schemas.microsoft.com/office/drawing/2014/main" id="{88E2878D-EAE5-41AD-A791-B7C1A842E452}"/>
+                <a16:creationId xmlns:a16="http://schemas.microsoft.com/office/drawing/2014/main" id="{CAA65020-EC26-4167-B101-AB6835E9A56A}"/>
               </a:ext>
             </a:extLst>
           </p:cNvPr>
@@ -12771,10 +12771,10 @@
       <p:sp>
         <p:nvSpPr>
           <p:cNvPr id="28" name="">
-            <a:hlinkClick xmlns:r="http://schemas.openxmlformats.org/officeDocument/2006/relationships" xmlns:a="http://schemas.openxmlformats.org/drawingml/2006/main" r:id="Ree4171d3a6de4212"/>
-            <a:extLst xmlns:a="http://schemas.openxmlformats.org/drawingml/2006/main">
-              <a:ext uri="{FF2B5EF4-FFF2-40B4-BE49-F238E27FC236}">
-                <a16:creationId xmlns:a16="http://schemas.microsoft.com/office/drawing/2014/main" id="{94848DB2-01AA-4C19-9BAA-B53CFC50763C}"/>
+            <a:hlinkClick xmlns:r="http://schemas.openxmlformats.org/officeDocument/2006/relationships" xmlns:a="http://schemas.openxmlformats.org/drawingml/2006/main" r:id="R1eef90a9958b4247"/>
+            <a:extLst xmlns:a="http://schemas.openxmlformats.org/drawingml/2006/main">
+              <a:ext uri="{FF2B5EF4-FFF2-40B4-BE49-F238E27FC236}">
+                <a16:creationId xmlns:a16="http://schemas.microsoft.com/office/drawing/2014/main" id="{AD1E8DDD-B430-452D-B3CD-38411DC09FDE}"/>
               </a:ext>
             </a:extLst>
           </p:cNvPr>
@@ -12832,7 +12832,7 @@
           <p:cNvPr id="29" name="">
             <a:extLst xmlns:a="http://schemas.openxmlformats.org/drawingml/2006/main">
               <a:ext uri="{FF2B5EF4-FFF2-40B4-BE49-F238E27FC236}">
-                <a16:creationId xmlns:a16="http://schemas.microsoft.com/office/drawing/2014/main" id="{9A262735-2670-495D-B2AC-B8FC9B5C6CA7}"/>
+                <a16:creationId xmlns:a16="http://schemas.microsoft.com/office/drawing/2014/main" id="{0E77579C-DAAE-4CB2-86CF-9DD5BA954F59}"/>
               </a:ext>
             </a:extLst>
           </p:cNvPr>
@@ -12865,7 +12865,7 @@
           <p:cNvPr id="30" name="">
             <a:extLst xmlns:a="http://schemas.openxmlformats.org/drawingml/2006/main">
               <a:ext uri="{FF2B5EF4-FFF2-40B4-BE49-F238E27FC236}">
-                <a16:creationId xmlns:a16="http://schemas.microsoft.com/office/drawing/2014/main" id="{E23B7785-AEA4-4C19-80FA-B1DA1933FF8F}"/>
+                <a16:creationId xmlns:a16="http://schemas.microsoft.com/office/drawing/2014/main" id="{73A7BC16-3361-4727-942C-4570B0D4CDC7}"/>
               </a:ext>
             </a:extLst>
           </p:cNvPr>
@@ -12923,7 +12923,7 @@
           <p:cNvPr id="31" name="">
             <a:extLst xmlns:a="http://schemas.openxmlformats.org/drawingml/2006/main">
               <a:ext uri="{FF2B5EF4-FFF2-40B4-BE49-F238E27FC236}">
-                <a16:creationId xmlns:a16="http://schemas.microsoft.com/office/drawing/2014/main" id="{4D7A5080-46B8-4957-BE69-B25785CAE615}"/>
+                <a16:creationId xmlns:a16="http://schemas.microsoft.com/office/drawing/2014/main" id="{4EB33D44-C45E-4F72-9D71-A2DF8E7C7A1E}"/>
               </a:ext>
             </a:extLst>
           </p:cNvPr>
@@ -12981,7 +12981,7 @@
           <p:cNvPr id="32" name="">
             <a:extLst xmlns:a="http://schemas.openxmlformats.org/drawingml/2006/main">
               <a:ext uri="{FF2B5EF4-FFF2-40B4-BE49-F238E27FC236}">
-                <a16:creationId xmlns:a16="http://schemas.microsoft.com/office/drawing/2014/main" id="{40859E58-D390-4860-BDA8-0F8A1BA661C5}"/>
+                <a16:creationId xmlns:a16="http://schemas.microsoft.com/office/drawing/2014/main" id="{AAEAEC77-0A7F-4742-9F64-AF7F0726C121}"/>
               </a:ext>
             </a:extLst>
           </p:cNvPr>
@@ -13037,10 +13037,10 @@
       <p:sp>
         <p:nvSpPr>
           <p:cNvPr id="33" name="">
-            <a:hlinkClick xmlns:r="http://schemas.openxmlformats.org/officeDocument/2006/relationships" xmlns:a="http://schemas.openxmlformats.org/drawingml/2006/main" r:id="R806c102c64dd43b2"/>
-            <a:extLst xmlns:a="http://schemas.openxmlformats.org/drawingml/2006/main">
-              <a:ext uri="{FF2B5EF4-FFF2-40B4-BE49-F238E27FC236}">
-                <a16:creationId xmlns:a16="http://schemas.microsoft.com/office/drawing/2014/main" id="{D597BD6C-FD26-4E82-9DF5-96ACED0FB9E9}"/>
+            <a:hlinkClick xmlns:r="http://schemas.openxmlformats.org/officeDocument/2006/relationships" xmlns:a="http://schemas.openxmlformats.org/drawingml/2006/main" r:id="Rf2130ad4a6a34843"/>
+            <a:extLst xmlns:a="http://schemas.openxmlformats.org/drawingml/2006/main">
+              <a:ext uri="{FF2B5EF4-FFF2-40B4-BE49-F238E27FC236}">
+                <a16:creationId xmlns:a16="http://schemas.microsoft.com/office/drawing/2014/main" id="{8EBEF3A7-E1F0-49C3-A172-DA59D0DB619D}"/>
               </a:ext>
             </a:extLst>
           </p:cNvPr>
@@ -13098,7 +13098,7 @@
           <p:cNvPr id="34" name="">
             <a:extLst xmlns:a="http://schemas.openxmlformats.org/drawingml/2006/main">
               <a:ext uri="{FF2B5EF4-FFF2-40B4-BE49-F238E27FC236}">
-                <a16:creationId xmlns:a16="http://schemas.microsoft.com/office/drawing/2014/main" id="{48027D20-B576-4DF9-8733-485424D71C61}"/>
+                <a16:creationId xmlns:a16="http://schemas.microsoft.com/office/drawing/2014/main" id="{77E0AECF-8B0C-4F26-8038-6331EC7CF591}"/>
               </a:ext>
             </a:extLst>
           </p:cNvPr>
@@ -13133,7 +13133,7 @@
           <p:cNvPr id="35" name="">
             <a:extLst xmlns:a="http://schemas.openxmlformats.org/drawingml/2006/main">
               <a:ext uri="{FF2B5EF4-FFF2-40B4-BE49-F238E27FC236}">
-                <a16:creationId xmlns:a16="http://schemas.microsoft.com/office/drawing/2014/main" id="{656E13B7-4749-4FFB-A475-658A53D90A3A}"/>
+                <a16:creationId xmlns:a16="http://schemas.microsoft.com/office/drawing/2014/main" id="{9E0C36E0-6BB4-41D8-A70B-D19C79FCC4D6}"/>
               </a:ext>
             </a:extLst>
           </p:cNvPr>
@@ -13181,7 +13181,7 @@
                 <a:ea typeface="Aptos"/>
                 <a:cs typeface="Aptos"/>
               </a:rPr>
-              <a:t>Snapshot: waters-ci-20260909033329 · As of 2026-09-08 · Business magnitude requires Waters internal data.</a:t>
+              <a:t>Snapshot: waters-ci-20260909112945 · As of 2026-09-09 · Business magnitude requires Waters internal data.</a:t>
             </a:r>
           </a:p>
         </p:txBody>
@@ -13191,7 +13191,7 @@
           <p:cNvPr id="36" name="">
             <a:extLst xmlns:a="http://schemas.openxmlformats.org/drawingml/2006/main">
               <a:ext uri="{FF2B5EF4-FFF2-40B4-BE49-F238E27FC236}">
-                <a16:creationId xmlns:a16="http://schemas.microsoft.com/office/drawing/2014/main" id="{930BF492-16D0-4068-9F45-2F0994597587}"/>
+                <a16:creationId xmlns:a16="http://schemas.microsoft.com/office/drawing/2014/main" id="{848FF59F-154A-4EF0-A583-64B3EF69FAE9}"/>
               </a:ext>
             </a:extLst>
           </p:cNvPr>
@@ -13239,7 +13239,7 @@
                 <a:ea typeface="Aptos"/>
                 <a:cs typeface="Aptos"/>
               </a:rPr>
-              <a:t>WATERS NEXT GEN COMPETITIVE INTELLIGENCE · 08 SEP 2026 · waters-ci-20260909033329</a:t>
+              <a:t>WATERS NEXT GEN COMPETITIVE INTELLIGENCE · 09 SEP 2026 · waters-ci-20260909112945</a:t>
             </a:r>
           </a:p>
         </p:txBody>
@@ -13249,7 +13249,7 @@
           <p:cNvPr id="37" name="">
             <a:extLst xmlns:a="http://schemas.openxmlformats.org/drawingml/2006/main">
               <a:ext uri="{FF2B5EF4-FFF2-40B4-BE49-F238E27FC236}">
-                <a16:creationId xmlns:a16="http://schemas.microsoft.com/office/drawing/2014/main" id="{A57D99CE-148E-41E9-85F1-731ED4F14F69}"/>
+                <a16:creationId xmlns:a16="http://schemas.microsoft.com/office/drawing/2014/main" id="{0CFFDE49-3790-4CF6-8FEE-C910D4866072}"/>
               </a:ext>
             </a:extLst>
           </p:cNvPr>
@@ -13305,7 +13305,7 @@
     </p:spTree>
     <p:extLst>
       <p:ext uri="{BB962C8B-B14F-4D97-AF65-F5344CB8AC3E}">
-        <p14:creationId xmlns:p14="http://schemas.microsoft.com/office/powerpoint/2010/main" val="1596368821"/>
+        <p14:creationId xmlns:p14="http://schemas.microsoft.com/office/powerpoint/2010/main" val="353118322"/>
       </p:ext>
     </p:extLst>
   </p:cSld>

</xml_diff>

<commit_message>
Finalize September 9 production refresh
</commit_message>
<xml_diff>
--- a/deploy-site/exports/waters-nextgen-leadership-brief.pptx
+++ b/deploy-site/exports/waters-nextgen-leadership-brief.pptx
@@ -2,20 +2,20 @@
 <file path=ppt/presentation.xml><?xml version="1.0" encoding="utf-8"?>
 <p:presentation xmlns:p="http://schemas.openxmlformats.org/presentationml/2006/main">
   <p:sldMasterIdLst>
-    <p:sldMasterId xmlns:r="http://schemas.openxmlformats.org/officeDocument/2006/relationships" id="2147483648" r:id="R271cffb010344991"/>
+    <p:sldMasterId xmlns:r="http://schemas.openxmlformats.org/officeDocument/2006/relationships" id="2147483648" r:id="R5809ba138ca64a1a"/>
   </p:sldMasterIdLst>
   <p:notesMasterIdLst>
-    <p:notesMasterId xmlns:r="http://schemas.openxmlformats.org/officeDocument/2006/relationships" r:id="R5df3b5a2f91440cf"/>
+    <p:notesMasterId xmlns:r="http://schemas.openxmlformats.org/officeDocument/2006/relationships" r:id="Rdf3e6a7cc99a4163"/>
   </p:notesMasterIdLst>
   <p:sldIdLst>
-    <p:sldId xmlns:r="http://schemas.openxmlformats.org/officeDocument/2006/relationships" id="256" r:id="R310060d6e99345a8"/>
-    <p:sldId xmlns:r="http://schemas.openxmlformats.org/officeDocument/2006/relationships" id="257" r:id="R0ffaf92ce50843c0"/>
-    <p:sldId xmlns:r="http://schemas.openxmlformats.org/officeDocument/2006/relationships" id="258" r:id="Ra3ab73da68e94ce2"/>
-    <p:sldId xmlns:r="http://schemas.openxmlformats.org/officeDocument/2006/relationships" id="259" r:id="R86092c59df9247e8"/>
-    <p:sldId xmlns:r="http://schemas.openxmlformats.org/officeDocument/2006/relationships" id="260" r:id="Rcdbf9c8451834300"/>
-    <p:sldId xmlns:r="http://schemas.openxmlformats.org/officeDocument/2006/relationships" id="261" r:id="Rd6c1d4321af24cc2"/>
-    <p:sldId xmlns:r="http://schemas.openxmlformats.org/officeDocument/2006/relationships" id="262" r:id="R3b22aa68c9684e1f"/>
-    <p:sldId xmlns:r="http://schemas.openxmlformats.org/officeDocument/2006/relationships" id="263" r:id="Rd54c489790e04100"/>
+    <p:sldId xmlns:r="http://schemas.openxmlformats.org/officeDocument/2006/relationships" id="256" r:id="Re5e389bc5dd5418d"/>
+    <p:sldId xmlns:r="http://schemas.openxmlformats.org/officeDocument/2006/relationships" id="257" r:id="R6cfd38aadd724eed"/>
+    <p:sldId xmlns:r="http://schemas.openxmlformats.org/officeDocument/2006/relationships" id="258" r:id="R92403de8bfd84d4b"/>
+    <p:sldId xmlns:r="http://schemas.openxmlformats.org/officeDocument/2006/relationships" id="259" r:id="R003c41e6e6e14d4a"/>
+    <p:sldId xmlns:r="http://schemas.openxmlformats.org/officeDocument/2006/relationships" id="260" r:id="Rbdf8ae0a26d541b7"/>
+    <p:sldId xmlns:r="http://schemas.openxmlformats.org/officeDocument/2006/relationships" id="261" r:id="R7816a5d813184f68"/>
+    <p:sldId xmlns:r="http://schemas.openxmlformats.org/officeDocument/2006/relationships" id="262" r:id="R6ffc17f0d02c4eea"/>
+    <p:sldId xmlns:r="http://schemas.openxmlformats.org/officeDocument/2006/relationships" id="263" r:id="Rb029b294ba70455c"/>
   </p:sldIdLst>
   <p:sldSz cx="12192000" cy="6858000"/>
   <p:notesSz cx="6858000" cy="9144000"/>
@@ -1282,7 +1282,7 @@
   </p:cSld>
   <p:clrMap bg1="lt1" tx1="dk1" bg2="lt2" tx2="dk2" accent1="accent1" accent2="accent2" accent3="accent3" accent4="accent4" accent5="accent5" accent6="accent6" hlink="hlink" folHlink="folHlink"/>
   <p:sldLayoutIdLst>
-    <p:sldLayoutId xmlns:r="http://schemas.openxmlformats.org/officeDocument/2006/relationships" id="2147483649" r:id="R3babc0b8e5844f74"/>
+    <p:sldLayoutId xmlns:r="http://schemas.openxmlformats.org/officeDocument/2006/relationships" id="2147483649" r:id="R08b37a1f92874044"/>
   </p:sldLayoutIdLst>
   <p:txStyles>
     <p:titleStyle>
@@ -1833,7 +1833,7 @@
           <p:cNvPr id="14" name="">
             <a:extLst xmlns:a="http://schemas.openxmlformats.org/drawingml/2006/main">
               <a:ext uri="{FF2B5EF4-FFF2-40B4-BE49-F238E27FC236}">
-                <a16:creationId xmlns:a16="http://schemas.microsoft.com/office/drawing/2014/main" id="{C62340F1-FC31-432C-AB16-5616B206F07E}"/>
+                <a16:creationId xmlns:a16="http://schemas.microsoft.com/office/drawing/2014/main" id="{72BA1910-FADE-4483-B70C-7D5175E5DA80}"/>
               </a:ext>
             </a:extLst>
           </p:cNvPr>
@@ -1866,7 +1866,7 @@
           <p:cNvPr id="2" name="">
             <a:extLst xmlns:a="http://schemas.openxmlformats.org/drawingml/2006/main">
               <a:ext uri="{FF2B5EF4-FFF2-40B4-BE49-F238E27FC236}">
-                <a16:creationId xmlns:a16="http://schemas.microsoft.com/office/drawing/2014/main" id="{0DDDB182-977F-4221-A460-BE7CBD5C2E52}"/>
+                <a16:creationId xmlns:a16="http://schemas.microsoft.com/office/drawing/2014/main" id="{A8EA3194-5D69-49D2-BF7B-279664933BB8}"/>
               </a:ext>
             </a:extLst>
           </p:cNvPr>
@@ -1924,7 +1924,7 @@
           <p:cNvPr id="3" name="">
             <a:extLst xmlns:a="http://schemas.openxmlformats.org/drawingml/2006/main">
               <a:ext uri="{FF2B5EF4-FFF2-40B4-BE49-F238E27FC236}">
-                <a16:creationId xmlns:a16="http://schemas.microsoft.com/office/drawing/2014/main" id="{C18DAF57-CA7B-43E0-B17F-5012C2631A24}"/>
+                <a16:creationId xmlns:a16="http://schemas.microsoft.com/office/drawing/2014/main" id="{DCFA4D38-9686-482E-ADAA-9E40ECFA329B}"/>
               </a:ext>
             </a:extLst>
           </p:cNvPr>
@@ -1982,7 +1982,7 @@
           <p:cNvPr id="4" name="">
             <a:extLst xmlns:a="http://schemas.openxmlformats.org/drawingml/2006/main">
               <a:ext uri="{FF2B5EF4-FFF2-40B4-BE49-F238E27FC236}">
-                <a16:creationId xmlns:a16="http://schemas.microsoft.com/office/drawing/2014/main" id="{8646CBA2-B02F-4382-BBB5-BBB0F708FCC0}"/>
+                <a16:creationId xmlns:a16="http://schemas.microsoft.com/office/drawing/2014/main" id="{B7D6C0FC-1713-4035-9D89-AD9035EE2DDF}"/>
               </a:ext>
             </a:extLst>
           </p:cNvPr>
@@ -2040,7 +2040,7 @@
           <p:cNvPr id="5" name="">
             <a:extLst xmlns:a="http://schemas.openxmlformats.org/drawingml/2006/main">
               <a:ext uri="{FF2B5EF4-FFF2-40B4-BE49-F238E27FC236}">
-                <a16:creationId xmlns:a16="http://schemas.microsoft.com/office/drawing/2014/main" id="{31BEF88F-5921-44F2-BE09-4B13E5D30BA7}"/>
+                <a16:creationId xmlns:a16="http://schemas.microsoft.com/office/drawing/2014/main" id="{D231480F-5F5A-448D-84C1-345DFA5B70D7}"/>
               </a:ext>
             </a:extLst>
           </p:cNvPr>
@@ -2098,7 +2098,7 @@
           <p:cNvPr id="6" name="">
             <a:extLst xmlns:a="http://schemas.openxmlformats.org/drawingml/2006/main">
               <a:ext uri="{FF2B5EF4-FFF2-40B4-BE49-F238E27FC236}">
-                <a16:creationId xmlns:a16="http://schemas.microsoft.com/office/drawing/2014/main" id="{A369DA15-54A5-4AAC-A056-8E130C6252EF}"/>
+                <a16:creationId xmlns:a16="http://schemas.microsoft.com/office/drawing/2014/main" id="{608C1011-E461-4BEB-84E1-0D2640871CB3}"/>
               </a:ext>
             </a:extLst>
           </p:cNvPr>
@@ -2133,7 +2133,7 @@
           <p:cNvPr id="7" name="">
             <a:extLst xmlns:a="http://schemas.openxmlformats.org/drawingml/2006/main">
               <a:ext uri="{FF2B5EF4-FFF2-40B4-BE49-F238E27FC236}">
-                <a16:creationId xmlns:a16="http://schemas.microsoft.com/office/drawing/2014/main" id="{BC2AC289-40A3-48C6-833C-2E00F94744FA}"/>
+                <a16:creationId xmlns:a16="http://schemas.microsoft.com/office/drawing/2014/main" id="{AD6C8E68-30AC-47B8-B97D-F2DB9B419A92}"/>
               </a:ext>
             </a:extLst>
           </p:cNvPr>
@@ -2191,7 +2191,7 @@
           <p:cNvPr id="8" name="">
             <a:extLst xmlns:a="http://schemas.openxmlformats.org/drawingml/2006/main">
               <a:ext uri="{FF2B5EF4-FFF2-40B4-BE49-F238E27FC236}">
-                <a16:creationId xmlns:a16="http://schemas.microsoft.com/office/drawing/2014/main" id="{9F6AB1FE-0A61-44E2-9B07-4A7BEF50E984}"/>
+                <a16:creationId xmlns:a16="http://schemas.microsoft.com/office/drawing/2014/main" id="{BBBD36C9-0108-41D1-B15E-544BC90521C1}"/>
               </a:ext>
             </a:extLst>
           </p:cNvPr>
@@ -2249,7 +2249,7 @@
           <p:cNvPr id="9" name="">
             <a:extLst xmlns:a="http://schemas.openxmlformats.org/drawingml/2006/main">
               <a:ext uri="{FF2B5EF4-FFF2-40B4-BE49-F238E27FC236}">
-                <a16:creationId xmlns:a16="http://schemas.microsoft.com/office/drawing/2014/main" id="{043354ED-E682-490B-B288-AE0792D9DBD5}"/>
+                <a16:creationId xmlns:a16="http://schemas.microsoft.com/office/drawing/2014/main" id="{BEDF5F6D-CBA2-46CA-895C-06513EC86331}"/>
               </a:ext>
             </a:extLst>
           </p:cNvPr>
@@ -2307,7 +2307,7 @@
           <p:cNvPr id="10" name="">
             <a:extLst xmlns:a="http://schemas.openxmlformats.org/drawingml/2006/main">
               <a:ext uri="{FF2B5EF4-FFF2-40B4-BE49-F238E27FC236}">
-                <a16:creationId xmlns:a16="http://schemas.microsoft.com/office/drawing/2014/main" id="{0F357B13-2D0F-4C03-9B97-61E80E2A4BC5}"/>
+                <a16:creationId xmlns:a16="http://schemas.microsoft.com/office/drawing/2014/main" id="{B70CC70A-D0F3-4F73-A874-F214A7871EF4}"/>
               </a:ext>
             </a:extLst>
           </p:cNvPr>
@@ -2340,7 +2340,7 @@
           <p:cNvPr id="11" name="">
             <a:extLst xmlns:a="http://schemas.openxmlformats.org/drawingml/2006/main">
               <a:ext uri="{FF2B5EF4-FFF2-40B4-BE49-F238E27FC236}">
-                <a16:creationId xmlns:a16="http://schemas.microsoft.com/office/drawing/2014/main" id="{BE163B6B-3EC0-4BF9-AFCB-C2C2F053224B}"/>
+                <a16:creationId xmlns:a16="http://schemas.microsoft.com/office/drawing/2014/main" id="{236CC6CD-F56D-471B-A090-A9C6EFD89BBE}"/>
               </a:ext>
             </a:extLst>
           </p:cNvPr>
@@ -2398,7 +2398,7 @@
           <p:cNvPr id="12" name="">
             <a:extLst xmlns:a="http://schemas.openxmlformats.org/drawingml/2006/main">
               <a:ext uri="{FF2B5EF4-FFF2-40B4-BE49-F238E27FC236}">
-                <a16:creationId xmlns:a16="http://schemas.microsoft.com/office/drawing/2014/main" id="{E8BDC085-31E1-4B43-B0B8-AEADD383D4FB}"/>
+                <a16:creationId xmlns:a16="http://schemas.microsoft.com/office/drawing/2014/main" id="{AEEEF89B-1771-427B-A49B-900122D46372}"/>
               </a:ext>
             </a:extLst>
           </p:cNvPr>
@@ -2446,7 +2446,7 @@
                 <a:ea typeface="Aptos"/>
                 <a:cs typeface="Aptos"/>
               </a:rPr>
-              <a:t>Prepared for roadmap review · waters-ci-20260909112945</a:t>
+              <a:t>Prepared for roadmap review · waters-ci-20260909133432</a:t>
             </a:r>
           </a:p>
         </p:txBody>
@@ -2456,7 +2456,7 @@
           <p:cNvPr id="13" name="">
             <a:extLst xmlns:a="http://schemas.openxmlformats.org/drawingml/2006/main">
               <a:ext uri="{FF2B5EF4-FFF2-40B4-BE49-F238E27FC236}">
-                <a16:creationId xmlns:a16="http://schemas.microsoft.com/office/drawing/2014/main" id="{1B14847F-FCA7-408D-8567-A2ACCCCCACC7}"/>
+                <a16:creationId xmlns:a16="http://schemas.microsoft.com/office/drawing/2014/main" id="{7494891F-F702-48D5-BE6E-60E23F0C452A}"/>
               </a:ext>
             </a:extLst>
           </p:cNvPr>
@@ -2512,7 +2512,7 @@
     </p:spTree>
     <p:extLst>
       <p:ext uri="{BB962C8B-B14F-4D97-AF65-F5344CB8AC3E}">
-        <p14:creationId xmlns:p14="http://schemas.microsoft.com/office/powerpoint/2010/main" val="1552316189"/>
+        <p14:creationId xmlns:p14="http://schemas.microsoft.com/office/powerpoint/2010/main" val="1378616655"/>
       </p:ext>
     </p:extLst>
   </p:cSld>
@@ -2543,7 +2543,7 @@
           <p:cNvPr id="25" name="">
             <a:extLst xmlns:a="http://schemas.openxmlformats.org/drawingml/2006/main">
               <a:ext uri="{FF2B5EF4-FFF2-40B4-BE49-F238E27FC236}">
-                <a16:creationId xmlns:a16="http://schemas.microsoft.com/office/drawing/2014/main" id="{FD89D103-D39D-40A2-87C0-FCA11F6461D1}"/>
+                <a16:creationId xmlns:a16="http://schemas.microsoft.com/office/drawing/2014/main" id="{36719432-DF06-449A-AC3B-208823FFA9BF}"/>
               </a:ext>
             </a:extLst>
           </p:cNvPr>
@@ -2601,7 +2601,7 @@
           <p:cNvPr id="2" name="">
             <a:extLst xmlns:a="http://schemas.openxmlformats.org/drawingml/2006/main">
               <a:ext uri="{FF2B5EF4-FFF2-40B4-BE49-F238E27FC236}">
-                <a16:creationId xmlns:a16="http://schemas.microsoft.com/office/drawing/2014/main" id="{4130E08A-1EB7-4588-A382-8CE73391E471}"/>
+                <a16:creationId xmlns:a16="http://schemas.microsoft.com/office/drawing/2014/main" id="{7C0B5A00-4639-4219-A1C7-778424D78804}"/>
               </a:ext>
             </a:extLst>
           </p:cNvPr>
@@ -2659,7 +2659,7 @@
           <p:cNvPr id="3" name="">
             <a:extLst xmlns:a="http://schemas.openxmlformats.org/drawingml/2006/main">
               <a:ext uri="{FF2B5EF4-FFF2-40B4-BE49-F238E27FC236}">
-                <a16:creationId xmlns:a16="http://schemas.microsoft.com/office/drawing/2014/main" id="{3E3B26C0-2CC1-4731-A64A-BA84D985CF9F}"/>
+                <a16:creationId xmlns:a16="http://schemas.microsoft.com/office/drawing/2014/main" id="{0A226C46-345D-4205-83BB-FE50EFA2E06E}"/>
               </a:ext>
             </a:extLst>
           </p:cNvPr>
@@ -2717,7 +2717,7 @@
           <p:cNvPr id="4" name="">
             <a:extLst xmlns:a="http://schemas.openxmlformats.org/drawingml/2006/main">
               <a:ext uri="{FF2B5EF4-FFF2-40B4-BE49-F238E27FC236}">
-                <a16:creationId xmlns:a16="http://schemas.microsoft.com/office/drawing/2014/main" id="{5A7CA80B-2475-4C1C-9FA6-3CC1317CD433}"/>
+                <a16:creationId xmlns:a16="http://schemas.microsoft.com/office/drawing/2014/main" id="{B9170CF6-86E2-49A4-A034-E14FB7A4FE2A}"/>
               </a:ext>
             </a:extLst>
           </p:cNvPr>
@@ -2750,7 +2750,7 @@
           <p:cNvPr id="5" name="">
             <a:extLst xmlns:a="http://schemas.openxmlformats.org/drawingml/2006/main">
               <a:ext uri="{FF2B5EF4-FFF2-40B4-BE49-F238E27FC236}">
-                <a16:creationId xmlns:a16="http://schemas.microsoft.com/office/drawing/2014/main" id="{51AB222A-7265-47BC-B217-E52EAB026C34}"/>
+                <a16:creationId xmlns:a16="http://schemas.microsoft.com/office/drawing/2014/main" id="{8E886B72-38CB-4F59-92DB-CEA8D22F9830}"/>
               </a:ext>
             </a:extLst>
           </p:cNvPr>
@@ -2785,7 +2785,7 @@
           <p:cNvPr id="6" name="">
             <a:extLst xmlns:a="http://schemas.openxmlformats.org/drawingml/2006/main">
               <a:ext uri="{FF2B5EF4-FFF2-40B4-BE49-F238E27FC236}">
-                <a16:creationId xmlns:a16="http://schemas.microsoft.com/office/drawing/2014/main" id="{E9508E6B-5953-4A4B-A0DF-B30DC6653CD7}"/>
+                <a16:creationId xmlns:a16="http://schemas.microsoft.com/office/drawing/2014/main" id="{E7B84A33-1FFF-47D8-83B2-B92382FF3DEE}"/>
               </a:ext>
             </a:extLst>
           </p:cNvPr>
@@ -2843,7 +2843,7 @@
           <p:cNvPr id="7" name="">
             <a:extLst xmlns:a="http://schemas.openxmlformats.org/drawingml/2006/main">
               <a:ext uri="{FF2B5EF4-FFF2-40B4-BE49-F238E27FC236}">
-                <a16:creationId xmlns:a16="http://schemas.microsoft.com/office/drawing/2014/main" id="{8925766A-6F4D-424C-93AF-4B9C919E3E37}"/>
+                <a16:creationId xmlns:a16="http://schemas.microsoft.com/office/drawing/2014/main" id="{EFCC04B3-E68A-4CB9-AB50-618613AEFA6B}"/>
               </a:ext>
             </a:extLst>
           </p:cNvPr>
@@ -2901,7 +2901,7 @@
           <p:cNvPr id="8" name="">
             <a:extLst xmlns:a="http://schemas.openxmlformats.org/drawingml/2006/main">
               <a:ext uri="{FF2B5EF4-FFF2-40B4-BE49-F238E27FC236}">
-                <a16:creationId xmlns:a16="http://schemas.microsoft.com/office/drawing/2014/main" id="{19CAA47B-F9C3-4507-AD66-1BFD6C43E6CC}"/>
+                <a16:creationId xmlns:a16="http://schemas.microsoft.com/office/drawing/2014/main" id="{FCAB36F7-54D3-4C2D-B9F5-0F90273DB271}"/>
               </a:ext>
             </a:extLst>
           </p:cNvPr>
@@ -2936,7 +2936,7 @@
           <p:cNvPr id="9" name="">
             <a:extLst xmlns:a="http://schemas.openxmlformats.org/drawingml/2006/main">
               <a:ext uri="{FF2B5EF4-FFF2-40B4-BE49-F238E27FC236}">
-                <a16:creationId xmlns:a16="http://schemas.microsoft.com/office/drawing/2014/main" id="{E66542DE-1A56-4EE1-B14B-3411F7B8067B}"/>
+                <a16:creationId xmlns:a16="http://schemas.microsoft.com/office/drawing/2014/main" id="{933F6B76-5160-43BC-BA9A-7AC3F8842F2E}"/>
               </a:ext>
             </a:extLst>
           </p:cNvPr>
@@ -2969,7 +2969,7 @@
           <p:cNvPr id="10" name="">
             <a:extLst xmlns:a="http://schemas.openxmlformats.org/drawingml/2006/main">
               <a:ext uri="{FF2B5EF4-FFF2-40B4-BE49-F238E27FC236}">
-                <a16:creationId xmlns:a16="http://schemas.microsoft.com/office/drawing/2014/main" id="{A850D6F2-A913-4408-B4DC-88F6653CCCE4}"/>
+                <a16:creationId xmlns:a16="http://schemas.microsoft.com/office/drawing/2014/main" id="{6D5819A4-2196-45A4-84DE-3C5C4B64D46E}"/>
               </a:ext>
             </a:extLst>
           </p:cNvPr>
@@ -3027,7 +3027,7 @@
           <p:cNvPr id="11" name="">
             <a:extLst xmlns:a="http://schemas.openxmlformats.org/drawingml/2006/main">
               <a:ext uri="{FF2B5EF4-FFF2-40B4-BE49-F238E27FC236}">
-                <a16:creationId xmlns:a16="http://schemas.microsoft.com/office/drawing/2014/main" id="{86EB5470-4B90-4607-8324-6A5B002B10A5}"/>
+                <a16:creationId xmlns:a16="http://schemas.microsoft.com/office/drawing/2014/main" id="{4711A3D7-36E4-441F-8369-E47FCAB2856C}"/>
               </a:ext>
             </a:extLst>
           </p:cNvPr>
@@ -3085,7 +3085,7 @@
           <p:cNvPr id="12" name="">
             <a:extLst xmlns:a="http://schemas.openxmlformats.org/drawingml/2006/main">
               <a:ext uri="{FF2B5EF4-FFF2-40B4-BE49-F238E27FC236}">
-                <a16:creationId xmlns:a16="http://schemas.microsoft.com/office/drawing/2014/main" id="{8F8DAFC0-F5F3-4DD7-85E2-3037EE7FF10F}"/>
+                <a16:creationId xmlns:a16="http://schemas.microsoft.com/office/drawing/2014/main" id="{9CE23AD3-FAD3-4668-B72C-72E38BF281DC}"/>
               </a:ext>
             </a:extLst>
           </p:cNvPr>
@@ -3143,7 +3143,7 @@
           <p:cNvPr id="13" name="">
             <a:extLst xmlns:a="http://schemas.openxmlformats.org/drawingml/2006/main">
               <a:ext uri="{FF2B5EF4-FFF2-40B4-BE49-F238E27FC236}">
-                <a16:creationId xmlns:a16="http://schemas.microsoft.com/office/drawing/2014/main" id="{07109A02-B40E-42B3-B939-31FBD9A2CEE2}"/>
+                <a16:creationId xmlns:a16="http://schemas.microsoft.com/office/drawing/2014/main" id="{EEA6F795-226F-4EA3-AA6D-B88BEFAD9FF7}"/>
               </a:ext>
             </a:extLst>
           </p:cNvPr>
@@ -3178,7 +3178,7 @@
           <p:cNvPr id="14" name="">
             <a:extLst xmlns:a="http://schemas.openxmlformats.org/drawingml/2006/main">
               <a:ext uri="{FF2B5EF4-FFF2-40B4-BE49-F238E27FC236}">
-                <a16:creationId xmlns:a16="http://schemas.microsoft.com/office/drawing/2014/main" id="{E0AB0905-952A-4D16-B3A5-E1671F903391}"/>
+                <a16:creationId xmlns:a16="http://schemas.microsoft.com/office/drawing/2014/main" id="{53453ACD-517C-4FBF-BC59-EDAC38477CC2}"/>
               </a:ext>
             </a:extLst>
           </p:cNvPr>
@@ -3211,7 +3211,7 @@
           <p:cNvPr id="15" name="">
             <a:extLst xmlns:a="http://schemas.openxmlformats.org/drawingml/2006/main">
               <a:ext uri="{FF2B5EF4-FFF2-40B4-BE49-F238E27FC236}">
-                <a16:creationId xmlns:a16="http://schemas.microsoft.com/office/drawing/2014/main" id="{277087F6-0A2D-4B3E-89CC-D4D29A459611}"/>
+                <a16:creationId xmlns:a16="http://schemas.microsoft.com/office/drawing/2014/main" id="{A0026F98-0A33-46C9-83FE-AAF7E35C8328}"/>
               </a:ext>
             </a:extLst>
           </p:cNvPr>
@@ -3269,7 +3269,7 @@
           <p:cNvPr id="16" name="">
             <a:extLst xmlns:a="http://schemas.openxmlformats.org/drawingml/2006/main">
               <a:ext uri="{FF2B5EF4-FFF2-40B4-BE49-F238E27FC236}">
-                <a16:creationId xmlns:a16="http://schemas.microsoft.com/office/drawing/2014/main" id="{32DEE198-A681-47E6-BDC7-E39BD2D2ED30}"/>
+                <a16:creationId xmlns:a16="http://schemas.microsoft.com/office/drawing/2014/main" id="{D47F50C2-6577-4E66-9534-A46A230E8E89}"/>
               </a:ext>
             </a:extLst>
           </p:cNvPr>
@@ -3327,7 +3327,7 @@
           <p:cNvPr id="17" name="">
             <a:extLst xmlns:a="http://schemas.openxmlformats.org/drawingml/2006/main">
               <a:ext uri="{FF2B5EF4-FFF2-40B4-BE49-F238E27FC236}">
-                <a16:creationId xmlns:a16="http://schemas.microsoft.com/office/drawing/2014/main" id="{55F85E3F-CB6A-4D91-963A-FD74756CBC84}"/>
+                <a16:creationId xmlns:a16="http://schemas.microsoft.com/office/drawing/2014/main" id="{F3FD46AB-FFC7-4DFD-93B9-72C0FBE6B10D}"/>
               </a:ext>
             </a:extLst>
           </p:cNvPr>
@@ -3385,7 +3385,7 @@
           <p:cNvPr id="18" name="">
             <a:extLst xmlns:a="http://schemas.openxmlformats.org/drawingml/2006/main">
               <a:ext uri="{FF2B5EF4-FFF2-40B4-BE49-F238E27FC236}">
-                <a16:creationId xmlns:a16="http://schemas.microsoft.com/office/drawing/2014/main" id="{3C2389B3-2961-4BBE-97B0-2F2B607D6D44}"/>
+                <a16:creationId xmlns:a16="http://schemas.microsoft.com/office/drawing/2014/main" id="{6C9AD0B3-57B6-4A3F-9A2E-F0C50FA2B012}"/>
               </a:ext>
             </a:extLst>
           </p:cNvPr>
@@ -3420,7 +3420,7 @@
           <p:cNvPr id="19" name="">
             <a:extLst xmlns:a="http://schemas.openxmlformats.org/drawingml/2006/main">
               <a:ext uri="{FF2B5EF4-FFF2-40B4-BE49-F238E27FC236}">
-                <a16:creationId xmlns:a16="http://schemas.microsoft.com/office/drawing/2014/main" id="{78B2089D-0555-4772-B7B8-EE0A1AD9DA05}"/>
+                <a16:creationId xmlns:a16="http://schemas.microsoft.com/office/drawing/2014/main" id="{85CF0D71-C652-450F-A2A6-38EDC8349528}"/>
               </a:ext>
             </a:extLst>
           </p:cNvPr>
@@ -3453,7 +3453,7 @@
           <p:cNvPr id="20" name="">
             <a:extLst xmlns:a="http://schemas.openxmlformats.org/drawingml/2006/main">
               <a:ext uri="{FF2B5EF4-FFF2-40B4-BE49-F238E27FC236}">
-                <a16:creationId xmlns:a16="http://schemas.microsoft.com/office/drawing/2014/main" id="{F6E1C802-FFB5-48D0-9F2E-F2519C64FC1E}"/>
+                <a16:creationId xmlns:a16="http://schemas.microsoft.com/office/drawing/2014/main" id="{24FC7B46-3762-41E8-960E-23E04D435B7C}"/>
               </a:ext>
             </a:extLst>
           </p:cNvPr>
@@ -3511,7 +3511,7 @@
           <p:cNvPr id="21" name="">
             <a:extLst xmlns:a="http://schemas.openxmlformats.org/drawingml/2006/main">
               <a:ext uri="{FF2B5EF4-FFF2-40B4-BE49-F238E27FC236}">
-                <a16:creationId xmlns:a16="http://schemas.microsoft.com/office/drawing/2014/main" id="{71FEC57E-37D7-4FF4-8841-8F6A3C855CBC}"/>
+                <a16:creationId xmlns:a16="http://schemas.microsoft.com/office/drawing/2014/main" id="{6CB1806B-A0B2-4FF1-B29B-A9412D046144}"/>
               </a:ext>
             </a:extLst>
           </p:cNvPr>
@@ -3569,7 +3569,7 @@
           <p:cNvPr id="22" name="">
             <a:extLst xmlns:a="http://schemas.openxmlformats.org/drawingml/2006/main">
               <a:ext uri="{FF2B5EF4-FFF2-40B4-BE49-F238E27FC236}">
-                <a16:creationId xmlns:a16="http://schemas.microsoft.com/office/drawing/2014/main" id="{96FBB7E2-6B8D-4C21-BA7C-6D1D6B805C87}"/>
+                <a16:creationId xmlns:a16="http://schemas.microsoft.com/office/drawing/2014/main" id="{71AF2C45-B07B-4521-88B3-E64B5AED8293}"/>
               </a:ext>
             </a:extLst>
           </p:cNvPr>
@@ -3627,7 +3627,7 @@
           <p:cNvPr id="23" name="">
             <a:extLst xmlns:a="http://schemas.openxmlformats.org/drawingml/2006/main">
               <a:ext uri="{FF2B5EF4-FFF2-40B4-BE49-F238E27FC236}">
-                <a16:creationId xmlns:a16="http://schemas.microsoft.com/office/drawing/2014/main" id="{16BB9E55-56E1-435A-B919-65C71E79DFD8}"/>
+                <a16:creationId xmlns:a16="http://schemas.microsoft.com/office/drawing/2014/main" id="{624C0187-94C8-4F4F-BCD2-22DFCEAA2D02}"/>
               </a:ext>
             </a:extLst>
           </p:cNvPr>
@@ -3675,7 +3675,7 @@
                 <a:ea typeface="Aptos"/>
                 <a:cs typeface="Aptos"/>
               </a:rPr>
-              <a:t>WATERS NEXT GEN COMPETITIVE INTELLIGENCE · 09 SEP 2026 · waters-ci-20260909112945</a:t>
+              <a:t>WATERS NEXT GEN COMPETITIVE INTELLIGENCE · 09 SEP 2026 · waters-ci-20260909133432</a:t>
             </a:r>
           </a:p>
         </p:txBody>
@@ -3685,7 +3685,7 @@
           <p:cNvPr id="24" name="">
             <a:extLst xmlns:a="http://schemas.openxmlformats.org/drawingml/2006/main">
               <a:ext uri="{FF2B5EF4-FFF2-40B4-BE49-F238E27FC236}">
-                <a16:creationId xmlns:a16="http://schemas.microsoft.com/office/drawing/2014/main" id="{4DF03679-FB0B-4B25-900A-941ADEFFC978}"/>
+                <a16:creationId xmlns:a16="http://schemas.microsoft.com/office/drawing/2014/main" id="{883BD188-E4D6-462B-A8C6-FC7C9E95CB93}"/>
               </a:ext>
             </a:extLst>
           </p:cNvPr>
@@ -3741,7 +3741,7 @@
     </p:spTree>
     <p:extLst>
       <p:ext uri="{BB962C8B-B14F-4D97-AF65-F5344CB8AC3E}">
-        <p14:creationId xmlns:p14="http://schemas.microsoft.com/office/powerpoint/2010/main" val="340963108"/>
+        <p14:creationId xmlns:p14="http://schemas.microsoft.com/office/powerpoint/2010/main" val="1498044568"/>
       </p:ext>
     </p:extLst>
   </p:cSld>
@@ -3772,7 +3772,7 @@
           <p:cNvPr id="37" name="">
             <a:extLst xmlns:a="http://schemas.openxmlformats.org/drawingml/2006/main">
               <a:ext uri="{FF2B5EF4-FFF2-40B4-BE49-F238E27FC236}">
-                <a16:creationId xmlns:a16="http://schemas.microsoft.com/office/drawing/2014/main" id="{003F29AE-875D-485F-A86C-301CF2F5803D}"/>
+                <a16:creationId xmlns:a16="http://schemas.microsoft.com/office/drawing/2014/main" id="{2FF7FCAC-434E-4B26-A59C-2DAADC8E0C25}"/>
               </a:ext>
             </a:extLst>
           </p:cNvPr>
@@ -3830,7 +3830,7 @@
           <p:cNvPr id="2" name="">
             <a:extLst xmlns:a="http://schemas.openxmlformats.org/drawingml/2006/main">
               <a:ext uri="{FF2B5EF4-FFF2-40B4-BE49-F238E27FC236}">
-                <a16:creationId xmlns:a16="http://schemas.microsoft.com/office/drawing/2014/main" id="{6108350E-AB09-4E30-A435-0520DF6448E1}"/>
+                <a16:creationId xmlns:a16="http://schemas.microsoft.com/office/drawing/2014/main" id="{C9CC157B-3429-41CF-926E-A55F1A898BAA}"/>
               </a:ext>
             </a:extLst>
           </p:cNvPr>
@@ -3888,7 +3888,7 @@
           <p:cNvPr id="3" name="">
             <a:extLst xmlns:a="http://schemas.openxmlformats.org/drawingml/2006/main">
               <a:ext uri="{FF2B5EF4-FFF2-40B4-BE49-F238E27FC236}">
-                <a16:creationId xmlns:a16="http://schemas.microsoft.com/office/drawing/2014/main" id="{B0EBB4C3-DFD3-4F2A-A14C-0ABB9B658DD8}"/>
+                <a16:creationId xmlns:a16="http://schemas.microsoft.com/office/drawing/2014/main" id="{C06643DF-D67D-48EC-99B4-13EAF6C3ECB1}"/>
               </a:ext>
             </a:extLst>
           </p:cNvPr>
@@ -3946,7 +3946,7 @@
           <p:cNvPr id="4" name="">
             <a:extLst xmlns:a="http://schemas.openxmlformats.org/drawingml/2006/main">
               <a:ext uri="{FF2B5EF4-FFF2-40B4-BE49-F238E27FC236}">
-                <a16:creationId xmlns:a16="http://schemas.microsoft.com/office/drawing/2014/main" id="{306C095C-9616-4863-8D77-0A334611E669}"/>
+                <a16:creationId xmlns:a16="http://schemas.microsoft.com/office/drawing/2014/main" id="{DC45BBF5-D7DF-464C-AF6C-9D700AA49CEF}"/>
               </a:ext>
             </a:extLst>
           </p:cNvPr>
@@ -3979,7 +3979,7 @@
           <p:cNvPr id="5" name="">
             <a:extLst xmlns:a="http://schemas.openxmlformats.org/drawingml/2006/main">
               <a:ext uri="{FF2B5EF4-FFF2-40B4-BE49-F238E27FC236}">
-                <a16:creationId xmlns:a16="http://schemas.microsoft.com/office/drawing/2014/main" id="{EB6BF80A-CB43-46F7-9CA2-2FD1E7226B26}"/>
+                <a16:creationId xmlns:a16="http://schemas.microsoft.com/office/drawing/2014/main" id="{7A00839D-06D7-4C2A-B112-2FC435E881E5}"/>
               </a:ext>
             </a:extLst>
           </p:cNvPr>
@@ -4014,7 +4014,7 @@
           <p:cNvPr id="6" name="">
             <a:extLst xmlns:a="http://schemas.openxmlformats.org/drawingml/2006/main">
               <a:ext uri="{FF2B5EF4-FFF2-40B4-BE49-F238E27FC236}">
-                <a16:creationId xmlns:a16="http://schemas.microsoft.com/office/drawing/2014/main" id="{2E496052-54A1-40BC-8796-0A890565E8B7}"/>
+                <a16:creationId xmlns:a16="http://schemas.microsoft.com/office/drawing/2014/main" id="{3BDDD148-DC19-486D-AFEF-6213508FF42E}"/>
               </a:ext>
             </a:extLst>
           </p:cNvPr>
@@ -4049,7 +4049,7 @@
           <p:cNvPr id="7" name="">
             <a:extLst xmlns:a="http://schemas.openxmlformats.org/drawingml/2006/main">
               <a:ext uri="{FF2B5EF4-FFF2-40B4-BE49-F238E27FC236}">
-                <a16:creationId xmlns:a16="http://schemas.microsoft.com/office/drawing/2014/main" id="{220001D8-AE90-4675-81A5-6ACE132EBB75}"/>
+                <a16:creationId xmlns:a16="http://schemas.microsoft.com/office/drawing/2014/main" id="{905865EC-1449-4B10-86A7-A1E3B90DA091}"/>
               </a:ext>
             </a:extLst>
           </p:cNvPr>
@@ -4107,7 +4107,7 @@
           <p:cNvPr id="8" name="">
             <a:extLst xmlns:a="http://schemas.openxmlformats.org/drawingml/2006/main">
               <a:ext uri="{FF2B5EF4-FFF2-40B4-BE49-F238E27FC236}">
-                <a16:creationId xmlns:a16="http://schemas.microsoft.com/office/drawing/2014/main" id="{93147591-DC18-4C2F-9E14-894401B35E23}"/>
+                <a16:creationId xmlns:a16="http://schemas.microsoft.com/office/drawing/2014/main" id="{0A681654-A7CC-4124-B182-9E7953F2A736}"/>
               </a:ext>
             </a:extLst>
           </p:cNvPr>
@@ -4165,7 +4165,7 @@
           <p:cNvPr id="9" name="">
             <a:extLst xmlns:a="http://schemas.openxmlformats.org/drawingml/2006/main">
               <a:ext uri="{FF2B5EF4-FFF2-40B4-BE49-F238E27FC236}">
-                <a16:creationId xmlns:a16="http://schemas.microsoft.com/office/drawing/2014/main" id="{BE136975-7B54-4CA4-BD91-67CA6F7E593F}"/>
+                <a16:creationId xmlns:a16="http://schemas.microsoft.com/office/drawing/2014/main" id="{6E6BE4CC-C9CE-4D8D-BD54-C537C8035E33}"/>
               </a:ext>
             </a:extLst>
           </p:cNvPr>
@@ -4223,7 +4223,7 @@
           <p:cNvPr id="10" name="">
             <a:extLst xmlns:a="http://schemas.openxmlformats.org/drawingml/2006/main">
               <a:ext uri="{FF2B5EF4-FFF2-40B4-BE49-F238E27FC236}">
-                <a16:creationId xmlns:a16="http://schemas.microsoft.com/office/drawing/2014/main" id="{F960E3F8-223F-4258-935F-265DA733AAF7}"/>
+                <a16:creationId xmlns:a16="http://schemas.microsoft.com/office/drawing/2014/main" id="{E8F05BAD-70C8-4E0E-A2FA-B4D11E93DD38}"/>
               </a:ext>
             </a:extLst>
           </p:cNvPr>
@@ -4281,7 +4281,7 @@
           <p:cNvPr id="11" name="">
             <a:extLst xmlns:a="http://schemas.openxmlformats.org/drawingml/2006/main">
               <a:ext uri="{FF2B5EF4-FFF2-40B4-BE49-F238E27FC236}">
-                <a16:creationId xmlns:a16="http://schemas.microsoft.com/office/drawing/2014/main" id="{208460AB-B902-429F-A554-F69348667AA0}"/>
+                <a16:creationId xmlns:a16="http://schemas.microsoft.com/office/drawing/2014/main" id="{00D015D2-FA52-43DA-9ECF-6E3CD65E8EEE}"/>
               </a:ext>
             </a:extLst>
           </p:cNvPr>
@@ -4316,7 +4316,7 @@
           <p:cNvPr id="12" name="">
             <a:extLst xmlns:a="http://schemas.openxmlformats.org/drawingml/2006/main">
               <a:ext uri="{FF2B5EF4-FFF2-40B4-BE49-F238E27FC236}">
-                <a16:creationId xmlns:a16="http://schemas.microsoft.com/office/drawing/2014/main" id="{E6B43D1A-0F11-48EB-949D-634534E1113E}"/>
+                <a16:creationId xmlns:a16="http://schemas.microsoft.com/office/drawing/2014/main" id="{BFB153FE-70F5-4864-BC55-96514CACE3BB}"/>
               </a:ext>
             </a:extLst>
           </p:cNvPr>
@@ -4351,7 +4351,7 @@
           <p:cNvPr id="13" name="">
             <a:extLst xmlns:a="http://schemas.openxmlformats.org/drawingml/2006/main">
               <a:ext uri="{FF2B5EF4-FFF2-40B4-BE49-F238E27FC236}">
-                <a16:creationId xmlns:a16="http://schemas.microsoft.com/office/drawing/2014/main" id="{4EAC3DC5-8B08-4D8A-9E2F-1E9C0CD898FF}"/>
+                <a16:creationId xmlns:a16="http://schemas.microsoft.com/office/drawing/2014/main" id="{F4A5D144-807A-4D16-84F3-8A8A3CEA8304}"/>
               </a:ext>
             </a:extLst>
           </p:cNvPr>
@@ -4409,7 +4409,7 @@
           <p:cNvPr id="14" name="">
             <a:extLst xmlns:a="http://schemas.openxmlformats.org/drawingml/2006/main">
               <a:ext uri="{FF2B5EF4-FFF2-40B4-BE49-F238E27FC236}">
-                <a16:creationId xmlns:a16="http://schemas.microsoft.com/office/drawing/2014/main" id="{16EEA57A-9A17-4692-8CF7-E2B3E1861128}"/>
+                <a16:creationId xmlns:a16="http://schemas.microsoft.com/office/drawing/2014/main" id="{AD5E4FC7-6BB1-4553-94AA-2A843DEB717D}"/>
               </a:ext>
             </a:extLst>
           </p:cNvPr>
@@ -4467,7 +4467,7 @@
           <p:cNvPr id="15" name="">
             <a:extLst xmlns:a="http://schemas.openxmlformats.org/drawingml/2006/main">
               <a:ext uri="{FF2B5EF4-FFF2-40B4-BE49-F238E27FC236}">
-                <a16:creationId xmlns:a16="http://schemas.microsoft.com/office/drawing/2014/main" id="{CDDE43FF-2E4C-4BDF-B975-253459051529}"/>
+                <a16:creationId xmlns:a16="http://schemas.microsoft.com/office/drawing/2014/main" id="{2F7FFA7A-4E25-4686-8A30-8D11B027932C}"/>
               </a:ext>
             </a:extLst>
           </p:cNvPr>
@@ -4525,7 +4525,7 @@
           <p:cNvPr id="16" name="">
             <a:extLst xmlns:a="http://schemas.openxmlformats.org/drawingml/2006/main">
               <a:ext uri="{FF2B5EF4-FFF2-40B4-BE49-F238E27FC236}">
-                <a16:creationId xmlns:a16="http://schemas.microsoft.com/office/drawing/2014/main" id="{845CB96A-7A07-4935-8568-EEE8703FF340}"/>
+                <a16:creationId xmlns:a16="http://schemas.microsoft.com/office/drawing/2014/main" id="{CB247234-5A79-43CB-904A-E6798E879042}"/>
               </a:ext>
             </a:extLst>
           </p:cNvPr>
@@ -4583,7 +4583,7 @@
           <p:cNvPr id="17" name="">
             <a:extLst xmlns:a="http://schemas.openxmlformats.org/drawingml/2006/main">
               <a:ext uri="{FF2B5EF4-FFF2-40B4-BE49-F238E27FC236}">
-                <a16:creationId xmlns:a16="http://schemas.microsoft.com/office/drawing/2014/main" id="{9D75738F-517A-49F8-B2B5-0D7AC127A6A0}"/>
+                <a16:creationId xmlns:a16="http://schemas.microsoft.com/office/drawing/2014/main" id="{66D8DED9-0567-431C-BD2A-E45304842FC4}"/>
               </a:ext>
             </a:extLst>
           </p:cNvPr>
@@ -4618,7 +4618,7 @@
           <p:cNvPr id="18" name="">
             <a:extLst xmlns:a="http://schemas.openxmlformats.org/drawingml/2006/main">
               <a:ext uri="{FF2B5EF4-FFF2-40B4-BE49-F238E27FC236}">
-                <a16:creationId xmlns:a16="http://schemas.microsoft.com/office/drawing/2014/main" id="{696D032C-DB06-44AF-A9F2-CEAF33A897D2}"/>
+                <a16:creationId xmlns:a16="http://schemas.microsoft.com/office/drawing/2014/main" id="{57462239-8AA7-4329-ACA1-A927AE0F5662}"/>
               </a:ext>
             </a:extLst>
           </p:cNvPr>
@@ -4653,7 +4653,7 @@
           <p:cNvPr id="19" name="">
             <a:extLst xmlns:a="http://schemas.openxmlformats.org/drawingml/2006/main">
               <a:ext uri="{FF2B5EF4-FFF2-40B4-BE49-F238E27FC236}">
-                <a16:creationId xmlns:a16="http://schemas.microsoft.com/office/drawing/2014/main" id="{DCA462C8-97B2-407D-A76C-2769594D8E77}"/>
+                <a16:creationId xmlns:a16="http://schemas.microsoft.com/office/drawing/2014/main" id="{37EC736B-421A-43E4-990A-84E17DB964CE}"/>
               </a:ext>
             </a:extLst>
           </p:cNvPr>
@@ -4711,7 +4711,7 @@
           <p:cNvPr id="20" name="">
             <a:extLst xmlns:a="http://schemas.openxmlformats.org/drawingml/2006/main">
               <a:ext uri="{FF2B5EF4-FFF2-40B4-BE49-F238E27FC236}">
-                <a16:creationId xmlns:a16="http://schemas.microsoft.com/office/drawing/2014/main" id="{374F3372-7A52-4EEC-B4C2-ABCBDF8B69F2}"/>
+                <a16:creationId xmlns:a16="http://schemas.microsoft.com/office/drawing/2014/main" id="{4DF16A64-B35A-4581-85B9-3CED1E512BB6}"/>
               </a:ext>
             </a:extLst>
           </p:cNvPr>
@@ -4769,7 +4769,7 @@
           <p:cNvPr id="21" name="">
             <a:extLst xmlns:a="http://schemas.openxmlformats.org/drawingml/2006/main">
               <a:ext uri="{FF2B5EF4-FFF2-40B4-BE49-F238E27FC236}">
-                <a16:creationId xmlns:a16="http://schemas.microsoft.com/office/drawing/2014/main" id="{03659CEE-4785-4406-A97F-C17C5203C7FF}"/>
+                <a16:creationId xmlns:a16="http://schemas.microsoft.com/office/drawing/2014/main" id="{D4C548CD-EF5C-4292-A81F-3442E481D3CE}"/>
               </a:ext>
             </a:extLst>
           </p:cNvPr>
@@ -4827,7 +4827,7 @@
           <p:cNvPr id="22" name="">
             <a:extLst xmlns:a="http://schemas.openxmlformats.org/drawingml/2006/main">
               <a:ext uri="{FF2B5EF4-FFF2-40B4-BE49-F238E27FC236}">
-                <a16:creationId xmlns:a16="http://schemas.microsoft.com/office/drawing/2014/main" id="{EF4DF4B3-F054-478F-BB21-B23BFC425DAE}"/>
+                <a16:creationId xmlns:a16="http://schemas.microsoft.com/office/drawing/2014/main" id="{22B7D7A7-D3BC-4873-B646-C262609073F4}"/>
               </a:ext>
             </a:extLst>
           </p:cNvPr>
@@ -4885,7 +4885,7 @@
           <p:cNvPr id="23" name="">
             <a:extLst xmlns:a="http://schemas.openxmlformats.org/drawingml/2006/main">
               <a:ext uri="{FF2B5EF4-FFF2-40B4-BE49-F238E27FC236}">
-                <a16:creationId xmlns:a16="http://schemas.microsoft.com/office/drawing/2014/main" id="{B12431BF-0E65-4485-94F5-B567642F5102}"/>
+                <a16:creationId xmlns:a16="http://schemas.microsoft.com/office/drawing/2014/main" id="{5B11C4C0-662D-44F9-BF92-EA449EEE807F}"/>
               </a:ext>
             </a:extLst>
           </p:cNvPr>
@@ -4920,7 +4920,7 @@
           <p:cNvPr id="24" name="">
             <a:extLst xmlns:a="http://schemas.openxmlformats.org/drawingml/2006/main">
               <a:ext uri="{FF2B5EF4-FFF2-40B4-BE49-F238E27FC236}">
-                <a16:creationId xmlns:a16="http://schemas.microsoft.com/office/drawing/2014/main" id="{D96689AA-282A-4BDF-8ABF-819E23D0E30B}"/>
+                <a16:creationId xmlns:a16="http://schemas.microsoft.com/office/drawing/2014/main" id="{1103C446-7D40-48DE-8346-B1434F935D29}"/>
               </a:ext>
             </a:extLst>
           </p:cNvPr>
@@ -4955,7 +4955,7 @@
           <p:cNvPr id="25" name="">
             <a:extLst xmlns:a="http://schemas.openxmlformats.org/drawingml/2006/main">
               <a:ext uri="{FF2B5EF4-FFF2-40B4-BE49-F238E27FC236}">
-                <a16:creationId xmlns:a16="http://schemas.microsoft.com/office/drawing/2014/main" id="{830F4E57-5983-449C-BC52-9F93CA997FF1}"/>
+                <a16:creationId xmlns:a16="http://schemas.microsoft.com/office/drawing/2014/main" id="{7508CBA8-5A90-4825-97AA-2EB92C055A8F}"/>
               </a:ext>
             </a:extLst>
           </p:cNvPr>
@@ -5013,7 +5013,7 @@
           <p:cNvPr id="26" name="">
             <a:extLst xmlns:a="http://schemas.openxmlformats.org/drawingml/2006/main">
               <a:ext uri="{FF2B5EF4-FFF2-40B4-BE49-F238E27FC236}">
-                <a16:creationId xmlns:a16="http://schemas.microsoft.com/office/drawing/2014/main" id="{9F1972C4-9D03-45BB-8291-3592AFC8C7B1}"/>
+                <a16:creationId xmlns:a16="http://schemas.microsoft.com/office/drawing/2014/main" id="{91DC6F58-FC90-494B-946A-9E916A85CD65}"/>
               </a:ext>
             </a:extLst>
           </p:cNvPr>
@@ -5071,7 +5071,7 @@
           <p:cNvPr id="27" name="">
             <a:extLst xmlns:a="http://schemas.openxmlformats.org/drawingml/2006/main">
               <a:ext uri="{FF2B5EF4-FFF2-40B4-BE49-F238E27FC236}">
-                <a16:creationId xmlns:a16="http://schemas.microsoft.com/office/drawing/2014/main" id="{5E76D97B-41BE-4AD5-820B-FB05926544A9}"/>
+                <a16:creationId xmlns:a16="http://schemas.microsoft.com/office/drawing/2014/main" id="{732D4CD7-27B4-4A04-B867-A2FA946347CF}"/>
               </a:ext>
             </a:extLst>
           </p:cNvPr>
@@ -5129,7 +5129,7 @@
           <p:cNvPr id="28" name="">
             <a:extLst xmlns:a="http://schemas.openxmlformats.org/drawingml/2006/main">
               <a:ext uri="{FF2B5EF4-FFF2-40B4-BE49-F238E27FC236}">
-                <a16:creationId xmlns:a16="http://schemas.microsoft.com/office/drawing/2014/main" id="{6C813436-73BF-4803-A695-CADA67BA7E28}"/>
+                <a16:creationId xmlns:a16="http://schemas.microsoft.com/office/drawing/2014/main" id="{151ACE12-5AC7-456E-A6E1-50A8B0750129}"/>
               </a:ext>
             </a:extLst>
           </p:cNvPr>
@@ -5187,7 +5187,7 @@
           <p:cNvPr id="29" name="">
             <a:extLst xmlns:a="http://schemas.openxmlformats.org/drawingml/2006/main">
               <a:ext uri="{FF2B5EF4-FFF2-40B4-BE49-F238E27FC236}">
-                <a16:creationId xmlns:a16="http://schemas.microsoft.com/office/drawing/2014/main" id="{98964E11-BD5A-4A40-B456-CE8337B06D85}"/>
+                <a16:creationId xmlns:a16="http://schemas.microsoft.com/office/drawing/2014/main" id="{353C02C2-4A48-4831-95CB-753CC03787AE}"/>
               </a:ext>
             </a:extLst>
           </p:cNvPr>
@@ -5222,7 +5222,7 @@
           <p:cNvPr id="30" name="">
             <a:extLst xmlns:a="http://schemas.openxmlformats.org/drawingml/2006/main">
               <a:ext uri="{FF2B5EF4-FFF2-40B4-BE49-F238E27FC236}">
-                <a16:creationId xmlns:a16="http://schemas.microsoft.com/office/drawing/2014/main" id="{8891FCFE-38FB-4ACE-9630-9BE1637D929E}"/>
+                <a16:creationId xmlns:a16="http://schemas.microsoft.com/office/drawing/2014/main" id="{EA654BEE-3A1A-4DBA-B0F4-87CB6746EA37}"/>
               </a:ext>
             </a:extLst>
           </p:cNvPr>
@@ -5257,7 +5257,7 @@
           <p:cNvPr id="31" name="">
             <a:extLst xmlns:a="http://schemas.openxmlformats.org/drawingml/2006/main">
               <a:ext uri="{FF2B5EF4-FFF2-40B4-BE49-F238E27FC236}">
-                <a16:creationId xmlns:a16="http://schemas.microsoft.com/office/drawing/2014/main" id="{740D70BD-9FCE-41BC-9BBD-F9044A876F2C}"/>
+                <a16:creationId xmlns:a16="http://schemas.microsoft.com/office/drawing/2014/main" id="{3CA465BF-EB64-45E6-B6AB-C758542F97EE}"/>
               </a:ext>
             </a:extLst>
           </p:cNvPr>
@@ -5315,7 +5315,7 @@
           <p:cNvPr id="32" name="">
             <a:extLst xmlns:a="http://schemas.openxmlformats.org/drawingml/2006/main">
               <a:ext uri="{FF2B5EF4-FFF2-40B4-BE49-F238E27FC236}">
-                <a16:creationId xmlns:a16="http://schemas.microsoft.com/office/drawing/2014/main" id="{8B6D4C6E-CB7A-467A-A754-49E513FDF927}"/>
+                <a16:creationId xmlns:a16="http://schemas.microsoft.com/office/drawing/2014/main" id="{9374E71E-9F66-43BA-B009-CFBA004251D5}"/>
               </a:ext>
             </a:extLst>
           </p:cNvPr>
@@ -5373,7 +5373,7 @@
           <p:cNvPr id="33" name="">
             <a:extLst xmlns:a="http://schemas.openxmlformats.org/drawingml/2006/main">
               <a:ext uri="{FF2B5EF4-FFF2-40B4-BE49-F238E27FC236}">
-                <a16:creationId xmlns:a16="http://schemas.microsoft.com/office/drawing/2014/main" id="{21F50050-EB2C-4D74-A111-60BD0B2621E5}"/>
+                <a16:creationId xmlns:a16="http://schemas.microsoft.com/office/drawing/2014/main" id="{1F67A33F-38E9-4C43-915D-CFC4BAC86795}"/>
               </a:ext>
             </a:extLst>
           </p:cNvPr>
@@ -5431,7 +5431,7 @@
           <p:cNvPr id="34" name="">
             <a:extLst xmlns:a="http://schemas.openxmlformats.org/drawingml/2006/main">
               <a:ext uri="{FF2B5EF4-FFF2-40B4-BE49-F238E27FC236}">
-                <a16:creationId xmlns:a16="http://schemas.microsoft.com/office/drawing/2014/main" id="{80F1FE81-D78E-4137-B5F0-B2CC752F212A}"/>
+                <a16:creationId xmlns:a16="http://schemas.microsoft.com/office/drawing/2014/main" id="{E80BA7DF-B325-400F-9407-89AE35A01CE2}"/>
               </a:ext>
             </a:extLst>
           </p:cNvPr>
@@ -5489,7 +5489,7 @@
           <p:cNvPr id="35" name="">
             <a:extLst xmlns:a="http://schemas.openxmlformats.org/drawingml/2006/main">
               <a:ext uri="{FF2B5EF4-FFF2-40B4-BE49-F238E27FC236}">
-                <a16:creationId xmlns:a16="http://schemas.microsoft.com/office/drawing/2014/main" id="{7BC460F6-320E-4F4C-AF13-43CFFABC0803}"/>
+                <a16:creationId xmlns:a16="http://schemas.microsoft.com/office/drawing/2014/main" id="{46E2D456-4E36-413A-93C5-2EE82DB57444}"/>
               </a:ext>
             </a:extLst>
           </p:cNvPr>
@@ -5537,7 +5537,7 @@
                 <a:ea typeface="Aptos"/>
                 <a:cs typeface="Aptos"/>
               </a:rPr>
-              <a:t>WATERS NEXT GEN COMPETITIVE INTELLIGENCE · 09 SEP 2026 · waters-ci-20260909112945</a:t>
+              <a:t>WATERS NEXT GEN COMPETITIVE INTELLIGENCE · 09 SEP 2026 · waters-ci-20260909133432</a:t>
             </a:r>
           </a:p>
         </p:txBody>
@@ -5547,7 +5547,7 @@
           <p:cNvPr id="36" name="">
             <a:extLst xmlns:a="http://schemas.openxmlformats.org/drawingml/2006/main">
               <a:ext uri="{FF2B5EF4-FFF2-40B4-BE49-F238E27FC236}">
-                <a16:creationId xmlns:a16="http://schemas.microsoft.com/office/drawing/2014/main" id="{675D4DB0-A5ED-4C12-AA92-E37552CB8FD8}"/>
+                <a16:creationId xmlns:a16="http://schemas.microsoft.com/office/drawing/2014/main" id="{3349C64A-EF75-4C31-B2DE-BEA86A8C0043}"/>
               </a:ext>
             </a:extLst>
           </p:cNvPr>
@@ -5603,7 +5603,7 @@
     </p:spTree>
     <p:extLst>
       <p:ext uri="{BB962C8B-B14F-4D97-AF65-F5344CB8AC3E}">
-        <p14:creationId xmlns:p14="http://schemas.microsoft.com/office/powerpoint/2010/main" val="644380637"/>
+        <p14:creationId xmlns:p14="http://schemas.microsoft.com/office/powerpoint/2010/main" val="1609909160"/>
       </p:ext>
     </p:extLst>
   </p:cSld>
@@ -5634,7 +5634,7 @@
           <p:cNvPr id="31" name="">
             <a:extLst xmlns:a="http://schemas.openxmlformats.org/drawingml/2006/main">
               <a:ext uri="{FF2B5EF4-FFF2-40B4-BE49-F238E27FC236}">
-                <a16:creationId xmlns:a16="http://schemas.microsoft.com/office/drawing/2014/main" id="{A602E93E-06A6-4F3C-BFDA-0FC197D91887}"/>
+                <a16:creationId xmlns:a16="http://schemas.microsoft.com/office/drawing/2014/main" id="{FB626CB6-B9B0-4170-812C-2F096DAB797D}"/>
               </a:ext>
             </a:extLst>
           </p:cNvPr>
@@ -5692,7 +5692,7 @@
           <p:cNvPr id="2" name="">
             <a:extLst xmlns:a="http://schemas.openxmlformats.org/drawingml/2006/main">
               <a:ext uri="{FF2B5EF4-FFF2-40B4-BE49-F238E27FC236}">
-                <a16:creationId xmlns:a16="http://schemas.microsoft.com/office/drawing/2014/main" id="{2A3066EB-891F-46E2-86A6-F6699BC9D4FC}"/>
+                <a16:creationId xmlns:a16="http://schemas.microsoft.com/office/drawing/2014/main" id="{87310D00-CBD1-4AA3-AF55-32612436C368}"/>
               </a:ext>
             </a:extLst>
           </p:cNvPr>
@@ -5750,7 +5750,7 @@
           <p:cNvPr id="3" name="">
             <a:extLst xmlns:a="http://schemas.openxmlformats.org/drawingml/2006/main">
               <a:ext uri="{FF2B5EF4-FFF2-40B4-BE49-F238E27FC236}">
-                <a16:creationId xmlns:a16="http://schemas.microsoft.com/office/drawing/2014/main" id="{FF661B67-2B47-47B4-AED3-63A7C2901005}"/>
+                <a16:creationId xmlns:a16="http://schemas.microsoft.com/office/drawing/2014/main" id="{24E6B765-DE54-4ABD-8CA2-598917DF8771}"/>
               </a:ext>
             </a:extLst>
           </p:cNvPr>
@@ -5808,7 +5808,7 @@
           <p:cNvPr id="4" name="">
             <a:extLst xmlns:a="http://schemas.openxmlformats.org/drawingml/2006/main">
               <a:ext uri="{FF2B5EF4-FFF2-40B4-BE49-F238E27FC236}">
-                <a16:creationId xmlns:a16="http://schemas.microsoft.com/office/drawing/2014/main" id="{4737CFB6-30EC-44B4-A98E-28633123D79B}"/>
+                <a16:creationId xmlns:a16="http://schemas.microsoft.com/office/drawing/2014/main" id="{3F2E5C3B-CDFF-4D0B-BCAA-A0CA01ACF316}"/>
               </a:ext>
             </a:extLst>
           </p:cNvPr>
@@ -5841,7 +5841,7 @@
           <p:cNvPr id="5" name="">
             <a:extLst xmlns:a="http://schemas.openxmlformats.org/drawingml/2006/main">
               <a:ext uri="{FF2B5EF4-FFF2-40B4-BE49-F238E27FC236}">
-                <a16:creationId xmlns:a16="http://schemas.microsoft.com/office/drawing/2014/main" id="{D2D97D41-482D-4D1B-AED9-D0029B2952A9}"/>
+                <a16:creationId xmlns:a16="http://schemas.microsoft.com/office/drawing/2014/main" id="{CB64A828-0802-40D7-9D27-A82260C6C368}"/>
               </a:ext>
             </a:extLst>
           </p:cNvPr>
@@ -5876,7 +5876,7 @@
           <p:cNvPr id="6" name="">
             <a:extLst xmlns:a="http://schemas.openxmlformats.org/drawingml/2006/main">
               <a:ext uri="{FF2B5EF4-FFF2-40B4-BE49-F238E27FC236}">
-                <a16:creationId xmlns:a16="http://schemas.microsoft.com/office/drawing/2014/main" id="{6E9B15CC-CA92-4DD7-90F9-65BF7A5EB9E3}"/>
+                <a16:creationId xmlns:a16="http://schemas.microsoft.com/office/drawing/2014/main" id="{D8D9A290-D61D-489D-B382-B0E49BD05218}"/>
               </a:ext>
             </a:extLst>
           </p:cNvPr>
@@ -5909,7 +5909,7 @@
           <p:cNvPr id="7" name="">
             <a:extLst xmlns:a="http://schemas.openxmlformats.org/drawingml/2006/main">
               <a:ext uri="{FF2B5EF4-FFF2-40B4-BE49-F238E27FC236}">
-                <a16:creationId xmlns:a16="http://schemas.microsoft.com/office/drawing/2014/main" id="{3EBFF141-7D84-426F-99E1-C26AFC6F1C08}"/>
+                <a16:creationId xmlns:a16="http://schemas.microsoft.com/office/drawing/2014/main" id="{7FF29546-2456-4A44-BB0E-9F5026F87A9D}"/>
               </a:ext>
             </a:extLst>
           </p:cNvPr>
@@ -5967,7 +5967,7 @@
           <p:cNvPr id="8" name="">
             <a:extLst xmlns:a="http://schemas.openxmlformats.org/drawingml/2006/main">
               <a:ext uri="{FF2B5EF4-FFF2-40B4-BE49-F238E27FC236}">
-                <a16:creationId xmlns:a16="http://schemas.microsoft.com/office/drawing/2014/main" id="{C97A2655-B9ED-4756-A7F7-C4DA1816E69D}"/>
+                <a16:creationId xmlns:a16="http://schemas.microsoft.com/office/drawing/2014/main" id="{724B29D2-3A80-45E1-AEE7-7C9108823E01}"/>
               </a:ext>
             </a:extLst>
           </p:cNvPr>
@@ -6025,7 +6025,7 @@
           <p:cNvPr id="9" name="">
             <a:extLst xmlns:a="http://schemas.openxmlformats.org/drawingml/2006/main">
               <a:ext uri="{FF2B5EF4-FFF2-40B4-BE49-F238E27FC236}">
-                <a16:creationId xmlns:a16="http://schemas.microsoft.com/office/drawing/2014/main" id="{A183D680-D68F-4AD5-B15F-3C7D87430E0C}"/>
+                <a16:creationId xmlns:a16="http://schemas.microsoft.com/office/drawing/2014/main" id="{3D2C28ED-A4AA-4F96-A79F-E80B3C5E1129}"/>
               </a:ext>
             </a:extLst>
           </p:cNvPr>
@@ -6083,7 +6083,7 @@
           <p:cNvPr id="10" name="">
             <a:extLst xmlns:a="http://schemas.openxmlformats.org/drawingml/2006/main">
               <a:ext uri="{FF2B5EF4-FFF2-40B4-BE49-F238E27FC236}">
-                <a16:creationId xmlns:a16="http://schemas.microsoft.com/office/drawing/2014/main" id="{284BC3D0-968C-44E8-A670-0366EC18F5CB}"/>
+                <a16:creationId xmlns:a16="http://schemas.microsoft.com/office/drawing/2014/main" id="{58EC6FA3-3192-440D-87C2-D5D6831759C0}"/>
               </a:ext>
             </a:extLst>
           </p:cNvPr>
@@ -6141,7 +6141,7 @@
           <p:cNvPr id="11" name="">
             <a:extLst xmlns:a="http://schemas.openxmlformats.org/drawingml/2006/main">
               <a:ext uri="{FF2B5EF4-FFF2-40B4-BE49-F238E27FC236}">
-                <a16:creationId xmlns:a16="http://schemas.microsoft.com/office/drawing/2014/main" id="{B0C73C5C-689C-4CC0-AD3D-880EF8FF3524}"/>
+                <a16:creationId xmlns:a16="http://schemas.microsoft.com/office/drawing/2014/main" id="{FA51AC83-86A8-4917-BC37-414669F52A13}"/>
               </a:ext>
             </a:extLst>
           </p:cNvPr>
@@ -6176,7 +6176,7 @@
           <p:cNvPr id="12" name="">
             <a:extLst xmlns:a="http://schemas.openxmlformats.org/drawingml/2006/main">
               <a:ext uri="{FF2B5EF4-FFF2-40B4-BE49-F238E27FC236}">
-                <a16:creationId xmlns:a16="http://schemas.microsoft.com/office/drawing/2014/main" id="{109B73A7-800B-4612-AC28-7C70E80C477A}"/>
+                <a16:creationId xmlns:a16="http://schemas.microsoft.com/office/drawing/2014/main" id="{32E9EC60-FB0E-4F98-BED1-68BF8B51E0E0}"/>
               </a:ext>
             </a:extLst>
           </p:cNvPr>
@@ -6209,7 +6209,7 @@
           <p:cNvPr id="13" name="">
             <a:extLst xmlns:a="http://schemas.openxmlformats.org/drawingml/2006/main">
               <a:ext uri="{FF2B5EF4-FFF2-40B4-BE49-F238E27FC236}">
-                <a16:creationId xmlns:a16="http://schemas.microsoft.com/office/drawing/2014/main" id="{33DC6C0B-850F-4668-969E-A5113FB94C22}"/>
+                <a16:creationId xmlns:a16="http://schemas.microsoft.com/office/drawing/2014/main" id="{D02FD80F-9BE7-4E5E-BC83-1205049313D0}"/>
               </a:ext>
             </a:extLst>
           </p:cNvPr>
@@ -6267,7 +6267,7 @@
           <p:cNvPr id="14" name="">
             <a:extLst xmlns:a="http://schemas.openxmlformats.org/drawingml/2006/main">
               <a:ext uri="{FF2B5EF4-FFF2-40B4-BE49-F238E27FC236}">
-                <a16:creationId xmlns:a16="http://schemas.microsoft.com/office/drawing/2014/main" id="{561F2D01-5F88-4EC7-B87F-22D09C3E302F}"/>
+                <a16:creationId xmlns:a16="http://schemas.microsoft.com/office/drawing/2014/main" id="{50291C59-2834-405F-8D40-BF455980F2FF}"/>
               </a:ext>
             </a:extLst>
           </p:cNvPr>
@@ -6325,7 +6325,7 @@
           <p:cNvPr id="15" name="">
             <a:extLst xmlns:a="http://schemas.openxmlformats.org/drawingml/2006/main">
               <a:ext uri="{FF2B5EF4-FFF2-40B4-BE49-F238E27FC236}">
-                <a16:creationId xmlns:a16="http://schemas.microsoft.com/office/drawing/2014/main" id="{B418B1CD-F765-4E40-86CA-E67458144360}"/>
+                <a16:creationId xmlns:a16="http://schemas.microsoft.com/office/drawing/2014/main" id="{1CC94239-131C-4836-BEFA-8B7AA30827CD}"/>
               </a:ext>
             </a:extLst>
           </p:cNvPr>
@@ -6383,7 +6383,7 @@
           <p:cNvPr id="16" name="">
             <a:extLst xmlns:a="http://schemas.openxmlformats.org/drawingml/2006/main">
               <a:ext uri="{FF2B5EF4-FFF2-40B4-BE49-F238E27FC236}">
-                <a16:creationId xmlns:a16="http://schemas.microsoft.com/office/drawing/2014/main" id="{D073F833-B6EF-4758-B97D-A5C31E585CA6}"/>
+                <a16:creationId xmlns:a16="http://schemas.microsoft.com/office/drawing/2014/main" id="{07DB89A4-0218-4025-B8FA-45FC197D3705}"/>
               </a:ext>
             </a:extLst>
           </p:cNvPr>
@@ -6441,7 +6441,7 @@
           <p:cNvPr id="17" name="">
             <a:extLst xmlns:a="http://schemas.openxmlformats.org/drawingml/2006/main">
               <a:ext uri="{FF2B5EF4-FFF2-40B4-BE49-F238E27FC236}">
-                <a16:creationId xmlns:a16="http://schemas.microsoft.com/office/drawing/2014/main" id="{EA719B8C-08CE-4593-94E2-92F2A6237F9D}"/>
+                <a16:creationId xmlns:a16="http://schemas.microsoft.com/office/drawing/2014/main" id="{D8C7EE1C-77F7-4967-80EE-8C9BDD411442}"/>
               </a:ext>
             </a:extLst>
           </p:cNvPr>
@@ -6476,7 +6476,7 @@
           <p:cNvPr id="18" name="">
             <a:extLst xmlns:a="http://schemas.openxmlformats.org/drawingml/2006/main">
               <a:ext uri="{FF2B5EF4-FFF2-40B4-BE49-F238E27FC236}">
-                <a16:creationId xmlns:a16="http://schemas.microsoft.com/office/drawing/2014/main" id="{3359F255-1004-4739-9269-8942F5917EC8}"/>
+                <a16:creationId xmlns:a16="http://schemas.microsoft.com/office/drawing/2014/main" id="{E8C4EE5A-7E24-494F-8B72-61A88351A902}"/>
               </a:ext>
             </a:extLst>
           </p:cNvPr>
@@ -6509,7 +6509,7 @@
           <p:cNvPr id="19" name="">
             <a:extLst xmlns:a="http://schemas.openxmlformats.org/drawingml/2006/main">
               <a:ext uri="{FF2B5EF4-FFF2-40B4-BE49-F238E27FC236}">
-                <a16:creationId xmlns:a16="http://schemas.microsoft.com/office/drawing/2014/main" id="{2AD1CCB2-FE63-4ACC-919C-5B0F130C1E0F}"/>
+                <a16:creationId xmlns:a16="http://schemas.microsoft.com/office/drawing/2014/main" id="{89C499CA-53A2-41FC-9EBF-2FDB1DFC9F9E}"/>
               </a:ext>
             </a:extLst>
           </p:cNvPr>
@@ -6567,7 +6567,7 @@
           <p:cNvPr id="20" name="">
             <a:extLst xmlns:a="http://schemas.openxmlformats.org/drawingml/2006/main">
               <a:ext uri="{FF2B5EF4-FFF2-40B4-BE49-F238E27FC236}">
-                <a16:creationId xmlns:a16="http://schemas.microsoft.com/office/drawing/2014/main" id="{3054B42F-3098-4357-8A8F-5BAA5540EEE7}"/>
+                <a16:creationId xmlns:a16="http://schemas.microsoft.com/office/drawing/2014/main" id="{969F526F-D20D-49CF-9633-3A6536975B3A}"/>
               </a:ext>
             </a:extLst>
           </p:cNvPr>
@@ -6625,7 +6625,7 @@
           <p:cNvPr id="21" name="">
             <a:extLst xmlns:a="http://schemas.openxmlformats.org/drawingml/2006/main">
               <a:ext uri="{FF2B5EF4-FFF2-40B4-BE49-F238E27FC236}">
-                <a16:creationId xmlns:a16="http://schemas.microsoft.com/office/drawing/2014/main" id="{900D9478-5C40-4EA0-B571-72AB47B33CD1}"/>
+                <a16:creationId xmlns:a16="http://schemas.microsoft.com/office/drawing/2014/main" id="{449FF1A6-7264-46D4-B797-6B172F792A07}"/>
               </a:ext>
             </a:extLst>
           </p:cNvPr>
@@ -6683,7 +6683,7 @@
           <p:cNvPr id="22" name="">
             <a:extLst xmlns:a="http://schemas.openxmlformats.org/drawingml/2006/main">
               <a:ext uri="{FF2B5EF4-FFF2-40B4-BE49-F238E27FC236}">
-                <a16:creationId xmlns:a16="http://schemas.microsoft.com/office/drawing/2014/main" id="{44D55E92-AF9F-4589-9243-D5AF039FC024}"/>
+                <a16:creationId xmlns:a16="http://schemas.microsoft.com/office/drawing/2014/main" id="{F6FB014E-C97A-4A46-8DFB-633EEFB79C32}"/>
               </a:ext>
             </a:extLst>
           </p:cNvPr>
@@ -6741,7 +6741,7 @@
           <p:cNvPr id="23" name="">
             <a:extLst xmlns:a="http://schemas.openxmlformats.org/drawingml/2006/main">
               <a:ext uri="{FF2B5EF4-FFF2-40B4-BE49-F238E27FC236}">
-                <a16:creationId xmlns:a16="http://schemas.microsoft.com/office/drawing/2014/main" id="{A1000944-D79A-4692-8070-97F2E3E7863D}"/>
+                <a16:creationId xmlns:a16="http://schemas.microsoft.com/office/drawing/2014/main" id="{29825D11-51C5-4228-B3E4-F0A6E1E443DC}"/>
               </a:ext>
             </a:extLst>
           </p:cNvPr>
@@ -6776,7 +6776,7 @@
           <p:cNvPr id="24" name="">
             <a:extLst xmlns:a="http://schemas.openxmlformats.org/drawingml/2006/main">
               <a:ext uri="{FF2B5EF4-FFF2-40B4-BE49-F238E27FC236}">
-                <a16:creationId xmlns:a16="http://schemas.microsoft.com/office/drawing/2014/main" id="{6B85E3AF-2D79-4928-AF3B-B46C331AC18A}"/>
+                <a16:creationId xmlns:a16="http://schemas.microsoft.com/office/drawing/2014/main" id="{DC7E37D6-B690-4B8F-B655-00FC9F226754}"/>
               </a:ext>
             </a:extLst>
           </p:cNvPr>
@@ -6809,7 +6809,7 @@
           <p:cNvPr id="25" name="">
             <a:extLst xmlns:a="http://schemas.openxmlformats.org/drawingml/2006/main">
               <a:ext uri="{FF2B5EF4-FFF2-40B4-BE49-F238E27FC236}">
-                <a16:creationId xmlns:a16="http://schemas.microsoft.com/office/drawing/2014/main" id="{72D9C2A5-32EB-459E-972F-F147648E8D61}"/>
+                <a16:creationId xmlns:a16="http://schemas.microsoft.com/office/drawing/2014/main" id="{01D6A801-2904-4B80-B4BA-B1408E7C6040}"/>
               </a:ext>
             </a:extLst>
           </p:cNvPr>
@@ -6867,7 +6867,7 @@
           <p:cNvPr id="26" name="">
             <a:extLst xmlns:a="http://schemas.openxmlformats.org/drawingml/2006/main">
               <a:ext uri="{FF2B5EF4-FFF2-40B4-BE49-F238E27FC236}">
-                <a16:creationId xmlns:a16="http://schemas.microsoft.com/office/drawing/2014/main" id="{3AF7A319-F30C-4482-AFEE-D5AC798729B5}"/>
+                <a16:creationId xmlns:a16="http://schemas.microsoft.com/office/drawing/2014/main" id="{872D4D5E-D989-4217-BBD1-60AE502AECE8}"/>
               </a:ext>
             </a:extLst>
           </p:cNvPr>
@@ -6925,7 +6925,7 @@
           <p:cNvPr id="27" name="">
             <a:extLst xmlns:a="http://schemas.openxmlformats.org/drawingml/2006/main">
               <a:ext uri="{FF2B5EF4-FFF2-40B4-BE49-F238E27FC236}">
-                <a16:creationId xmlns:a16="http://schemas.microsoft.com/office/drawing/2014/main" id="{7ABDE7BE-324D-423E-89F4-24A7A11A9264}"/>
+                <a16:creationId xmlns:a16="http://schemas.microsoft.com/office/drawing/2014/main" id="{F93B4429-2AD0-4C53-9395-03A5EB29A179}"/>
               </a:ext>
             </a:extLst>
           </p:cNvPr>
@@ -6983,7 +6983,7 @@
           <p:cNvPr id="28" name="">
             <a:extLst xmlns:a="http://schemas.openxmlformats.org/drawingml/2006/main">
               <a:ext uri="{FF2B5EF4-FFF2-40B4-BE49-F238E27FC236}">
-                <a16:creationId xmlns:a16="http://schemas.microsoft.com/office/drawing/2014/main" id="{6D58918A-D869-401B-9944-258FD45E5313}"/>
+                <a16:creationId xmlns:a16="http://schemas.microsoft.com/office/drawing/2014/main" id="{67DB9F55-D27F-4E30-A76A-5002A6D39A1C}"/>
               </a:ext>
             </a:extLst>
           </p:cNvPr>
@@ -7041,7 +7041,7 @@
           <p:cNvPr id="29" name="">
             <a:extLst xmlns:a="http://schemas.openxmlformats.org/drawingml/2006/main">
               <a:ext uri="{FF2B5EF4-FFF2-40B4-BE49-F238E27FC236}">
-                <a16:creationId xmlns:a16="http://schemas.microsoft.com/office/drawing/2014/main" id="{FDF2646C-59DB-4819-ACDC-B6EE2ED943EC}"/>
+                <a16:creationId xmlns:a16="http://schemas.microsoft.com/office/drawing/2014/main" id="{418996E4-8A89-40D8-B9BA-38FAB7710857}"/>
               </a:ext>
             </a:extLst>
           </p:cNvPr>
@@ -7089,7 +7089,7 @@
                 <a:ea typeface="Aptos"/>
                 <a:cs typeface="Aptos"/>
               </a:rPr>
-              <a:t>WATERS NEXT GEN COMPETITIVE INTELLIGENCE · 09 SEP 2026 · waters-ci-20260909112945</a:t>
+              <a:t>WATERS NEXT GEN COMPETITIVE INTELLIGENCE · 09 SEP 2026 · waters-ci-20260909133432</a:t>
             </a:r>
           </a:p>
         </p:txBody>
@@ -7099,7 +7099,7 @@
           <p:cNvPr id="30" name="">
             <a:extLst xmlns:a="http://schemas.openxmlformats.org/drawingml/2006/main">
               <a:ext uri="{FF2B5EF4-FFF2-40B4-BE49-F238E27FC236}">
-                <a16:creationId xmlns:a16="http://schemas.microsoft.com/office/drawing/2014/main" id="{023F1C89-3E61-4A39-B3CA-700F007276EC}"/>
+                <a16:creationId xmlns:a16="http://schemas.microsoft.com/office/drawing/2014/main" id="{EA771178-6C77-468A-91AF-3911A134E9AC}"/>
               </a:ext>
             </a:extLst>
           </p:cNvPr>
@@ -7155,7 +7155,7 @@
     </p:spTree>
     <p:extLst>
       <p:ext uri="{BB962C8B-B14F-4D97-AF65-F5344CB8AC3E}">
-        <p14:creationId xmlns:p14="http://schemas.microsoft.com/office/powerpoint/2010/main" val="1053356057"/>
+        <p14:creationId xmlns:p14="http://schemas.microsoft.com/office/powerpoint/2010/main" val="187045915"/>
       </p:ext>
     </p:extLst>
   </p:cSld>
@@ -7186,7 +7186,7 @@
           <p:cNvPr id="17" name="">
             <a:extLst xmlns:a="http://schemas.openxmlformats.org/drawingml/2006/main">
               <a:ext uri="{FF2B5EF4-FFF2-40B4-BE49-F238E27FC236}">
-                <a16:creationId xmlns:a16="http://schemas.microsoft.com/office/drawing/2014/main" id="{9B17873F-3DB6-4CD4-B73E-A55B007A8829}"/>
+                <a16:creationId xmlns:a16="http://schemas.microsoft.com/office/drawing/2014/main" id="{EF900EA3-BF09-41B7-B673-558DFDF41008}"/>
               </a:ext>
             </a:extLst>
           </p:cNvPr>
@@ -7244,7 +7244,7 @@
           <p:cNvPr id="2" name="">
             <a:extLst xmlns:a="http://schemas.openxmlformats.org/drawingml/2006/main">
               <a:ext uri="{FF2B5EF4-FFF2-40B4-BE49-F238E27FC236}">
-                <a16:creationId xmlns:a16="http://schemas.microsoft.com/office/drawing/2014/main" id="{A829DDB5-8AE8-4EE2-8DFC-E47C63BC4F18}"/>
+                <a16:creationId xmlns:a16="http://schemas.microsoft.com/office/drawing/2014/main" id="{59E0FBF9-9773-463D-A960-F95F0111D94E}"/>
               </a:ext>
             </a:extLst>
           </p:cNvPr>
@@ -7302,7 +7302,7 @@
           <p:cNvPr id="3" name="">
             <a:extLst xmlns:a="http://schemas.openxmlformats.org/drawingml/2006/main">
               <a:ext uri="{FF2B5EF4-FFF2-40B4-BE49-F238E27FC236}">
-                <a16:creationId xmlns:a16="http://schemas.microsoft.com/office/drawing/2014/main" id="{49759280-73A9-4172-9A2A-17162AF3AA63}"/>
+                <a16:creationId xmlns:a16="http://schemas.microsoft.com/office/drawing/2014/main" id="{5EDDF474-3BCD-49E9-97AA-416E06AF095C}"/>
               </a:ext>
             </a:extLst>
           </p:cNvPr>
@@ -7360,7 +7360,7 @@
           <p:cNvPr id="4" name="">
             <a:extLst xmlns:a="http://schemas.openxmlformats.org/drawingml/2006/main">
               <a:ext uri="{FF2B5EF4-FFF2-40B4-BE49-F238E27FC236}">
-                <a16:creationId xmlns:a16="http://schemas.microsoft.com/office/drawing/2014/main" id="{1539661F-1A8E-40D1-9C19-9BE93B56C6E4}"/>
+                <a16:creationId xmlns:a16="http://schemas.microsoft.com/office/drawing/2014/main" id="{D9726CBF-DF48-4DBA-B8D3-6A42B344B8F8}"/>
               </a:ext>
             </a:extLst>
           </p:cNvPr>
@@ -7393,7 +7393,7 @@
           <p:cNvPr id="5" name="">
             <a:extLst xmlns:a="http://schemas.openxmlformats.org/drawingml/2006/main">
               <a:ext uri="{FF2B5EF4-FFF2-40B4-BE49-F238E27FC236}">
-                <a16:creationId xmlns:a16="http://schemas.microsoft.com/office/drawing/2014/main" id="{3B26024F-B940-4733-B946-703C4A0E051C}"/>
+                <a16:creationId xmlns:a16="http://schemas.microsoft.com/office/drawing/2014/main" id="{52033ED3-2FFB-4CB9-8DD5-6F7C8161AC28}"/>
               </a:ext>
             </a:extLst>
           </p:cNvPr>
@@ -7428,7 +7428,7 @@
           <p:cNvPr id="6" name="">
             <a:extLst xmlns:a="http://schemas.openxmlformats.org/drawingml/2006/main">
               <a:ext uri="{FF2B5EF4-FFF2-40B4-BE49-F238E27FC236}">
-                <a16:creationId xmlns:a16="http://schemas.microsoft.com/office/drawing/2014/main" id="{1596A643-6A22-486F-AE35-C13155C55CC2}"/>
+                <a16:creationId xmlns:a16="http://schemas.microsoft.com/office/drawing/2014/main" id="{12962C5F-63F3-411B-B8BC-ACEDA287FC43}"/>
               </a:ext>
             </a:extLst>
           </p:cNvPr>
@@ -7486,7 +7486,7 @@
           <p:cNvPr id="7" name="">
             <a:extLst xmlns:a="http://schemas.openxmlformats.org/drawingml/2006/main">
               <a:ext uri="{FF2B5EF4-FFF2-40B4-BE49-F238E27FC236}">
-                <a16:creationId xmlns:a16="http://schemas.microsoft.com/office/drawing/2014/main" id="{F4F370A5-24E6-48BF-8C45-BDBB42BFF50A}"/>
+                <a16:creationId xmlns:a16="http://schemas.microsoft.com/office/drawing/2014/main" id="{5A033062-C78C-415D-8417-A9337D23D27F}"/>
               </a:ext>
             </a:extLst>
           </p:cNvPr>
@@ -7544,7 +7544,7 @@
           <p:cNvPr id="8" name="">
             <a:extLst xmlns:a="http://schemas.openxmlformats.org/drawingml/2006/main">
               <a:ext uri="{FF2B5EF4-FFF2-40B4-BE49-F238E27FC236}">
-                <a16:creationId xmlns:a16="http://schemas.microsoft.com/office/drawing/2014/main" id="{4E99C859-AD18-4E64-8AAA-ACDFEEDAB358}"/>
+                <a16:creationId xmlns:a16="http://schemas.microsoft.com/office/drawing/2014/main" id="{7D3FEED9-78B6-433C-BB3C-5A19B196A40B}"/>
               </a:ext>
             </a:extLst>
           </p:cNvPr>
@@ -7602,7 +7602,7 @@
           <p:cNvPr id="9" name="">
             <a:extLst xmlns:a="http://schemas.openxmlformats.org/drawingml/2006/main">
               <a:ext uri="{FF2B5EF4-FFF2-40B4-BE49-F238E27FC236}">
-                <a16:creationId xmlns:a16="http://schemas.microsoft.com/office/drawing/2014/main" id="{B8CF2545-E797-4A42-8636-BBAC0B324F04}"/>
+                <a16:creationId xmlns:a16="http://schemas.microsoft.com/office/drawing/2014/main" id="{07353741-01A6-49ED-858D-1B06DB132C17}"/>
               </a:ext>
             </a:extLst>
           </p:cNvPr>
@@ -7683,7 +7683,7 @@
           <p:cNvPr id="10" name="">
             <a:extLst xmlns:a="http://schemas.openxmlformats.org/drawingml/2006/main">
               <a:ext uri="{FF2B5EF4-FFF2-40B4-BE49-F238E27FC236}">
-                <a16:creationId xmlns:a16="http://schemas.microsoft.com/office/drawing/2014/main" id="{3D1D979F-A8D1-42D0-A3C4-39124E511A02}"/>
+                <a16:creationId xmlns:a16="http://schemas.microsoft.com/office/drawing/2014/main" id="{0FE4E95E-4C8E-42ED-A79A-A55CDBF834D1}"/>
               </a:ext>
             </a:extLst>
           </p:cNvPr>
@@ -7718,7 +7718,7 @@
           <p:cNvPr id="11" name="">
             <a:extLst xmlns:a="http://schemas.openxmlformats.org/drawingml/2006/main">
               <a:ext uri="{FF2B5EF4-FFF2-40B4-BE49-F238E27FC236}">
-                <a16:creationId xmlns:a16="http://schemas.microsoft.com/office/drawing/2014/main" id="{802AA16E-5DC1-4EAB-89DF-6DFABCA1FB2A}"/>
+                <a16:creationId xmlns:a16="http://schemas.microsoft.com/office/drawing/2014/main" id="{7B581209-E6A0-4FE4-84FE-A24F13C1D873}"/>
               </a:ext>
             </a:extLst>
           </p:cNvPr>
@@ -7776,7 +7776,7 @@
           <p:cNvPr id="12" name="">
             <a:extLst xmlns:a="http://schemas.openxmlformats.org/drawingml/2006/main">
               <a:ext uri="{FF2B5EF4-FFF2-40B4-BE49-F238E27FC236}">
-                <a16:creationId xmlns:a16="http://schemas.microsoft.com/office/drawing/2014/main" id="{61CB749F-A0E8-467F-906E-DD1CD9DA7C44}"/>
+                <a16:creationId xmlns:a16="http://schemas.microsoft.com/office/drawing/2014/main" id="{7DBF65C8-B1FC-4827-8002-34EC3D79596F}"/>
               </a:ext>
             </a:extLst>
           </p:cNvPr>
@@ -7834,7 +7834,7 @@
           <p:cNvPr id="13" name="">
             <a:extLst xmlns:a="http://schemas.openxmlformats.org/drawingml/2006/main">
               <a:ext uri="{FF2B5EF4-FFF2-40B4-BE49-F238E27FC236}">
-                <a16:creationId xmlns:a16="http://schemas.microsoft.com/office/drawing/2014/main" id="{EAECF090-873B-410E-A8E6-56499C13D5B1}"/>
+                <a16:creationId xmlns:a16="http://schemas.microsoft.com/office/drawing/2014/main" id="{64C8DC90-02E9-485A-B8AC-F6CE2CFB2BBB}"/>
               </a:ext>
             </a:extLst>
           </p:cNvPr>
@@ -7892,7 +7892,7 @@
           <p:cNvPr id="14" name="">
             <a:extLst xmlns:a="http://schemas.openxmlformats.org/drawingml/2006/main">
               <a:ext uri="{FF2B5EF4-FFF2-40B4-BE49-F238E27FC236}">
-                <a16:creationId xmlns:a16="http://schemas.microsoft.com/office/drawing/2014/main" id="{5ABF325D-2A17-48FB-8304-EE62056AD290}"/>
+                <a16:creationId xmlns:a16="http://schemas.microsoft.com/office/drawing/2014/main" id="{CB0704EA-FC31-4271-B37C-76E60C46FCE7}"/>
               </a:ext>
             </a:extLst>
           </p:cNvPr>
@@ -7996,7 +7996,7 @@
           <p:cNvPr id="15" name="">
             <a:extLst xmlns:a="http://schemas.openxmlformats.org/drawingml/2006/main">
               <a:ext uri="{FF2B5EF4-FFF2-40B4-BE49-F238E27FC236}">
-                <a16:creationId xmlns:a16="http://schemas.microsoft.com/office/drawing/2014/main" id="{F9B61FB5-C460-46BE-ACDD-8D5824436F7A}"/>
+                <a16:creationId xmlns:a16="http://schemas.microsoft.com/office/drawing/2014/main" id="{FC2AC9D1-6B2D-4C0C-BC23-F9E33DFEFE80}"/>
               </a:ext>
             </a:extLst>
           </p:cNvPr>
@@ -8044,7 +8044,7 @@
                 <a:ea typeface="Aptos"/>
                 <a:cs typeface="Aptos"/>
               </a:rPr>
-              <a:t>WATERS NEXT GEN COMPETITIVE INTELLIGENCE · 09 SEP 2026 · waters-ci-20260909112945</a:t>
+              <a:t>WATERS NEXT GEN COMPETITIVE INTELLIGENCE · 09 SEP 2026 · waters-ci-20260909133432</a:t>
             </a:r>
           </a:p>
         </p:txBody>
@@ -8054,7 +8054,7 @@
           <p:cNvPr id="16" name="">
             <a:extLst xmlns:a="http://schemas.openxmlformats.org/drawingml/2006/main">
               <a:ext uri="{FF2B5EF4-FFF2-40B4-BE49-F238E27FC236}">
-                <a16:creationId xmlns:a16="http://schemas.microsoft.com/office/drawing/2014/main" id="{044CD433-27D5-4455-9BF2-43822F4737C3}"/>
+                <a16:creationId xmlns:a16="http://schemas.microsoft.com/office/drawing/2014/main" id="{71B1A10C-4499-47C6-ADC0-6FBF925615F5}"/>
               </a:ext>
             </a:extLst>
           </p:cNvPr>
@@ -8110,7 +8110,7 @@
     </p:spTree>
     <p:extLst>
       <p:ext uri="{BB962C8B-B14F-4D97-AF65-F5344CB8AC3E}">
-        <p14:creationId xmlns:p14="http://schemas.microsoft.com/office/powerpoint/2010/main" val="129386814"/>
+        <p14:creationId xmlns:p14="http://schemas.microsoft.com/office/powerpoint/2010/main" val="1182539556"/>
       </p:ext>
     </p:extLst>
   </p:cSld>
@@ -8141,7 +8141,7 @@
           <p:cNvPr id="37" name="">
             <a:extLst xmlns:a="http://schemas.openxmlformats.org/drawingml/2006/main">
               <a:ext uri="{FF2B5EF4-FFF2-40B4-BE49-F238E27FC236}">
-                <a16:creationId xmlns:a16="http://schemas.microsoft.com/office/drawing/2014/main" id="{0855513E-0D7D-4008-840A-1F4120850647}"/>
+                <a16:creationId xmlns:a16="http://schemas.microsoft.com/office/drawing/2014/main" id="{4087154B-47F3-475A-897B-A49E8C3B4C65}"/>
               </a:ext>
             </a:extLst>
           </p:cNvPr>
@@ -8199,7 +8199,7 @@
           <p:cNvPr id="2" name="">
             <a:extLst xmlns:a="http://schemas.openxmlformats.org/drawingml/2006/main">
               <a:ext uri="{FF2B5EF4-FFF2-40B4-BE49-F238E27FC236}">
-                <a16:creationId xmlns:a16="http://schemas.microsoft.com/office/drawing/2014/main" id="{7BFD64A3-BE89-4C94-BAAD-7D41A8A3D551}"/>
+                <a16:creationId xmlns:a16="http://schemas.microsoft.com/office/drawing/2014/main" id="{7225D830-719E-4F73-9DEF-FBDB16FC182A}"/>
               </a:ext>
             </a:extLst>
           </p:cNvPr>
@@ -8257,7 +8257,7 @@
           <p:cNvPr id="3" name="">
             <a:extLst xmlns:a="http://schemas.openxmlformats.org/drawingml/2006/main">
               <a:ext uri="{FF2B5EF4-FFF2-40B4-BE49-F238E27FC236}">
-                <a16:creationId xmlns:a16="http://schemas.microsoft.com/office/drawing/2014/main" id="{CA9AB492-FC90-4818-A582-A0D94830A953}"/>
+                <a16:creationId xmlns:a16="http://schemas.microsoft.com/office/drawing/2014/main" id="{BA7E46ED-8166-4708-95D4-D13F3B97656C}"/>
               </a:ext>
             </a:extLst>
           </p:cNvPr>
@@ -8315,7 +8315,7 @@
           <p:cNvPr id="4" name="">
             <a:extLst xmlns:a="http://schemas.openxmlformats.org/drawingml/2006/main">
               <a:ext uri="{FF2B5EF4-FFF2-40B4-BE49-F238E27FC236}">
-                <a16:creationId xmlns:a16="http://schemas.microsoft.com/office/drawing/2014/main" id="{8E8B70D1-E64D-4A78-9B21-743D62656EDF}"/>
+                <a16:creationId xmlns:a16="http://schemas.microsoft.com/office/drawing/2014/main" id="{BF6327C9-BFA0-4ED7-8742-A5AE99460626}"/>
               </a:ext>
             </a:extLst>
           </p:cNvPr>
@@ -8348,7 +8348,7 @@
           <p:cNvPr id="5" name="">
             <a:extLst xmlns:a="http://schemas.openxmlformats.org/drawingml/2006/main">
               <a:ext uri="{FF2B5EF4-FFF2-40B4-BE49-F238E27FC236}">
-                <a16:creationId xmlns:a16="http://schemas.microsoft.com/office/drawing/2014/main" id="{D0F23227-9CEE-40C9-958C-7DE649031A51}"/>
+                <a16:creationId xmlns:a16="http://schemas.microsoft.com/office/drawing/2014/main" id="{3CBB7564-A1EE-4E98-88BE-6542263DE208}"/>
               </a:ext>
             </a:extLst>
           </p:cNvPr>
@@ -8383,7 +8383,7 @@
           <p:cNvPr id="6" name="">
             <a:extLst xmlns:a="http://schemas.openxmlformats.org/drawingml/2006/main">
               <a:ext uri="{FF2B5EF4-FFF2-40B4-BE49-F238E27FC236}">
-                <a16:creationId xmlns:a16="http://schemas.microsoft.com/office/drawing/2014/main" id="{584D23EA-39A1-49B5-B969-8AC4B88E7E72}"/>
+                <a16:creationId xmlns:a16="http://schemas.microsoft.com/office/drawing/2014/main" id="{47C831A2-F570-40C2-BDE2-8A03F5EAC93D}"/>
               </a:ext>
             </a:extLst>
           </p:cNvPr>
@@ -8416,7 +8416,7 @@
           <p:cNvPr id="7" name="">
             <a:extLst xmlns:a="http://schemas.openxmlformats.org/drawingml/2006/main">
               <a:ext uri="{FF2B5EF4-FFF2-40B4-BE49-F238E27FC236}">
-                <a16:creationId xmlns:a16="http://schemas.microsoft.com/office/drawing/2014/main" id="{A684D5E1-5386-4683-965B-99A100AD900D}"/>
+                <a16:creationId xmlns:a16="http://schemas.microsoft.com/office/drawing/2014/main" id="{E029CF38-520D-44BD-B2DB-CC30B61DA5E3}"/>
               </a:ext>
             </a:extLst>
           </p:cNvPr>
@@ -8474,7 +8474,7 @@
           <p:cNvPr id="8" name="">
             <a:extLst xmlns:a="http://schemas.openxmlformats.org/drawingml/2006/main">
               <a:ext uri="{FF2B5EF4-FFF2-40B4-BE49-F238E27FC236}">
-                <a16:creationId xmlns:a16="http://schemas.microsoft.com/office/drawing/2014/main" id="{F1D6C0F1-F159-44A2-8F02-EE42CE91F786}"/>
+                <a16:creationId xmlns:a16="http://schemas.microsoft.com/office/drawing/2014/main" id="{3FABE8C9-C004-42ED-A56C-1DA2E764C5C6}"/>
               </a:ext>
             </a:extLst>
           </p:cNvPr>
@@ -8532,7 +8532,7 @@
           <p:cNvPr id="9" name="">
             <a:extLst xmlns:a="http://schemas.openxmlformats.org/drawingml/2006/main">
               <a:ext uri="{FF2B5EF4-FFF2-40B4-BE49-F238E27FC236}">
-                <a16:creationId xmlns:a16="http://schemas.microsoft.com/office/drawing/2014/main" id="{AB98CA39-DE83-4041-AB35-F4A33C7F47BA}"/>
+                <a16:creationId xmlns:a16="http://schemas.microsoft.com/office/drawing/2014/main" id="{7EF432C1-752E-4379-A431-C4726DD09C67}"/>
               </a:ext>
             </a:extLst>
           </p:cNvPr>
@@ -8590,7 +8590,7 @@
           <p:cNvPr id="10" name="">
             <a:extLst xmlns:a="http://schemas.openxmlformats.org/drawingml/2006/main">
               <a:ext uri="{FF2B5EF4-FFF2-40B4-BE49-F238E27FC236}">
-                <a16:creationId xmlns:a16="http://schemas.microsoft.com/office/drawing/2014/main" id="{09865E78-3ED3-4E90-A863-04E5E36C85A0}"/>
+                <a16:creationId xmlns:a16="http://schemas.microsoft.com/office/drawing/2014/main" id="{9F202FA6-573D-4263-9F96-BBE7748FCA99}"/>
               </a:ext>
             </a:extLst>
           </p:cNvPr>
@@ -8648,7 +8648,7 @@
           <p:cNvPr id="11" name="">
             <a:extLst xmlns:a="http://schemas.openxmlformats.org/drawingml/2006/main">
               <a:ext uri="{FF2B5EF4-FFF2-40B4-BE49-F238E27FC236}">
-                <a16:creationId xmlns:a16="http://schemas.microsoft.com/office/drawing/2014/main" id="{AD4A7090-D43E-4239-9D8E-D7FFCBAB2469}"/>
+                <a16:creationId xmlns:a16="http://schemas.microsoft.com/office/drawing/2014/main" id="{802480B2-3B33-41DC-BE18-AAF734ECBAC1}"/>
               </a:ext>
             </a:extLst>
           </p:cNvPr>
@@ -8681,7 +8681,7 @@
           <p:cNvPr id="12" name="">
             <a:extLst xmlns:a="http://schemas.openxmlformats.org/drawingml/2006/main">
               <a:ext uri="{FF2B5EF4-FFF2-40B4-BE49-F238E27FC236}">
-                <a16:creationId xmlns:a16="http://schemas.microsoft.com/office/drawing/2014/main" id="{936D3D74-A8B6-44AB-8717-27C046859A92}"/>
+                <a16:creationId xmlns:a16="http://schemas.microsoft.com/office/drawing/2014/main" id="{E985209E-E137-429E-ABEF-AC681CB84331}"/>
               </a:ext>
             </a:extLst>
           </p:cNvPr>
@@ -8739,7 +8739,7 @@
           <p:cNvPr id="13" name="">
             <a:extLst xmlns:a="http://schemas.openxmlformats.org/drawingml/2006/main">
               <a:ext uri="{FF2B5EF4-FFF2-40B4-BE49-F238E27FC236}">
-                <a16:creationId xmlns:a16="http://schemas.microsoft.com/office/drawing/2014/main" id="{CFC65E3D-F0C7-4051-9792-7FD2BD240C9A}"/>
+                <a16:creationId xmlns:a16="http://schemas.microsoft.com/office/drawing/2014/main" id="{46931C9D-CD8C-4382-8D9E-341E7ADC307E}"/>
               </a:ext>
             </a:extLst>
           </p:cNvPr>
@@ -8797,7 +8797,7 @@
           <p:cNvPr id="14" name="">
             <a:extLst xmlns:a="http://schemas.openxmlformats.org/drawingml/2006/main">
               <a:ext uri="{FF2B5EF4-FFF2-40B4-BE49-F238E27FC236}">
-                <a16:creationId xmlns:a16="http://schemas.microsoft.com/office/drawing/2014/main" id="{2F8236CC-E050-46BC-95AD-4DC4EADDCAA4}"/>
+                <a16:creationId xmlns:a16="http://schemas.microsoft.com/office/drawing/2014/main" id="{BDABD930-68CF-4E10-B1B0-F8B82692F2BE}"/>
               </a:ext>
             </a:extLst>
           </p:cNvPr>
@@ -8855,7 +8855,7 @@
           <p:cNvPr id="15" name="">
             <a:extLst xmlns:a="http://schemas.openxmlformats.org/drawingml/2006/main">
               <a:ext uri="{FF2B5EF4-FFF2-40B4-BE49-F238E27FC236}">
-                <a16:creationId xmlns:a16="http://schemas.microsoft.com/office/drawing/2014/main" id="{4D718464-C75B-46A1-905C-3985491C644C}"/>
+                <a16:creationId xmlns:a16="http://schemas.microsoft.com/office/drawing/2014/main" id="{CF078A79-DFC4-47DB-ABE8-2D1B32EAB9E4}"/>
               </a:ext>
             </a:extLst>
           </p:cNvPr>
@@ -8890,7 +8890,7 @@
           <p:cNvPr id="16" name="">
             <a:extLst xmlns:a="http://schemas.openxmlformats.org/drawingml/2006/main">
               <a:ext uri="{FF2B5EF4-FFF2-40B4-BE49-F238E27FC236}">
-                <a16:creationId xmlns:a16="http://schemas.microsoft.com/office/drawing/2014/main" id="{CA4CCD55-0D1E-467C-8A24-58626E4C3E82}"/>
+                <a16:creationId xmlns:a16="http://schemas.microsoft.com/office/drawing/2014/main" id="{0D325B65-A8BB-4233-90A2-0E2CFA85D37E}"/>
               </a:ext>
             </a:extLst>
           </p:cNvPr>
@@ -8923,7 +8923,7 @@
           <p:cNvPr id="17" name="">
             <a:extLst xmlns:a="http://schemas.openxmlformats.org/drawingml/2006/main">
               <a:ext uri="{FF2B5EF4-FFF2-40B4-BE49-F238E27FC236}">
-                <a16:creationId xmlns:a16="http://schemas.microsoft.com/office/drawing/2014/main" id="{BFC9C9D0-3B3A-4F1F-A79D-D95660405843}"/>
+                <a16:creationId xmlns:a16="http://schemas.microsoft.com/office/drawing/2014/main" id="{72659997-725A-4C97-B837-97707159DD46}"/>
               </a:ext>
             </a:extLst>
           </p:cNvPr>
@@ -8981,7 +8981,7 @@
           <p:cNvPr id="18" name="">
             <a:extLst xmlns:a="http://schemas.openxmlformats.org/drawingml/2006/main">
               <a:ext uri="{FF2B5EF4-FFF2-40B4-BE49-F238E27FC236}">
-                <a16:creationId xmlns:a16="http://schemas.microsoft.com/office/drawing/2014/main" id="{4F062ED4-9A04-4E05-9F9C-D06F93AB20B2}"/>
+                <a16:creationId xmlns:a16="http://schemas.microsoft.com/office/drawing/2014/main" id="{F11B62AC-14A8-410D-8683-7EE948305A63}"/>
               </a:ext>
             </a:extLst>
           </p:cNvPr>
@@ -9039,7 +9039,7 @@
           <p:cNvPr id="19" name="">
             <a:extLst xmlns:a="http://schemas.openxmlformats.org/drawingml/2006/main">
               <a:ext uri="{FF2B5EF4-FFF2-40B4-BE49-F238E27FC236}">
-                <a16:creationId xmlns:a16="http://schemas.microsoft.com/office/drawing/2014/main" id="{0309E4B3-7D26-4139-AFA2-608869FDC4DB}"/>
+                <a16:creationId xmlns:a16="http://schemas.microsoft.com/office/drawing/2014/main" id="{728D64AD-AE41-4931-963C-9BD7366A9B9A}"/>
               </a:ext>
             </a:extLst>
           </p:cNvPr>
@@ -9097,7 +9097,7 @@
           <p:cNvPr id="20" name="">
             <a:extLst xmlns:a="http://schemas.openxmlformats.org/drawingml/2006/main">
               <a:ext uri="{FF2B5EF4-FFF2-40B4-BE49-F238E27FC236}">
-                <a16:creationId xmlns:a16="http://schemas.microsoft.com/office/drawing/2014/main" id="{08F23992-85C6-47BB-893A-6F3B39A0B98D}"/>
+                <a16:creationId xmlns:a16="http://schemas.microsoft.com/office/drawing/2014/main" id="{725763BA-BF01-473C-B4B0-43989FB1AEBF}"/>
               </a:ext>
             </a:extLst>
           </p:cNvPr>
@@ -9155,7 +9155,7 @@
           <p:cNvPr id="21" name="">
             <a:extLst xmlns:a="http://schemas.openxmlformats.org/drawingml/2006/main">
               <a:ext uri="{FF2B5EF4-FFF2-40B4-BE49-F238E27FC236}">
-                <a16:creationId xmlns:a16="http://schemas.microsoft.com/office/drawing/2014/main" id="{4C6559AF-0242-4164-99AB-7844249A4BED}"/>
+                <a16:creationId xmlns:a16="http://schemas.microsoft.com/office/drawing/2014/main" id="{A4BCBF3E-802C-4B72-A571-5BDD88C73881}"/>
               </a:ext>
             </a:extLst>
           </p:cNvPr>
@@ -9188,7 +9188,7 @@
           <p:cNvPr id="22" name="">
             <a:extLst xmlns:a="http://schemas.openxmlformats.org/drawingml/2006/main">
               <a:ext uri="{FF2B5EF4-FFF2-40B4-BE49-F238E27FC236}">
-                <a16:creationId xmlns:a16="http://schemas.microsoft.com/office/drawing/2014/main" id="{19C733C1-B876-42DE-A2F5-AC3D66055376}"/>
+                <a16:creationId xmlns:a16="http://schemas.microsoft.com/office/drawing/2014/main" id="{1ECB3A03-CB79-45EC-B1FB-660DDC9B2B04}"/>
               </a:ext>
             </a:extLst>
           </p:cNvPr>
@@ -9246,7 +9246,7 @@
           <p:cNvPr id="23" name="">
             <a:extLst xmlns:a="http://schemas.openxmlformats.org/drawingml/2006/main">
               <a:ext uri="{FF2B5EF4-FFF2-40B4-BE49-F238E27FC236}">
-                <a16:creationId xmlns:a16="http://schemas.microsoft.com/office/drawing/2014/main" id="{2A07057B-4E7D-4A5F-924D-DD71190403A3}"/>
+                <a16:creationId xmlns:a16="http://schemas.microsoft.com/office/drawing/2014/main" id="{D300689C-1D44-4EF1-8DBE-88837F3F7280}"/>
               </a:ext>
             </a:extLst>
           </p:cNvPr>
@@ -9304,7 +9304,7 @@
           <p:cNvPr id="24" name="">
             <a:extLst xmlns:a="http://schemas.openxmlformats.org/drawingml/2006/main">
               <a:ext uri="{FF2B5EF4-FFF2-40B4-BE49-F238E27FC236}">
-                <a16:creationId xmlns:a16="http://schemas.microsoft.com/office/drawing/2014/main" id="{F6C3DB9A-7EF2-4650-BCEC-05C90F738432}"/>
+                <a16:creationId xmlns:a16="http://schemas.microsoft.com/office/drawing/2014/main" id="{1D5D1327-DD14-4DBD-A1FB-0C9AE9751940}"/>
               </a:ext>
             </a:extLst>
           </p:cNvPr>
@@ -9362,7 +9362,7 @@
           <p:cNvPr id="25" name="">
             <a:extLst xmlns:a="http://schemas.openxmlformats.org/drawingml/2006/main">
               <a:ext uri="{FF2B5EF4-FFF2-40B4-BE49-F238E27FC236}">
-                <a16:creationId xmlns:a16="http://schemas.microsoft.com/office/drawing/2014/main" id="{AF4BB833-0F60-4E85-9908-73A92E875C44}"/>
+                <a16:creationId xmlns:a16="http://schemas.microsoft.com/office/drawing/2014/main" id="{A58AAE16-6AD2-46F5-9184-90E0937E4ADB}"/>
               </a:ext>
             </a:extLst>
           </p:cNvPr>
@@ -9397,7 +9397,7 @@
           <p:cNvPr id="26" name="">
             <a:extLst xmlns:a="http://schemas.openxmlformats.org/drawingml/2006/main">
               <a:ext uri="{FF2B5EF4-FFF2-40B4-BE49-F238E27FC236}">
-                <a16:creationId xmlns:a16="http://schemas.microsoft.com/office/drawing/2014/main" id="{49E6B0E4-519A-4E62-8BAF-558D9273760A}"/>
+                <a16:creationId xmlns:a16="http://schemas.microsoft.com/office/drawing/2014/main" id="{BCBC0F9A-7A2E-47DB-B238-62309E20FFA1}"/>
               </a:ext>
             </a:extLst>
           </p:cNvPr>
@@ -9430,7 +9430,7 @@
           <p:cNvPr id="27" name="">
             <a:extLst xmlns:a="http://schemas.openxmlformats.org/drawingml/2006/main">
               <a:ext uri="{FF2B5EF4-FFF2-40B4-BE49-F238E27FC236}">
-                <a16:creationId xmlns:a16="http://schemas.microsoft.com/office/drawing/2014/main" id="{205AD7AB-0D9C-483D-B89D-CC62AC13385A}"/>
+                <a16:creationId xmlns:a16="http://schemas.microsoft.com/office/drawing/2014/main" id="{BB07C01E-EF0C-4396-936C-390DF87BD2E8}"/>
               </a:ext>
             </a:extLst>
           </p:cNvPr>
@@ -9488,7 +9488,7 @@
           <p:cNvPr id="28" name="">
             <a:extLst xmlns:a="http://schemas.openxmlformats.org/drawingml/2006/main">
               <a:ext uri="{FF2B5EF4-FFF2-40B4-BE49-F238E27FC236}">
-                <a16:creationId xmlns:a16="http://schemas.microsoft.com/office/drawing/2014/main" id="{6966B345-492A-4F4E-BC76-8C7CE33FA319}"/>
+                <a16:creationId xmlns:a16="http://schemas.microsoft.com/office/drawing/2014/main" id="{92205ED0-E72A-4309-B8E5-312DC0C6C72C}"/>
               </a:ext>
             </a:extLst>
           </p:cNvPr>
@@ -9546,7 +9546,7 @@
           <p:cNvPr id="29" name="">
             <a:extLst xmlns:a="http://schemas.openxmlformats.org/drawingml/2006/main">
               <a:ext uri="{FF2B5EF4-FFF2-40B4-BE49-F238E27FC236}">
-                <a16:creationId xmlns:a16="http://schemas.microsoft.com/office/drawing/2014/main" id="{0BC47E0D-D068-4D4E-A077-B46EBF36D03C}"/>
+                <a16:creationId xmlns:a16="http://schemas.microsoft.com/office/drawing/2014/main" id="{4DB0CE5A-A717-4954-9BF2-E82FDD00C90C}"/>
               </a:ext>
             </a:extLst>
           </p:cNvPr>
@@ -9604,7 +9604,7 @@
           <p:cNvPr id="30" name="">
             <a:extLst xmlns:a="http://schemas.openxmlformats.org/drawingml/2006/main">
               <a:ext uri="{FF2B5EF4-FFF2-40B4-BE49-F238E27FC236}">
-                <a16:creationId xmlns:a16="http://schemas.microsoft.com/office/drawing/2014/main" id="{9BA4936F-6414-4B07-872E-AD917B43EA8E}"/>
+                <a16:creationId xmlns:a16="http://schemas.microsoft.com/office/drawing/2014/main" id="{351C0DDB-D13C-4B61-A072-EFD102B0FED5}"/>
               </a:ext>
             </a:extLst>
           </p:cNvPr>
@@ -9662,7 +9662,7 @@
           <p:cNvPr id="31" name="">
             <a:extLst xmlns:a="http://schemas.openxmlformats.org/drawingml/2006/main">
               <a:ext uri="{FF2B5EF4-FFF2-40B4-BE49-F238E27FC236}">
-                <a16:creationId xmlns:a16="http://schemas.microsoft.com/office/drawing/2014/main" id="{24658716-2310-4626-B092-BD4345805A70}"/>
+                <a16:creationId xmlns:a16="http://schemas.microsoft.com/office/drawing/2014/main" id="{3AD80FE4-FF2A-451F-9390-31C9D32DDBC8}"/>
               </a:ext>
             </a:extLst>
           </p:cNvPr>
@@ -9695,7 +9695,7 @@
           <p:cNvPr id="32" name="">
             <a:extLst xmlns:a="http://schemas.openxmlformats.org/drawingml/2006/main">
               <a:ext uri="{FF2B5EF4-FFF2-40B4-BE49-F238E27FC236}">
-                <a16:creationId xmlns:a16="http://schemas.microsoft.com/office/drawing/2014/main" id="{A7D27ADA-4553-4D76-B3DC-B3A0683EDE74}"/>
+                <a16:creationId xmlns:a16="http://schemas.microsoft.com/office/drawing/2014/main" id="{9A62E080-471E-4F7D-814F-5FCCBC0CC36B}"/>
               </a:ext>
             </a:extLst>
           </p:cNvPr>
@@ -9753,7 +9753,7 @@
           <p:cNvPr id="33" name="">
             <a:extLst xmlns:a="http://schemas.openxmlformats.org/drawingml/2006/main">
               <a:ext uri="{FF2B5EF4-FFF2-40B4-BE49-F238E27FC236}">
-                <a16:creationId xmlns:a16="http://schemas.microsoft.com/office/drawing/2014/main" id="{35906157-844D-461A-815B-DEACE3F7A24B}"/>
+                <a16:creationId xmlns:a16="http://schemas.microsoft.com/office/drawing/2014/main" id="{63996005-194B-475A-93B7-B95B68EBE69A}"/>
               </a:ext>
             </a:extLst>
           </p:cNvPr>
@@ -9811,7 +9811,7 @@
           <p:cNvPr id="34" name="">
             <a:extLst xmlns:a="http://schemas.openxmlformats.org/drawingml/2006/main">
               <a:ext uri="{FF2B5EF4-FFF2-40B4-BE49-F238E27FC236}">
-                <a16:creationId xmlns:a16="http://schemas.microsoft.com/office/drawing/2014/main" id="{4DB0D7C2-EFAC-4AEB-AF72-D0B32DEC62B4}"/>
+                <a16:creationId xmlns:a16="http://schemas.microsoft.com/office/drawing/2014/main" id="{63E0080B-13BE-4972-90A4-F66E3D4B92D6}"/>
               </a:ext>
             </a:extLst>
           </p:cNvPr>
@@ -9869,7 +9869,7 @@
           <p:cNvPr id="35" name="">
             <a:extLst xmlns:a="http://schemas.openxmlformats.org/drawingml/2006/main">
               <a:ext uri="{FF2B5EF4-FFF2-40B4-BE49-F238E27FC236}">
-                <a16:creationId xmlns:a16="http://schemas.microsoft.com/office/drawing/2014/main" id="{53454FCA-1A96-48F8-A5DC-09699CE65248}"/>
+                <a16:creationId xmlns:a16="http://schemas.microsoft.com/office/drawing/2014/main" id="{2FDF3616-3637-4DDB-B8E9-91E8FEF82E6D}"/>
               </a:ext>
             </a:extLst>
           </p:cNvPr>
@@ -9917,7 +9917,7 @@
                 <a:ea typeface="Aptos"/>
                 <a:cs typeface="Aptos"/>
               </a:rPr>
-              <a:t>WATERS NEXT GEN COMPETITIVE INTELLIGENCE · 09 SEP 2026 · waters-ci-20260909112945</a:t>
+              <a:t>WATERS NEXT GEN COMPETITIVE INTELLIGENCE · 09 SEP 2026 · waters-ci-20260909133432</a:t>
             </a:r>
           </a:p>
         </p:txBody>
@@ -9927,7 +9927,7 @@
           <p:cNvPr id="36" name="">
             <a:extLst xmlns:a="http://schemas.openxmlformats.org/drawingml/2006/main">
               <a:ext uri="{FF2B5EF4-FFF2-40B4-BE49-F238E27FC236}">
-                <a16:creationId xmlns:a16="http://schemas.microsoft.com/office/drawing/2014/main" id="{18534EEA-1D10-478A-8F3A-40368BF6B1DC}"/>
+                <a16:creationId xmlns:a16="http://schemas.microsoft.com/office/drawing/2014/main" id="{F8610B77-617D-4E29-947A-8282C5420FCC}"/>
               </a:ext>
             </a:extLst>
           </p:cNvPr>
@@ -9983,7 +9983,7 @@
     </p:spTree>
     <p:extLst>
       <p:ext uri="{BB962C8B-B14F-4D97-AF65-F5344CB8AC3E}">
-        <p14:creationId xmlns:p14="http://schemas.microsoft.com/office/powerpoint/2010/main" val="1615002033"/>
+        <p14:creationId xmlns:p14="http://schemas.microsoft.com/office/powerpoint/2010/main" val="1834904639"/>
       </p:ext>
     </p:extLst>
   </p:cSld>
@@ -10014,7 +10014,7 @@
           <p:cNvPr id="26" name="">
             <a:extLst xmlns:a="http://schemas.openxmlformats.org/drawingml/2006/main">
               <a:ext uri="{FF2B5EF4-FFF2-40B4-BE49-F238E27FC236}">
-                <a16:creationId xmlns:a16="http://schemas.microsoft.com/office/drawing/2014/main" id="{A85D94E8-0706-4C74-A785-F684C84E0305}"/>
+                <a16:creationId xmlns:a16="http://schemas.microsoft.com/office/drawing/2014/main" id="{B46BFCA1-B9E2-43C1-9AC2-2472E74D5167}"/>
               </a:ext>
             </a:extLst>
           </p:cNvPr>
@@ -10072,7 +10072,7 @@
           <p:cNvPr id="2" name="">
             <a:extLst xmlns:a="http://schemas.openxmlformats.org/drawingml/2006/main">
               <a:ext uri="{FF2B5EF4-FFF2-40B4-BE49-F238E27FC236}">
-                <a16:creationId xmlns:a16="http://schemas.microsoft.com/office/drawing/2014/main" id="{B7E52171-CAB0-4146-956C-0066988585A8}"/>
+                <a16:creationId xmlns:a16="http://schemas.microsoft.com/office/drawing/2014/main" id="{395A95A2-6BAC-4EE0-A391-B667A855B068}"/>
               </a:ext>
             </a:extLst>
           </p:cNvPr>
@@ -10130,7 +10130,7 @@
           <p:cNvPr id="3" name="">
             <a:extLst xmlns:a="http://schemas.openxmlformats.org/drawingml/2006/main">
               <a:ext uri="{FF2B5EF4-FFF2-40B4-BE49-F238E27FC236}">
-                <a16:creationId xmlns:a16="http://schemas.microsoft.com/office/drawing/2014/main" id="{889C5799-3FDB-461C-9459-2B8B00751D25}"/>
+                <a16:creationId xmlns:a16="http://schemas.microsoft.com/office/drawing/2014/main" id="{C0D14CA6-F918-478D-AA43-88BA15382FAA}"/>
               </a:ext>
             </a:extLst>
           </p:cNvPr>
@@ -10188,7 +10188,7 @@
           <p:cNvPr id="4" name="">
             <a:extLst xmlns:a="http://schemas.openxmlformats.org/drawingml/2006/main">
               <a:ext uri="{FF2B5EF4-FFF2-40B4-BE49-F238E27FC236}">
-                <a16:creationId xmlns:a16="http://schemas.microsoft.com/office/drawing/2014/main" id="{D5CC0E9D-A9D1-4FF3-84AE-4D3B3553037B}"/>
+                <a16:creationId xmlns:a16="http://schemas.microsoft.com/office/drawing/2014/main" id="{197A0E97-4DD6-423B-B748-4E6BBD6A2745}"/>
               </a:ext>
             </a:extLst>
           </p:cNvPr>
@@ -10221,7 +10221,7 @@
           <p:cNvPr id="5" name="">
             <a:extLst xmlns:a="http://schemas.openxmlformats.org/drawingml/2006/main">
               <a:ext uri="{FF2B5EF4-FFF2-40B4-BE49-F238E27FC236}">
-                <a16:creationId xmlns:a16="http://schemas.microsoft.com/office/drawing/2014/main" id="{624C34B2-54DA-4289-8142-7E1E30D501DC}"/>
+                <a16:creationId xmlns:a16="http://schemas.microsoft.com/office/drawing/2014/main" id="{233A8E28-C6BC-4850-9593-C5A45664C150}"/>
               </a:ext>
             </a:extLst>
           </p:cNvPr>
@@ -10254,7 +10254,7 @@
           <p:cNvPr id="6" name="">
             <a:extLst xmlns:a="http://schemas.openxmlformats.org/drawingml/2006/main">
               <a:ext uri="{FF2B5EF4-FFF2-40B4-BE49-F238E27FC236}">
-                <a16:creationId xmlns:a16="http://schemas.microsoft.com/office/drawing/2014/main" id="{5015C516-010C-4399-9430-29B930C8A212}"/>
+                <a16:creationId xmlns:a16="http://schemas.microsoft.com/office/drawing/2014/main" id="{930836FB-B009-4F83-8CB4-BABF86C6AFB9}"/>
               </a:ext>
             </a:extLst>
           </p:cNvPr>
@@ -10289,7 +10289,7 @@
           <p:cNvPr id="7" name="">
             <a:extLst xmlns:a="http://schemas.openxmlformats.org/drawingml/2006/main">
               <a:ext uri="{FF2B5EF4-FFF2-40B4-BE49-F238E27FC236}">
-                <a16:creationId xmlns:a16="http://schemas.microsoft.com/office/drawing/2014/main" id="{C36D0BE3-E389-462E-B4E7-1070490FCC37}"/>
+                <a16:creationId xmlns:a16="http://schemas.microsoft.com/office/drawing/2014/main" id="{1D022D19-DC7F-4D5A-A677-633EFFCA6D99}"/>
               </a:ext>
             </a:extLst>
           </p:cNvPr>
@@ -10347,7 +10347,7 @@
           <p:cNvPr id="8" name="">
             <a:extLst xmlns:a="http://schemas.openxmlformats.org/drawingml/2006/main">
               <a:ext uri="{FF2B5EF4-FFF2-40B4-BE49-F238E27FC236}">
-                <a16:creationId xmlns:a16="http://schemas.microsoft.com/office/drawing/2014/main" id="{47061B23-C9E0-41DC-B87D-E9B8CCBE2DC8}"/>
+                <a16:creationId xmlns:a16="http://schemas.microsoft.com/office/drawing/2014/main" id="{7FA6BA1D-1B02-4EE3-8382-436D553CBF03}"/>
               </a:ext>
             </a:extLst>
           </p:cNvPr>
@@ -10405,7 +10405,7 @@
           <p:cNvPr id="9" name="">
             <a:extLst xmlns:a="http://schemas.openxmlformats.org/drawingml/2006/main">
               <a:ext uri="{FF2B5EF4-FFF2-40B4-BE49-F238E27FC236}">
-                <a16:creationId xmlns:a16="http://schemas.microsoft.com/office/drawing/2014/main" id="{BB4E3FD3-C610-49FA-BDEB-1F1896BB0441}"/>
+                <a16:creationId xmlns:a16="http://schemas.microsoft.com/office/drawing/2014/main" id="{C373D399-EF7F-466A-9143-614F573A09AD}"/>
               </a:ext>
             </a:extLst>
           </p:cNvPr>
@@ -10463,7 +10463,7 @@
           <p:cNvPr id="10" name="">
             <a:extLst xmlns:a="http://schemas.openxmlformats.org/drawingml/2006/main">
               <a:ext uri="{FF2B5EF4-FFF2-40B4-BE49-F238E27FC236}">
-                <a16:creationId xmlns:a16="http://schemas.microsoft.com/office/drawing/2014/main" id="{A7F22FC1-C6A9-48A0-9975-BD4F3F01E8AD}"/>
+                <a16:creationId xmlns:a16="http://schemas.microsoft.com/office/drawing/2014/main" id="{58BB4E9A-516E-4E90-8791-F077EE269837}"/>
               </a:ext>
             </a:extLst>
           </p:cNvPr>
@@ -10498,7 +10498,7 @@
           <p:cNvPr id="11" name="">
             <a:extLst xmlns:a="http://schemas.openxmlformats.org/drawingml/2006/main">
               <a:ext uri="{FF2B5EF4-FFF2-40B4-BE49-F238E27FC236}">
-                <a16:creationId xmlns:a16="http://schemas.microsoft.com/office/drawing/2014/main" id="{C2C5B95F-A5A9-4B03-80BF-7DA3AFF13A23}"/>
+                <a16:creationId xmlns:a16="http://schemas.microsoft.com/office/drawing/2014/main" id="{B9D8D822-3250-462E-902A-A23D8A0D7206}"/>
               </a:ext>
             </a:extLst>
           </p:cNvPr>
@@ -10556,7 +10556,7 @@
           <p:cNvPr id="12" name="">
             <a:extLst xmlns:a="http://schemas.openxmlformats.org/drawingml/2006/main">
               <a:ext uri="{FF2B5EF4-FFF2-40B4-BE49-F238E27FC236}">
-                <a16:creationId xmlns:a16="http://schemas.microsoft.com/office/drawing/2014/main" id="{AF266151-A88D-4312-AD6B-AEAB0DA130B9}"/>
+                <a16:creationId xmlns:a16="http://schemas.microsoft.com/office/drawing/2014/main" id="{0B0B133B-C997-4A21-B23D-7AEB9D8FE129}"/>
               </a:ext>
             </a:extLst>
           </p:cNvPr>
@@ -10614,7 +10614,7 @@
           <p:cNvPr id="13" name="">
             <a:extLst xmlns:a="http://schemas.openxmlformats.org/drawingml/2006/main">
               <a:ext uri="{FF2B5EF4-FFF2-40B4-BE49-F238E27FC236}">
-                <a16:creationId xmlns:a16="http://schemas.microsoft.com/office/drawing/2014/main" id="{F4E66F71-76D4-4F18-BE52-6B5E91B354B0}"/>
+                <a16:creationId xmlns:a16="http://schemas.microsoft.com/office/drawing/2014/main" id="{950AB0A2-158C-4985-9974-801685872F71}"/>
               </a:ext>
             </a:extLst>
           </p:cNvPr>
@@ -10672,7 +10672,7 @@
           <p:cNvPr id="14" name="">
             <a:extLst xmlns:a="http://schemas.openxmlformats.org/drawingml/2006/main">
               <a:ext uri="{FF2B5EF4-FFF2-40B4-BE49-F238E27FC236}">
-                <a16:creationId xmlns:a16="http://schemas.microsoft.com/office/drawing/2014/main" id="{93166028-BB3F-4AAD-B5BA-435E9E35DE7B}"/>
+                <a16:creationId xmlns:a16="http://schemas.microsoft.com/office/drawing/2014/main" id="{84E9E856-55CF-4E75-AF0B-CBC95D255D36}"/>
               </a:ext>
             </a:extLst>
           </p:cNvPr>
@@ -10707,7 +10707,7 @@
           <p:cNvPr id="15" name="">
             <a:extLst xmlns:a="http://schemas.openxmlformats.org/drawingml/2006/main">
               <a:ext uri="{FF2B5EF4-FFF2-40B4-BE49-F238E27FC236}">
-                <a16:creationId xmlns:a16="http://schemas.microsoft.com/office/drawing/2014/main" id="{71EDC104-C2B5-4E43-94E2-D75CA8A208B9}"/>
+                <a16:creationId xmlns:a16="http://schemas.microsoft.com/office/drawing/2014/main" id="{8BFF1B9A-6047-4053-96A5-C54C1F4DE05D}"/>
               </a:ext>
             </a:extLst>
           </p:cNvPr>
@@ -10765,7 +10765,7 @@
           <p:cNvPr id="16" name="">
             <a:extLst xmlns:a="http://schemas.openxmlformats.org/drawingml/2006/main">
               <a:ext uri="{FF2B5EF4-FFF2-40B4-BE49-F238E27FC236}">
-                <a16:creationId xmlns:a16="http://schemas.microsoft.com/office/drawing/2014/main" id="{EB341E2F-F277-400B-B5FA-5596E99966FB}"/>
+                <a16:creationId xmlns:a16="http://schemas.microsoft.com/office/drawing/2014/main" id="{8259569F-187D-45DB-9409-57BA8C07FFAB}"/>
               </a:ext>
             </a:extLst>
           </p:cNvPr>
@@ -10823,7 +10823,7 @@
           <p:cNvPr id="17" name="">
             <a:extLst xmlns:a="http://schemas.openxmlformats.org/drawingml/2006/main">
               <a:ext uri="{FF2B5EF4-FFF2-40B4-BE49-F238E27FC236}">
-                <a16:creationId xmlns:a16="http://schemas.microsoft.com/office/drawing/2014/main" id="{96BB9EE6-DAB4-4576-A7C4-FCEA7060BE0A}"/>
+                <a16:creationId xmlns:a16="http://schemas.microsoft.com/office/drawing/2014/main" id="{4AE95D6F-0352-4C1B-9751-A9EFD2749832}"/>
               </a:ext>
             </a:extLst>
           </p:cNvPr>
@@ -10881,7 +10881,7 @@
           <p:cNvPr id="18" name="">
             <a:extLst xmlns:a="http://schemas.openxmlformats.org/drawingml/2006/main">
               <a:ext uri="{FF2B5EF4-FFF2-40B4-BE49-F238E27FC236}">
-                <a16:creationId xmlns:a16="http://schemas.microsoft.com/office/drawing/2014/main" id="{8250A084-8949-460A-AD34-8BE375A769FF}"/>
+                <a16:creationId xmlns:a16="http://schemas.microsoft.com/office/drawing/2014/main" id="{6390B6F4-731E-454B-A131-CE9F24564054}"/>
               </a:ext>
             </a:extLst>
           </p:cNvPr>
@@ -10916,7 +10916,7 @@
           <p:cNvPr id="19" name="">
             <a:extLst xmlns:a="http://schemas.openxmlformats.org/drawingml/2006/main">
               <a:ext uri="{FF2B5EF4-FFF2-40B4-BE49-F238E27FC236}">
-                <a16:creationId xmlns:a16="http://schemas.microsoft.com/office/drawing/2014/main" id="{4305DC72-967E-4A71-81AD-C11E54C53F32}"/>
+                <a16:creationId xmlns:a16="http://schemas.microsoft.com/office/drawing/2014/main" id="{19AB79FD-02E8-4703-A0A7-05CB3EE5FE53}"/>
               </a:ext>
             </a:extLst>
           </p:cNvPr>
@@ -10974,7 +10974,7 @@
           <p:cNvPr id="20" name="">
             <a:extLst xmlns:a="http://schemas.openxmlformats.org/drawingml/2006/main">
               <a:ext uri="{FF2B5EF4-FFF2-40B4-BE49-F238E27FC236}">
-                <a16:creationId xmlns:a16="http://schemas.microsoft.com/office/drawing/2014/main" id="{0A306023-12D9-40A7-8616-B394999975AE}"/>
+                <a16:creationId xmlns:a16="http://schemas.microsoft.com/office/drawing/2014/main" id="{AE59CF25-A4F3-44D8-9E69-3C2F72311ADE}"/>
               </a:ext>
             </a:extLst>
           </p:cNvPr>
@@ -11032,7 +11032,7 @@
           <p:cNvPr id="21" name="">
             <a:extLst xmlns:a="http://schemas.openxmlformats.org/drawingml/2006/main">
               <a:ext uri="{FF2B5EF4-FFF2-40B4-BE49-F238E27FC236}">
-                <a16:creationId xmlns:a16="http://schemas.microsoft.com/office/drawing/2014/main" id="{A9C889D2-B363-4F95-9DD5-70B222824EBA}"/>
+                <a16:creationId xmlns:a16="http://schemas.microsoft.com/office/drawing/2014/main" id="{157F3BB3-3CD7-46A3-BDF4-5B255FE1C63A}"/>
               </a:ext>
             </a:extLst>
           </p:cNvPr>
@@ -11090,7 +11090,7 @@
           <p:cNvPr id="22" name="">
             <a:extLst xmlns:a="http://schemas.openxmlformats.org/drawingml/2006/main">
               <a:ext uri="{FF2B5EF4-FFF2-40B4-BE49-F238E27FC236}">
-                <a16:creationId xmlns:a16="http://schemas.microsoft.com/office/drawing/2014/main" id="{33139A98-08A1-4BD4-9D86-A6BB93A79607}"/>
+                <a16:creationId xmlns:a16="http://schemas.microsoft.com/office/drawing/2014/main" id="{84D042AF-4568-430E-AD83-B4D169FBD185}"/>
               </a:ext>
             </a:extLst>
           </p:cNvPr>
@@ -11125,7 +11125,7 @@
           <p:cNvPr id="23" name="">
             <a:extLst xmlns:a="http://schemas.openxmlformats.org/drawingml/2006/main">
               <a:ext uri="{FF2B5EF4-FFF2-40B4-BE49-F238E27FC236}">
-                <a16:creationId xmlns:a16="http://schemas.microsoft.com/office/drawing/2014/main" id="{7452B773-978E-42BC-93E3-4D5000696F5E}"/>
+                <a16:creationId xmlns:a16="http://schemas.microsoft.com/office/drawing/2014/main" id="{9572E660-A4D7-484F-8476-815474C57AF1}"/>
               </a:ext>
             </a:extLst>
           </p:cNvPr>
@@ -11183,7 +11183,7 @@
           <p:cNvPr id="24" name="">
             <a:extLst xmlns:a="http://schemas.openxmlformats.org/drawingml/2006/main">
               <a:ext uri="{FF2B5EF4-FFF2-40B4-BE49-F238E27FC236}">
-                <a16:creationId xmlns:a16="http://schemas.microsoft.com/office/drawing/2014/main" id="{D76AC0EC-2E96-4BD4-B5C6-ADDA18D8E821}"/>
+                <a16:creationId xmlns:a16="http://schemas.microsoft.com/office/drawing/2014/main" id="{428F4E39-6617-4B54-B903-061CB53E26D7}"/>
               </a:ext>
             </a:extLst>
           </p:cNvPr>
@@ -11231,7 +11231,7 @@
                 <a:ea typeface="Aptos"/>
                 <a:cs typeface="Aptos"/>
               </a:rPr>
-              <a:t>WATERS NEXT GEN COMPETITIVE INTELLIGENCE · 09 SEP 2026 · waters-ci-20260909112945</a:t>
+              <a:t>WATERS NEXT GEN COMPETITIVE INTELLIGENCE · 09 SEP 2026 · waters-ci-20260909133432</a:t>
             </a:r>
           </a:p>
         </p:txBody>
@@ -11241,7 +11241,7 @@
           <p:cNvPr id="25" name="">
             <a:extLst xmlns:a="http://schemas.openxmlformats.org/drawingml/2006/main">
               <a:ext uri="{FF2B5EF4-FFF2-40B4-BE49-F238E27FC236}">
-                <a16:creationId xmlns:a16="http://schemas.microsoft.com/office/drawing/2014/main" id="{FAC61558-25A3-46D1-A16C-E321F7E5E2CA}"/>
+                <a16:creationId xmlns:a16="http://schemas.microsoft.com/office/drawing/2014/main" id="{3DDE4F73-F9E6-4A35-9BA6-4AFAA7FE75DA}"/>
               </a:ext>
             </a:extLst>
           </p:cNvPr>
@@ -11297,7 +11297,7 @@
     </p:spTree>
     <p:extLst>
       <p:ext uri="{BB962C8B-B14F-4D97-AF65-F5344CB8AC3E}">
-        <p14:creationId xmlns:p14="http://schemas.microsoft.com/office/powerpoint/2010/main" val="1282611542"/>
+        <p14:creationId xmlns:p14="http://schemas.microsoft.com/office/powerpoint/2010/main" val="1636234132"/>
       </p:ext>
     </p:extLst>
   </p:cSld>
@@ -11328,7 +11328,7 @@
           <p:cNvPr id="38" name="">
             <a:extLst xmlns:a="http://schemas.openxmlformats.org/drawingml/2006/main">
               <a:ext uri="{FF2B5EF4-FFF2-40B4-BE49-F238E27FC236}">
-                <a16:creationId xmlns:a16="http://schemas.microsoft.com/office/drawing/2014/main" id="{3BAF95BC-20D2-41D4-9B41-7A98B786377F}"/>
+                <a16:creationId xmlns:a16="http://schemas.microsoft.com/office/drawing/2014/main" id="{A269D91B-FBE8-4C1A-AB12-2B3C707A4256}"/>
               </a:ext>
             </a:extLst>
           </p:cNvPr>
@@ -11386,7 +11386,7 @@
           <p:cNvPr id="2" name="">
             <a:extLst xmlns:a="http://schemas.openxmlformats.org/drawingml/2006/main">
               <a:ext uri="{FF2B5EF4-FFF2-40B4-BE49-F238E27FC236}">
-                <a16:creationId xmlns:a16="http://schemas.microsoft.com/office/drawing/2014/main" id="{B6A72877-A5D8-4439-80EA-D21C023C2B2D}"/>
+                <a16:creationId xmlns:a16="http://schemas.microsoft.com/office/drawing/2014/main" id="{09135479-C642-4DD3-95FC-58128553F2C3}"/>
               </a:ext>
             </a:extLst>
           </p:cNvPr>
@@ -11444,7 +11444,7 @@
           <p:cNvPr id="3" name="">
             <a:extLst xmlns:a="http://schemas.openxmlformats.org/drawingml/2006/main">
               <a:ext uri="{FF2B5EF4-FFF2-40B4-BE49-F238E27FC236}">
-                <a16:creationId xmlns:a16="http://schemas.microsoft.com/office/drawing/2014/main" id="{3A982968-7BAF-45F6-BA4D-4ED4C3A20999}"/>
+                <a16:creationId xmlns:a16="http://schemas.microsoft.com/office/drawing/2014/main" id="{335F900B-C036-4D74-8EB8-832E69E3163A}"/>
               </a:ext>
             </a:extLst>
           </p:cNvPr>
@@ -11502,7 +11502,7 @@
           <p:cNvPr id="4" name="">
             <a:extLst xmlns:a="http://schemas.openxmlformats.org/drawingml/2006/main">
               <a:ext uri="{FF2B5EF4-FFF2-40B4-BE49-F238E27FC236}">
-                <a16:creationId xmlns:a16="http://schemas.microsoft.com/office/drawing/2014/main" id="{7EDF386E-C4C6-4188-87B5-49DA9BC4E7FC}"/>
+                <a16:creationId xmlns:a16="http://schemas.microsoft.com/office/drawing/2014/main" id="{C1F7689F-8C5B-4299-B338-E4865124B915}"/>
               </a:ext>
             </a:extLst>
           </p:cNvPr>
@@ -11535,7 +11535,7 @@
           <p:cNvPr id="5" name="">
             <a:extLst xmlns:a="http://schemas.openxmlformats.org/drawingml/2006/main">
               <a:ext uri="{FF2B5EF4-FFF2-40B4-BE49-F238E27FC236}">
-                <a16:creationId xmlns:a16="http://schemas.microsoft.com/office/drawing/2014/main" id="{902978F0-7D7E-4FE8-B7E3-B7CE162053D0}"/>
+                <a16:creationId xmlns:a16="http://schemas.microsoft.com/office/drawing/2014/main" id="{5BA55212-6DE2-4A4B-B717-3D8D83CC0FCC}"/>
               </a:ext>
             </a:extLst>
           </p:cNvPr>
@@ -11593,7 +11593,7 @@
           <p:cNvPr id="6" name="">
             <a:extLst xmlns:a="http://schemas.openxmlformats.org/drawingml/2006/main">
               <a:ext uri="{FF2B5EF4-FFF2-40B4-BE49-F238E27FC236}">
-                <a16:creationId xmlns:a16="http://schemas.microsoft.com/office/drawing/2014/main" id="{F50760F0-759E-48D1-A08F-8BEBE7709018}"/>
+                <a16:creationId xmlns:a16="http://schemas.microsoft.com/office/drawing/2014/main" id="{ECA3008E-EDC6-4395-A1C3-006C45936AE3}"/>
               </a:ext>
             </a:extLst>
           </p:cNvPr>
@@ -11651,7 +11651,7 @@
           <p:cNvPr id="7" name="">
             <a:extLst xmlns:a="http://schemas.openxmlformats.org/drawingml/2006/main">
               <a:ext uri="{FF2B5EF4-FFF2-40B4-BE49-F238E27FC236}">
-                <a16:creationId xmlns:a16="http://schemas.microsoft.com/office/drawing/2014/main" id="{F39D8E63-C06C-4AF9-9A57-7F643C1E2F5C}"/>
+                <a16:creationId xmlns:a16="http://schemas.microsoft.com/office/drawing/2014/main" id="{F62BD6EB-B8A7-4372-803F-5A53300FE941}"/>
               </a:ext>
             </a:extLst>
           </p:cNvPr>
@@ -11707,10 +11707,10 @@
       <p:sp>
         <p:nvSpPr>
           <p:cNvPr id="8" name="">
-            <a:hlinkClick xmlns:r="http://schemas.openxmlformats.org/officeDocument/2006/relationships" xmlns:a="http://schemas.openxmlformats.org/drawingml/2006/main" r:id="R5ca3a74df9b24f7b"/>
-            <a:extLst xmlns:a="http://schemas.openxmlformats.org/drawingml/2006/main">
-              <a:ext uri="{FF2B5EF4-FFF2-40B4-BE49-F238E27FC236}">
-                <a16:creationId xmlns:a16="http://schemas.microsoft.com/office/drawing/2014/main" id="{C356FB99-75A5-4636-8DB4-6CA98136C0C4}"/>
+            <a:hlinkClick xmlns:r="http://schemas.openxmlformats.org/officeDocument/2006/relationships" xmlns:a="http://schemas.openxmlformats.org/drawingml/2006/main" r:id="R1435959a10104b2e"/>
+            <a:extLst xmlns:a="http://schemas.openxmlformats.org/drawingml/2006/main">
+              <a:ext uri="{FF2B5EF4-FFF2-40B4-BE49-F238E27FC236}">
+                <a16:creationId xmlns:a16="http://schemas.microsoft.com/office/drawing/2014/main" id="{D8FF5087-73D6-4D69-B9A2-3418C6AD0D97}"/>
               </a:ext>
             </a:extLst>
           </p:cNvPr>
@@ -11768,7 +11768,7 @@
           <p:cNvPr id="9" name="">
             <a:extLst xmlns:a="http://schemas.openxmlformats.org/drawingml/2006/main">
               <a:ext uri="{FF2B5EF4-FFF2-40B4-BE49-F238E27FC236}">
-                <a16:creationId xmlns:a16="http://schemas.microsoft.com/office/drawing/2014/main" id="{CE121BEA-204F-436A-98D0-8C9E4D952871}"/>
+                <a16:creationId xmlns:a16="http://schemas.microsoft.com/office/drawing/2014/main" id="{01E8015E-4B9F-4F3F-A85D-2323B264C5BB}"/>
               </a:ext>
             </a:extLst>
           </p:cNvPr>
@@ -11801,7 +11801,7 @@
           <p:cNvPr id="10" name="">
             <a:extLst xmlns:a="http://schemas.openxmlformats.org/drawingml/2006/main">
               <a:ext uri="{FF2B5EF4-FFF2-40B4-BE49-F238E27FC236}">
-                <a16:creationId xmlns:a16="http://schemas.microsoft.com/office/drawing/2014/main" id="{9355D116-6FBB-444E-A8EC-ECDB36BA23C7}"/>
+                <a16:creationId xmlns:a16="http://schemas.microsoft.com/office/drawing/2014/main" id="{7FDD8D04-E761-4182-905A-E022CA80EAC1}"/>
               </a:ext>
             </a:extLst>
           </p:cNvPr>
@@ -11859,7 +11859,7 @@
           <p:cNvPr id="11" name="">
             <a:extLst xmlns:a="http://schemas.openxmlformats.org/drawingml/2006/main">
               <a:ext uri="{FF2B5EF4-FFF2-40B4-BE49-F238E27FC236}">
-                <a16:creationId xmlns:a16="http://schemas.microsoft.com/office/drawing/2014/main" id="{53ADC45F-4FE5-4FAB-AACF-8CF76EA77085}"/>
+                <a16:creationId xmlns:a16="http://schemas.microsoft.com/office/drawing/2014/main" id="{343D23E9-20E0-41C8-AAF1-C046A532BD9E}"/>
               </a:ext>
             </a:extLst>
           </p:cNvPr>
@@ -11917,7 +11917,7 @@
           <p:cNvPr id="12" name="">
             <a:extLst xmlns:a="http://schemas.openxmlformats.org/drawingml/2006/main">
               <a:ext uri="{FF2B5EF4-FFF2-40B4-BE49-F238E27FC236}">
-                <a16:creationId xmlns:a16="http://schemas.microsoft.com/office/drawing/2014/main" id="{7896C773-62A3-40F2-A40A-6D1A2DC9880E}"/>
+                <a16:creationId xmlns:a16="http://schemas.microsoft.com/office/drawing/2014/main" id="{01869BBC-01E0-4C23-A37E-6FD1A85D7EAE}"/>
               </a:ext>
             </a:extLst>
           </p:cNvPr>
@@ -11973,10 +11973,10 @@
       <p:sp>
         <p:nvSpPr>
           <p:cNvPr id="13" name="">
-            <a:hlinkClick xmlns:r="http://schemas.openxmlformats.org/officeDocument/2006/relationships" xmlns:a="http://schemas.openxmlformats.org/drawingml/2006/main" r:id="R30c6b86e035c4548"/>
-            <a:extLst xmlns:a="http://schemas.openxmlformats.org/drawingml/2006/main">
-              <a:ext uri="{FF2B5EF4-FFF2-40B4-BE49-F238E27FC236}">
-                <a16:creationId xmlns:a16="http://schemas.microsoft.com/office/drawing/2014/main" id="{1A2BCB05-8143-405A-9553-E07C5DDEBCAD}"/>
+            <a:hlinkClick xmlns:r="http://schemas.openxmlformats.org/officeDocument/2006/relationships" xmlns:a="http://schemas.openxmlformats.org/drawingml/2006/main" r:id="R708919d86ad84c7a"/>
+            <a:extLst xmlns:a="http://schemas.openxmlformats.org/drawingml/2006/main">
+              <a:ext uri="{FF2B5EF4-FFF2-40B4-BE49-F238E27FC236}">
+                <a16:creationId xmlns:a16="http://schemas.microsoft.com/office/drawing/2014/main" id="{33D9E0F6-C06A-443F-B9CF-7BAF51E2C35B}"/>
               </a:ext>
             </a:extLst>
           </p:cNvPr>
@@ -12034,7 +12034,7 @@
           <p:cNvPr id="14" name="">
             <a:extLst xmlns:a="http://schemas.openxmlformats.org/drawingml/2006/main">
               <a:ext uri="{FF2B5EF4-FFF2-40B4-BE49-F238E27FC236}">
-                <a16:creationId xmlns:a16="http://schemas.microsoft.com/office/drawing/2014/main" id="{02628B9A-F78C-48C6-ADBE-9EB72D2E57A8}"/>
+                <a16:creationId xmlns:a16="http://schemas.microsoft.com/office/drawing/2014/main" id="{C5D6346C-4853-4657-B535-EAD99D010D61}"/>
               </a:ext>
             </a:extLst>
           </p:cNvPr>
@@ -12067,7 +12067,7 @@
           <p:cNvPr id="15" name="">
             <a:extLst xmlns:a="http://schemas.openxmlformats.org/drawingml/2006/main">
               <a:ext uri="{FF2B5EF4-FFF2-40B4-BE49-F238E27FC236}">
-                <a16:creationId xmlns:a16="http://schemas.microsoft.com/office/drawing/2014/main" id="{6EED42FF-065B-46FF-941C-AA6B88EF402C}"/>
+                <a16:creationId xmlns:a16="http://schemas.microsoft.com/office/drawing/2014/main" id="{713BD8AC-28FC-4598-980F-8763C0FA7C6C}"/>
               </a:ext>
             </a:extLst>
           </p:cNvPr>
@@ -12125,7 +12125,7 @@
           <p:cNvPr id="16" name="">
             <a:extLst xmlns:a="http://schemas.openxmlformats.org/drawingml/2006/main">
               <a:ext uri="{FF2B5EF4-FFF2-40B4-BE49-F238E27FC236}">
-                <a16:creationId xmlns:a16="http://schemas.microsoft.com/office/drawing/2014/main" id="{23756B1C-7126-46B8-8D11-AA8EB41E3B61}"/>
+                <a16:creationId xmlns:a16="http://schemas.microsoft.com/office/drawing/2014/main" id="{B7007BAA-24AD-4027-B2A5-8646DAEDF273}"/>
               </a:ext>
             </a:extLst>
           </p:cNvPr>
@@ -12183,7 +12183,7 @@
           <p:cNvPr id="17" name="">
             <a:extLst xmlns:a="http://schemas.openxmlformats.org/drawingml/2006/main">
               <a:ext uri="{FF2B5EF4-FFF2-40B4-BE49-F238E27FC236}">
-                <a16:creationId xmlns:a16="http://schemas.microsoft.com/office/drawing/2014/main" id="{56C85A41-8BD0-45D6-850B-C0895189756C}"/>
+                <a16:creationId xmlns:a16="http://schemas.microsoft.com/office/drawing/2014/main" id="{B2C98EEA-F63A-4869-BAF4-831E99DCE67D}"/>
               </a:ext>
             </a:extLst>
           </p:cNvPr>
@@ -12239,10 +12239,10 @@
       <p:sp>
         <p:nvSpPr>
           <p:cNvPr id="18" name="">
-            <a:hlinkClick xmlns:r="http://schemas.openxmlformats.org/officeDocument/2006/relationships" xmlns:a="http://schemas.openxmlformats.org/drawingml/2006/main" r:id="R171e3dc593f54270"/>
-            <a:extLst xmlns:a="http://schemas.openxmlformats.org/drawingml/2006/main">
-              <a:ext uri="{FF2B5EF4-FFF2-40B4-BE49-F238E27FC236}">
-                <a16:creationId xmlns:a16="http://schemas.microsoft.com/office/drawing/2014/main" id="{83F33022-9A1A-4056-9E6E-82601F2F1E07}"/>
+            <a:hlinkClick xmlns:r="http://schemas.openxmlformats.org/officeDocument/2006/relationships" xmlns:a="http://schemas.openxmlformats.org/drawingml/2006/main" r:id="Rac5432a937f444d7"/>
+            <a:extLst xmlns:a="http://schemas.openxmlformats.org/drawingml/2006/main">
+              <a:ext uri="{FF2B5EF4-FFF2-40B4-BE49-F238E27FC236}">
+                <a16:creationId xmlns:a16="http://schemas.microsoft.com/office/drawing/2014/main" id="{E6ABFCB9-97B8-4CA2-B80D-D8058A7D537A}"/>
               </a:ext>
             </a:extLst>
           </p:cNvPr>
@@ -12300,7 +12300,7 @@
           <p:cNvPr id="19" name="">
             <a:extLst xmlns:a="http://schemas.openxmlformats.org/drawingml/2006/main">
               <a:ext uri="{FF2B5EF4-FFF2-40B4-BE49-F238E27FC236}">
-                <a16:creationId xmlns:a16="http://schemas.microsoft.com/office/drawing/2014/main" id="{C5444E43-0506-469B-A870-7480AC9DDA91}"/>
+                <a16:creationId xmlns:a16="http://schemas.microsoft.com/office/drawing/2014/main" id="{B13A46A4-3422-4FF9-9311-9D4C285407B0}"/>
               </a:ext>
             </a:extLst>
           </p:cNvPr>
@@ -12333,7 +12333,7 @@
           <p:cNvPr id="20" name="">
             <a:extLst xmlns:a="http://schemas.openxmlformats.org/drawingml/2006/main">
               <a:ext uri="{FF2B5EF4-FFF2-40B4-BE49-F238E27FC236}">
-                <a16:creationId xmlns:a16="http://schemas.microsoft.com/office/drawing/2014/main" id="{FD71A2EE-AEA0-4D42-ACCD-5B99294C6E35}"/>
+                <a16:creationId xmlns:a16="http://schemas.microsoft.com/office/drawing/2014/main" id="{EE5A726C-06B7-4269-AC1C-FF31F066D7C5}"/>
               </a:ext>
             </a:extLst>
           </p:cNvPr>
@@ -12391,7 +12391,7 @@
           <p:cNvPr id="21" name="">
             <a:extLst xmlns:a="http://schemas.openxmlformats.org/drawingml/2006/main">
               <a:ext uri="{FF2B5EF4-FFF2-40B4-BE49-F238E27FC236}">
-                <a16:creationId xmlns:a16="http://schemas.microsoft.com/office/drawing/2014/main" id="{42E521A3-1440-487C-A2CD-A71BF91DC4B3}"/>
+                <a16:creationId xmlns:a16="http://schemas.microsoft.com/office/drawing/2014/main" id="{528FE4E2-9502-45D2-B0E5-CC60B65E9F8A}"/>
               </a:ext>
             </a:extLst>
           </p:cNvPr>
@@ -12449,7 +12449,7 @@
           <p:cNvPr id="22" name="">
             <a:extLst xmlns:a="http://schemas.openxmlformats.org/drawingml/2006/main">
               <a:ext uri="{FF2B5EF4-FFF2-40B4-BE49-F238E27FC236}">
-                <a16:creationId xmlns:a16="http://schemas.microsoft.com/office/drawing/2014/main" id="{86BDE670-2DEB-4E46-AC01-58F7F2D8395E}"/>
+                <a16:creationId xmlns:a16="http://schemas.microsoft.com/office/drawing/2014/main" id="{04B697BE-D113-46AB-97C4-381E2D316DBB}"/>
               </a:ext>
             </a:extLst>
           </p:cNvPr>
@@ -12505,10 +12505,10 @@
       <p:sp>
         <p:nvSpPr>
           <p:cNvPr id="23" name="">
-            <a:hlinkClick xmlns:r="http://schemas.openxmlformats.org/officeDocument/2006/relationships" xmlns:a="http://schemas.openxmlformats.org/drawingml/2006/main" r:id="R76c6eceb8f624ad4"/>
-            <a:extLst xmlns:a="http://schemas.openxmlformats.org/drawingml/2006/main">
-              <a:ext uri="{FF2B5EF4-FFF2-40B4-BE49-F238E27FC236}">
-                <a16:creationId xmlns:a16="http://schemas.microsoft.com/office/drawing/2014/main" id="{CE552775-8184-43C8-A58D-8754BB1B1BB3}"/>
+            <a:hlinkClick xmlns:r="http://schemas.openxmlformats.org/officeDocument/2006/relationships" xmlns:a="http://schemas.openxmlformats.org/drawingml/2006/main" r:id="R3f131596bee94986"/>
+            <a:extLst xmlns:a="http://schemas.openxmlformats.org/drawingml/2006/main">
+              <a:ext uri="{FF2B5EF4-FFF2-40B4-BE49-F238E27FC236}">
+                <a16:creationId xmlns:a16="http://schemas.microsoft.com/office/drawing/2014/main" id="{068F4C55-9628-402E-A07C-90E5D5AF825A}"/>
               </a:ext>
             </a:extLst>
           </p:cNvPr>
@@ -12566,7 +12566,7 @@
           <p:cNvPr id="24" name="">
             <a:extLst xmlns:a="http://schemas.openxmlformats.org/drawingml/2006/main">
               <a:ext uri="{FF2B5EF4-FFF2-40B4-BE49-F238E27FC236}">
-                <a16:creationId xmlns:a16="http://schemas.microsoft.com/office/drawing/2014/main" id="{D932D7B9-EE0D-4456-A2F0-2F687099B5A2}"/>
+                <a16:creationId xmlns:a16="http://schemas.microsoft.com/office/drawing/2014/main" id="{DCA00EEC-FF23-4DFB-B92F-A1D7B6D3688F}"/>
               </a:ext>
             </a:extLst>
           </p:cNvPr>
@@ -12599,7 +12599,7 @@
           <p:cNvPr id="25" name="">
             <a:extLst xmlns:a="http://schemas.openxmlformats.org/drawingml/2006/main">
               <a:ext uri="{FF2B5EF4-FFF2-40B4-BE49-F238E27FC236}">
-                <a16:creationId xmlns:a16="http://schemas.microsoft.com/office/drawing/2014/main" id="{76EBD36D-B4C5-4E09-B947-EF4866BF86BF}"/>
+                <a16:creationId xmlns:a16="http://schemas.microsoft.com/office/drawing/2014/main" id="{0016A7F1-0B98-4421-A00F-0A730AB8B37D}"/>
               </a:ext>
             </a:extLst>
           </p:cNvPr>
@@ -12657,7 +12657,7 @@
           <p:cNvPr id="26" name="">
             <a:extLst xmlns:a="http://schemas.openxmlformats.org/drawingml/2006/main">
               <a:ext uri="{FF2B5EF4-FFF2-40B4-BE49-F238E27FC236}">
-                <a16:creationId xmlns:a16="http://schemas.microsoft.com/office/drawing/2014/main" id="{CF64EDA7-67A6-4BF3-906D-F1BC7D7C9604}"/>
+                <a16:creationId xmlns:a16="http://schemas.microsoft.com/office/drawing/2014/main" id="{FE997726-A39A-496D-862B-135C44F08EC3}"/>
               </a:ext>
             </a:extLst>
           </p:cNvPr>
@@ -12715,7 +12715,7 @@
           <p:cNvPr id="27" name="">
             <a:extLst xmlns:a="http://schemas.openxmlformats.org/drawingml/2006/main">
               <a:ext uri="{FF2B5EF4-FFF2-40B4-BE49-F238E27FC236}">
-                <a16:creationId xmlns:a16="http://schemas.microsoft.com/office/drawing/2014/main" id="{CAA65020-EC26-4167-B101-AB6835E9A56A}"/>
+                <a16:creationId xmlns:a16="http://schemas.microsoft.com/office/drawing/2014/main" id="{C2A57DC4-EE85-46C8-B7A6-6AC21EBACC2C}"/>
               </a:ext>
             </a:extLst>
           </p:cNvPr>
@@ -12771,10 +12771,10 @@
       <p:sp>
         <p:nvSpPr>
           <p:cNvPr id="28" name="">
-            <a:hlinkClick xmlns:r="http://schemas.openxmlformats.org/officeDocument/2006/relationships" xmlns:a="http://schemas.openxmlformats.org/drawingml/2006/main" r:id="R1eef90a9958b4247"/>
-            <a:extLst xmlns:a="http://schemas.openxmlformats.org/drawingml/2006/main">
-              <a:ext uri="{FF2B5EF4-FFF2-40B4-BE49-F238E27FC236}">
-                <a16:creationId xmlns:a16="http://schemas.microsoft.com/office/drawing/2014/main" id="{AD1E8DDD-B430-452D-B3CD-38411DC09FDE}"/>
+            <a:hlinkClick xmlns:r="http://schemas.openxmlformats.org/officeDocument/2006/relationships" xmlns:a="http://schemas.openxmlformats.org/drawingml/2006/main" r:id="Rad57e0df94c94570"/>
+            <a:extLst xmlns:a="http://schemas.openxmlformats.org/drawingml/2006/main">
+              <a:ext uri="{FF2B5EF4-FFF2-40B4-BE49-F238E27FC236}">
+                <a16:creationId xmlns:a16="http://schemas.microsoft.com/office/drawing/2014/main" id="{63F7ADC2-1F65-475B-AD0B-0EF7575897F9}"/>
               </a:ext>
             </a:extLst>
           </p:cNvPr>
@@ -12832,7 +12832,7 @@
           <p:cNvPr id="29" name="">
             <a:extLst xmlns:a="http://schemas.openxmlformats.org/drawingml/2006/main">
               <a:ext uri="{FF2B5EF4-FFF2-40B4-BE49-F238E27FC236}">
-                <a16:creationId xmlns:a16="http://schemas.microsoft.com/office/drawing/2014/main" id="{0E77579C-DAAE-4CB2-86CF-9DD5BA954F59}"/>
+                <a16:creationId xmlns:a16="http://schemas.microsoft.com/office/drawing/2014/main" id="{8ECCFD8B-495A-44CC-873F-97BC602BF84C}"/>
               </a:ext>
             </a:extLst>
           </p:cNvPr>
@@ -12865,7 +12865,7 @@
           <p:cNvPr id="30" name="">
             <a:extLst xmlns:a="http://schemas.openxmlformats.org/drawingml/2006/main">
               <a:ext uri="{FF2B5EF4-FFF2-40B4-BE49-F238E27FC236}">
-                <a16:creationId xmlns:a16="http://schemas.microsoft.com/office/drawing/2014/main" id="{73A7BC16-3361-4727-942C-4570B0D4CDC7}"/>
+                <a16:creationId xmlns:a16="http://schemas.microsoft.com/office/drawing/2014/main" id="{C33192CB-2A90-4E77-A6C2-F04BC7AD6A07}"/>
               </a:ext>
             </a:extLst>
           </p:cNvPr>
@@ -12923,7 +12923,7 @@
           <p:cNvPr id="31" name="">
             <a:extLst xmlns:a="http://schemas.openxmlformats.org/drawingml/2006/main">
               <a:ext uri="{FF2B5EF4-FFF2-40B4-BE49-F238E27FC236}">
-                <a16:creationId xmlns:a16="http://schemas.microsoft.com/office/drawing/2014/main" id="{4EB33D44-C45E-4F72-9D71-A2DF8E7C7A1E}"/>
+                <a16:creationId xmlns:a16="http://schemas.microsoft.com/office/drawing/2014/main" id="{008F3EB6-6D04-4CAE-9786-69A639286A68}"/>
               </a:ext>
             </a:extLst>
           </p:cNvPr>
@@ -12981,7 +12981,7 @@
           <p:cNvPr id="32" name="">
             <a:extLst xmlns:a="http://schemas.openxmlformats.org/drawingml/2006/main">
               <a:ext uri="{FF2B5EF4-FFF2-40B4-BE49-F238E27FC236}">
-                <a16:creationId xmlns:a16="http://schemas.microsoft.com/office/drawing/2014/main" id="{AAEAEC77-0A7F-4742-9F64-AF7F0726C121}"/>
+                <a16:creationId xmlns:a16="http://schemas.microsoft.com/office/drawing/2014/main" id="{23A59D14-42D1-4FA7-ABF6-6B9EB5CDAB95}"/>
               </a:ext>
             </a:extLst>
           </p:cNvPr>
@@ -13037,10 +13037,10 @@
       <p:sp>
         <p:nvSpPr>
           <p:cNvPr id="33" name="">
-            <a:hlinkClick xmlns:r="http://schemas.openxmlformats.org/officeDocument/2006/relationships" xmlns:a="http://schemas.openxmlformats.org/drawingml/2006/main" r:id="Rf2130ad4a6a34843"/>
-            <a:extLst xmlns:a="http://schemas.openxmlformats.org/drawingml/2006/main">
-              <a:ext uri="{FF2B5EF4-FFF2-40B4-BE49-F238E27FC236}">
-                <a16:creationId xmlns:a16="http://schemas.microsoft.com/office/drawing/2014/main" id="{8EBEF3A7-E1F0-49C3-A172-DA59D0DB619D}"/>
+            <a:hlinkClick xmlns:r="http://schemas.openxmlformats.org/officeDocument/2006/relationships" xmlns:a="http://schemas.openxmlformats.org/drawingml/2006/main" r:id="R088ea92e518a4013"/>
+            <a:extLst xmlns:a="http://schemas.openxmlformats.org/drawingml/2006/main">
+              <a:ext uri="{FF2B5EF4-FFF2-40B4-BE49-F238E27FC236}">
+                <a16:creationId xmlns:a16="http://schemas.microsoft.com/office/drawing/2014/main" id="{83B163CC-08A6-432D-9AB5-52CA5CD951F2}"/>
               </a:ext>
             </a:extLst>
           </p:cNvPr>
@@ -13098,7 +13098,7 @@
           <p:cNvPr id="34" name="">
             <a:extLst xmlns:a="http://schemas.openxmlformats.org/drawingml/2006/main">
               <a:ext uri="{FF2B5EF4-FFF2-40B4-BE49-F238E27FC236}">
-                <a16:creationId xmlns:a16="http://schemas.microsoft.com/office/drawing/2014/main" id="{77E0AECF-8B0C-4F26-8038-6331EC7CF591}"/>
+                <a16:creationId xmlns:a16="http://schemas.microsoft.com/office/drawing/2014/main" id="{2B3C638C-755E-4635-A531-383DB288364D}"/>
               </a:ext>
             </a:extLst>
           </p:cNvPr>
@@ -13133,7 +13133,7 @@
           <p:cNvPr id="35" name="">
             <a:extLst xmlns:a="http://schemas.openxmlformats.org/drawingml/2006/main">
               <a:ext uri="{FF2B5EF4-FFF2-40B4-BE49-F238E27FC236}">
-                <a16:creationId xmlns:a16="http://schemas.microsoft.com/office/drawing/2014/main" id="{9E0C36E0-6BB4-41D8-A70B-D19C79FCC4D6}"/>
+                <a16:creationId xmlns:a16="http://schemas.microsoft.com/office/drawing/2014/main" id="{3AF51A8B-4E6F-4030-9F48-3C6A45DC8E41}"/>
               </a:ext>
             </a:extLst>
           </p:cNvPr>
@@ -13181,7 +13181,7 @@
                 <a:ea typeface="Aptos"/>
                 <a:cs typeface="Aptos"/>
               </a:rPr>
-              <a:t>Snapshot: waters-ci-20260909112945 · As of 2026-09-09 · Business magnitude requires Waters internal data.</a:t>
+              <a:t>Snapshot: waters-ci-20260909133432 · As of 2026-09-09 · Business magnitude requires Waters internal data.</a:t>
             </a:r>
           </a:p>
         </p:txBody>
@@ -13191,7 +13191,7 @@
           <p:cNvPr id="36" name="">
             <a:extLst xmlns:a="http://schemas.openxmlformats.org/drawingml/2006/main">
               <a:ext uri="{FF2B5EF4-FFF2-40B4-BE49-F238E27FC236}">
-                <a16:creationId xmlns:a16="http://schemas.microsoft.com/office/drawing/2014/main" id="{848FF59F-154A-4EF0-A583-64B3EF69FAE9}"/>
+                <a16:creationId xmlns:a16="http://schemas.microsoft.com/office/drawing/2014/main" id="{147C3B0B-4289-4576-A4DB-8949DCF3BE52}"/>
               </a:ext>
             </a:extLst>
           </p:cNvPr>
@@ -13239,7 +13239,7 @@
                 <a:ea typeface="Aptos"/>
                 <a:cs typeface="Aptos"/>
               </a:rPr>
-              <a:t>WATERS NEXT GEN COMPETITIVE INTELLIGENCE · 09 SEP 2026 · waters-ci-20260909112945</a:t>
+              <a:t>WATERS NEXT GEN COMPETITIVE INTELLIGENCE · 09 SEP 2026 · waters-ci-20260909133432</a:t>
             </a:r>
           </a:p>
         </p:txBody>
@@ -13249,7 +13249,7 @@
           <p:cNvPr id="37" name="">
             <a:extLst xmlns:a="http://schemas.openxmlformats.org/drawingml/2006/main">
               <a:ext uri="{FF2B5EF4-FFF2-40B4-BE49-F238E27FC236}">
-                <a16:creationId xmlns:a16="http://schemas.microsoft.com/office/drawing/2014/main" id="{0CFFDE49-3790-4CF6-8FEE-C910D4866072}"/>
+                <a16:creationId xmlns:a16="http://schemas.microsoft.com/office/drawing/2014/main" id="{A12FD2C7-3915-4B4E-8061-7E34C8776F6C}"/>
               </a:ext>
             </a:extLst>
           </p:cNvPr>
@@ -13305,7 +13305,7 @@
     </p:spTree>
     <p:extLst>
       <p:ext uri="{BB962C8B-B14F-4D97-AF65-F5344CB8AC3E}">
-        <p14:creationId xmlns:p14="http://schemas.microsoft.com/office/powerpoint/2010/main" val="353118322"/>
+        <p14:creationId xmlns:p14="http://schemas.microsoft.com/office/powerpoint/2010/main" val="350869296"/>
       </p:ext>
     </p:extLst>
   </p:cSld>

</xml_diff>